<commit_message>
Rebuild slide deck sa punim bonus figurama (posle pun --all + bonus)
Pun pipeline reproduciran end-to-end (--all): 33232 celije, lineage T/B/Mono/NK.
Bonus full nalazi: mixture sub-aditivna 84-93% (antagonizam), Monocyti jedini gde
je mixture najjaci (emergentno), klasteri stabilni (ARI 0.76-0.96).

Co-Authored-By: Claude Opus 4.8 <noreply@anthropic.com>
</commit_message>
<xml_diff>
--- a/results/slides/GI_nanoplastic.pptx
+++ b/results/slides/GI_nanoplastic.pptx
@@ -3179,16 +3179,64 @@
           </a:p>
         </p:txBody>
       </p:sp>
-      <p:sp>
-        <p:nvSpPr>
-          <p:cNvPr id="3" name="TextBox 2"/>
+      <p:pic>
+        <p:nvPicPr>
+          <p:cNvPr id="3" name="Picture 2" descr="07_module_scores.png"/>
+          <p:cNvPicPr>
+            <a:picLocks noChangeAspect="1"/>
+          </p:cNvPicPr>
+          <p:nvPr/>
+        </p:nvPicPr>
+        <p:blipFill>
+          <a:blip r:embed="rId2"/>
+          <a:stretch>
+            <a:fillRect/>
+          </a:stretch>
+        </p:blipFill>
+        <p:spPr>
+          <a:xfrm>
+            <a:off x="274320" y="1463040"/>
+            <a:ext cx="7360920" cy="4206240"/>
+          </a:xfrm>
+          <a:prstGeom prst="rect">
+            <a:avLst/>
+          </a:prstGeom>
+        </p:spPr>
+      </p:pic>
+      <p:pic>
+        <p:nvPicPr>
+          <p:cNvPr id="4" name="Picture 3" descr="07_mixture_additivity.png"/>
+          <p:cNvPicPr>
+            <a:picLocks noChangeAspect="1"/>
+          </p:cNvPicPr>
+          <p:nvPr/>
+        </p:nvPicPr>
+        <p:blipFill>
+          <a:blip r:embed="rId3"/>
+          <a:stretch>
+            <a:fillRect/>
+          </a:stretch>
+        </p:blipFill>
+        <p:spPr>
+          <a:xfrm>
+            <a:off x="4663440" y="1463040"/>
+            <a:ext cx="21031200" cy="4206240"/>
+          </a:xfrm>
+          <a:prstGeom prst="rect">
+            <a:avLst/>
+          </a:prstGeom>
+        </p:spPr>
+      </p:pic>
+      <p:sp>
+        <p:nvSpPr>
+          <p:cNvPr id="5" name="TextBox 4"/>
           <p:cNvSpPr txBox="1"/>
           <p:nvPr/>
         </p:nvSpPr>
         <p:spPr>
           <a:xfrm>
-            <a:off x="914400" y="2286000"/>
-            <a:ext cx="7315200" cy="914400"/>
+            <a:off x="457200" y="6126480"/>
+            <a:ext cx="8229600" cy="548640"/>
           </a:xfrm>
           <a:prstGeom prst="rect">
             <a:avLst/>
@@ -3201,8 +3249,11 @@
           </a:bodyPr>
           <a:lstStyle/>
           <a:p>
-            <a:r>
-              <a:t>(figure not generated yet -- run the pipeline)</a:t>
+            <a:pPr>
+              <a:defRPr sz="1200"/>
+            </a:pPr>
+            <a:r>
+              <a:t>Stress/inflammation module scores; mixture additivity (observed vs 40+200 expectation).</a:t>
             </a:r>
           </a:p>
         </p:txBody>
@@ -3997,7 +4048,7 @@
       </p:sp>
       <p:pic>
         <p:nvPicPr>
-          <p:cNvPr id="3" name="Picture 2" descr="06_size_categories.png"/>
+          <p:cNvPr id="3" name="Picture 2" descr="07_dose_response.png"/>
           <p:cNvPicPr>
             <a:picLocks noChangeAspect="1"/>
           </p:cNvPicPr>
@@ -4011,17 +4062,41 @@
         </p:blipFill>
         <p:spPr>
           <a:xfrm>
-            <a:off x="1097280" y="1371600"/>
-            <a:ext cx="8558784" cy="4754880"/>
+            <a:off x="274320" y="1463040"/>
+            <a:ext cx="6729984" cy="4206240"/>
           </a:xfrm>
           <a:prstGeom prst="rect">
             <a:avLst/>
           </a:prstGeom>
         </p:spPr>
       </p:pic>
-      <p:sp>
-        <p:nvSpPr>
-          <p:cNvPr id="4" name="TextBox 3"/>
+      <p:pic>
+        <p:nvPicPr>
+          <p:cNvPr id="4" name="Picture 3" descr="06_size_categories.png"/>
+          <p:cNvPicPr>
+            <a:picLocks noChangeAspect="1"/>
+          </p:cNvPicPr>
+          <p:nvPr/>
+        </p:nvPicPr>
+        <p:blipFill>
+          <a:blip r:embed="rId3"/>
+          <a:stretch>
+            <a:fillRect/>
+          </a:stretch>
+        </p:blipFill>
+        <p:spPr>
+          <a:xfrm>
+            <a:off x="4663440" y="1463040"/>
+            <a:ext cx="7571232" cy="4206240"/>
+          </a:xfrm>
+          <a:prstGeom prst="rect">
+            <a:avLst/>
+          </a:prstGeom>
+        </p:spPr>
+      </p:pic>
+      <p:sp>
+        <p:nvSpPr>
+          <p:cNvPr id="5" name="TextBox 4"/>
           <p:cNvSpPr txBox="1"/>
           <p:nvPr/>
         </p:nvSpPr>

</xml_diff>

<commit_message>
fix: slide figures no longer overflow / overlap
_figure_slide sized pictures by height only, so landscape figures (violin
strips 3.75:1, mixture-additivity 5:1) rendered far wider than the slide and
spilled off the edge / overlapped in the two-up layout -- all 12 deck figures
overflowed.

New _place_fit scales each image to FIT its box by whichever dimension binds
(width or height), preserving aspect ratio, and centres it. Verified: 0
pictures exceed the 10x7.5in slide bounds. Deck rebuilt from the current
results/full/figures/ (also fixes the stale-figures issue).
</commit_message>
<xml_diff>
--- a/results/slides/GI_nanoplastic.pptx
+++ b/results/slides/GI_nanoplastic.pptx
@@ -3195,8 +3195,8 @@
         </p:blipFill>
         <p:spPr>
           <a:xfrm>
-            <a:off x="274320" y="1463040"/>
-            <a:ext cx="7360920" cy="4206240"/>
+            <a:off x="274320" y="2455817"/>
+            <a:ext cx="4206240" cy="2403565"/>
           </a:xfrm>
           <a:prstGeom prst="rect">
             <a:avLst/>
@@ -3219,8 +3219,8 @@
         </p:blipFill>
         <p:spPr>
           <a:xfrm>
-            <a:off x="4663440" y="1463040"/>
-            <a:ext cx="21031200" cy="4206240"/>
+            <a:off x="4663440" y="3236976"/>
+            <a:ext cx="4206240" cy="841247"/>
           </a:xfrm>
           <a:prstGeom prst="rect">
             <a:avLst/>
@@ -3235,8 +3235,8 @@
         </p:nvSpPr>
         <p:spPr>
           <a:xfrm>
-            <a:off x="457200" y="6126480"/>
-            <a:ext cx="8229600" cy="548640"/>
+            <a:off x="457200" y="6309360"/>
+            <a:ext cx="8229600" cy="457200"/>
           </a:xfrm>
           <a:prstGeom prst="rect">
             <a:avLst/>
@@ -3590,8 +3590,8 @@
         </p:blipFill>
         <p:spPr>
           <a:xfrm>
-            <a:off x="274320" y="1463040"/>
-            <a:ext cx="15773400" cy="4206240"/>
+            <a:off x="274320" y="3096768"/>
+            <a:ext cx="4206240" cy="1121664"/>
           </a:xfrm>
           <a:prstGeom prst="rect">
             <a:avLst/>
@@ -3614,8 +3614,8 @@
         </p:blipFill>
         <p:spPr>
           <a:xfrm>
-            <a:off x="4663440" y="1463040"/>
-            <a:ext cx="4907280" cy="4206240"/>
+            <a:off x="4663440" y="1854925"/>
+            <a:ext cx="4206240" cy="3605348"/>
           </a:xfrm>
           <a:prstGeom prst="rect">
             <a:avLst/>
@@ -3630,8 +3630,8 @@
         </p:nvSpPr>
         <p:spPr>
           <a:xfrm>
-            <a:off x="457200" y="6126480"/>
-            <a:ext cx="8229600" cy="548640"/>
+            <a:off x="457200" y="6309360"/>
+            <a:ext cx="8229600" cy="457200"/>
           </a:xfrm>
           <a:prstGeom prst="rect">
             <a:avLst/>
@@ -3708,8 +3708,8 @@
         </p:blipFill>
         <p:spPr>
           <a:xfrm>
-            <a:off x="274320" y="1463040"/>
-            <a:ext cx="4907280" cy="4206240"/>
+            <a:off x="274320" y="1854925"/>
+            <a:ext cx="4206240" cy="3605348"/>
           </a:xfrm>
           <a:prstGeom prst="rect">
             <a:avLst/>
@@ -3732,8 +3732,8 @@
         </p:blipFill>
         <p:spPr>
           <a:xfrm>
-            <a:off x="4663440" y="1463040"/>
-            <a:ext cx="4907280" cy="4206240"/>
+            <a:off x="4663440" y="1854925"/>
+            <a:ext cx="4206240" cy="3605348"/>
           </a:xfrm>
           <a:prstGeom prst="rect">
             <a:avLst/>
@@ -3748,8 +3748,8 @@
         </p:nvSpPr>
         <p:spPr>
           <a:xfrm>
-            <a:off x="457200" y="6126480"/>
-            <a:ext cx="8229600" cy="548640"/>
+            <a:off x="457200" y="6309360"/>
+            <a:ext cx="8229600" cy="457200"/>
           </a:xfrm>
           <a:prstGeom prst="rect">
             <a:avLst/>
@@ -3826,8 +3826,8 @@
         </p:blipFill>
         <p:spPr>
           <a:xfrm>
-            <a:off x="274320" y="1463040"/>
-            <a:ext cx="5608320" cy="4206240"/>
+            <a:off x="274320" y="2080260"/>
+            <a:ext cx="4206240" cy="3154679"/>
           </a:xfrm>
           <a:prstGeom prst="rect">
             <a:avLst/>
@@ -3850,8 +3850,8 @@
         </p:blipFill>
         <p:spPr>
           <a:xfrm>
-            <a:off x="4663440" y="1463040"/>
-            <a:ext cx="5338016" cy="4206240"/>
+            <a:off x="4663440" y="2000387"/>
+            <a:ext cx="4206240" cy="3314425"/>
           </a:xfrm>
           <a:prstGeom prst="rect">
             <a:avLst/>
@@ -3866,8 +3866,8 @@
         </p:nvSpPr>
         <p:spPr>
           <a:xfrm>
-            <a:off x="457200" y="6126480"/>
-            <a:ext cx="8229600" cy="548640"/>
+            <a:off x="457200" y="6309360"/>
+            <a:ext cx="8229600" cy="457200"/>
           </a:xfrm>
           <a:prstGeom prst="rect">
             <a:avLst/>
@@ -3944,8 +3944,8 @@
         </p:blipFill>
         <p:spPr>
           <a:xfrm>
-            <a:off x="274320" y="1463040"/>
-            <a:ext cx="6729984" cy="4206240"/>
+            <a:off x="274320" y="2343150"/>
+            <a:ext cx="4206240" cy="2628899"/>
           </a:xfrm>
           <a:prstGeom prst="rect">
             <a:avLst/>
@@ -3968,8 +3968,8 @@
         </p:blipFill>
         <p:spPr>
           <a:xfrm>
-            <a:off x="4663440" y="1463040"/>
-            <a:ext cx="7571232" cy="4206240"/>
+            <a:off x="4663440" y="2489200"/>
+            <a:ext cx="4206240" cy="2336800"/>
           </a:xfrm>
           <a:prstGeom prst="rect">
             <a:avLst/>
@@ -3984,8 +3984,8 @@
         </p:nvSpPr>
         <p:spPr>
           <a:xfrm>
-            <a:off x="457200" y="6126480"/>
-            <a:ext cx="8229600" cy="548640"/>
+            <a:off x="457200" y="6309360"/>
+            <a:ext cx="8229600" cy="457200"/>
           </a:xfrm>
           <a:prstGeom prst="rect">
             <a:avLst/>
@@ -4062,8 +4062,8 @@
         </p:blipFill>
         <p:spPr>
           <a:xfrm>
-            <a:off x="274320" y="1463040"/>
-            <a:ext cx="6729984" cy="4206240"/>
+            <a:off x="274320" y="2343150"/>
+            <a:ext cx="4206240" cy="2628899"/>
           </a:xfrm>
           <a:prstGeom prst="rect">
             <a:avLst/>
@@ -4086,8 +4086,8 @@
         </p:blipFill>
         <p:spPr>
           <a:xfrm>
-            <a:off x="4663440" y="1463040"/>
-            <a:ext cx="7571232" cy="4206240"/>
+            <a:off x="4663440" y="2489200"/>
+            <a:ext cx="4206240" cy="2336800"/>
           </a:xfrm>
           <a:prstGeom prst="rect">
             <a:avLst/>
@@ -4102,8 +4102,8 @@
         </p:nvSpPr>
         <p:spPr>
           <a:xfrm>
-            <a:off x="457200" y="6126480"/>
-            <a:ext cx="8229600" cy="548640"/>
+            <a:off x="457200" y="6309360"/>
+            <a:ext cx="8229600" cy="457200"/>
           </a:xfrm>
           <a:prstGeom prst="rect">
             <a:avLst/>

</xml_diff>

<commit_message>
style: 16:9 widescreen deck with width-aware figure layout
Deck was 4:3 (10x7.5in) -- dated and narrow. Switch to 16:9 (13.333x7.5).
Layout math now derives from SLIDE_W / MARGIN instead of hardcoded 10in-based
positions, so single figures centre across the full width and two-up figures
span the whole slide with a gap (no left-alignment / empty right band).

Verified: ratio 1.778, 0 pictures overflow bounds, single figures centred.
</commit_message>
<xml_diff>
--- a/results/slides/GI_nanoplastic.pptx
+++ b/results/slides/GI_nanoplastic.pptx
@@ -17,7 +17,7 @@
     <p:sldId id="265" r:id="rId16"/>
     <p:sldId id="266" r:id="rId17"/>
   </p:sldIdLst>
-  <p:sldSz cx="9144000" cy="6858000" type="screen4x3"/>
+  <p:sldSz cx="12191695" cy="6858000" type="screen4x3"/>
   <p:notesSz cx="6858000" cy="9144000"/>
   <p:defaultTextStyle>
     <a:defPPr>
@@ -3195,8 +3195,8 @@
         </p:blipFill>
         <p:spPr>
           <a:xfrm>
-            <a:off x="274320" y="2455817"/>
-            <a:ext cx="4206240" cy="2403565"/>
+            <a:off x="365760" y="2059620"/>
+            <a:ext cx="5592927" cy="3195958"/>
           </a:xfrm>
           <a:prstGeom prst="rect">
             <a:avLst/>
@@ -3219,8 +3219,8 @@
         </p:blipFill>
         <p:spPr>
           <a:xfrm>
-            <a:off x="4663440" y="3236976"/>
-            <a:ext cx="4206240" cy="841247"/>
+            <a:off x="6233007" y="3098307"/>
+            <a:ext cx="5592927" cy="1118585"/>
           </a:xfrm>
           <a:prstGeom prst="rect">
             <a:avLst/>
@@ -3235,8 +3235,8 @@
         </p:nvSpPr>
         <p:spPr>
           <a:xfrm>
-            <a:off x="457200" y="6309360"/>
-            <a:ext cx="8229600" cy="457200"/>
+            <a:off x="365760" y="6309360"/>
+            <a:ext cx="11460175" cy="457200"/>
           </a:xfrm>
           <a:prstGeom prst="rect">
             <a:avLst/>
@@ -3590,8 +3590,8 @@
         </p:blipFill>
         <p:spPr>
           <a:xfrm>
-            <a:off x="274320" y="3096768"/>
-            <a:ext cx="4206240" cy="1121664"/>
+            <a:off x="365760" y="2911876"/>
+            <a:ext cx="5592927" cy="1491447"/>
           </a:xfrm>
           <a:prstGeom prst="rect">
             <a:avLst/>
@@ -3614,8 +3614,8 @@
         </p:blipFill>
         <p:spPr>
           <a:xfrm>
-            <a:off x="4663440" y="1854925"/>
-            <a:ext cx="4206240" cy="3605348"/>
+            <a:off x="6362471" y="1371600"/>
+            <a:ext cx="5334000" cy="4572000"/>
           </a:xfrm>
           <a:prstGeom prst="rect">
             <a:avLst/>
@@ -3630,8 +3630,8 @@
         </p:nvSpPr>
         <p:spPr>
           <a:xfrm>
-            <a:off x="457200" y="6309360"/>
-            <a:ext cx="8229600" cy="457200"/>
+            <a:off x="365760" y="6309360"/>
+            <a:ext cx="11460175" cy="457200"/>
           </a:xfrm>
           <a:prstGeom prst="rect">
             <a:avLst/>
@@ -3708,8 +3708,8 @@
         </p:blipFill>
         <p:spPr>
           <a:xfrm>
-            <a:off x="274320" y="1854925"/>
-            <a:ext cx="4206240" cy="3605348"/>
+            <a:off x="495223" y="1371600"/>
+            <a:ext cx="5334000" cy="4572000"/>
           </a:xfrm>
           <a:prstGeom prst="rect">
             <a:avLst/>
@@ -3732,8 +3732,8 @@
         </p:blipFill>
         <p:spPr>
           <a:xfrm>
-            <a:off x="4663440" y="1854925"/>
-            <a:ext cx="4206240" cy="3605348"/>
+            <a:off x="6362471" y="1371600"/>
+            <a:ext cx="5334000" cy="4572000"/>
           </a:xfrm>
           <a:prstGeom prst="rect">
             <a:avLst/>
@@ -3748,8 +3748,8 @@
         </p:nvSpPr>
         <p:spPr>
           <a:xfrm>
-            <a:off x="457200" y="6309360"/>
-            <a:ext cx="8229600" cy="457200"/>
+            <a:off x="365760" y="6309360"/>
+            <a:ext cx="11460175" cy="457200"/>
           </a:xfrm>
           <a:prstGeom prst="rect">
             <a:avLst/>
@@ -3826,8 +3826,8 @@
         </p:blipFill>
         <p:spPr>
           <a:xfrm>
-            <a:off x="274320" y="2080260"/>
-            <a:ext cx="4206240" cy="3154679"/>
+            <a:off x="365760" y="1560252"/>
+            <a:ext cx="5592927" cy="4194695"/>
           </a:xfrm>
           <a:prstGeom prst="rect">
             <a:avLst/>
@@ -3850,8 +3850,8 @@
         </p:blipFill>
         <p:spPr>
           <a:xfrm>
-            <a:off x="4663440" y="2000387"/>
-            <a:ext cx="4206240" cy="3314425"/>
+            <a:off x="6233007" y="1454047"/>
+            <a:ext cx="5592927" cy="4407104"/>
           </a:xfrm>
           <a:prstGeom prst="rect">
             <a:avLst/>
@@ -3866,8 +3866,8 @@
         </p:nvSpPr>
         <p:spPr>
           <a:xfrm>
-            <a:off x="457200" y="6309360"/>
-            <a:ext cx="8229600" cy="457200"/>
+            <a:off x="365760" y="6309360"/>
+            <a:ext cx="11460175" cy="457200"/>
           </a:xfrm>
           <a:prstGeom prst="rect">
             <a:avLst/>
@@ -3944,8 +3944,8 @@
         </p:blipFill>
         <p:spPr>
           <a:xfrm>
-            <a:off x="274320" y="2343150"/>
-            <a:ext cx="4206240" cy="2628899"/>
+            <a:off x="365760" y="1909810"/>
+            <a:ext cx="5592927" cy="3495579"/>
           </a:xfrm>
           <a:prstGeom prst="rect">
             <a:avLst/>
@@ -3968,8 +3968,8 @@
         </p:blipFill>
         <p:spPr>
           <a:xfrm>
-            <a:off x="4663440" y="2489200"/>
-            <a:ext cx="4206240" cy="2336800"/>
+            <a:off x="6233007" y="2104009"/>
+            <a:ext cx="5592927" cy="3107181"/>
           </a:xfrm>
           <a:prstGeom prst="rect">
             <a:avLst/>
@@ -3984,8 +3984,8 @@
         </p:nvSpPr>
         <p:spPr>
           <a:xfrm>
-            <a:off x="457200" y="6309360"/>
-            <a:ext cx="8229600" cy="457200"/>
+            <a:off x="365760" y="6309360"/>
+            <a:ext cx="11460175" cy="457200"/>
           </a:xfrm>
           <a:prstGeom prst="rect">
             <a:avLst/>
@@ -4062,8 +4062,8 @@
         </p:blipFill>
         <p:spPr>
           <a:xfrm>
-            <a:off x="274320" y="2343150"/>
-            <a:ext cx="4206240" cy="2628899"/>
+            <a:off x="365760" y="1909810"/>
+            <a:ext cx="5592927" cy="3495579"/>
           </a:xfrm>
           <a:prstGeom prst="rect">
             <a:avLst/>
@@ -4086,8 +4086,8 @@
         </p:blipFill>
         <p:spPr>
           <a:xfrm>
-            <a:off x="4663440" y="2489200"/>
-            <a:ext cx="4206240" cy="2336800"/>
+            <a:off x="6233007" y="2104009"/>
+            <a:ext cx="5592927" cy="3107181"/>
           </a:xfrm>
           <a:prstGeom prst="rect">
             <a:avLst/>
@@ -4102,8 +4102,8 @@
         </p:nvSpPr>
         <p:spPr>
           <a:xfrm>
-            <a:off x="457200" y="6309360"/>
-            <a:ext cx="8229600" cy="457200"/>
+            <a:off x="365760" y="6309360"/>
+            <a:ext cx="11460175" cy="457200"/>
           </a:xfrm>
           <a:prstGeom prst="rect">
             <a:avLst/>

</xml_diff>

<commit_message>
fix: stretch text to full width; split overcrowded figure slides
Two issues after the 16:9 switch:
1. Title/bullet placeholders kept the built-in layout's ~9in (4:3) width, so
   text hugged the left with a dead band on the right -- looked off-centre.
   _stretch() now re-spans every text placeholder to the usable width.
2. The QC slide (violin strip 3.75:1 + scatter) and Bonus slide (module-scores
   + additivity 5:1) crammed two wide figures side by side, shrinking both to
   unreadable. Each is now split into two full-width single-figure slides.

Deck: 11 -> 13 slides. Verified: 0 narrow text placeholders, 0 figure overflow.
</commit_message>
<xml_diff>
--- a/results/slides/GI_nanoplastic.pptx
+++ b/results/slides/GI_nanoplastic.pptx
@@ -16,6 +16,8 @@
     <p:sldId id="264" r:id="rId15"/>
     <p:sldId id="265" r:id="rId16"/>
     <p:sldId id="266" r:id="rId17"/>
+    <p:sldId id="267" r:id="rId18"/>
+    <p:sldId id="268" r:id="rId19"/>
   </p:sldIdLst>
   <p:sldSz cx="12191695" cy="6858000" type="screen4x3"/>
   <p:notesSz cx="6858000" cy="9144000"/>
@@ -3108,7 +3110,12 @@
             <p:ph type="ctrTitle"/>
           </p:nvPr>
         </p:nvSpPr>
-        <p:spPr/>
+        <p:spPr>
+          <a:xfrm>
+            <a:off x="365760" y="0"/>
+            <a:ext cx="11460175" cy="0"/>
+          </a:xfrm>
+        </p:spPr>
         <p:txBody>
           <a:bodyPr/>
           <a:lstStyle/>
@@ -3129,7 +3136,12 @@
             <p:ph type="subTitle" idx="1"/>
           </p:nvPr>
         </p:nvSpPr>
-        <p:spPr/>
+        <p:spPr>
+          <a:xfrm>
+            <a:off x="365760" y="0"/>
+            <a:ext cx="11460175" cy="0"/>
+          </a:xfrm>
+        </p:spPr>
         <p:txBody>
           <a:bodyPr/>
           <a:lstStyle/>
@@ -3168,92 +3180,79 @@
             <p:ph type="title"/>
           </p:nvPr>
         </p:nvSpPr>
-        <p:spPr/>
-        <p:txBody>
-          <a:bodyPr/>
-          <a:lstStyle/>
-          <a:p>
-            <a:r>
-              <a:t>Bonus analyses</a:t>
-            </a:r>
-          </a:p>
-        </p:txBody>
-      </p:sp>
-      <p:pic>
-        <p:nvPicPr>
-          <p:cNvPr id="3" name="Picture 2" descr="07_module_scores.png"/>
-          <p:cNvPicPr>
-            <a:picLocks noChangeAspect="1"/>
-          </p:cNvPicPr>
-          <p:nvPr/>
-        </p:nvPicPr>
-        <p:blipFill>
-          <a:blip r:embed="rId2"/>
-          <a:stretch>
-            <a:fillRect/>
-          </a:stretch>
-        </p:blipFill>
-        <p:spPr>
-          <a:xfrm>
-            <a:off x="365760" y="2059620"/>
-            <a:ext cx="5592927" cy="3195958"/>
-          </a:xfrm>
-          <a:prstGeom prst="rect">
-            <a:avLst/>
-          </a:prstGeom>
-        </p:spPr>
-      </p:pic>
-      <p:pic>
-        <p:nvPicPr>
-          <p:cNvPr id="4" name="Picture 3" descr="07_mixture_additivity.png"/>
-          <p:cNvPicPr>
-            <a:picLocks noChangeAspect="1"/>
-          </p:cNvPicPr>
-          <p:nvPr/>
-        </p:nvPicPr>
-        <p:blipFill>
-          <a:blip r:embed="rId3"/>
-          <a:stretch>
-            <a:fillRect/>
-          </a:stretch>
-        </p:blipFill>
-        <p:spPr>
-          <a:xfrm>
-            <a:off x="6233007" y="3098307"/>
-            <a:ext cx="5592927" cy="1118585"/>
-          </a:xfrm>
-          <a:prstGeom prst="rect">
-            <a:avLst/>
-          </a:prstGeom>
-        </p:spPr>
-      </p:pic>
-      <p:sp>
-        <p:nvSpPr>
-          <p:cNvPr id="5" name="TextBox 4"/>
-          <p:cNvSpPr txBox="1"/>
-          <p:nvPr/>
-        </p:nvSpPr>
-        <p:spPr>
-          <a:xfrm>
-            <a:off x="365760" y="6309360"/>
-            <a:ext cx="11460175" cy="457200"/>
-          </a:xfrm>
-          <a:prstGeom prst="rect">
-            <a:avLst/>
-          </a:prstGeom>
-          <a:noFill/>
-        </p:spPr>
-        <p:txBody>
-          <a:bodyPr wrap="none">
-            <a:spAutoFit/>
-          </a:bodyPr>
+        <p:spPr>
+          <a:xfrm>
+            <a:off x="365760" y="0"/>
+            <a:ext cx="11460175" cy="0"/>
+          </a:xfrm>
+        </p:spPr>
+        <p:txBody>
+          <a:bodyPr/>
+          <a:lstStyle/>
+          <a:p>
+            <a:r>
+              <a:t>Key biological finding</a:t>
+            </a:r>
+          </a:p>
+        </p:txBody>
+      </p:sp>
+      <p:sp>
+        <p:nvSpPr>
+          <p:cNvPr id="3" name="Content Placeholder 2"/>
+          <p:cNvSpPr>
+            <a:spLocks noGrp="1"/>
+          </p:cNvSpPr>
+          <p:nvPr>
+            <p:ph idx="1"/>
+          </p:nvPr>
+        </p:nvSpPr>
+        <p:spPr>
+          <a:xfrm>
+            <a:off x="365760" y="0"/>
+            <a:ext cx="11460175" cy="0"/>
+          </a:xfrm>
+        </p:spPr>
+        <p:txBody>
+          <a:bodyPr/>
           <a:lstStyle/>
           <a:p>
             <a:pPr>
-              <a:defRPr sz="1200"/>
+              <a:defRPr sz="1800"/>
             </a:pPr>
             <a:r>
-              <a:t>Stress/inflammation module scores; mixture additivity (observed vs 40+200 expectation).</a:t>
+              <a:t>Monocytes show the strongest transcriptional response to nanoplastic.</a:t>
+            </a:r>
+          </a:p>
+          <a:p>
+            <a:pPr>
+              <a:defRPr sz="1800"/>
+            </a:pPr>
+            <a:r>
+              <a:t>200 nm particles drive MORE lineage-unique genes than 40 nm.</a:t>
+            </a:r>
+          </a:p>
+          <a:p>
+            <a:pPr>
+              <a:defRPr sz="1800"/>
+            </a:pPr>
+            <a:r>
+              <a:t>The 40+200 nm mixture produces an EMERGENT monocyte response -</a:t>
+            </a:r>
+          </a:p>
+          <a:p>
+            <a:pPr>
+              <a:defRPr sz="1800"/>
+            </a:pPr>
+            <a:r>
+              <a:t>  genes significant only in the mixture, in neither single size.</a:t>
+            </a:r>
+          </a:p>
+          <a:p>
+            <a:pPr>
+              <a:defRPr sz="1800"/>
+            </a:pPr>
+            <a:r>
+              <a:t>In lymphocytes the mixture is weaker than either size (sub-additive).</a:t>
             </a:r>
           </a:p>
         </p:txBody>
@@ -3286,7 +3285,210 @@
             <p:ph type="title"/>
           </p:nvPr>
         </p:nvSpPr>
-        <p:spPr/>
+        <p:spPr>
+          <a:xfrm>
+            <a:off x="365760" y="0"/>
+            <a:ext cx="11460175" cy="0"/>
+          </a:xfrm>
+        </p:spPr>
+        <p:txBody>
+          <a:bodyPr/>
+          <a:lstStyle/>
+          <a:p>
+            <a:r>
+              <a:t>Bonus analyses (1/2): stress/inflammation module scores</a:t>
+            </a:r>
+          </a:p>
+        </p:txBody>
+      </p:sp>
+      <p:pic>
+        <p:nvPicPr>
+          <p:cNvPr id="3" name="Picture 2" descr="07_module_scores.png"/>
+          <p:cNvPicPr>
+            <a:picLocks noChangeAspect="1"/>
+          </p:cNvPicPr>
+          <p:nvPr/>
+        </p:nvPicPr>
+        <p:blipFill>
+          <a:blip r:embed="rId2"/>
+          <a:stretch>
+            <a:fillRect/>
+          </a:stretch>
+        </p:blipFill>
+        <p:spPr>
+          <a:xfrm>
+            <a:off x="2095347" y="1371600"/>
+            <a:ext cx="8001000" cy="4572000"/>
+          </a:xfrm>
+          <a:prstGeom prst="rect">
+            <a:avLst/>
+          </a:prstGeom>
+        </p:spPr>
+      </p:pic>
+      <p:sp>
+        <p:nvSpPr>
+          <p:cNvPr id="4" name="TextBox 3"/>
+          <p:cNvSpPr txBox="1"/>
+          <p:nvPr/>
+        </p:nvSpPr>
+        <p:spPr>
+          <a:xfrm>
+            <a:off x="365760" y="6309360"/>
+            <a:ext cx="11460175" cy="457200"/>
+          </a:xfrm>
+          <a:prstGeom prst="rect">
+            <a:avLst/>
+          </a:prstGeom>
+          <a:noFill/>
+        </p:spPr>
+        <p:txBody>
+          <a:bodyPr wrap="none">
+            <a:spAutoFit/>
+          </a:bodyPr>
+          <a:lstStyle/>
+          <a:p>
+            <a:pPr>
+              <a:defRPr sz="1200"/>
+            </a:pPr>
+            <a:r>
+              <a:t>Per-sample mean module scores for stress and inflammation gene programs.</a:t>
+            </a:r>
+          </a:p>
+        </p:txBody>
+      </p:sp>
+    </p:spTree>
+  </p:cSld>
+  <p:clrMapOvr>
+    <a:masterClrMapping/>
+  </p:clrMapOvr>
+</p:sld>
+</file>
+
+<file path=ppt/slides/slide12.xml><?xml version="1.0" encoding="utf-8"?>
+<p:sld xmlns:a="http://schemas.openxmlformats.org/drawingml/2006/main" xmlns:p="http://schemas.openxmlformats.org/presentationml/2006/main" xmlns:r="http://schemas.openxmlformats.org/officeDocument/2006/relationships">
+  <p:cSld>
+    <p:spTree>
+      <p:nvGrpSpPr>
+        <p:cNvPr id="1" name=""/>
+        <p:cNvGrpSpPr/>
+        <p:nvPr/>
+      </p:nvGrpSpPr>
+      <p:grpSpPr/>
+      <p:sp>
+        <p:nvSpPr>
+          <p:cNvPr id="2" name="Title 1"/>
+          <p:cNvSpPr>
+            <a:spLocks noGrp="1"/>
+          </p:cNvSpPr>
+          <p:nvPr>
+            <p:ph type="title"/>
+          </p:nvPr>
+        </p:nvSpPr>
+        <p:spPr>
+          <a:xfrm>
+            <a:off x="365760" y="0"/>
+            <a:ext cx="11460175" cy="0"/>
+          </a:xfrm>
+        </p:spPr>
+        <p:txBody>
+          <a:bodyPr/>
+          <a:lstStyle/>
+          <a:p>
+            <a:r>
+              <a:t>Bonus analyses (2/2): mixture additivity</a:t>
+            </a:r>
+          </a:p>
+        </p:txBody>
+      </p:sp>
+      <p:pic>
+        <p:nvPicPr>
+          <p:cNvPr id="3" name="Picture 2" descr="07_mixture_additivity.png"/>
+          <p:cNvPicPr>
+            <a:picLocks noChangeAspect="1"/>
+          </p:cNvPicPr>
+          <p:nvPr/>
+        </p:nvPicPr>
+        <p:blipFill>
+          <a:blip r:embed="rId2"/>
+          <a:stretch>
+            <a:fillRect/>
+          </a:stretch>
+        </p:blipFill>
+        <p:spPr>
+          <a:xfrm>
+            <a:off x="365760" y="2511582"/>
+            <a:ext cx="11460175" cy="2292035"/>
+          </a:xfrm>
+          <a:prstGeom prst="rect">
+            <a:avLst/>
+          </a:prstGeom>
+        </p:spPr>
+      </p:pic>
+      <p:sp>
+        <p:nvSpPr>
+          <p:cNvPr id="4" name="TextBox 3"/>
+          <p:cNvSpPr txBox="1"/>
+          <p:nvPr/>
+        </p:nvSpPr>
+        <p:spPr>
+          <a:xfrm>
+            <a:off x="365760" y="6309360"/>
+            <a:ext cx="11460175" cy="457200"/>
+          </a:xfrm>
+          <a:prstGeom prst="rect">
+            <a:avLst/>
+          </a:prstGeom>
+          <a:noFill/>
+        </p:spPr>
+        <p:txBody>
+          <a:bodyPr wrap="none">
+            <a:spAutoFit/>
+          </a:bodyPr>
+          <a:lstStyle/>
+          <a:p>
+            <a:pPr>
+              <a:defRPr sz="1200"/>
+            </a:pPr>
+            <a:r>
+              <a:t>Observed mixture response vs the 40+200 nm additive expectation, per lineage.</a:t>
+            </a:r>
+          </a:p>
+        </p:txBody>
+      </p:sp>
+    </p:spTree>
+  </p:cSld>
+  <p:clrMapOvr>
+    <a:masterClrMapping/>
+  </p:clrMapOvr>
+</p:sld>
+</file>
+
+<file path=ppt/slides/slide13.xml><?xml version="1.0" encoding="utf-8"?>
+<p:sld xmlns:a="http://schemas.openxmlformats.org/drawingml/2006/main" xmlns:p="http://schemas.openxmlformats.org/presentationml/2006/main" xmlns:r="http://schemas.openxmlformats.org/officeDocument/2006/relationships">
+  <p:cSld>
+    <p:spTree>
+      <p:nvGrpSpPr>
+        <p:cNvPr id="1" name=""/>
+        <p:cNvGrpSpPr/>
+        <p:nvPr/>
+      </p:nvGrpSpPr>
+      <p:grpSpPr/>
+      <p:sp>
+        <p:nvSpPr>
+          <p:cNvPr id="2" name="Title 1"/>
+          <p:cNvSpPr>
+            <a:spLocks noGrp="1"/>
+          </p:cNvSpPr>
+          <p:nvPr>
+            <p:ph type="title"/>
+          </p:nvPr>
+        </p:nvSpPr>
+        <p:spPr>
+          <a:xfrm>
+            <a:off x="365760" y="0"/>
+            <a:ext cx="11460175" cy="0"/>
+          </a:xfrm>
+        </p:spPr>
         <p:txBody>
           <a:bodyPr/>
           <a:lstStyle/>
@@ -3307,7 +3509,12 @@
             <p:ph idx="1"/>
           </p:nvPr>
         </p:nvSpPr>
-        <p:spPr/>
+        <p:spPr>
+          <a:xfrm>
+            <a:off x="365760" y="0"/>
+            <a:ext cx="11460175" cy="0"/>
+          </a:xfrm>
+        </p:spPr>
         <p:txBody>
           <a:bodyPr/>
           <a:lstStyle/>
@@ -3373,7 +3580,12 @@
             <p:ph type="title"/>
           </p:nvPr>
         </p:nvSpPr>
-        <p:spPr/>
+        <p:spPr>
+          <a:xfrm>
+            <a:off x="365760" y="0"/>
+            <a:ext cx="11460175" cy="0"/>
+          </a:xfrm>
+        </p:spPr>
         <p:txBody>
           <a:bodyPr/>
           <a:lstStyle/>
@@ -3394,7 +3606,12 @@
             <p:ph idx="1"/>
           </p:nvPr>
         </p:nvSpPr>
-        <p:spPr/>
+        <p:spPr>
+          <a:xfrm>
+            <a:off x="365760" y="0"/>
+            <a:ext cx="11460175" cy="0"/>
+          </a:xfrm>
+        </p:spPr>
         <p:txBody>
           <a:bodyPr/>
           <a:lstStyle/>
@@ -3460,7 +3677,12 @@
             <p:ph type="title"/>
           </p:nvPr>
         </p:nvSpPr>
-        <p:spPr/>
+        <p:spPr>
+          <a:xfrm>
+            <a:off x="365760" y="0"/>
+            <a:ext cx="11460175" cy="0"/>
+          </a:xfrm>
+        </p:spPr>
         <p:txBody>
           <a:bodyPr/>
           <a:lstStyle/>
@@ -3481,7 +3703,12 @@
             <p:ph idx="1"/>
           </p:nvPr>
         </p:nvSpPr>
-        <p:spPr/>
+        <p:spPr>
+          <a:xfrm>
+            <a:off x="365760" y="0"/>
+            <a:ext cx="11460175" cy="0"/>
+          </a:xfrm>
+        </p:spPr>
         <p:txBody>
           <a:bodyPr/>
           <a:lstStyle/>
@@ -3563,13 +3790,18 @@
             <p:ph type="title"/>
           </p:nvPr>
         </p:nvSpPr>
-        <p:spPr/>
-        <p:txBody>
-          <a:bodyPr/>
-          <a:lstStyle/>
-          <a:p>
-            <a:r>
-              <a:t>QC &amp; preprocessing</a:t>
+        <p:spPr>
+          <a:xfrm>
+            <a:off x="365760" y="0"/>
+            <a:ext cx="11460175" cy="0"/>
+          </a:xfrm>
+        </p:spPr>
+        <p:txBody>
+          <a:bodyPr/>
+          <a:lstStyle/>
+          <a:p>
+            <a:r>
+              <a:t>QC &amp; preprocessing (1/2): per-sample QC metrics</a:t>
             </a:r>
           </a:p>
         </p:txBody>
@@ -3590,41 +3822,17 @@
         </p:blipFill>
         <p:spPr>
           <a:xfrm>
-            <a:off x="365760" y="2911876"/>
-            <a:ext cx="5592927" cy="1491447"/>
+            <a:off x="365760" y="2129576"/>
+            <a:ext cx="11460175" cy="3056046"/>
           </a:xfrm>
           <a:prstGeom prst="rect">
             <a:avLst/>
           </a:prstGeom>
         </p:spPr>
       </p:pic>
-      <p:pic>
-        <p:nvPicPr>
-          <p:cNvPr id="4" name="Picture 3" descr="01_qc_scatter_counts_mito.png"/>
-          <p:cNvPicPr>
-            <a:picLocks noChangeAspect="1"/>
-          </p:cNvPicPr>
-          <p:nvPr/>
-        </p:nvPicPr>
-        <p:blipFill>
-          <a:blip r:embed="rId3"/>
-          <a:stretch>
-            <a:fillRect/>
-          </a:stretch>
-        </p:blipFill>
-        <p:spPr>
-          <a:xfrm>
-            <a:off x="6362471" y="1371600"/>
-            <a:ext cx="5334000" cy="4572000"/>
-          </a:xfrm>
-          <a:prstGeom prst="rect">
-            <a:avLst/>
-          </a:prstGeom>
-        </p:spPr>
-      </p:pic>
-      <p:sp>
-        <p:nvSpPr>
-          <p:cNvPr id="5" name="TextBox 4"/>
+      <p:sp>
+        <p:nvSpPr>
+          <p:cNvPr id="4" name="TextBox 3"/>
           <p:cNvSpPr txBox="1"/>
           <p:nvPr/>
         </p:nvSpPr>
@@ -3648,7 +3856,7 @@
               <a:defRPr sz="1200"/>
             </a:pPr>
             <a:r>
-              <a:t>Thresholds: max_genes~p99, max_mito between p95-p99; justified on the real distribution.</a:t>
+              <a:t>Violins of the 3 QC metrics after filtering. Thresholds justified on the real distribution (max_genes ~p99, max_mito between p95-p99).</a:t>
             </a:r>
           </a:p>
         </p:txBody>
@@ -3681,20 +3889,25 @@
             <p:ph type="title"/>
           </p:nvPr>
         </p:nvSpPr>
-        <p:spPr/>
-        <p:txBody>
-          <a:bodyPr/>
-          <a:lstStyle/>
-          <a:p>
-            <a:r>
-              <a:t>Integration removes the batch effect</a:t>
+        <p:spPr>
+          <a:xfrm>
+            <a:off x="365760" y="0"/>
+            <a:ext cx="11460175" cy="0"/>
+          </a:xfrm>
+        </p:spPr>
+        <p:txBody>
+          <a:bodyPr/>
+          <a:lstStyle/>
+          <a:p>
+            <a:r>
+              <a:t>QC &amp; preprocessing (2/2): counts vs %mito</a:t>
             </a:r>
           </a:p>
         </p:txBody>
       </p:sp>
       <p:pic>
         <p:nvPicPr>
-          <p:cNvPr id="3" name="Picture 2" descr="02_umap_pre_harmony_by_sample.png"/>
+          <p:cNvPr id="3" name="Picture 2" descr="01_qc_scatter_counts_mito.png"/>
           <p:cNvPicPr>
             <a:picLocks noChangeAspect="1"/>
           </p:cNvPicPr>
@@ -3708,7 +3921,7 @@
         </p:blipFill>
         <p:spPr>
           <a:xfrm>
-            <a:off x="495223" y="1371600"/>
+            <a:off x="3428847" y="1371600"/>
             <a:ext cx="5334000" cy="4572000"/>
           </a:xfrm>
           <a:prstGeom prst="rect">
@@ -3716,33 +3929,9 @@
           </a:prstGeom>
         </p:spPr>
       </p:pic>
-      <p:pic>
-        <p:nvPicPr>
-          <p:cNvPr id="4" name="Picture 3" descr="02_umap_by_sample.png"/>
-          <p:cNvPicPr>
-            <a:picLocks noChangeAspect="1"/>
-          </p:cNvPicPr>
-          <p:nvPr/>
-        </p:nvPicPr>
-        <p:blipFill>
-          <a:blip r:embed="rId3"/>
-          <a:stretch>
-            <a:fillRect/>
-          </a:stretch>
-        </p:blipFill>
-        <p:spPr>
-          <a:xfrm>
-            <a:off x="6362471" y="1371600"/>
-            <a:ext cx="5334000" cy="4572000"/>
-          </a:xfrm>
-          <a:prstGeom prst="rect">
-            <a:avLst/>
-          </a:prstGeom>
-        </p:spPr>
-      </p:pic>
-      <p:sp>
-        <p:nvSpPr>
-          <p:cNvPr id="5" name="TextBox 4"/>
+      <p:sp>
+        <p:nvSpPr>
+          <p:cNvPr id="4" name="TextBox 3"/>
           <p:cNvSpPr txBox="1"/>
           <p:nvPr/>
         </p:nvSpPr>
@@ -3766,7 +3955,7 @@
               <a:defRPr sz="1200"/>
             </a:pPr>
             <a:r>
-              <a:t>Before (left) vs after Harmony (right), coloured by sample: samples mix after correction.</a:t>
+              <a:t>total_counts vs %mito (pre-filter); threshold lines drawn. Drops likely doublets and dying cells.</a:t>
             </a:r>
           </a:p>
         </p:txBody>
@@ -3799,20 +3988,25 @@
             <p:ph type="title"/>
           </p:nvPr>
         </p:nvSpPr>
-        <p:spPr/>
-        <p:txBody>
-          <a:bodyPr/>
-          <a:lstStyle/>
-          <a:p>
-            <a:r>
-              <a:t>Cell-type annotation</a:t>
+        <p:spPr>
+          <a:xfrm>
+            <a:off x="365760" y="0"/>
+            <a:ext cx="11460175" cy="0"/>
+          </a:xfrm>
+        </p:spPr>
+        <p:txBody>
+          <a:bodyPr/>
+          <a:lstStyle/>
+          <a:p>
+            <a:r>
+              <a:t>Integration removes the batch effect</a:t>
             </a:r>
           </a:p>
         </p:txBody>
       </p:sp>
       <p:pic>
         <p:nvPicPr>
-          <p:cNvPr id="3" name="Picture 2" descr="03_umap_lineage.png"/>
+          <p:cNvPr id="3" name="Picture 2" descr="02_umap_pre_harmony_by_sample.png"/>
           <p:cNvPicPr>
             <a:picLocks noChangeAspect="1"/>
           </p:cNvPicPr>
@@ -3826,8 +4020,8 @@
         </p:blipFill>
         <p:spPr>
           <a:xfrm>
-            <a:off x="365760" y="1560252"/>
-            <a:ext cx="5592927" cy="4194695"/>
+            <a:off x="495223" y="1371600"/>
+            <a:ext cx="5334000" cy="4572000"/>
           </a:xfrm>
           <a:prstGeom prst="rect">
             <a:avLst/>
@@ -3836,7 +4030,7 @@
       </p:pic>
       <p:pic>
         <p:nvPicPr>
-          <p:cNvPr id="4" name="Picture 3" descr="03_marker_dotplot.png"/>
+          <p:cNvPr id="4" name="Picture 3" descr="02_umap_by_sample.png"/>
           <p:cNvPicPr>
             <a:picLocks noChangeAspect="1"/>
           </p:cNvPicPr>
@@ -3850,8 +4044,8 @@
         </p:blipFill>
         <p:spPr>
           <a:xfrm>
-            <a:off x="6233007" y="1454047"/>
-            <a:ext cx="5592927" cy="4407104"/>
+            <a:off x="6362471" y="1371600"/>
+            <a:ext cx="5334000" cy="4572000"/>
           </a:xfrm>
           <a:prstGeom prst="rect">
             <a:avLst/>
@@ -3884,7 +4078,7 @@
               <a:defRPr sz="1200"/>
             </a:pPr>
             <a:r>
-              <a:t>celltypist lineages; agreement with Azimuth 92.7% and CoDi 93.1% (independent references).</a:t>
+              <a:t>Before (left) vs after Harmony (right), coloured by sample: samples mix after correction.</a:t>
             </a:r>
           </a:p>
         </p:txBody>
@@ -3917,20 +4111,25 @@
             <p:ph type="title"/>
           </p:nvPr>
         </p:nvSpPr>
-        <p:spPr/>
-        <p:txBody>
-          <a:bodyPr/>
-          <a:lstStyle/>
-          <a:p>
-            <a:r>
-              <a:t>Composition shifts vs control</a:t>
+        <p:spPr>
+          <a:xfrm>
+            <a:off x="365760" y="0"/>
+            <a:ext cx="11460175" cy="0"/>
+          </a:xfrm>
+        </p:spPr>
+        <p:txBody>
+          <a:bodyPr/>
+          <a:lstStyle/>
+          <a:p>
+            <a:r>
+              <a:t>Cell-type annotation</a:t>
             </a:r>
           </a:p>
         </p:txBody>
       </p:sp>
       <p:pic>
         <p:nvPicPr>
-          <p:cNvPr id="3" name="Picture 2" descr="04_composition_stacked.png"/>
+          <p:cNvPr id="3" name="Picture 2" descr="03_umap_lineage.png"/>
           <p:cNvPicPr>
             <a:picLocks noChangeAspect="1"/>
           </p:cNvPicPr>
@@ -3944,8 +4143,8 @@
         </p:blipFill>
         <p:spPr>
           <a:xfrm>
-            <a:off x="365760" y="1909810"/>
-            <a:ext cx="5592927" cy="3495579"/>
+            <a:off x="365760" y="1560252"/>
+            <a:ext cx="5592927" cy="4194695"/>
           </a:xfrm>
           <a:prstGeom prst="rect">
             <a:avLst/>
@@ -3954,7 +4153,7 @@
       </p:pic>
       <p:pic>
         <p:nvPicPr>
-          <p:cNvPr id="4" name="Picture 3" descr="04_composition_grouped.png"/>
+          <p:cNvPr id="4" name="Picture 3" descr="03_marker_dotplot.png"/>
           <p:cNvPicPr>
             <a:picLocks noChangeAspect="1"/>
           </p:cNvPicPr>
@@ -3968,8 +4167,8 @@
         </p:blipFill>
         <p:spPr>
           <a:xfrm>
-            <a:off x="6233007" y="2104009"/>
-            <a:ext cx="5592927" cy="3107181"/>
+            <a:off x="6233007" y="1454047"/>
+            <a:ext cx="5592927" cy="4407104"/>
           </a:xfrm>
           <a:prstGeom prst="rect">
             <a:avLst/>
@@ -4002,7 +4201,7 @@
               <a:defRPr sz="1200"/>
             </a:pPr>
             <a:r>
-              <a:t>Cell-type proportions per sample; PSNP_200nm shows the largest compositional shift.</a:t>
+              <a:t>celltypist lineages; agreement with Azimuth 92.7% and CoDi 93.1% (independent references).</a:t>
             </a:r>
           </a:p>
         </p:txBody>
@@ -4035,20 +4234,25 @@
             <p:ph type="title"/>
           </p:nvPr>
         </p:nvSpPr>
-        <p:spPr/>
-        <p:txBody>
-          <a:bodyPr/>
-          <a:lstStyle/>
-          <a:p>
-            <a:r>
-              <a:t>Differential expression: dose-response</a:t>
+        <p:spPr>
+          <a:xfrm>
+            <a:off x="365760" y="0"/>
+            <a:ext cx="11460175" cy="0"/>
+          </a:xfrm>
+        </p:spPr>
+        <p:txBody>
+          <a:bodyPr/>
+          <a:lstStyle/>
+          <a:p>
+            <a:r>
+              <a:t>Composition shifts vs control</a:t>
             </a:r>
           </a:p>
         </p:txBody>
       </p:sp>
       <p:pic>
         <p:nvPicPr>
-          <p:cNvPr id="3" name="Picture 2" descr="07_dose_response.png"/>
+          <p:cNvPr id="3" name="Picture 2" descr="04_composition_stacked.png"/>
           <p:cNvPicPr>
             <a:picLocks noChangeAspect="1"/>
           </p:cNvPicPr>
@@ -4072,7 +4276,7 @@
       </p:pic>
       <p:pic>
         <p:nvPicPr>
-          <p:cNvPr id="4" name="Picture 3" descr="06_size_categories.png"/>
+          <p:cNvPr id="4" name="Picture 3" descr="04_composition_grouped.png"/>
           <p:cNvPicPr>
             <a:picLocks noChangeAspect="1"/>
           </p:cNvPicPr>
@@ -4120,7 +4324,7 @@
               <a:defRPr sz="1200"/>
             </a:pPr>
             <a:r>
-              <a:t>Monocytes respond most; 200 nm drives more unique genes than 40 nm; mixture-emergent in monocytes.</a:t>
+              <a:t>Cell-type proportions per sample; PSNP_200nm shows the largest compositional shift.</a:t>
             </a:r>
           </a:p>
         </p:txBody>
@@ -4153,69 +4357,97 @@
             <p:ph type="title"/>
           </p:nvPr>
         </p:nvSpPr>
-        <p:spPr/>
-        <p:txBody>
-          <a:bodyPr/>
-          <a:lstStyle/>
-          <a:p>
-            <a:r>
-              <a:t>Key biological finding</a:t>
-            </a:r>
-          </a:p>
-        </p:txBody>
-      </p:sp>
-      <p:sp>
-        <p:nvSpPr>
-          <p:cNvPr id="3" name="Content Placeholder 2"/>
-          <p:cNvSpPr>
-            <a:spLocks noGrp="1"/>
-          </p:cNvSpPr>
-          <p:nvPr>
-            <p:ph idx="1"/>
-          </p:nvPr>
-        </p:nvSpPr>
-        <p:spPr/>
-        <p:txBody>
-          <a:bodyPr/>
+        <p:spPr>
+          <a:xfrm>
+            <a:off x="365760" y="0"/>
+            <a:ext cx="11460175" cy="0"/>
+          </a:xfrm>
+        </p:spPr>
+        <p:txBody>
+          <a:bodyPr/>
+          <a:lstStyle/>
+          <a:p>
+            <a:r>
+              <a:t>Differential expression: dose-response</a:t>
+            </a:r>
+          </a:p>
+        </p:txBody>
+      </p:sp>
+      <p:pic>
+        <p:nvPicPr>
+          <p:cNvPr id="3" name="Picture 2" descr="07_dose_response.png"/>
+          <p:cNvPicPr>
+            <a:picLocks noChangeAspect="1"/>
+          </p:cNvPicPr>
+          <p:nvPr/>
+        </p:nvPicPr>
+        <p:blipFill>
+          <a:blip r:embed="rId2"/>
+          <a:stretch>
+            <a:fillRect/>
+          </a:stretch>
+        </p:blipFill>
+        <p:spPr>
+          <a:xfrm>
+            <a:off x="365760" y="1909810"/>
+            <a:ext cx="5592927" cy="3495579"/>
+          </a:xfrm>
+          <a:prstGeom prst="rect">
+            <a:avLst/>
+          </a:prstGeom>
+        </p:spPr>
+      </p:pic>
+      <p:pic>
+        <p:nvPicPr>
+          <p:cNvPr id="4" name="Picture 3" descr="06_size_categories.png"/>
+          <p:cNvPicPr>
+            <a:picLocks noChangeAspect="1"/>
+          </p:cNvPicPr>
+          <p:nvPr/>
+        </p:nvPicPr>
+        <p:blipFill>
+          <a:blip r:embed="rId3"/>
+          <a:stretch>
+            <a:fillRect/>
+          </a:stretch>
+        </p:blipFill>
+        <p:spPr>
+          <a:xfrm>
+            <a:off x="6233007" y="2104009"/>
+            <a:ext cx="5592927" cy="3107181"/>
+          </a:xfrm>
+          <a:prstGeom prst="rect">
+            <a:avLst/>
+          </a:prstGeom>
+        </p:spPr>
+      </p:pic>
+      <p:sp>
+        <p:nvSpPr>
+          <p:cNvPr id="5" name="TextBox 4"/>
+          <p:cNvSpPr txBox="1"/>
+          <p:nvPr/>
+        </p:nvSpPr>
+        <p:spPr>
+          <a:xfrm>
+            <a:off x="365760" y="6309360"/>
+            <a:ext cx="11460175" cy="457200"/>
+          </a:xfrm>
+          <a:prstGeom prst="rect">
+            <a:avLst/>
+          </a:prstGeom>
+          <a:noFill/>
+        </p:spPr>
+        <p:txBody>
+          <a:bodyPr wrap="none">
+            <a:spAutoFit/>
+          </a:bodyPr>
           <a:lstStyle/>
           <a:p>
             <a:pPr>
-              <a:defRPr sz="1800"/>
+              <a:defRPr sz="1200"/>
             </a:pPr>
             <a:r>
-              <a:t>Monocytes show the strongest transcriptional response to nanoplastic.</a:t>
-            </a:r>
-          </a:p>
-          <a:p>
-            <a:pPr>
-              <a:defRPr sz="1800"/>
-            </a:pPr>
-            <a:r>
-              <a:t>200 nm particles drive MORE lineage-unique genes than 40 nm.</a:t>
-            </a:r>
-          </a:p>
-          <a:p>
-            <a:pPr>
-              <a:defRPr sz="1800"/>
-            </a:pPr>
-            <a:r>
-              <a:t>The 40+200 nm mixture produces an EMERGENT monocyte response -</a:t>
-            </a:r>
-          </a:p>
-          <a:p>
-            <a:pPr>
-              <a:defRPr sz="1800"/>
-            </a:pPr>
-            <a:r>
-              <a:t>  genes significant only in the mixture, in neither single size.</a:t>
-            </a:r>
-          </a:p>
-          <a:p>
-            <a:pPr>
-              <a:defRPr sz="1800"/>
-            </a:pPr>
-            <a:r>
-              <a:t>In lymphocytes the mixture is weaker than either size (sub-additive).</a:t>
+              <a:t>Monocytes respond most; 200 nm drives more unique genes than 40 nm; mixture-emergent in monocytes.</a:t>
             </a:r>
           </a:p>
         </p:txBody>

</xml_diff>

<commit_message>
fix: text overflowed vertically -- _stretch zeroed placeholder top/height
Setting only ph.left/ph.width materialized each placeholder's xfrm; the unset
top and height then defaulted to 0, collapsing every title/body box to the top
edge with no height so text spilled out of bounds.

_stretch now captures the inherited top/height before mutating and restores
them, changing only left/width. Verified: 0 placeholders with zero height or
off-slide bounds; titles at top~0.3in h~1.25, bodies at top~1.75in h~5.
</commit_message>
<xml_diff>
--- a/results/slides/GI_nanoplastic.pptx
+++ b/results/slides/GI_nanoplastic.pptx
@@ -3112,8 +3112,8 @@
         </p:nvSpPr>
         <p:spPr>
           <a:xfrm>
-            <a:off x="365760" y="0"/>
-            <a:ext cx="11460175" cy="0"/>
+            <a:off x="365760" y="2130425"/>
+            <a:ext cx="11460175" cy="1470025"/>
           </a:xfrm>
         </p:spPr>
         <p:txBody>
@@ -3138,8 +3138,8 @@
         </p:nvSpPr>
         <p:spPr>
           <a:xfrm>
-            <a:off x="365760" y="0"/>
-            <a:ext cx="11460175" cy="0"/>
+            <a:off x="365760" y="3886200"/>
+            <a:ext cx="11460175" cy="1752600"/>
           </a:xfrm>
         </p:spPr>
         <p:txBody>
@@ -3182,8 +3182,8 @@
         </p:nvSpPr>
         <p:spPr>
           <a:xfrm>
-            <a:off x="365760" y="0"/>
-            <a:ext cx="11460175" cy="0"/>
+            <a:off x="365760" y="274638"/>
+            <a:ext cx="11460175" cy="1143000"/>
           </a:xfrm>
         </p:spPr>
         <p:txBody>
@@ -3208,8 +3208,8 @@
         </p:nvSpPr>
         <p:spPr>
           <a:xfrm>
-            <a:off x="365760" y="0"/>
-            <a:ext cx="11460175" cy="0"/>
+            <a:off x="365760" y="1600200"/>
+            <a:ext cx="11460175" cy="4525963"/>
           </a:xfrm>
         </p:spPr>
         <p:txBody>
@@ -3287,8 +3287,8 @@
         </p:nvSpPr>
         <p:spPr>
           <a:xfrm>
-            <a:off x="365760" y="0"/>
-            <a:ext cx="11460175" cy="0"/>
+            <a:off x="365760" y="274638"/>
+            <a:ext cx="11460175" cy="1143000"/>
           </a:xfrm>
         </p:spPr>
         <p:txBody>
@@ -3386,8 +3386,8 @@
         </p:nvSpPr>
         <p:spPr>
           <a:xfrm>
-            <a:off x="365760" y="0"/>
-            <a:ext cx="11460175" cy="0"/>
+            <a:off x="365760" y="274638"/>
+            <a:ext cx="11460175" cy="1143000"/>
           </a:xfrm>
         </p:spPr>
         <p:txBody>
@@ -3485,8 +3485,8 @@
         </p:nvSpPr>
         <p:spPr>
           <a:xfrm>
-            <a:off x="365760" y="0"/>
-            <a:ext cx="11460175" cy="0"/>
+            <a:off x="365760" y="274638"/>
+            <a:ext cx="11460175" cy="1143000"/>
           </a:xfrm>
         </p:spPr>
         <p:txBody>
@@ -3511,8 +3511,8 @@
         </p:nvSpPr>
         <p:spPr>
           <a:xfrm>
-            <a:off x="365760" y="0"/>
-            <a:ext cx="11460175" cy="0"/>
+            <a:off x="365760" y="1600200"/>
+            <a:ext cx="11460175" cy="4525963"/>
           </a:xfrm>
         </p:spPr>
         <p:txBody>
@@ -3582,8 +3582,8 @@
         </p:nvSpPr>
         <p:spPr>
           <a:xfrm>
-            <a:off x="365760" y="0"/>
-            <a:ext cx="11460175" cy="0"/>
+            <a:off x="365760" y="274638"/>
+            <a:ext cx="11460175" cy="1143000"/>
           </a:xfrm>
         </p:spPr>
         <p:txBody>
@@ -3608,8 +3608,8 @@
         </p:nvSpPr>
         <p:spPr>
           <a:xfrm>
-            <a:off x="365760" y="0"/>
-            <a:ext cx="11460175" cy="0"/>
+            <a:off x="365760" y="1600200"/>
+            <a:ext cx="11460175" cy="4525963"/>
           </a:xfrm>
         </p:spPr>
         <p:txBody>
@@ -3679,8 +3679,8 @@
         </p:nvSpPr>
         <p:spPr>
           <a:xfrm>
-            <a:off x="365760" y="0"/>
-            <a:ext cx="11460175" cy="0"/>
+            <a:off x="365760" y="274638"/>
+            <a:ext cx="11460175" cy="1143000"/>
           </a:xfrm>
         </p:spPr>
         <p:txBody>
@@ -3705,8 +3705,8 @@
         </p:nvSpPr>
         <p:spPr>
           <a:xfrm>
-            <a:off x="365760" y="0"/>
-            <a:ext cx="11460175" cy="0"/>
+            <a:off x="365760" y="1600200"/>
+            <a:ext cx="11460175" cy="4525963"/>
           </a:xfrm>
         </p:spPr>
         <p:txBody>
@@ -3792,8 +3792,8 @@
         </p:nvSpPr>
         <p:spPr>
           <a:xfrm>
-            <a:off x="365760" y="0"/>
-            <a:ext cx="11460175" cy="0"/>
+            <a:off x="365760" y="274638"/>
+            <a:ext cx="11460175" cy="1143000"/>
           </a:xfrm>
         </p:spPr>
         <p:txBody>
@@ -3891,8 +3891,8 @@
         </p:nvSpPr>
         <p:spPr>
           <a:xfrm>
-            <a:off x="365760" y="0"/>
-            <a:ext cx="11460175" cy="0"/>
+            <a:off x="365760" y="274638"/>
+            <a:ext cx="11460175" cy="1143000"/>
           </a:xfrm>
         </p:spPr>
         <p:txBody>
@@ -3990,8 +3990,8 @@
         </p:nvSpPr>
         <p:spPr>
           <a:xfrm>
-            <a:off x="365760" y="0"/>
-            <a:ext cx="11460175" cy="0"/>
+            <a:off x="365760" y="274638"/>
+            <a:ext cx="11460175" cy="1143000"/>
           </a:xfrm>
         </p:spPr>
         <p:txBody>
@@ -4113,8 +4113,8 @@
         </p:nvSpPr>
         <p:spPr>
           <a:xfrm>
-            <a:off x="365760" y="0"/>
-            <a:ext cx="11460175" cy="0"/>
+            <a:off x="365760" y="274638"/>
+            <a:ext cx="11460175" cy="1143000"/>
           </a:xfrm>
         </p:spPr>
         <p:txBody>
@@ -4236,8 +4236,8 @@
         </p:nvSpPr>
         <p:spPr>
           <a:xfrm>
-            <a:off x="365760" y="0"/>
-            <a:ext cx="11460175" cy="0"/>
+            <a:off x="365760" y="274638"/>
+            <a:ext cx="11460175" cy="1143000"/>
           </a:xfrm>
         </p:spPr>
         <p:txBody>
@@ -4359,8 +4359,8 @@
         </p:nvSpPr>
         <p:spPr>
           <a:xfrm>
-            <a:off x="365760" y="0"/>
-            <a:ext cx="11460175" cy="0"/>
+            <a:off x="365760" y="274638"/>
+            <a:ext cx="11460175" cy="1143000"/>
           </a:xfrm>
         </p:spPr>
         <p:txBody>

</xml_diff>

<commit_message>
docs: add biological interpretation of the emergent monocyte response
The ~180 mixture-only monocyte genes are inflammation-dominated: pathway
enrichment (adj p ~ 1e-21) returns interleukin/cytokine/TNF signalling and
'response to lipopolysaccharide' -- a bacterial-infection-like program driven by
plastic. Top mixture-only up-genes: RIPK2, TRAF1, PIK3CB. Reading: two
sub-threshold exposures push monocytes over an inflammatory activation
threshold (emergent, non-additive; consistent with immune priming).

- README "Key result": add the interpretation + top genes + enrichment pointer.
- Deck: new "What the mixture does: emergent inflammation" slide (13 -> 14).
- VIDEO_SCRIPT: renumber to the current 14-slide deck (QC + Bonus are now two
  slides each) and add the interpretation section; refresh YouTube description.

Verified: 14 slides, 0 bad geometry, facts consistent across all three files.
</commit_message>
<xml_diff>
--- a/results/slides/GI_nanoplastic.pptx
+++ b/results/slides/GI_nanoplastic.pptx
@@ -18,6 +18,7 @@
     <p:sldId id="266" r:id="rId17"/>
     <p:sldId id="267" r:id="rId18"/>
     <p:sldId id="268" r:id="rId19"/>
+    <p:sldId id="269" r:id="rId20"/>
   </p:sldIdLst>
   <p:sldSz cx="12191695" cy="6858000" type="screen4x3"/>
   <p:notesSz cx="6858000" cy="9144000"/>
@@ -3296,62 +3297,84 @@
           <a:lstStyle/>
           <a:p>
             <a:r>
-              <a:t>Bonus analyses (1/2): stress/inflammation module scores</a:t>
-            </a:r>
-          </a:p>
-        </p:txBody>
-      </p:sp>
-      <p:pic>
-        <p:nvPicPr>
-          <p:cNvPr id="3" name="Picture 2" descr="07_module_scores.png"/>
-          <p:cNvPicPr>
-            <a:picLocks noChangeAspect="1"/>
-          </p:cNvPicPr>
-          <p:nvPr/>
-        </p:nvPicPr>
-        <p:blipFill>
-          <a:blip r:embed="rId2"/>
-          <a:stretch>
-            <a:fillRect/>
-          </a:stretch>
-        </p:blipFill>
-        <p:spPr>
-          <a:xfrm>
-            <a:off x="2095347" y="1371600"/>
-            <a:ext cx="8001000" cy="4572000"/>
-          </a:xfrm>
-          <a:prstGeom prst="rect">
-            <a:avLst/>
-          </a:prstGeom>
-        </p:spPr>
-      </p:pic>
-      <p:sp>
-        <p:nvSpPr>
-          <p:cNvPr id="4" name="TextBox 3"/>
-          <p:cNvSpPr txBox="1"/>
-          <p:nvPr/>
-        </p:nvSpPr>
-        <p:spPr>
-          <a:xfrm>
-            <a:off x="365760" y="6309360"/>
-            <a:ext cx="11460175" cy="457200"/>
-          </a:xfrm>
-          <a:prstGeom prst="rect">
-            <a:avLst/>
-          </a:prstGeom>
-          <a:noFill/>
-        </p:spPr>
-        <p:txBody>
-          <a:bodyPr wrap="none">
-            <a:spAutoFit/>
-          </a:bodyPr>
+              <a:t>What the mixture does: emergent inflammation</a:t>
+            </a:r>
+          </a:p>
+        </p:txBody>
+      </p:sp>
+      <p:sp>
+        <p:nvSpPr>
+          <p:cNvPr id="3" name="Content Placeholder 2"/>
+          <p:cNvSpPr>
+            <a:spLocks noGrp="1"/>
+          </p:cNvSpPr>
+          <p:nvPr>
+            <p:ph idx="1"/>
+          </p:nvPr>
+        </p:nvSpPr>
+        <p:spPr>
+          <a:xfrm>
+            <a:off x="365760" y="1600200"/>
+            <a:ext cx="11460175" cy="4525963"/>
+          </a:xfrm>
+        </p:spPr>
+        <p:txBody>
+          <a:bodyPr/>
           <a:lstStyle/>
           <a:p>
             <a:pPr>
-              <a:defRPr sz="1200"/>
+              <a:defRPr sz="1800"/>
             </a:pPr>
             <a:r>
-              <a:t>Per-sample mean module scores for stress and inflammation gene programs.</a:t>
+              <a:t>The 180 mixture-only monocyte genes are dominated by INFLAMMATION.</a:t>
+            </a:r>
+          </a:p>
+          <a:p>
+            <a:pPr>
+              <a:defRPr sz="1800"/>
+            </a:pPr>
+            <a:r>
+              <a:t>Pathway enrichment (p ~ 1e-21): interleukin, cytokine &amp; TNF signalling,</a:t>
+            </a:r>
+          </a:p>
+          <a:p>
+            <a:pPr>
+              <a:defRPr sz="1800"/>
+            </a:pPr>
+            <a:r>
+              <a:t>  and 'response to lipopolysaccharide' - i.e. a bacterial-attack-like program.</a:t>
+            </a:r>
+          </a:p>
+          <a:p>
+            <a:pPr>
+              <a:defRPr sz="1800"/>
+            </a:pPr>
+            <a:r>
+              <a:t>Top mixture-only genes up: RIPK2, TRAF1, PIK3CB (innate/TNF signalling).</a:t>
+            </a:r>
+          </a:p>
+          <a:p>
+            <a:pPr>
+              <a:defRPr sz="1800"/>
+            </a:pPr>
+            <a:r>
+              <a:t>Interpretation: two sub-threshold exposures together push monocytes over</a:t>
+            </a:r>
+          </a:p>
+          <a:p>
+            <a:pPr>
+              <a:defRPr sz="1800"/>
+            </a:pPr>
+            <a:r>
+              <a:t>  an inflammatory activation threshold - an emergent, non-additive effect.</a:t>
+            </a:r>
+          </a:p>
+          <a:p>
+            <a:pPr>
+              <a:defRPr sz="1800"/>
+            </a:pPr>
+            <a:r>
+              <a:t>Real exposure is always to mixtures -&gt; single-size studies may under-estimate risk.</a:t>
             </a:r>
           </a:p>
         </p:txBody>
@@ -3395,6 +3418,105 @@
           <a:lstStyle/>
           <a:p>
             <a:r>
+              <a:t>Bonus analyses (1/2): stress/inflammation module scores</a:t>
+            </a:r>
+          </a:p>
+        </p:txBody>
+      </p:sp>
+      <p:pic>
+        <p:nvPicPr>
+          <p:cNvPr id="3" name="Picture 2" descr="07_module_scores.png"/>
+          <p:cNvPicPr>
+            <a:picLocks noChangeAspect="1"/>
+          </p:cNvPicPr>
+          <p:nvPr/>
+        </p:nvPicPr>
+        <p:blipFill>
+          <a:blip r:embed="rId2"/>
+          <a:stretch>
+            <a:fillRect/>
+          </a:stretch>
+        </p:blipFill>
+        <p:spPr>
+          <a:xfrm>
+            <a:off x="2095347" y="1371600"/>
+            <a:ext cx="8001000" cy="4572000"/>
+          </a:xfrm>
+          <a:prstGeom prst="rect">
+            <a:avLst/>
+          </a:prstGeom>
+        </p:spPr>
+      </p:pic>
+      <p:sp>
+        <p:nvSpPr>
+          <p:cNvPr id="4" name="TextBox 3"/>
+          <p:cNvSpPr txBox="1"/>
+          <p:nvPr/>
+        </p:nvSpPr>
+        <p:spPr>
+          <a:xfrm>
+            <a:off x="365760" y="6309360"/>
+            <a:ext cx="11460175" cy="457200"/>
+          </a:xfrm>
+          <a:prstGeom prst="rect">
+            <a:avLst/>
+          </a:prstGeom>
+          <a:noFill/>
+        </p:spPr>
+        <p:txBody>
+          <a:bodyPr wrap="none">
+            <a:spAutoFit/>
+          </a:bodyPr>
+          <a:lstStyle/>
+          <a:p>
+            <a:pPr>
+              <a:defRPr sz="1200"/>
+            </a:pPr>
+            <a:r>
+              <a:t>Per-sample mean module scores for stress and inflammation gene programs.</a:t>
+            </a:r>
+          </a:p>
+        </p:txBody>
+      </p:sp>
+    </p:spTree>
+  </p:cSld>
+  <p:clrMapOvr>
+    <a:masterClrMapping/>
+  </p:clrMapOvr>
+</p:sld>
+</file>
+
+<file path=ppt/slides/slide13.xml><?xml version="1.0" encoding="utf-8"?>
+<p:sld xmlns:a="http://schemas.openxmlformats.org/drawingml/2006/main" xmlns:p="http://schemas.openxmlformats.org/presentationml/2006/main" xmlns:r="http://schemas.openxmlformats.org/officeDocument/2006/relationships">
+  <p:cSld>
+    <p:spTree>
+      <p:nvGrpSpPr>
+        <p:cNvPr id="1" name=""/>
+        <p:cNvGrpSpPr/>
+        <p:nvPr/>
+      </p:nvGrpSpPr>
+      <p:grpSpPr/>
+      <p:sp>
+        <p:nvSpPr>
+          <p:cNvPr id="2" name="Title 1"/>
+          <p:cNvSpPr>
+            <a:spLocks noGrp="1"/>
+          </p:cNvSpPr>
+          <p:nvPr>
+            <p:ph type="title"/>
+          </p:nvPr>
+        </p:nvSpPr>
+        <p:spPr>
+          <a:xfrm>
+            <a:off x="365760" y="274638"/>
+            <a:ext cx="11460175" cy="1143000"/>
+          </a:xfrm>
+        </p:spPr>
+        <p:txBody>
+          <a:bodyPr/>
+          <a:lstStyle/>
+          <a:p>
+            <a:r>
               <a:t>Bonus analyses (2/2): mixture additivity</a:t>
             </a:r>
           </a:p>
@@ -3463,7 +3585,7 @@
 </p:sld>
 </file>
 
-<file path=ppt/slides/slide13.xml><?xml version="1.0" encoding="utf-8"?>
+<file path=ppt/slides/slide14.xml><?xml version="1.0" encoding="utf-8"?>
 <p:sld xmlns:a="http://schemas.openxmlformats.org/drawingml/2006/main" xmlns:p="http://schemas.openxmlformats.org/presentationml/2006/main" xmlns:r="http://schemas.openxmlformats.org/officeDocument/2006/relationships">
   <p:cSld>
     <p:spTree>

</xml_diff>

<commit_message>
docs: clarify all 5 bonus analyses; add intro; de-AI the video script
Deck: add an "Additional analyses (5 implemented)" slide listing all five
(module scoring, mixture additivity, clustering robustness, ligand-receptor,
dose-response) before the two figure slides, so the deck no longer looks like
only two bonus analyses were done. 14 -> 15 slides.

Video script:
- add a spoken intro (name, master's student at School of Electrical
  Engineering, Genome Informatics 2026);
- section 10 now names and explains all five additional analyses, not just the
  two shown;
- rewritten in plain spoken English (removed em-dash overuse and
  "not X but Y" phrasing per Wikipedia:Signs_of_AI_writing);
- renumbered slide references to the 15-slide deck.
</commit_message>
<xml_diff>
--- a/results/slides/GI_nanoplastic.pptx
+++ b/results/slides/GI_nanoplastic.pptx
@@ -5,22 +5,23 @@
     <p:sldMasterId id="2147483648" r:id="rId1"/>
   </p:sldMasterIdLst>
   <p:sldIdLst>
-    <p:sldId id="256" r:id="rId7"/>
-    <p:sldId id="257" r:id="rId8"/>
-    <p:sldId id="258" r:id="rId9"/>
-    <p:sldId id="259" r:id="rId10"/>
-    <p:sldId id="260" r:id="rId11"/>
-    <p:sldId id="261" r:id="rId12"/>
-    <p:sldId id="262" r:id="rId13"/>
-    <p:sldId id="263" r:id="rId14"/>
-    <p:sldId id="264" r:id="rId15"/>
-    <p:sldId id="265" r:id="rId16"/>
-    <p:sldId id="266" r:id="rId17"/>
-    <p:sldId id="267" r:id="rId18"/>
-    <p:sldId id="268" r:id="rId19"/>
-    <p:sldId id="269" r:id="rId20"/>
+    <p:sldId id="256" r:id="rId2"/>
+    <p:sldId id="257" r:id="rId3"/>
+    <p:sldId id="258" r:id="rId4"/>
+    <p:sldId id="259" r:id="rId5"/>
+    <p:sldId id="260" r:id="rId6"/>
+    <p:sldId id="261" r:id="rId7"/>
+    <p:sldId id="262" r:id="rId8"/>
+    <p:sldId id="263" r:id="rId9"/>
+    <p:sldId id="264" r:id="rId10"/>
+    <p:sldId id="265" r:id="rId11"/>
+    <p:sldId id="266" r:id="rId12"/>
+    <p:sldId id="267" r:id="rId13"/>
+    <p:sldId id="268" r:id="rId14"/>
+    <p:sldId id="269" r:id="rId15"/>
+    <p:sldId id="270" r:id="rId16"/>
   </p:sldIdLst>
-  <p:sldSz cx="12191695" cy="6858000" type="screen4x3"/>
+  <p:sldSz cx="12192000" cy="6858000"/>
   <p:notesSz cx="6858000" cy="9144000"/>
   <p:defaultTextStyle>
     <a:defPPr>
@@ -117,6 +118,22 @@
       </a:defRPr>
     </a:lvl9pPr>
   </p:defaultTextStyle>
+  <p:extLst>
+    <p:ext uri="{EFAFB233-063F-42B5-8137-9DF3F51BA10A}">
+      <p15:sldGuideLst xmlns:p15="http://schemas.microsoft.com/office/powerpoint/2012/main">
+        <p15:guide id="1" orient="horz" pos="2160">
+          <p15:clr>
+            <a:srgbClr val="A4A3A4"/>
+          </p15:clr>
+        </p15:guide>
+        <p15:guide id="2" pos="2880">
+          <p15:clr>
+            <a:srgbClr val="A4A3A4"/>
+          </p15:clr>
+        </p15:guide>
+      </p15:sldGuideLst>
+    </p:ext>
+  </p:extLst>
 </p:presentation>
 </file>
 
@@ -158,10 +175,9 @@
           <a:lstStyle/>
           <a:p>
             <a:r>
-              <a:rPr lang="en-US" smtClean="0"/>
+              <a:rPr lang="en-US"/>
               <a:t>Click to edit Master title style</a:t>
             </a:r>
-            <a:endParaRPr lang="en-US"/>
           </a:p>
         </p:txBody>
       </p:sp>
@@ -277,10 +293,9 @@
           </a:lstStyle>
           <a:p>
             <a:r>
-              <a:rPr lang="en-US" smtClean="0"/>
+              <a:rPr lang="en-US"/>
               <a:t>Click to edit Master subtitle style</a:t>
             </a:r>
-            <a:endParaRPr lang="en-US"/>
           </a:p>
         </p:txBody>
       </p:sp>
@@ -301,7 +316,7 @@
           <a:p>
             <a:fld id="{5BCAD085-E8A6-8845-BD4E-CB4CCA059FC4}" type="datetimeFigureOut">
               <a:rPr lang="en-US" smtClean="0"/>
-              <a:t>1/27/13</a:t>
+              <a:t>7/27/2026</a:t>
             </a:fld>
             <a:endParaRPr lang="en-US"/>
           </a:p>
@@ -395,10 +410,9 @@
           <a:lstStyle/>
           <a:p>
             <a:r>
-              <a:rPr lang="en-US" smtClean="0"/>
+              <a:rPr lang="en-US"/>
               <a:t>Click to edit Master title style</a:t>
             </a:r>
-            <a:endParaRPr lang="en-US"/>
           </a:p>
         </p:txBody>
       </p:sp>
@@ -419,38 +433,37 @@
           <a:p>
             <a:pPr lvl="0"/>
             <a:r>
-              <a:rPr lang="en-US" smtClean="0"/>
+              <a:rPr lang="en-US"/>
               <a:t>Click to edit Master text styles</a:t>
             </a:r>
           </a:p>
           <a:p>
             <a:pPr lvl="1"/>
             <a:r>
-              <a:rPr lang="en-US" smtClean="0"/>
+              <a:rPr lang="en-US"/>
               <a:t>Second level</a:t>
             </a:r>
           </a:p>
           <a:p>
             <a:pPr lvl="2"/>
             <a:r>
-              <a:rPr lang="en-US" smtClean="0"/>
+              <a:rPr lang="en-US"/>
               <a:t>Third level</a:t>
             </a:r>
           </a:p>
           <a:p>
             <a:pPr lvl="3"/>
             <a:r>
-              <a:rPr lang="en-US" smtClean="0"/>
+              <a:rPr lang="en-US"/>
               <a:t>Fourth level</a:t>
             </a:r>
           </a:p>
           <a:p>
             <a:pPr lvl="4"/>
             <a:r>
-              <a:rPr lang="en-US" smtClean="0"/>
+              <a:rPr lang="en-US"/>
               <a:t>Fifth level</a:t>
             </a:r>
-            <a:endParaRPr lang="en-US"/>
           </a:p>
         </p:txBody>
       </p:sp>
@@ -471,7 +484,7 @@
           <a:p>
             <a:fld id="{5BCAD085-E8A6-8845-BD4E-CB4CCA059FC4}" type="datetimeFigureOut">
               <a:rPr lang="en-US" smtClean="0"/>
-              <a:t>1/27/13</a:t>
+              <a:t>7/27/2026</a:t>
             </a:fld>
             <a:endParaRPr lang="en-US"/>
           </a:p>
@@ -570,10 +583,9 @@
           <a:lstStyle/>
           <a:p>
             <a:r>
-              <a:rPr lang="en-US" smtClean="0"/>
+              <a:rPr lang="en-US"/>
               <a:t>Click to edit Master title style</a:t>
             </a:r>
-            <a:endParaRPr lang="en-US"/>
           </a:p>
         </p:txBody>
       </p:sp>
@@ -599,38 +611,37 @@
           <a:p>
             <a:pPr lvl="0"/>
             <a:r>
-              <a:rPr lang="en-US" smtClean="0"/>
+              <a:rPr lang="en-US"/>
               <a:t>Click to edit Master text styles</a:t>
             </a:r>
           </a:p>
           <a:p>
             <a:pPr lvl="1"/>
             <a:r>
-              <a:rPr lang="en-US" smtClean="0"/>
+              <a:rPr lang="en-US"/>
               <a:t>Second level</a:t>
             </a:r>
           </a:p>
           <a:p>
             <a:pPr lvl="2"/>
             <a:r>
-              <a:rPr lang="en-US" smtClean="0"/>
+              <a:rPr lang="en-US"/>
               <a:t>Third level</a:t>
             </a:r>
           </a:p>
           <a:p>
             <a:pPr lvl="3"/>
             <a:r>
-              <a:rPr lang="en-US" smtClean="0"/>
+              <a:rPr lang="en-US"/>
               <a:t>Fourth level</a:t>
             </a:r>
           </a:p>
           <a:p>
             <a:pPr lvl="4"/>
             <a:r>
-              <a:rPr lang="en-US" smtClean="0"/>
+              <a:rPr lang="en-US"/>
               <a:t>Fifth level</a:t>
             </a:r>
-            <a:endParaRPr lang="en-US"/>
           </a:p>
         </p:txBody>
       </p:sp>
@@ -651,7 +662,7 @@
           <a:p>
             <a:fld id="{5BCAD085-E8A6-8845-BD4E-CB4CCA059FC4}" type="datetimeFigureOut">
               <a:rPr lang="en-US" smtClean="0"/>
-              <a:t>1/27/13</a:t>
+              <a:t>7/27/2026</a:t>
             </a:fld>
             <a:endParaRPr lang="en-US"/>
           </a:p>
@@ -745,10 +756,9 @@
           <a:lstStyle/>
           <a:p>
             <a:r>
-              <a:rPr lang="en-US" smtClean="0"/>
+              <a:rPr lang="en-US"/>
               <a:t>Click to edit Master title style</a:t>
             </a:r>
-            <a:endParaRPr lang="en-US"/>
           </a:p>
         </p:txBody>
       </p:sp>
@@ -769,38 +779,37 @@
           <a:p>
             <a:pPr lvl="0"/>
             <a:r>
-              <a:rPr lang="en-US" smtClean="0"/>
+              <a:rPr lang="en-US"/>
               <a:t>Click to edit Master text styles</a:t>
             </a:r>
           </a:p>
           <a:p>
             <a:pPr lvl="1"/>
             <a:r>
-              <a:rPr lang="en-US" smtClean="0"/>
+              <a:rPr lang="en-US"/>
               <a:t>Second level</a:t>
             </a:r>
           </a:p>
           <a:p>
             <a:pPr lvl="2"/>
             <a:r>
-              <a:rPr lang="en-US" smtClean="0"/>
+              <a:rPr lang="en-US"/>
               <a:t>Third level</a:t>
             </a:r>
           </a:p>
           <a:p>
             <a:pPr lvl="3"/>
             <a:r>
-              <a:rPr lang="en-US" smtClean="0"/>
+              <a:rPr lang="en-US"/>
               <a:t>Fourth level</a:t>
             </a:r>
           </a:p>
           <a:p>
             <a:pPr lvl="4"/>
             <a:r>
-              <a:rPr lang="en-US" smtClean="0"/>
+              <a:rPr lang="en-US"/>
               <a:t>Fifth level</a:t>
             </a:r>
-            <a:endParaRPr lang="en-US"/>
           </a:p>
         </p:txBody>
       </p:sp>
@@ -821,7 +830,7 @@
           <a:p>
             <a:fld id="{5BCAD085-E8A6-8845-BD4E-CB4CCA059FC4}" type="datetimeFigureOut">
               <a:rPr lang="en-US" smtClean="0"/>
-              <a:t>1/27/13</a:t>
+              <a:t>7/27/2026</a:t>
             </a:fld>
             <a:endParaRPr lang="en-US"/>
           </a:p>
@@ -924,10 +933,9 @@
           </a:lstStyle>
           <a:p>
             <a:r>
-              <a:rPr lang="en-US" smtClean="0"/>
+              <a:rPr lang="en-US"/>
               <a:t>Click to edit Master title style</a:t>
             </a:r>
-            <a:endParaRPr lang="en-US"/>
           </a:p>
         </p:txBody>
       </p:sp>
@@ -1044,7 +1052,7 @@
           <a:p>
             <a:pPr lvl="0"/>
             <a:r>
-              <a:rPr lang="en-US" smtClean="0"/>
+              <a:rPr lang="en-US"/>
               <a:t>Click to edit Master text styles</a:t>
             </a:r>
           </a:p>
@@ -1067,7 +1075,7 @@
           <a:p>
             <a:fld id="{5BCAD085-E8A6-8845-BD4E-CB4CCA059FC4}" type="datetimeFigureOut">
               <a:rPr lang="en-US" smtClean="0"/>
-              <a:t>1/27/13</a:t>
+              <a:t>7/27/2026</a:t>
             </a:fld>
             <a:endParaRPr lang="en-US"/>
           </a:p>
@@ -1161,10 +1169,9 @@
           <a:lstStyle/>
           <a:p>
             <a:r>
-              <a:rPr lang="en-US" smtClean="0"/>
+              <a:rPr lang="en-US"/>
               <a:t>Click to edit Master title style</a:t>
             </a:r>
-            <a:endParaRPr lang="en-US"/>
           </a:p>
         </p:txBody>
       </p:sp>
@@ -1218,38 +1225,37 @@
           <a:p>
             <a:pPr lvl="0"/>
             <a:r>
-              <a:rPr lang="en-US" smtClean="0"/>
+              <a:rPr lang="en-US"/>
               <a:t>Click to edit Master text styles</a:t>
             </a:r>
           </a:p>
           <a:p>
             <a:pPr lvl="1"/>
             <a:r>
-              <a:rPr lang="en-US" smtClean="0"/>
+              <a:rPr lang="en-US"/>
               <a:t>Second level</a:t>
             </a:r>
           </a:p>
           <a:p>
             <a:pPr lvl="2"/>
             <a:r>
-              <a:rPr lang="en-US" smtClean="0"/>
+              <a:rPr lang="en-US"/>
               <a:t>Third level</a:t>
             </a:r>
           </a:p>
           <a:p>
             <a:pPr lvl="3"/>
             <a:r>
-              <a:rPr lang="en-US" smtClean="0"/>
+              <a:rPr lang="en-US"/>
               <a:t>Fourth level</a:t>
             </a:r>
           </a:p>
           <a:p>
             <a:pPr lvl="4"/>
             <a:r>
-              <a:rPr lang="en-US" smtClean="0"/>
+              <a:rPr lang="en-US"/>
               <a:t>Fifth level</a:t>
             </a:r>
-            <a:endParaRPr lang="en-US"/>
           </a:p>
         </p:txBody>
       </p:sp>
@@ -1303,38 +1309,37 @@
           <a:p>
             <a:pPr lvl="0"/>
             <a:r>
-              <a:rPr lang="en-US" smtClean="0"/>
+              <a:rPr lang="en-US"/>
               <a:t>Click to edit Master text styles</a:t>
             </a:r>
           </a:p>
           <a:p>
             <a:pPr lvl="1"/>
             <a:r>
-              <a:rPr lang="en-US" smtClean="0"/>
+              <a:rPr lang="en-US"/>
               <a:t>Second level</a:t>
             </a:r>
           </a:p>
           <a:p>
             <a:pPr lvl="2"/>
             <a:r>
-              <a:rPr lang="en-US" smtClean="0"/>
+              <a:rPr lang="en-US"/>
               <a:t>Third level</a:t>
             </a:r>
           </a:p>
           <a:p>
             <a:pPr lvl="3"/>
             <a:r>
-              <a:rPr lang="en-US" smtClean="0"/>
+              <a:rPr lang="en-US"/>
               <a:t>Fourth level</a:t>
             </a:r>
           </a:p>
           <a:p>
             <a:pPr lvl="4"/>
             <a:r>
-              <a:rPr lang="en-US" smtClean="0"/>
+              <a:rPr lang="en-US"/>
               <a:t>Fifth level</a:t>
             </a:r>
-            <a:endParaRPr lang="en-US"/>
           </a:p>
         </p:txBody>
       </p:sp>
@@ -1355,7 +1360,7 @@
           <a:p>
             <a:fld id="{5BCAD085-E8A6-8845-BD4E-CB4CCA059FC4}" type="datetimeFigureOut">
               <a:rPr lang="en-US" smtClean="0"/>
-              <a:t>1/27/13</a:t>
+              <a:t>7/27/2026</a:t>
             </a:fld>
             <a:endParaRPr lang="en-US"/>
           </a:p>
@@ -1453,10 +1458,9 @@
           </a:lstStyle>
           <a:p>
             <a:r>
-              <a:rPr lang="en-US" smtClean="0"/>
+              <a:rPr lang="en-US"/>
               <a:t>Click to edit Master title style</a:t>
             </a:r>
-            <a:endParaRPr lang="en-US"/>
           </a:p>
         </p:txBody>
       </p:sp>
@@ -1519,7 +1523,7 @@
           <a:p>
             <a:pPr lvl="0"/>
             <a:r>
-              <a:rPr lang="en-US" smtClean="0"/>
+              <a:rPr lang="en-US"/>
               <a:t>Click to edit Master text styles</a:t>
             </a:r>
           </a:p>
@@ -1575,38 +1579,37 @@
           <a:p>
             <a:pPr lvl="0"/>
             <a:r>
-              <a:rPr lang="en-US" smtClean="0"/>
+              <a:rPr lang="en-US"/>
               <a:t>Click to edit Master text styles</a:t>
             </a:r>
           </a:p>
           <a:p>
             <a:pPr lvl="1"/>
             <a:r>
-              <a:rPr lang="en-US" smtClean="0"/>
+              <a:rPr lang="en-US"/>
               <a:t>Second level</a:t>
             </a:r>
           </a:p>
           <a:p>
             <a:pPr lvl="2"/>
             <a:r>
-              <a:rPr lang="en-US" smtClean="0"/>
+              <a:rPr lang="en-US"/>
               <a:t>Third level</a:t>
             </a:r>
           </a:p>
           <a:p>
             <a:pPr lvl="3"/>
             <a:r>
-              <a:rPr lang="en-US" smtClean="0"/>
+              <a:rPr lang="en-US"/>
               <a:t>Fourth level</a:t>
             </a:r>
           </a:p>
           <a:p>
             <a:pPr lvl="4"/>
             <a:r>
-              <a:rPr lang="en-US" smtClean="0"/>
+              <a:rPr lang="en-US"/>
               <a:t>Fifth level</a:t>
             </a:r>
-            <a:endParaRPr lang="en-US"/>
           </a:p>
         </p:txBody>
       </p:sp>
@@ -1669,7 +1672,7 @@
           <a:p>
             <a:pPr lvl="0"/>
             <a:r>
-              <a:rPr lang="en-US" smtClean="0"/>
+              <a:rPr lang="en-US"/>
               <a:t>Click to edit Master text styles</a:t>
             </a:r>
           </a:p>
@@ -1725,38 +1728,37 @@
           <a:p>
             <a:pPr lvl="0"/>
             <a:r>
-              <a:rPr lang="en-US" smtClean="0"/>
+              <a:rPr lang="en-US"/>
               <a:t>Click to edit Master text styles</a:t>
             </a:r>
           </a:p>
           <a:p>
             <a:pPr lvl="1"/>
             <a:r>
-              <a:rPr lang="en-US" smtClean="0"/>
+              <a:rPr lang="en-US"/>
               <a:t>Second level</a:t>
             </a:r>
           </a:p>
           <a:p>
             <a:pPr lvl="2"/>
             <a:r>
-              <a:rPr lang="en-US" smtClean="0"/>
+              <a:rPr lang="en-US"/>
               <a:t>Third level</a:t>
             </a:r>
           </a:p>
           <a:p>
             <a:pPr lvl="3"/>
             <a:r>
-              <a:rPr lang="en-US" smtClean="0"/>
+              <a:rPr lang="en-US"/>
               <a:t>Fourth level</a:t>
             </a:r>
           </a:p>
           <a:p>
             <a:pPr lvl="4"/>
             <a:r>
-              <a:rPr lang="en-US" smtClean="0"/>
+              <a:rPr lang="en-US"/>
               <a:t>Fifth level</a:t>
             </a:r>
-            <a:endParaRPr lang="en-US"/>
           </a:p>
         </p:txBody>
       </p:sp>
@@ -1777,7 +1779,7 @@
           <a:p>
             <a:fld id="{5BCAD085-E8A6-8845-BD4E-CB4CCA059FC4}" type="datetimeFigureOut">
               <a:rPr lang="en-US" smtClean="0"/>
-              <a:t>1/27/13</a:t>
+              <a:t>7/27/2026</a:t>
             </a:fld>
             <a:endParaRPr lang="en-US"/>
           </a:p>
@@ -1871,10 +1873,9 @@
           <a:lstStyle/>
           <a:p>
             <a:r>
-              <a:rPr lang="en-US" smtClean="0"/>
+              <a:rPr lang="en-US"/>
               <a:t>Click to edit Master title style</a:t>
             </a:r>
-            <a:endParaRPr lang="en-US"/>
           </a:p>
         </p:txBody>
       </p:sp>
@@ -1895,7 +1896,7 @@
           <a:p>
             <a:fld id="{5BCAD085-E8A6-8845-BD4E-CB4CCA059FC4}" type="datetimeFigureOut">
               <a:rPr lang="en-US" smtClean="0"/>
-              <a:t>1/27/13</a:t>
+              <a:t>7/27/2026</a:t>
             </a:fld>
             <a:endParaRPr lang="en-US"/>
           </a:p>
@@ -1990,7 +1991,7 @@
           <a:p>
             <a:fld id="{5BCAD085-E8A6-8845-BD4E-CB4CCA059FC4}" type="datetimeFigureOut">
               <a:rPr lang="en-US" smtClean="0"/>
-              <a:t>1/27/13</a:t>
+              <a:t>7/27/2026</a:t>
             </a:fld>
             <a:endParaRPr lang="en-US"/>
           </a:p>
@@ -2093,10 +2094,9 @@
           </a:lstStyle>
           <a:p>
             <a:r>
-              <a:rPr lang="en-US" smtClean="0"/>
+              <a:rPr lang="en-US"/>
               <a:t>Click to edit Master title style</a:t>
             </a:r>
-            <a:endParaRPr lang="en-US"/>
           </a:p>
         </p:txBody>
       </p:sp>
@@ -2150,38 +2150,37 @@
           <a:p>
             <a:pPr lvl="0"/>
             <a:r>
-              <a:rPr lang="en-US" smtClean="0"/>
+              <a:rPr lang="en-US"/>
               <a:t>Click to edit Master text styles</a:t>
             </a:r>
           </a:p>
           <a:p>
             <a:pPr lvl="1"/>
             <a:r>
-              <a:rPr lang="en-US" smtClean="0"/>
+              <a:rPr lang="en-US"/>
               <a:t>Second level</a:t>
             </a:r>
           </a:p>
           <a:p>
             <a:pPr lvl="2"/>
             <a:r>
-              <a:rPr lang="en-US" smtClean="0"/>
+              <a:rPr lang="en-US"/>
               <a:t>Third level</a:t>
             </a:r>
           </a:p>
           <a:p>
             <a:pPr lvl="3"/>
             <a:r>
-              <a:rPr lang="en-US" smtClean="0"/>
+              <a:rPr lang="en-US"/>
               <a:t>Fourth level</a:t>
             </a:r>
           </a:p>
           <a:p>
             <a:pPr lvl="4"/>
             <a:r>
-              <a:rPr lang="en-US" smtClean="0"/>
+              <a:rPr lang="en-US"/>
               <a:t>Fifth level</a:t>
             </a:r>
-            <a:endParaRPr lang="en-US"/>
           </a:p>
         </p:txBody>
       </p:sp>
@@ -2244,7 +2243,7 @@
           <a:p>
             <a:pPr lvl="0"/>
             <a:r>
-              <a:rPr lang="en-US" smtClean="0"/>
+              <a:rPr lang="en-US"/>
               <a:t>Click to edit Master text styles</a:t>
             </a:r>
           </a:p>
@@ -2267,7 +2266,7 @@
           <a:p>
             <a:fld id="{5BCAD085-E8A6-8845-BD4E-CB4CCA059FC4}" type="datetimeFigureOut">
               <a:rPr lang="en-US" smtClean="0"/>
-              <a:t>1/27/13</a:t>
+              <a:t>7/27/2026</a:t>
             </a:fld>
             <a:endParaRPr lang="en-US"/>
           </a:p>
@@ -2370,10 +2369,9 @@
           </a:lstStyle>
           <a:p>
             <a:r>
-              <a:rPr lang="en-US" smtClean="0"/>
+              <a:rPr lang="en-US"/>
               <a:t>Click to edit Master title style</a:t>
             </a:r>
-            <a:endParaRPr lang="en-US"/>
           </a:p>
         </p:txBody>
       </p:sp>
@@ -2497,7 +2495,7 @@
           <a:p>
             <a:pPr lvl="0"/>
             <a:r>
-              <a:rPr lang="en-US" smtClean="0"/>
+              <a:rPr lang="en-US"/>
               <a:t>Click to edit Master text styles</a:t>
             </a:r>
           </a:p>
@@ -2520,7 +2518,7 @@
           <a:p>
             <a:fld id="{5BCAD085-E8A6-8845-BD4E-CB4CCA059FC4}" type="datetimeFigureOut">
               <a:rPr lang="en-US" smtClean="0"/>
-              <a:t>1/27/13</a:t>
+              <a:t>7/27/2026</a:t>
             </a:fld>
             <a:endParaRPr lang="en-US"/>
           </a:p>
@@ -2629,10 +2627,9 @@
           <a:lstStyle/>
           <a:p>
             <a:r>
-              <a:rPr lang="en-US" smtClean="0"/>
+              <a:rPr lang="en-US"/>
               <a:t>Click to edit Master title style</a:t>
             </a:r>
-            <a:endParaRPr lang="en-US"/>
           </a:p>
         </p:txBody>
       </p:sp>
@@ -2663,38 +2660,37 @@
           <a:p>
             <a:pPr lvl="0"/>
             <a:r>
-              <a:rPr lang="en-US" smtClean="0"/>
+              <a:rPr lang="en-US"/>
               <a:t>Click to edit Master text styles</a:t>
             </a:r>
           </a:p>
           <a:p>
             <a:pPr lvl="1"/>
             <a:r>
-              <a:rPr lang="en-US" smtClean="0"/>
+              <a:rPr lang="en-US"/>
               <a:t>Second level</a:t>
             </a:r>
           </a:p>
           <a:p>
             <a:pPr lvl="2"/>
             <a:r>
-              <a:rPr lang="en-US" smtClean="0"/>
+              <a:rPr lang="en-US"/>
               <a:t>Third level</a:t>
             </a:r>
           </a:p>
           <a:p>
             <a:pPr lvl="3"/>
             <a:r>
-              <a:rPr lang="en-US" smtClean="0"/>
+              <a:rPr lang="en-US"/>
               <a:t>Fourth level</a:t>
             </a:r>
           </a:p>
           <a:p>
             <a:pPr lvl="4"/>
             <a:r>
-              <a:rPr lang="en-US" smtClean="0"/>
+              <a:rPr lang="en-US"/>
               <a:t>Fifth level</a:t>
             </a:r>
-            <a:endParaRPr lang="en-US"/>
           </a:p>
         </p:txBody>
       </p:sp>
@@ -2733,7 +2729,7 @@
           <a:p>
             <a:fld id="{5BCAD085-E8A6-8845-BD4E-CB4CCA059FC4}" type="datetimeFigureOut">
               <a:rPr lang="en-US" smtClean="0"/>
-              <a:t>1/27/13</a:t>
+              <a:t>7/27/2026</a:t>
             </a:fld>
             <a:endParaRPr lang="en-US"/>
           </a:p>
@@ -3092,7 +3088,7 @@
 </file>
 
 <file path=ppt/slides/slide1.xml><?xml version="1.0" encoding="utf-8"?>
-<p:sld xmlns:a="http://schemas.openxmlformats.org/drawingml/2006/main" xmlns:p="http://schemas.openxmlformats.org/presentationml/2006/main" xmlns:r="http://schemas.openxmlformats.org/officeDocument/2006/relationships">
+<p:sld xmlns:a="http://schemas.openxmlformats.org/drawingml/2006/main" xmlns:r="http://schemas.openxmlformats.org/officeDocument/2006/relationships" xmlns:p="http://schemas.openxmlformats.org/presentationml/2006/main">
   <p:cSld>
     <p:spTree>
       <p:nvGrpSpPr>
@@ -3100,7 +3096,14 @@
         <p:cNvGrpSpPr/>
         <p:nvPr/>
       </p:nvGrpSpPr>
-      <p:grpSpPr/>
+      <p:grpSpPr>
+        <a:xfrm>
+          <a:off x="0" y="0"/>
+          <a:ext cx="0" cy="0"/>
+          <a:chOff x="0" y="0"/>
+          <a:chExt cx="0" cy="0"/>
+        </a:xfrm>
+      </p:grpSpPr>
       <p:sp>
         <p:nvSpPr>
           <p:cNvPr id="2" name="Title 1"/>
@@ -3148,8 +3151,40 @@
           <a:lstStyle/>
           <a:p>
             <a:r>
-              <a:t>scRNA-seq of human PBMCs exposed to 40 nm / 200 nm / mixed polystyrene nanoparticles vs control  -  Genomics Informatics, ETF</a:t>
-            </a:r>
+              <a:rPr dirty="0" err="1"/>
+              <a:t>scRNA</a:t>
+            </a:r>
+            <a:r>
+              <a:rPr dirty="0"/>
+              <a:t>-seq of human PBMCs exposed to </a:t>
+            </a:r>
+            <a:br>
+              <a:rPr lang="en-US" dirty="0"/>
+            </a:br>
+            <a:r>
+              <a:rPr dirty="0"/>
+              <a:t>40 nm / 200 nm / mixed polystyrene nanoparticles vs control </a:t>
+            </a:r>
+            <a:endParaRPr lang="en-US" dirty="0"/>
+          </a:p>
+          <a:p>
+            <a:r>
+              <a:rPr dirty="0"/>
+              <a:t>Genom</a:t>
+            </a:r>
+            <a:r>
+              <a:rPr lang="en-US" dirty="0"/>
+              <a:t>e</a:t>
+            </a:r>
+            <a:r>
+              <a:rPr dirty="0"/>
+              <a:t> Informatics, ETF</a:t>
+            </a:r>
+            <a:r>
+              <a:rPr lang="en-US" dirty="0"/>
+              <a:t> Belgrade, 2026</a:t>
+            </a:r>
+            <a:endParaRPr dirty="0"/>
           </a:p>
         </p:txBody>
       </p:sp>
@@ -3162,7 +3197,7 @@
 </file>
 
 <file path=ppt/slides/slide10.xml><?xml version="1.0" encoding="utf-8"?>
-<p:sld xmlns:a="http://schemas.openxmlformats.org/drawingml/2006/main" xmlns:p="http://schemas.openxmlformats.org/presentationml/2006/main" xmlns:r="http://schemas.openxmlformats.org/officeDocument/2006/relationships">
+<p:sld xmlns:a="http://schemas.openxmlformats.org/drawingml/2006/main" xmlns:r="http://schemas.openxmlformats.org/officeDocument/2006/relationships" xmlns:p="http://schemas.openxmlformats.org/presentationml/2006/main">
   <p:cSld>
     <p:spTree>
       <p:nvGrpSpPr>
@@ -3170,7 +3205,14 @@
         <p:cNvGrpSpPr/>
         <p:nvPr/>
       </p:nvGrpSpPr>
-      <p:grpSpPr/>
+      <p:grpSpPr>
+        <a:xfrm>
+          <a:off x="0" y="0"/>
+          <a:ext cx="0" cy="0"/>
+          <a:chOff x="0" y="0"/>
+          <a:chExt cx="0" cy="0"/>
+        </a:xfrm>
+      </p:grpSpPr>
       <p:sp>
         <p:nvSpPr>
           <p:cNvPr id="2" name="Title 1"/>
@@ -3214,14 +3256,25 @@
           </a:xfrm>
         </p:spPr>
         <p:txBody>
-          <a:bodyPr/>
+          <a:bodyPr>
+            <a:normAutofit/>
+          </a:bodyPr>
           <a:lstStyle/>
           <a:p>
             <a:pPr>
               <a:defRPr sz="1800"/>
             </a:pPr>
             <a:r>
-              <a:t>Monocytes show the strongest transcriptional response to nanoplastic.</a:t>
+              <a:rPr sz="2400" dirty="0"/>
+              <a:t>Monocytes show the strongest transcriptional response to </a:t>
+            </a:r>
+            <a:r>
+              <a:rPr sz="2400" dirty="0" err="1"/>
+              <a:t>nanoplastic</a:t>
+            </a:r>
+            <a:r>
+              <a:rPr sz="2400" dirty="0"/>
+              <a:t>.</a:t>
             </a:r>
           </a:p>
           <a:p>
@@ -3229,6 +3282,7 @@
               <a:defRPr sz="1800"/>
             </a:pPr>
             <a:r>
+              <a:rPr sz="2400" dirty="0"/>
               <a:t>200 nm particles drive MORE lineage-unique genes than 40 nm.</a:t>
             </a:r>
           </a:p>
@@ -3237,7 +3291,19 @@
               <a:defRPr sz="1800"/>
             </a:pPr>
             <a:r>
-              <a:t>The 40+200 nm mixture produces an EMERGENT monocyte response -</a:t>
+              <a:rPr sz="2400" dirty="0"/>
+              <a:t>The 40+200 nm mixture produces an EMERGENT monocyte response </a:t>
+            </a:r>
+            <a:r>
+              <a:rPr lang="en-US" sz="2400" dirty="0"/>
+              <a:t>– </a:t>
+            </a:r>
+            <a:br>
+              <a:rPr lang="en-US" sz="2400" dirty="0"/>
+            </a:br>
+            <a:r>
+              <a:rPr sz="2400" dirty="0"/>
+              <a:t>genes significant only in the mixture, in neither single size.</a:t>
             </a:r>
           </a:p>
           <a:p>
@@ -3245,14 +3311,7 @@
               <a:defRPr sz="1800"/>
             </a:pPr>
             <a:r>
-              <a:t>  genes significant only in the mixture, in neither single size.</a:t>
-            </a:r>
-          </a:p>
-          <a:p>
-            <a:pPr>
-              <a:defRPr sz="1800"/>
-            </a:pPr>
-            <a:r>
+              <a:rPr sz="2400" dirty="0"/>
               <a:t>In lymphocytes the mixture is weaker than either size (sub-additive).</a:t>
             </a:r>
           </a:p>
@@ -3267,7 +3326,7 @@
 </file>
 
 <file path=ppt/slides/slide11.xml><?xml version="1.0" encoding="utf-8"?>
-<p:sld xmlns:a="http://schemas.openxmlformats.org/drawingml/2006/main" xmlns:p="http://schemas.openxmlformats.org/presentationml/2006/main" xmlns:r="http://schemas.openxmlformats.org/officeDocument/2006/relationships">
+<p:sld xmlns:a="http://schemas.openxmlformats.org/drawingml/2006/main" xmlns:r="http://schemas.openxmlformats.org/officeDocument/2006/relationships" xmlns:p="http://schemas.openxmlformats.org/presentationml/2006/main">
   <p:cSld>
     <p:spTree>
       <p:nvGrpSpPr>
@@ -3275,7 +3334,14 @@
         <p:cNvGrpSpPr/>
         <p:nvPr/>
       </p:nvGrpSpPr>
-      <p:grpSpPr/>
+      <p:grpSpPr>
+        <a:xfrm>
+          <a:off x="0" y="0"/>
+          <a:ext cx="0" cy="0"/>
+          <a:chOff x="0" y="0"/>
+          <a:chExt cx="0" cy="0"/>
+        </a:xfrm>
+      </p:grpSpPr>
       <p:sp>
         <p:nvSpPr>
           <p:cNvPr id="2" name="Title 1"/>
@@ -3319,13 +3385,16 @@
           </a:xfrm>
         </p:spPr>
         <p:txBody>
-          <a:bodyPr/>
+          <a:bodyPr>
+            <a:normAutofit/>
+          </a:bodyPr>
           <a:lstStyle/>
           <a:p>
             <a:pPr>
               <a:defRPr sz="1800"/>
             </a:pPr>
             <a:r>
+              <a:rPr sz="2400" dirty="0"/>
               <a:t>The 180 mixture-only monocyte genes are dominated by INFLAMMATION.</a:t>
             </a:r>
           </a:p>
@@ -3334,7 +3403,27 @@
               <a:defRPr sz="1800"/>
             </a:pPr>
             <a:r>
-              <a:t>Pathway enrichment (p ~ 1e-21): interleukin, cytokine &amp; TNF signalling,</a:t>
+              <a:rPr sz="2400" dirty="0"/>
+              <a:t>Pathway enrichment (p ~ 1e-21): interleukin, cytokine &amp; TNF </a:t>
+            </a:r>
+            <a:r>
+              <a:rPr sz="2400" dirty="0" err="1"/>
+              <a:t>signalling</a:t>
+            </a:r>
+            <a:r>
+              <a:rPr sz="2400" dirty="0"/>
+              <a:t>,</a:t>
+            </a:r>
+            <a:r>
+              <a:rPr lang="en-US" sz="2400" dirty="0"/>
+              <a:t> </a:t>
+            </a:r>
+            <a:br>
+              <a:rPr lang="en-US" sz="2400" dirty="0"/>
+            </a:br>
+            <a:r>
+              <a:rPr sz="2400" dirty="0"/>
+              <a:t>and 'response to lipopolysaccharide' - i.e. a bacterial-attack-like program.</a:t>
             </a:r>
           </a:p>
           <a:p>
@@ -3342,7 +3431,16 @@
               <a:defRPr sz="1800"/>
             </a:pPr>
             <a:r>
-              <a:t>  and 'response to lipopolysaccharide' - i.e. a bacterial-attack-like program.</a:t>
+              <a:rPr sz="2400" dirty="0"/>
+              <a:t>Top mixture-only genes up: RIPK2, TRAF1, PIK3CB (innate/TNF </a:t>
+            </a:r>
+            <a:r>
+              <a:rPr sz="2400" dirty="0" err="1"/>
+              <a:t>signalling</a:t>
+            </a:r>
+            <a:r>
+              <a:rPr sz="2400" dirty="0"/>
+              <a:t>).</a:t>
             </a:r>
           </a:p>
           <a:p>
@@ -3350,7 +3448,19 @@
               <a:defRPr sz="1800"/>
             </a:pPr>
             <a:r>
-              <a:t>Top mixture-only genes up: RIPK2, TRAF1, PIK3CB (innate/TNF signalling).</a:t>
+              <a:rPr sz="2400" dirty="0"/>
+              <a:t>Interpretation: two sub-threshold exposures together push monocytes over</a:t>
+            </a:r>
+            <a:r>
+              <a:rPr lang="en-US" sz="2400" dirty="0"/>
+              <a:t> </a:t>
+            </a:r>
+            <a:br>
+              <a:rPr lang="en-US" sz="2400" dirty="0"/>
+            </a:br>
+            <a:r>
+              <a:rPr sz="2400" dirty="0"/>
+              <a:t>an inflammatory activation threshold - an emergent, non-additive effect.</a:t>
             </a:r>
           </a:p>
           <a:p>
@@ -3358,22 +3468,7 @@
               <a:defRPr sz="1800"/>
             </a:pPr>
             <a:r>
-              <a:t>Interpretation: two sub-threshold exposures together push monocytes over</a:t>
-            </a:r>
-          </a:p>
-          <a:p>
-            <a:pPr>
-              <a:defRPr sz="1800"/>
-            </a:pPr>
-            <a:r>
-              <a:t>  an inflammatory activation threshold - an emergent, non-additive effect.</a:t>
-            </a:r>
-          </a:p>
-          <a:p>
-            <a:pPr>
-              <a:defRPr sz="1800"/>
-            </a:pPr>
-            <a:r>
+              <a:rPr sz="2400" dirty="0"/>
               <a:t>Real exposure is always to mixtures -&gt; single-size studies may under-estimate risk.</a:t>
             </a:r>
           </a:p>
@@ -3388,7 +3483,7 @@
 </file>
 
 <file path=ppt/slides/slide12.xml><?xml version="1.0" encoding="utf-8"?>
-<p:sld xmlns:a="http://schemas.openxmlformats.org/drawingml/2006/main" xmlns:p="http://schemas.openxmlformats.org/presentationml/2006/main" xmlns:r="http://schemas.openxmlformats.org/officeDocument/2006/relationships">
+<p:sld xmlns:a="http://schemas.openxmlformats.org/drawingml/2006/main" xmlns:r="http://schemas.openxmlformats.org/officeDocument/2006/relationships" xmlns:p="http://schemas.openxmlformats.org/presentationml/2006/main">
   <p:cSld>
     <p:spTree>
       <p:nvGrpSpPr>
@@ -3396,7 +3491,14 @@
         <p:cNvGrpSpPr/>
         <p:nvPr/>
       </p:nvGrpSpPr>
-      <p:grpSpPr/>
+      <p:grpSpPr>
+        <a:xfrm>
+          <a:off x="0" y="0"/>
+          <a:ext cx="0" cy="0"/>
+          <a:chOff x="0" y="0"/>
+          <a:chExt cx="0" cy="0"/>
+        </a:xfrm>
+      </p:grpSpPr>
       <p:sp>
         <p:nvSpPr>
           <p:cNvPr id="2" name="Title 1"/>
@@ -3418,7 +3520,145 @@
           <a:lstStyle/>
           <a:p>
             <a:r>
-              <a:t>Bonus analyses (1/2): stress/inflammation module scores</a:t>
+              <a:rPr dirty="0"/>
+              <a:t>Additional analyses (5 implemented)</a:t>
+            </a:r>
+          </a:p>
+        </p:txBody>
+      </p:sp>
+      <p:sp>
+        <p:nvSpPr>
+          <p:cNvPr id="3" name="Content Placeholder 2"/>
+          <p:cNvSpPr>
+            <a:spLocks noGrp="1"/>
+          </p:cNvSpPr>
+          <p:nvPr>
+            <p:ph idx="1"/>
+          </p:nvPr>
+        </p:nvSpPr>
+        <p:spPr>
+          <a:xfrm>
+            <a:off x="365760" y="1600200"/>
+            <a:ext cx="11460175" cy="4525963"/>
+          </a:xfrm>
+        </p:spPr>
+        <p:txBody>
+          <a:bodyPr>
+            <a:normAutofit/>
+          </a:bodyPr>
+          <a:lstStyle/>
+          <a:p>
+            <a:pPr>
+              <a:defRPr sz="1800"/>
+            </a:pPr>
+            <a:r>
+              <a:rPr sz="2400" dirty="0"/>
+              <a:t>1. Module scoring - stress &amp; inflammation gene programs per sample (shown next).</a:t>
+            </a:r>
+          </a:p>
+          <a:p>
+            <a:pPr>
+              <a:defRPr sz="1800"/>
+            </a:pPr>
+            <a:r>
+              <a:rPr sz="2400" dirty="0"/>
+              <a:t>2. Mixture additivity - is the mixture = 40nm + 200nm? (shown next).</a:t>
+            </a:r>
+          </a:p>
+          <a:p>
+            <a:pPr>
+              <a:defRPr sz="1800"/>
+            </a:pPr>
+            <a:r>
+              <a:rPr sz="2400" dirty="0"/>
+              <a:t>3. Clustering robustness - clusters stable across Leiden resolutions (ARI).</a:t>
+            </a:r>
+          </a:p>
+          <a:p>
+            <a:pPr>
+              <a:defRPr sz="1800"/>
+            </a:pPr>
+            <a:r>
+              <a:rPr sz="2400" dirty="0"/>
+              <a:t>4. Ligand-receptor - shift in cell-to-cell communication on exposure.</a:t>
+            </a:r>
+          </a:p>
+          <a:p>
+            <a:pPr>
+              <a:defRPr sz="1800"/>
+            </a:pPr>
+            <a:r>
+              <a:rPr sz="2400" dirty="0"/>
+              <a:t>5. Dose-response - disruption magnitude vs particle size.</a:t>
+            </a:r>
+          </a:p>
+          <a:p>
+            <a:pPr>
+              <a:defRPr sz="1800"/>
+            </a:pPr>
+            <a:r>
+              <a:rPr sz="2400" dirty="0"/>
+              <a:t>All five reinforce the same story: size-dependent, non-additive, monocyte-</a:t>
+            </a:r>
+            <a:r>
+              <a:rPr sz="2400" dirty="0" err="1"/>
+              <a:t>centred</a:t>
+            </a:r>
+            <a:r>
+              <a:rPr sz="2400" dirty="0"/>
+              <a:t>.</a:t>
+            </a:r>
+          </a:p>
+        </p:txBody>
+      </p:sp>
+    </p:spTree>
+  </p:cSld>
+  <p:clrMapOvr>
+    <a:masterClrMapping/>
+  </p:clrMapOvr>
+</p:sld>
+</file>
+
+<file path=ppt/slides/slide13.xml><?xml version="1.0" encoding="utf-8"?>
+<p:sld xmlns:a="http://schemas.openxmlformats.org/drawingml/2006/main" xmlns:r="http://schemas.openxmlformats.org/officeDocument/2006/relationships" xmlns:p="http://schemas.openxmlformats.org/presentationml/2006/main">
+  <p:cSld>
+    <p:spTree>
+      <p:nvGrpSpPr>
+        <p:cNvPr id="1" name=""/>
+        <p:cNvGrpSpPr/>
+        <p:nvPr/>
+      </p:nvGrpSpPr>
+      <p:grpSpPr>
+        <a:xfrm>
+          <a:off x="0" y="0"/>
+          <a:ext cx="0" cy="0"/>
+          <a:chOff x="0" y="0"/>
+          <a:chExt cx="0" cy="0"/>
+        </a:xfrm>
+      </p:grpSpPr>
+      <p:sp>
+        <p:nvSpPr>
+          <p:cNvPr id="2" name="Title 1"/>
+          <p:cNvSpPr>
+            <a:spLocks noGrp="1"/>
+          </p:cNvSpPr>
+          <p:nvPr>
+            <p:ph type="title"/>
+          </p:nvPr>
+        </p:nvSpPr>
+        <p:spPr>
+          <a:xfrm>
+            <a:off x="365760" y="274638"/>
+            <a:ext cx="11460175" cy="1143000"/>
+          </a:xfrm>
+        </p:spPr>
+        <p:txBody>
+          <a:bodyPr/>
+          <a:lstStyle/>
+          <a:p>
+            <a:r>
+              <a:rPr dirty="0"/>
+              <a:t>Additional analyses: stress/inflammation module scores</a:t>
             </a:r>
           </a:p>
         </p:txBody>
@@ -3439,7 +3679,7 @@
         </p:blipFill>
         <p:spPr>
           <a:xfrm>
-            <a:off x="2095347" y="1371600"/>
+            <a:off x="2095347" y="1417638"/>
             <a:ext cx="8001000" cy="4572000"/>
           </a:xfrm>
           <a:prstGeom prst="rect">
@@ -3473,7 +3713,7 @@
               <a:defRPr sz="1200"/>
             </a:pPr>
             <a:r>
-              <a:t>Per-sample mean module scores for stress and inflammation gene programs.</a:t>
+              <a:t>Analysis 1 of 5. Per-sample mean module scores for stress and inflammation gene programs.</a:t>
             </a:r>
           </a:p>
         </p:txBody>
@@ -3486,8 +3726,8 @@
 </p:sld>
 </file>
 
-<file path=ppt/slides/slide13.xml><?xml version="1.0" encoding="utf-8"?>
-<p:sld xmlns:a="http://schemas.openxmlformats.org/drawingml/2006/main" xmlns:p="http://schemas.openxmlformats.org/presentationml/2006/main" xmlns:r="http://schemas.openxmlformats.org/officeDocument/2006/relationships">
+<file path=ppt/slides/slide14.xml><?xml version="1.0" encoding="utf-8"?>
+<p:sld xmlns:a="http://schemas.openxmlformats.org/drawingml/2006/main" xmlns:r="http://schemas.openxmlformats.org/officeDocument/2006/relationships" xmlns:p="http://schemas.openxmlformats.org/presentationml/2006/main">
   <p:cSld>
     <p:spTree>
       <p:nvGrpSpPr>
@@ -3495,7 +3735,14 @@
         <p:cNvGrpSpPr/>
         <p:nvPr/>
       </p:nvGrpSpPr>
-      <p:grpSpPr/>
+      <p:grpSpPr>
+        <a:xfrm>
+          <a:off x="0" y="0"/>
+          <a:ext cx="0" cy="0"/>
+          <a:chOff x="0" y="0"/>
+          <a:chExt cx="0" cy="0"/>
+        </a:xfrm>
+      </p:grpSpPr>
       <p:sp>
         <p:nvSpPr>
           <p:cNvPr id="2" name="Title 1"/>
@@ -3517,7 +3764,7 @@
           <a:lstStyle/>
           <a:p>
             <a:r>
-              <a:t>Bonus analyses (2/2): mixture additivity</a:t>
+              <a:t>Additional analyses: mixture additivity</a:t>
             </a:r>
           </a:p>
         </p:txBody>
@@ -3572,7 +3819,7 @@
               <a:defRPr sz="1200"/>
             </a:pPr>
             <a:r>
-              <a:t>Observed mixture response vs the 40+200 nm additive expectation, per lineage.</a:t>
+              <a:t>Analysis 2 of 5. Observed mixture response vs the 40+200 nm additive expectation, per lineage.</a:t>
             </a:r>
           </a:p>
         </p:txBody>
@@ -3585,8 +3832,8 @@
 </p:sld>
 </file>
 
-<file path=ppt/slides/slide14.xml><?xml version="1.0" encoding="utf-8"?>
-<p:sld xmlns:a="http://schemas.openxmlformats.org/drawingml/2006/main" xmlns:p="http://schemas.openxmlformats.org/presentationml/2006/main" xmlns:r="http://schemas.openxmlformats.org/officeDocument/2006/relationships">
+<file path=ppt/slides/slide15.xml><?xml version="1.0" encoding="utf-8"?>
+<p:sld xmlns:a="http://schemas.openxmlformats.org/drawingml/2006/main" xmlns:r="http://schemas.openxmlformats.org/officeDocument/2006/relationships" xmlns:p="http://schemas.openxmlformats.org/presentationml/2006/main">
   <p:cSld>
     <p:spTree>
       <p:nvGrpSpPr>
@@ -3594,7 +3841,14 @@
         <p:cNvGrpSpPr/>
         <p:nvPr/>
       </p:nvGrpSpPr>
-      <p:grpSpPr/>
+      <p:grpSpPr>
+        <a:xfrm>
+          <a:off x="0" y="0"/>
+          <a:ext cx="0" cy="0"/>
+          <a:chOff x="0" y="0"/>
+          <a:chExt cx="0" cy="0"/>
+        </a:xfrm>
+      </p:grpSpPr>
       <p:sp>
         <p:nvSpPr>
           <p:cNvPr id="2" name="Title 1"/>
@@ -3616,6 +3870,7 @@
           <a:lstStyle/>
           <a:p>
             <a:r>
+              <a:rPr dirty="0"/>
               <a:t>Limitations &amp; reproducibility</a:t>
             </a:r>
           </a:p>
@@ -3638,13 +3893,16 @@
           </a:xfrm>
         </p:spPr>
         <p:txBody>
-          <a:bodyPr/>
+          <a:bodyPr>
+            <a:normAutofit/>
+          </a:bodyPr>
           <a:lstStyle/>
           <a:p>
             <a:pPr>
               <a:defRPr sz="1800"/>
             </a:pPr>
             <a:r>
+              <a:rPr sz="2400" dirty="0"/>
               <a:t>One donor, one sample per condition -&gt; NO biological replicates.</a:t>
             </a:r>
           </a:p>
@@ -3653,7 +3911,24 @@
               <a:defRPr sz="1800"/>
             </a:pPr>
             <a:r>
-              <a:t>DE is cell-level Wilcoxon (not pseudobulk); p-values exploratory, pseudoreplication caveat.</a:t>
+              <a:rPr sz="2400" dirty="0"/>
+              <a:t>DE is cell-level Wilcoxon (not </a:t>
+            </a:r>
+            <a:r>
+              <a:rPr sz="2400" dirty="0" err="1"/>
+              <a:t>pseudobulk</a:t>
+            </a:r>
+            <a:r>
+              <a:rPr sz="2400" dirty="0"/>
+              <a:t>); p-values exploratory, </a:t>
+            </a:r>
+            <a:r>
+              <a:rPr sz="2400" dirty="0" err="1"/>
+              <a:t>pseudoreplication</a:t>
+            </a:r>
+            <a:r>
+              <a:rPr sz="2400" dirty="0"/>
+              <a:t> caveat.</a:t>
             </a:r>
           </a:p>
           <a:p>
@@ -3661,6 +3936,7 @@
               <a:defRPr sz="1800"/>
             </a:pPr>
             <a:r>
+              <a:rPr sz="2400" dirty="0"/>
               <a:t>No external gene-level ground truth; DE validated internally + biologically.</a:t>
             </a:r>
           </a:p>
@@ -3669,6 +3945,7 @@
               <a:defRPr sz="1800"/>
             </a:pPr>
             <a:r>
+              <a:rPr sz="2400" dirty="0"/>
               <a:t>Everything reproduces: `python run_pipeline.py --all`; 37 offline intent tests.</a:t>
             </a:r>
           </a:p>
@@ -3683,7 +3960,7 @@
 </file>
 
 <file path=ppt/slides/slide2.xml><?xml version="1.0" encoding="utf-8"?>
-<p:sld xmlns:a="http://schemas.openxmlformats.org/drawingml/2006/main" xmlns:p="http://schemas.openxmlformats.org/presentationml/2006/main" xmlns:r="http://schemas.openxmlformats.org/officeDocument/2006/relationships">
+<p:sld xmlns:a="http://schemas.openxmlformats.org/drawingml/2006/main" xmlns:r="http://schemas.openxmlformats.org/officeDocument/2006/relationships" xmlns:p="http://schemas.openxmlformats.org/presentationml/2006/main">
   <p:cSld>
     <p:spTree>
       <p:nvGrpSpPr>
@@ -3691,7 +3968,14 @@
         <p:cNvGrpSpPr/>
         <p:nvPr/>
       </p:nvGrpSpPr>
-      <p:grpSpPr/>
+      <p:grpSpPr>
+        <a:xfrm>
+          <a:off x="0" y="0"/>
+          <a:ext cx="0" cy="0"/>
+          <a:chOff x="0" y="0"/>
+          <a:chExt cx="0" cy="0"/>
+        </a:xfrm>
+      </p:grpSpPr>
       <p:sp>
         <p:nvSpPr>
           <p:cNvPr id="2" name="Title 1"/>
@@ -3735,14 +4019,25 @@
           </a:xfrm>
         </p:spPr>
         <p:txBody>
-          <a:bodyPr/>
+          <a:bodyPr>
+            <a:normAutofit/>
+          </a:bodyPr>
           <a:lstStyle/>
           <a:p>
             <a:pPr>
               <a:defRPr sz="1800"/>
             </a:pPr>
             <a:r>
-              <a:t>Do small vs large nanoplastics provoke different immune responses?</a:t>
+              <a:rPr sz="2400" dirty="0"/>
+              <a:t>Do small vs large </a:t>
+            </a:r>
+            <a:r>
+              <a:rPr sz="2400" dirty="0" err="1"/>
+              <a:t>nanoplastics</a:t>
+            </a:r>
+            <a:r>
+              <a:rPr sz="2400" dirty="0"/>
+              <a:t> provoke different immune responses?</a:t>
             </a:r>
           </a:p>
           <a:p>
@@ -3750,6 +4045,7 @@
               <a:defRPr sz="1800"/>
             </a:pPr>
             <a:r>
+              <a:rPr sz="2400" dirty="0"/>
               <a:t>Does the 40+200 nm mixture do something neither size does alone?</a:t>
             </a:r>
           </a:p>
@@ -3758,7 +4054,16 @@
               <a:defRPr sz="1800"/>
             </a:pPr>
             <a:r>
-              <a:t>4 samples, one donor: PSNP_40nm, PSNP_200nm, PSNP_mixture, control</a:t>
+              <a:rPr sz="2400" dirty="0"/>
+              <a:t>4 samples, one donor: PSNP_40nm, PSNP_200nm, </a:t>
+            </a:r>
+            <a:r>
+              <a:rPr sz="2400" dirty="0" err="1"/>
+              <a:t>PSNP_mixture</a:t>
+            </a:r>
+            <a:r>
+              <a:rPr sz="2400" dirty="0"/>
+              <a:t>, control</a:t>
             </a:r>
           </a:p>
           <a:p>
@@ -3766,7 +4071,24 @@
               <a:defRPr sz="1800"/>
             </a:pPr>
             <a:r>
-              <a:t>~34,000 PBMCs, AnnData/.h5ad (Zenodo 10.5281/zenodo.15866724)</a:t>
+              <a:rPr sz="2400" dirty="0"/>
+              <a:t>~34,000 PBMCs, </a:t>
+            </a:r>
+            <a:r>
+              <a:rPr sz="2400" dirty="0" err="1"/>
+              <a:t>AnnData</a:t>
+            </a:r>
+            <a:r>
+              <a:rPr sz="2400" dirty="0"/>
+              <a:t>/.h5ad (</a:t>
+            </a:r>
+            <a:r>
+              <a:rPr sz="2400" dirty="0" err="1"/>
+              <a:t>Zenodo</a:t>
+            </a:r>
+            <a:r>
+              <a:rPr sz="2400" dirty="0"/>
+              <a:t> 10.5281/zenodo.15866724)</a:t>
             </a:r>
           </a:p>
         </p:txBody>
@@ -3780,7 +4102,7 @@
 </file>
 
 <file path=ppt/slides/slide3.xml><?xml version="1.0" encoding="utf-8"?>
-<p:sld xmlns:a="http://schemas.openxmlformats.org/drawingml/2006/main" xmlns:p="http://schemas.openxmlformats.org/presentationml/2006/main" xmlns:r="http://schemas.openxmlformats.org/officeDocument/2006/relationships">
+<p:sld xmlns:a="http://schemas.openxmlformats.org/drawingml/2006/main" xmlns:r="http://schemas.openxmlformats.org/officeDocument/2006/relationships" xmlns:p="http://schemas.openxmlformats.org/presentationml/2006/main">
   <p:cSld>
     <p:spTree>
       <p:nvGrpSpPr>
@@ -3788,7 +4110,14 @@
         <p:cNvGrpSpPr/>
         <p:nvPr/>
       </p:nvGrpSpPr>
-      <p:grpSpPr/>
+      <p:grpSpPr>
+        <a:xfrm>
+          <a:off x="0" y="0"/>
+          <a:ext cx="0" cy="0"/>
+          <a:chOff x="0" y="0"/>
+          <a:chExt cx="0" cy="0"/>
+        </a:xfrm>
+      </p:grpSpPr>
       <p:sp>
         <p:nvSpPr>
           <p:cNvPr id="2" name="Title 1"/>
@@ -3832,13 +4161,16 @@
           </a:xfrm>
         </p:spPr>
         <p:txBody>
-          <a:bodyPr/>
+          <a:bodyPr>
+            <a:normAutofit/>
+          </a:bodyPr>
           <a:lstStyle/>
           <a:p>
             <a:pPr>
               <a:defRPr sz="1800"/>
             </a:pPr>
             <a:r>
+              <a:rPr sz="2400" dirty="0"/>
               <a:t>1. QC &amp; preprocessing  -  thresholds justified on real percentiles</a:t>
             </a:r>
           </a:p>
@@ -3847,6 +4179,7 @@
               <a:defRPr sz="1800"/>
             </a:pPr>
             <a:r>
+              <a:rPr sz="2400" dirty="0"/>
               <a:t>2. Integration  -  Harmony batch correction, UMAP, Leiden</a:t>
             </a:r>
           </a:p>
@@ -3855,7 +4188,24 @@
               <a:defRPr sz="1800"/>
             </a:pPr>
             <a:r>
-              <a:t>3. Annotation  -  celltypist, cross-checked vs Azimuth &amp; CoDi (~93%)</a:t>
+              <a:rPr sz="2400" dirty="0"/>
+              <a:t>3. Annotation  -  </a:t>
+            </a:r>
+            <a:r>
+              <a:rPr sz="2400" dirty="0" err="1"/>
+              <a:t>celltypist</a:t>
+            </a:r>
+            <a:r>
+              <a:rPr sz="2400" dirty="0"/>
+              <a:t>, cross-checked vs Azimuth &amp; </a:t>
+            </a:r>
+            <a:r>
+              <a:rPr sz="2400" dirty="0" err="1"/>
+              <a:t>CoDi</a:t>
+            </a:r>
+            <a:r>
+              <a:rPr sz="2400" dirty="0"/>
+              <a:t> (~93%)</a:t>
             </a:r>
           </a:p>
           <a:p>
@@ -3863,6 +4213,7 @@
               <a:defRPr sz="1800"/>
             </a:pPr>
             <a:r>
+              <a:rPr sz="2400" dirty="0"/>
               <a:t>4. Composition  -  proportions + log2 fold-change vs control</a:t>
             </a:r>
           </a:p>
@@ -3871,6 +4222,7 @@
               <a:defRPr sz="1800"/>
             </a:pPr>
             <a:r>
+              <a:rPr sz="2400" dirty="0"/>
               <a:t>5. Differential expression  -  per-lineage Wilcoxon + pathway enrichment</a:t>
             </a:r>
           </a:p>
@@ -3879,6 +4231,7 @@
               <a:defRPr sz="1800"/>
             </a:pPr>
             <a:r>
+              <a:rPr sz="2400" dirty="0"/>
               <a:t>6. Size-specific effects  -  unique / shared / mixture-emergent genes</a:t>
             </a:r>
           </a:p>
@@ -3893,7 +4246,7 @@
 </file>
 
 <file path=ppt/slides/slide4.xml><?xml version="1.0" encoding="utf-8"?>
-<p:sld xmlns:a="http://schemas.openxmlformats.org/drawingml/2006/main" xmlns:p="http://schemas.openxmlformats.org/presentationml/2006/main" xmlns:r="http://schemas.openxmlformats.org/officeDocument/2006/relationships">
+<p:sld xmlns:a="http://schemas.openxmlformats.org/drawingml/2006/main" xmlns:r="http://schemas.openxmlformats.org/officeDocument/2006/relationships" xmlns:p="http://schemas.openxmlformats.org/presentationml/2006/main">
   <p:cSld>
     <p:spTree>
       <p:nvGrpSpPr>
@@ -3901,7 +4254,14 @@
         <p:cNvGrpSpPr/>
         <p:nvPr/>
       </p:nvGrpSpPr>
-      <p:grpSpPr/>
+      <p:grpSpPr>
+        <a:xfrm>
+          <a:off x="0" y="0"/>
+          <a:ext cx="0" cy="0"/>
+          <a:chOff x="0" y="0"/>
+          <a:chExt cx="0" cy="0"/>
+        </a:xfrm>
+      </p:grpSpPr>
       <p:sp>
         <p:nvSpPr>
           <p:cNvPr id="2" name="Title 1"/>
@@ -3923,6 +4283,7 @@
           <a:lstStyle/>
           <a:p>
             <a:r>
+              <a:rPr dirty="0"/>
               <a:t>QC &amp; preprocessing (1/2): per-sample QC metrics</a:t>
             </a:r>
           </a:p>
@@ -3992,7 +4353,7 @@
 </file>
 
 <file path=ppt/slides/slide5.xml><?xml version="1.0" encoding="utf-8"?>
-<p:sld xmlns:a="http://schemas.openxmlformats.org/drawingml/2006/main" xmlns:p="http://schemas.openxmlformats.org/presentationml/2006/main" xmlns:r="http://schemas.openxmlformats.org/officeDocument/2006/relationships">
+<p:sld xmlns:a="http://schemas.openxmlformats.org/drawingml/2006/main" xmlns:r="http://schemas.openxmlformats.org/officeDocument/2006/relationships" xmlns:p="http://schemas.openxmlformats.org/presentationml/2006/main">
   <p:cSld>
     <p:spTree>
       <p:nvGrpSpPr>
@@ -4000,7 +4361,14 @@
         <p:cNvGrpSpPr/>
         <p:nvPr/>
       </p:nvGrpSpPr>
-      <p:grpSpPr/>
+      <p:grpSpPr>
+        <a:xfrm>
+          <a:off x="0" y="0"/>
+          <a:ext cx="0" cy="0"/>
+          <a:chOff x="0" y="0"/>
+          <a:chExt cx="0" cy="0"/>
+        </a:xfrm>
+      </p:grpSpPr>
       <p:sp>
         <p:nvSpPr>
           <p:cNvPr id="2" name="Title 1"/>
@@ -4091,7 +4459,7 @@
 </file>
 
 <file path=ppt/slides/slide6.xml><?xml version="1.0" encoding="utf-8"?>
-<p:sld xmlns:a="http://schemas.openxmlformats.org/drawingml/2006/main" xmlns:p="http://schemas.openxmlformats.org/presentationml/2006/main" xmlns:r="http://schemas.openxmlformats.org/officeDocument/2006/relationships">
+<p:sld xmlns:a="http://schemas.openxmlformats.org/drawingml/2006/main" xmlns:r="http://schemas.openxmlformats.org/officeDocument/2006/relationships" xmlns:p="http://schemas.openxmlformats.org/presentationml/2006/main">
   <p:cSld>
     <p:spTree>
       <p:nvGrpSpPr>
@@ -4099,7 +4467,14 @@
         <p:cNvGrpSpPr/>
         <p:nvPr/>
       </p:nvGrpSpPr>
-      <p:grpSpPr/>
+      <p:grpSpPr>
+        <a:xfrm>
+          <a:off x="0" y="0"/>
+          <a:ext cx="0" cy="0"/>
+          <a:chOff x="0" y="0"/>
+          <a:chExt cx="0" cy="0"/>
+        </a:xfrm>
+      </p:grpSpPr>
       <p:sp>
         <p:nvSpPr>
           <p:cNvPr id="2" name="Title 1"/>
@@ -4214,7 +4589,7 @@
 </file>
 
 <file path=ppt/slides/slide7.xml><?xml version="1.0" encoding="utf-8"?>
-<p:sld xmlns:a="http://schemas.openxmlformats.org/drawingml/2006/main" xmlns:p="http://schemas.openxmlformats.org/presentationml/2006/main" xmlns:r="http://schemas.openxmlformats.org/officeDocument/2006/relationships">
+<p:sld xmlns:a="http://schemas.openxmlformats.org/drawingml/2006/main" xmlns:r="http://schemas.openxmlformats.org/officeDocument/2006/relationships" xmlns:p="http://schemas.openxmlformats.org/presentationml/2006/main">
   <p:cSld>
     <p:spTree>
       <p:nvGrpSpPr>
@@ -4222,7 +4597,14 @@
         <p:cNvGrpSpPr/>
         <p:nvPr/>
       </p:nvGrpSpPr>
-      <p:grpSpPr/>
+      <p:grpSpPr>
+        <a:xfrm>
+          <a:off x="0" y="0"/>
+          <a:ext cx="0" cy="0"/>
+          <a:chOff x="0" y="0"/>
+          <a:chExt cx="0" cy="0"/>
+        </a:xfrm>
+      </p:grpSpPr>
       <p:sp>
         <p:nvSpPr>
           <p:cNvPr id="2" name="Title 1"/>
@@ -4337,7 +4719,7 @@
 </file>
 
 <file path=ppt/slides/slide8.xml><?xml version="1.0" encoding="utf-8"?>
-<p:sld xmlns:a="http://schemas.openxmlformats.org/drawingml/2006/main" xmlns:p="http://schemas.openxmlformats.org/presentationml/2006/main" xmlns:r="http://schemas.openxmlformats.org/officeDocument/2006/relationships">
+<p:sld xmlns:a="http://schemas.openxmlformats.org/drawingml/2006/main" xmlns:r="http://schemas.openxmlformats.org/officeDocument/2006/relationships" xmlns:p="http://schemas.openxmlformats.org/presentationml/2006/main">
   <p:cSld>
     <p:spTree>
       <p:nvGrpSpPr>
@@ -4345,7 +4727,14 @@
         <p:cNvGrpSpPr/>
         <p:nvPr/>
       </p:nvGrpSpPr>
-      <p:grpSpPr/>
+      <p:grpSpPr>
+        <a:xfrm>
+          <a:off x="0" y="0"/>
+          <a:ext cx="0" cy="0"/>
+          <a:chOff x="0" y="0"/>
+          <a:chExt cx="0" cy="0"/>
+        </a:xfrm>
+      </p:grpSpPr>
       <p:sp>
         <p:nvSpPr>
           <p:cNvPr id="2" name="Title 1"/>
@@ -4460,7 +4849,7 @@
 </file>
 
 <file path=ppt/slides/slide9.xml><?xml version="1.0" encoding="utf-8"?>
-<p:sld xmlns:a="http://schemas.openxmlformats.org/drawingml/2006/main" xmlns:p="http://schemas.openxmlformats.org/presentationml/2006/main" xmlns:r="http://schemas.openxmlformats.org/officeDocument/2006/relationships">
+<p:sld xmlns:a="http://schemas.openxmlformats.org/drawingml/2006/main" xmlns:r="http://schemas.openxmlformats.org/officeDocument/2006/relationships" xmlns:p="http://schemas.openxmlformats.org/presentationml/2006/main">
   <p:cSld>
     <p:spTree>
       <p:nvGrpSpPr>
@@ -4468,7 +4857,14 @@
         <p:cNvGrpSpPr/>
         <p:nvPr/>
       </p:nvGrpSpPr>
-      <p:grpSpPr/>
+      <p:grpSpPr>
+        <a:xfrm>
+          <a:off x="0" y="0"/>
+          <a:ext cx="0" cy="0"/>
+          <a:chOff x="0" y="0"/>
+          <a:chExt cx="0" cy="0"/>
+        </a:xfrm>
+      </p:grpSpPr>
       <p:sp>
         <p:nvSpPr>
           <p:cNvPr id="2" name="Title 1"/>
@@ -4900,4 +5296,10 @@
   </a:objectDefaults>
   <a:extraClrSchemeLst/>
 </a:theme>
+</file>
+
+<file path=docMetadata/LabelInfo.xml><?xml version="1.0" encoding="utf-8"?>
+<clbl:labelList xmlns:clbl="http://schemas.microsoft.com/office/2020/mipLabelMetadata">
+  <clbl:label id="{f39aa4b3-b62d-42bf-8097-75e2c573ddfa}" enabled="1" method="Privileged" siteId="{3dd8961f-e488-4e60-8e11-a82d994e183d}" contentBits="0" removed="0"/>
+</clbl:labelList>
 </file>
</xml_diff>

<commit_message>
slides: add per-slide speaker notes; script describes every plot's axes
Speaker notes on all 16 slides (Presenter View) narrating what each figure
shows, including x/y axis meaning. VIDEO_SCRIPT sections 4-10 rewritten to
describe the plots aloud (UMAP axes, QC violins/scatter, composition
proportions, DE dose-response + size categories, and the 5 bonus figures).
</commit_message>
<xml_diff>
--- a/results/slides/GI_nanoplastic.pptx
+++ b/results/slides/GI_nanoplastic.pptx
@@ -5,23 +5,24 @@
     <p:sldMasterId id="2147483648" r:id="rId1"/>
   </p:sldMasterIdLst>
   <p:sldIdLst>
-    <p:sldId id="256" r:id="rId2"/>
-    <p:sldId id="257" r:id="rId3"/>
-    <p:sldId id="258" r:id="rId4"/>
-    <p:sldId id="259" r:id="rId5"/>
-    <p:sldId id="260" r:id="rId6"/>
-    <p:sldId id="261" r:id="rId7"/>
-    <p:sldId id="262" r:id="rId8"/>
-    <p:sldId id="263" r:id="rId9"/>
-    <p:sldId id="264" r:id="rId10"/>
-    <p:sldId id="265" r:id="rId11"/>
-    <p:sldId id="266" r:id="rId12"/>
-    <p:sldId id="267" r:id="rId13"/>
-    <p:sldId id="268" r:id="rId14"/>
-    <p:sldId id="269" r:id="rId15"/>
-    <p:sldId id="270" r:id="rId16"/>
+    <p:sldId id="256" r:id="rId7"/>
+    <p:sldId id="257" r:id="rId9"/>
+    <p:sldId id="258" r:id="rId10"/>
+    <p:sldId id="259" r:id="rId11"/>
+    <p:sldId id="260" r:id="rId12"/>
+    <p:sldId id="261" r:id="rId13"/>
+    <p:sldId id="262" r:id="rId14"/>
+    <p:sldId id="263" r:id="rId15"/>
+    <p:sldId id="264" r:id="rId16"/>
+    <p:sldId id="265" r:id="rId17"/>
+    <p:sldId id="266" r:id="rId18"/>
+    <p:sldId id="267" r:id="rId19"/>
+    <p:sldId id="268" r:id="rId20"/>
+    <p:sldId id="269" r:id="rId21"/>
+    <p:sldId id="270" r:id="rId22"/>
+    <p:sldId id="271" r:id="rId23"/>
   </p:sldIdLst>
-  <p:sldSz cx="12192000" cy="6858000"/>
+  <p:sldSz cx="12191695" cy="6858000" type="screen4x3"/>
   <p:notesSz cx="6858000" cy="9144000"/>
   <p:defaultTextStyle>
     <a:defPPr>
@@ -118,23 +119,1477 @@
       </a:defRPr>
     </a:lvl9pPr>
   </p:defaultTextStyle>
-  <p:extLst>
-    <p:ext uri="{EFAFB233-063F-42B5-8137-9DF3F51BA10A}">
-      <p15:sldGuideLst xmlns:p15="http://schemas.microsoft.com/office/powerpoint/2012/main">
-        <p15:guide id="1" orient="horz" pos="2160">
-          <p15:clr>
-            <a:srgbClr val="A4A3A4"/>
-          </p15:clr>
-        </p15:guide>
-        <p15:guide id="2" pos="2880">
-          <p15:clr>
-            <a:srgbClr val="A4A3A4"/>
-          </p15:clr>
-        </p15:guide>
-      </p15:sldGuideLst>
-    </p:ext>
-  </p:extLst>
 </p:presentation>
+</file>
+
+<file path=ppt/notesMasters/notesMaster1.xml><?xml version="1.0" encoding="utf-8"?>
+<p:notesMaster xmlns:a="http://schemas.openxmlformats.org/drawingml/2006/main" xmlns:p="http://schemas.openxmlformats.org/presentationml/2006/main" xmlns:r="http://schemas.openxmlformats.org/officeDocument/2006/relationships">
+  <p:cSld>
+    <p:bg>
+      <p:bgRef idx="1001">
+        <a:schemeClr val="bg1"/>
+      </p:bgRef>
+    </p:bg>
+    <p:spTree>
+      <p:nvGrpSpPr>
+        <p:cNvPr id="1" name=""/>
+        <p:cNvGrpSpPr/>
+        <p:nvPr/>
+      </p:nvGrpSpPr>
+      <p:grpSpPr>
+        <a:xfrm>
+          <a:off x="0" y="0"/>
+          <a:ext cx="0" cy="0"/>
+          <a:chOff x="0" y="0"/>
+          <a:chExt cx="0" cy="0"/>
+        </a:xfrm>
+      </p:grpSpPr>
+      <p:sp>
+        <p:nvSpPr>
+          <p:cNvPr id="2" name="Header Placeholder 1"/>
+          <p:cNvSpPr>
+            <a:spLocks noGrp="1"/>
+          </p:cNvSpPr>
+          <p:nvPr>
+            <p:ph type="hdr" sz="quarter"/>
+          </p:nvPr>
+        </p:nvSpPr>
+        <p:spPr>
+          <a:xfrm>
+            <a:off x="0" y="0"/>
+            <a:ext cx="2971800" cy="457200"/>
+          </a:xfrm>
+          <a:prstGeom prst="rect">
+            <a:avLst/>
+          </a:prstGeom>
+        </p:spPr>
+        <p:txBody>
+          <a:bodyPr vert="horz" lIns="91440" tIns="45720" rIns="91440" bIns="45720" rtlCol="0"/>
+          <a:lstStyle>
+            <a:lvl1pPr algn="l">
+              <a:defRPr sz="1200"/>
+            </a:lvl1pPr>
+          </a:lstStyle>
+          <a:p>
+            <a:endParaRPr lang="en-US"/>
+          </a:p>
+        </p:txBody>
+      </p:sp>
+      <p:sp>
+        <p:nvSpPr>
+          <p:cNvPr id="3" name="Date Placeholder 2"/>
+          <p:cNvSpPr>
+            <a:spLocks noGrp="1"/>
+          </p:cNvSpPr>
+          <p:nvPr>
+            <p:ph type="dt" idx="1"/>
+          </p:nvPr>
+        </p:nvSpPr>
+        <p:spPr>
+          <a:xfrm>
+            <a:off x="3884613" y="0"/>
+            <a:ext cx="2971800" cy="457200"/>
+          </a:xfrm>
+          <a:prstGeom prst="rect">
+            <a:avLst/>
+          </a:prstGeom>
+        </p:spPr>
+        <p:txBody>
+          <a:bodyPr vert="horz" lIns="91440" tIns="45720" rIns="91440" bIns="45720" rtlCol="0"/>
+          <a:lstStyle>
+            <a:lvl1pPr algn="r">
+              <a:defRPr sz="1200"/>
+            </a:lvl1pPr>
+          </a:lstStyle>
+          <a:p>
+            <a:fld id="{0F89C1C7-3DCD-1040-A9CF-14679D8B5DDD}" type="datetimeFigureOut">
+              <a:rPr lang="en-US" smtClean="0"/>
+              <a:t>10/17/16</a:t>
+            </a:fld>
+            <a:endParaRPr lang="en-US"/>
+          </a:p>
+        </p:txBody>
+      </p:sp>
+      <p:sp>
+        <p:nvSpPr>
+          <p:cNvPr id="4" name="Slide Image Placeholder 3"/>
+          <p:cNvSpPr>
+            <a:spLocks noGrp="1" noRot="1" noChangeAspect="1"/>
+          </p:cNvSpPr>
+          <p:nvPr>
+            <p:ph type="sldImg" idx="2"/>
+          </p:nvPr>
+        </p:nvSpPr>
+        <p:spPr>
+          <a:xfrm>
+            <a:off x="1143000" y="685800"/>
+            <a:ext cx="4572000" cy="3429000"/>
+          </a:xfrm>
+          <a:prstGeom prst="rect">
+            <a:avLst/>
+          </a:prstGeom>
+          <a:noFill/>
+          <a:ln w="12700">
+            <a:solidFill>
+              <a:prstClr val="black"/>
+            </a:solidFill>
+          </a:ln>
+        </p:spPr>
+        <p:txBody>
+          <a:bodyPr vert="horz" lIns="91440" tIns="45720" rIns="91440" bIns="45720" rtlCol="0" anchor="ctr"/>
+          <a:lstStyle/>
+          <a:p>
+            <a:endParaRPr lang="en-US"/>
+          </a:p>
+        </p:txBody>
+      </p:sp>
+      <p:sp>
+        <p:nvSpPr>
+          <p:cNvPr id="5" name="Notes Placeholder 4"/>
+          <p:cNvSpPr>
+            <a:spLocks noGrp="1"/>
+          </p:cNvSpPr>
+          <p:nvPr>
+            <p:ph type="body" sz="quarter" idx="3"/>
+          </p:nvPr>
+        </p:nvSpPr>
+        <p:spPr>
+          <a:xfrm>
+            <a:off x="685800" y="4343400"/>
+            <a:ext cx="5486400" cy="4114800"/>
+          </a:xfrm>
+          <a:prstGeom prst="rect">
+            <a:avLst/>
+          </a:prstGeom>
+        </p:spPr>
+        <p:txBody>
+          <a:bodyPr vert="horz" lIns="91440" tIns="45720" rIns="91440" bIns="45720" rtlCol="0"/>
+          <a:lstStyle/>
+          <a:p>
+            <a:pPr lvl="0"/>
+            <a:r>
+              <a:rPr lang="en-US" smtClean="0"/>
+              <a:t>Click to edit Master text styles</a:t>
+            </a:r>
+          </a:p>
+          <a:p>
+            <a:pPr lvl="1"/>
+            <a:r>
+              <a:rPr lang="en-US" smtClean="0"/>
+              <a:t>Second level</a:t>
+            </a:r>
+          </a:p>
+          <a:p>
+            <a:pPr lvl="2"/>
+            <a:r>
+              <a:rPr lang="en-US" smtClean="0"/>
+              <a:t>Third level</a:t>
+            </a:r>
+          </a:p>
+          <a:p>
+            <a:pPr lvl="3"/>
+            <a:r>
+              <a:rPr lang="en-US" smtClean="0"/>
+              <a:t>Fourth level</a:t>
+            </a:r>
+          </a:p>
+          <a:p>
+            <a:pPr lvl="4"/>
+            <a:r>
+              <a:rPr lang="en-US" smtClean="0"/>
+              <a:t>Fifth level</a:t>
+            </a:r>
+            <a:endParaRPr lang="en-US"/>
+          </a:p>
+        </p:txBody>
+      </p:sp>
+      <p:sp>
+        <p:nvSpPr>
+          <p:cNvPr id="6" name="Footer Placeholder 5"/>
+          <p:cNvSpPr>
+            <a:spLocks noGrp="1"/>
+          </p:cNvSpPr>
+          <p:nvPr>
+            <p:ph type="ftr" sz="quarter" idx="4"/>
+          </p:nvPr>
+        </p:nvSpPr>
+        <p:spPr>
+          <a:xfrm>
+            <a:off x="0" y="8685213"/>
+            <a:ext cx="2971800" cy="457200"/>
+          </a:xfrm>
+          <a:prstGeom prst="rect">
+            <a:avLst/>
+          </a:prstGeom>
+        </p:spPr>
+        <p:txBody>
+          <a:bodyPr vert="horz" lIns="91440" tIns="45720" rIns="91440" bIns="45720" rtlCol="0" anchor="b"/>
+          <a:lstStyle>
+            <a:lvl1pPr algn="l">
+              <a:defRPr sz="1200"/>
+            </a:lvl1pPr>
+          </a:lstStyle>
+          <a:p>
+            <a:endParaRPr lang="en-US"/>
+          </a:p>
+        </p:txBody>
+      </p:sp>
+      <p:sp>
+        <p:nvSpPr>
+          <p:cNvPr id="7" name="Slide Number Placeholder 6"/>
+          <p:cNvSpPr>
+            <a:spLocks noGrp="1"/>
+          </p:cNvSpPr>
+          <p:nvPr>
+            <p:ph type="sldNum" sz="quarter" idx="5"/>
+          </p:nvPr>
+        </p:nvSpPr>
+        <p:spPr>
+          <a:xfrm>
+            <a:off x="3884613" y="8685213"/>
+            <a:ext cx="2971800" cy="457200"/>
+          </a:xfrm>
+          <a:prstGeom prst="rect">
+            <a:avLst/>
+          </a:prstGeom>
+        </p:spPr>
+        <p:txBody>
+          <a:bodyPr vert="horz" lIns="91440" tIns="45720" rIns="91440" bIns="45720" rtlCol="0" anchor="b"/>
+          <a:lstStyle>
+            <a:lvl1pPr algn="r">
+              <a:defRPr sz="1200"/>
+            </a:lvl1pPr>
+          </a:lstStyle>
+          <a:p>
+            <a:fld id="{BB5E49A5-4136-284D-997B-48E1D791AD67}" type="slidenum">
+              <a:rPr lang="en-US" smtClean="0"/>
+              <a:t>‹#›</a:t>
+            </a:fld>
+            <a:endParaRPr lang="en-US"/>
+          </a:p>
+        </p:txBody>
+      </p:sp>
+    </p:spTree>
+    <p:extLst>
+      <p:ext uri="{BB962C8B-B14F-4D97-AF65-F5344CB8AC3E}">
+        <p14:creationId xmlns:p14="http://schemas.microsoft.com/office/powerpoint/2010/main" val="2623252185"/>
+      </p:ext>
+    </p:extLst>
+  </p:cSld>
+  <p:clrMap bg1="lt1" tx1="dk1" bg2="lt2" tx2="dk2" accent1="accent1" accent2="accent2" accent3="accent3" accent4="accent4" accent5="accent5" accent6="accent6" hlink="hlink" folHlink="folHlink"/>
+  <p:notesStyle>
+    <a:lvl1pPr marL="0" algn="l" defTabSz="457200" rtl="0" eaLnBrk="1" latinLnBrk="0" hangingPunct="1">
+      <a:defRPr sz="1200" kern="1200">
+        <a:solidFill>
+          <a:schemeClr val="tx1"/>
+        </a:solidFill>
+        <a:latin typeface="+mn-lt"/>
+        <a:ea typeface="+mn-ea"/>
+        <a:cs typeface="+mn-cs"/>
+      </a:defRPr>
+    </a:lvl1pPr>
+    <a:lvl2pPr marL="457200" algn="l" defTabSz="457200" rtl="0" eaLnBrk="1" latinLnBrk="0" hangingPunct="1">
+      <a:defRPr sz="1200" kern="1200">
+        <a:solidFill>
+          <a:schemeClr val="tx1"/>
+        </a:solidFill>
+        <a:latin typeface="+mn-lt"/>
+        <a:ea typeface="+mn-ea"/>
+        <a:cs typeface="+mn-cs"/>
+      </a:defRPr>
+    </a:lvl2pPr>
+    <a:lvl3pPr marL="914400" algn="l" defTabSz="457200" rtl="0" eaLnBrk="1" latinLnBrk="0" hangingPunct="1">
+      <a:defRPr sz="1200" kern="1200">
+        <a:solidFill>
+          <a:schemeClr val="tx1"/>
+        </a:solidFill>
+        <a:latin typeface="+mn-lt"/>
+        <a:ea typeface="+mn-ea"/>
+        <a:cs typeface="+mn-cs"/>
+      </a:defRPr>
+    </a:lvl3pPr>
+    <a:lvl4pPr marL="1371600" algn="l" defTabSz="457200" rtl="0" eaLnBrk="1" latinLnBrk="0" hangingPunct="1">
+      <a:defRPr sz="1200" kern="1200">
+        <a:solidFill>
+          <a:schemeClr val="tx1"/>
+        </a:solidFill>
+        <a:latin typeface="+mn-lt"/>
+        <a:ea typeface="+mn-ea"/>
+        <a:cs typeface="+mn-cs"/>
+      </a:defRPr>
+    </a:lvl4pPr>
+    <a:lvl5pPr marL="1828800" algn="l" defTabSz="457200" rtl="0" eaLnBrk="1" latinLnBrk="0" hangingPunct="1">
+      <a:defRPr sz="1200" kern="1200">
+        <a:solidFill>
+          <a:schemeClr val="tx1"/>
+        </a:solidFill>
+        <a:latin typeface="+mn-lt"/>
+        <a:ea typeface="+mn-ea"/>
+        <a:cs typeface="+mn-cs"/>
+      </a:defRPr>
+    </a:lvl5pPr>
+    <a:lvl6pPr marL="2286000" algn="l" defTabSz="457200" rtl="0" eaLnBrk="1" latinLnBrk="0" hangingPunct="1">
+      <a:defRPr sz="1200" kern="1200">
+        <a:solidFill>
+          <a:schemeClr val="tx1"/>
+        </a:solidFill>
+        <a:latin typeface="+mn-lt"/>
+        <a:ea typeface="+mn-ea"/>
+        <a:cs typeface="+mn-cs"/>
+      </a:defRPr>
+    </a:lvl6pPr>
+    <a:lvl7pPr marL="2743200" algn="l" defTabSz="457200" rtl="0" eaLnBrk="1" latinLnBrk="0" hangingPunct="1">
+      <a:defRPr sz="1200" kern="1200">
+        <a:solidFill>
+          <a:schemeClr val="tx1"/>
+        </a:solidFill>
+        <a:latin typeface="+mn-lt"/>
+        <a:ea typeface="+mn-ea"/>
+        <a:cs typeface="+mn-cs"/>
+      </a:defRPr>
+    </a:lvl7pPr>
+    <a:lvl8pPr marL="3200400" algn="l" defTabSz="457200" rtl="0" eaLnBrk="1" latinLnBrk="0" hangingPunct="1">
+      <a:defRPr sz="1200" kern="1200">
+        <a:solidFill>
+          <a:schemeClr val="tx1"/>
+        </a:solidFill>
+        <a:latin typeface="+mn-lt"/>
+        <a:ea typeface="+mn-ea"/>
+        <a:cs typeface="+mn-cs"/>
+      </a:defRPr>
+    </a:lvl8pPr>
+    <a:lvl9pPr marL="3657600" algn="l" defTabSz="457200" rtl="0" eaLnBrk="1" latinLnBrk="0" hangingPunct="1">
+      <a:defRPr sz="1200" kern="1200">
+        <a:solidFill>
+          <a:schemeClr val="tx1"/>
+        </a:solidFill>
+        <a:latin typeface="+mn-lt"/>
+        <a:ea typeface="+mn-ea"/>
+        <a:cs typeface="+mn-cs"/>
+      </a:defRPr>
+    </a:lvl9pPr>
+  </p:notesStyle>
+</p:notesMaster>
+</file>
+
+<file path=ppt/notesSlides/notesSlide1.xml><?xml version="1.0" encoding="utf-8"?>
+<p:notes xmlns:a="http://schemas.openxmlformats.org/drawingml/2006/main" xmlns:p="http://schemas.openxmlformats.org/presentationml/2006/main" xmlns:r="http://schemas.openxmlformats.org/officeDocument/2006/relationships">
+  <p:cSld>
+    <p:spTree>
+      <p:nvGrpSpPr>
+        <p:cNvPr id="1" name=""/>
+        <p:cNvGrpSpPr/>
+        <p:nvPr/>
+      </p:nvGrpSpPr>
+      <p:grpSpPr>
+        <a:xfrm>
+          <a:off x="0" y="0"/>
+          <a:ext cx="0" cy="0"/>
+          <a:chOff x="0" y="0"/>
+          <a:chExt cx="0" cy="0"/>
+        </a:xfrm>
+      </p:grpSpPr>
+      <p:sp>
+        <p:nvSpPr>
+          <p:cNvPr id="2" name="Slide Image Placeholder 1"/>
+          <p:cNvSpPr>
+            <a:spLocks noGrp="1"/>
+          </p:cNvSpPr>
+          <p:nvPr>
+            <p:ph type="sldImg" idx="2"/>
+          </p:nvPr>
+        </p:nvSpPr>
+        <p:spPr/>
+      </p:sp>
+      <p:sp>
+        <p:nvSpPr>
+          <p:cNvPr id="3" name="Notes Placeholder 2"/>
+          <p:cNvSpPr>
+            <a:spLocks noGrp="1"/>
+          </p:cNvSpPr>
+          <p:nvPr>
+            <p:ph type="body" idx="3" sz="quarter"/>
+          </p:nvPr>
+        </p:nvSpPr>
+        <p:spPr/>
+        <p:txBody>
+          <a:bodyPr/>
+          <a:lstStyle/>
+          <a:p>
+            <a:r>
+              <a:t>Intro: I'm Vuk Djordjevic, master's student at the School of Electrical Engineering, Genome Informatics 2026. This is a single-cell RNA-seq study of how human immune cells respond to nanoplastic particles of different sizes. The core question: does particle size matter, and does a mixture of sizes do something neither size does alone?</a:t>
+            </a:r>
+          </a:p>
+        </p:txBody>
+      </p:sp>
+      <p:sp>
+        <p:nvSpPr>
+          <p:cNvPr id="4" name="Slide Number Placeholder 3"/>
+          <p:cNvSpPr>
+            <a:spLocks noGrp="1"/>
+          </p:cNvSpPr>
+          <p:nvPr>
+            <p:ph type="sldNum" idx="5" sz="quarter"/>
+          </p:nvPr>
+        </p:nvSpPr>
+        <p:spPr/>
+      </p:sp>
+    </p:spTree>
+  </p:cSld>
+  <p:clrMapOvr>
+    <a:masterClrMapping/>
+  </p:clrMapOvr>
+</p:notes>
+</file>
+
+<file path=ppt/notesSlides/notesSlide10.xml><?xml version="1.0" encoding="utf-8"?>
+<p:notes xmlns:a="http://schemas.openxmlformats.org/drawingml/2006/main" xmlns:p="http://schemas.openxmlformats.org/presentationml/2006/main" xmlns:r="http://schemas.openxmlformats.org/officeDocument/2006/relationships">
+  <p:cSld>
+    <p:spTree>
+      <p:nvGrpSpPr>
+        <p:cNvPr id="1" name=""/>
+        <p:cNvGrpSpPr/>
+        <p:nvPr/>
+      </p:nvGrpSpPr>
+      <p:grpSpPr>
+        <a:xfrm>
+          <a:off x="0" y="0"/>
+          <a:ext cx="0" cy="0"/>
+          <a:chOff x="0" y="0"/>
+          <a:chExt cx="0" cy="0"/>
+        </a:xfrm>
+      </p:grpSpPr>
+      <p:sp>
+        <p:nvSpPr>
+          <p:cNvPr id="2" name="Slide Image Placeholder 1"/>
+          <p:cNvSpPr>
+            <a:spLocks noGrp="1"/>
+          </p:cNvSpPr>
+          <p:nvPr>
+            <p:ph type="sldImg" idx="2"/>
+          </p:nvPr>
+        </p:nvSpPr>
+        <p:spPr/>
+      </p:sp>
+      <p:sp>
+        <p:nvSpPr>
+          <p:cNvPr id="3" name="Notes Placeholder 2"/>
+          <p:cNvSpPr>
+            <a:spLocks noGrp="1"/>
+          </p:cNvSpPr>
+          <p:nvPr>
+            <p:ph type="body" idx="3" sz="quarter"/>
+          </p:nvPr>
+        </p:nvSpPr>
+        <p:spPr/>
+        <p:txBody>
+          <a:bodyPr/>
+          <a:lstStyle/>
+          <a:p>
+            <a:r>
+              <a:t>This is the headline. Three points: monocytes respond strongest; 200 nm drives more lineage-unique genes than 40 nm; and the 40+200 nm mixture produces an emergent monocyte response -- about 180 genes significant only in the mixture, in neither single size. In lymphocytes the opposite happens: the mixture is weaker than either size alone. So the combination of sizes does something the individual sizes do not.</a:t>
+            </a:r>
+          </a:p>
+        </p:txBody>
+      </p:sp>
+      <p:sp>
+        <p:nvSpPr>
+          <p:cNvPr id="4" name="Slide Number Placeholder 3"/>
+          <p:cNvSpPr>
+            <a:spLocks noGrp="1"/>
+          </p:cNvSpPr>
+          <p:nvPr>
+            <p:ph type="sldNum" idx="5" sz="quarter"/>
+          </p:nvPr>
+        </p:nvSpPr>
+        <p:spPr/>
+      </p:sp>
+    </p:spTree>
+  </p:cSld>
+  <p:clrMapOvr>
+    <a:masterClrMapping/>
+  </p:clrMapOvr>
+</p:notes>
+</file>
+
+<file path=ppt/notesSlides/notesSlide11.xml><?xml version="1.0" encoding="utf-8"?>
+<p:notes xmlns:a="http://schemas.openxmlformats.org/drawingml/2006/main" xmlns:p="http://schemas.openxmlformats.org/presentationml/2006/main" xmlns:r="http://schemas.openxmlformats.org/officeDocument/2006/relationships">
+  <p:cSld>
+    <p:spTree>
+      <p:nvGrpSpPr>
+        <p:cNvPr id="1" name=""/>
+        <p:cNvGrpSpPr/>
+        <p:nvPr/>
+      </p:nvGrpSpPr>
+      <p:grpSpPr>
+        <a:xfrm>
+          <a:off x="0" y="0"/>
+          <a:ext cx="0" cy="0"/>
+          <a:chOff x="0" y="0"/>
+          <a:chExt cx="0" cy="0"/>
+        </a:xfrm>
+      </p:grpSpPr>
+      <p:sp>
+        <p:nvSpPr>
+          <p:cNvPr id="2" name="Slide Image Placeholder 1"/>
+          <p:cNvSpPr>
+            <a:spLocks noGrp="1"/>
+          </p:cNvSpPr>
+          <p:nvPr>
+            <p:ph type="sldImg" idx="2"/>
+          </p:nvPr>
+        </p:nvSpPr>
+        <p:spPr/>
+      </p:sp>
+      <p:sp>
+        <p:nvSpPr>
+          <p:cNvPr id="3" name="Notes Placeholder 2"/>
+          <p:cNvSpPr>
+            <a:spLocks noGrp="1"/>
+          </p:cNvSpPr>
+          <p:nvPr>
+            <p:ph type="body" idx="3" sz="quarter"/>
+          </p:nvPr>
+        </p:nvSpPr>
+        <p:spPr/>
+        <p:txBody>
+          <a:bodyPr/>
+          <a:lstStyle/>
+          <a:p>
+            <a:r>
+              <a:t>What is that new thing? I ran pathway enrichment on the 180 mixture-only monocyte genes and it points clearly at inflammation. Top pathways, adjusted p about 1e-21: interleukin, cytokine and TNF signalling, plus 'response to lipopolysaccharide' -- the program a monocyte runs during a bacterial infection, here set off by plastic. Strongest genes up are RIPK2 and TRAF1, core innate-immune and TNF genes. Reading: 40 and 200 nm each cause sub-threshold changes, but together they push monocytes over an inflammatory threshold. Real exposure is always to mixtures, so single-size testing may under-estimate the risk.</a:t>
+            </a:r>
+          </a:p>
+        </p:txBody>
+      </p:sp>
+      <p:sp>
+        <p:nvSpPr>
+          <p:cNvPr id="4" name="Slide Number Placeholder 3"/>
+          <p:cNvSpPr>
+            <a:spLocks noGrp="1"/>
+          </p:cNvSpPr>
+          <p:nvPr>
+            <p:ph type="sldNum" idx="5" sz="quarter"/>
+          </p:nvPr>
+        </p:nvSpPr>
+        <p:spPr/>
+      </p:sp>
+    </p:spTree>
+  </p:cSld>
+  <p:clrMapOvr>
+    <a:masterClrMapping/>
+  </p:clrMapOvr>
+</p:notes>
+</file>
+
+<file path=ppt/notesSlides/notesSlide12.xml><?xml version="1.0" encoding="utf-8"?>
+<p:notes xmlns:a="http://schemas.openxmlformats.org/drawingml/2006/main" xmlns:p="http://schemas.openxmlformats.org/presentationml/2006/main" xmlns:r="http://schemas.openxmlformats.org/officeDocument/2006/relationships">
+  <p:cSld>
+    <p:spTree>
+      <p:nvGrpSpPr>
+        <p:cNvPr id="1" name=""/>
+        <p:cNvGrpSpPr/>
+        <p:nvPr/>
+      </p:nvGrpSpPr>
+      <p:grpSpPr>
+        <a:xfrm>
+          <a:off x="0" y="0"/>
+          <a:ext cx="0" cy="0"/>
+          <a:chOff x="0" y="0"/>
+          <a:chExt cx="0" cy="0"/>
+        </a:xfrm>
+      </p:grpSpPr>
+      <p:sp>
+        <p:nvSpPr>
+          <p:cNvPr id="2" name="Slide Image Placeholder 1"/>
+          <p:cNvSpPr>
+            <a:spLocks noGrp="1"/>
+          </p:cNvSpPr>
+          <p:nvPr>
+            <p:ph type="sldImg" idx="2"/>
+          </p:nvPr>
+        </p:nvSpPr>
+        <p:spPr/>
+      </p:sp>
+      <p:sp>
+        <p:nvSpPr>
+          <p:cNvPr id="3" name="Notes Placeholder 2"/>
+          <p:cNvSpPr>
+            <a:spLocks noGrp="1"/>
+          </p:cNvSpPr>
+          <p:nvPr>
+            <p:ph type="body" idx="3" sz="quarter"/>
+          </p:nvPr>
+        </p:nvSpPr>
+        <p:spPr/>
+        <p:txBody>
+          <a:bodyPr/>
+          <a:lstStyle/>
+          <a:p>
+            <a:r>
+              <a:t>For the additional-insights part I implemented five extra analyses; this slide lists them and the next slides show each. Module scoring, mixture additivity, clustering robustness, ligand-receptor communication, and dose-response. All five point the same way: a size-dependent, non-additive response centred on monocytes.</a:t>
+            </a:r>
+          </a:p>
+        </p:txBody>
+      </p:sp>
+      <p:sp>
+        <p:nvSpPr>
+          <p:cNvPr id="4" name="Slide Number Placeholder 3"/>
+          <p:cNvSpPr>
+            <a:spLocks noGrp="1"/>
+          </p:cNvSpPr>
+          <p:nvPr>
+            <p:ph type="sldNum" idx="5" sz="quarter"/>
+          </p:nvPr>
+        </p:nvSpPr>
+        <p:spPr/>
+      </p:sp>
+    </p:spTree>
+  </p:cSld>
+  <p:clrMapOvr>
+    <a:masterClrMapping/>
+  </p:clrMapOvr>
+</p:notes>
+</file>
+
+<file path=ppt/notesSlides/notesSlide13.xml><?xml version="1.0" encoding="utf-8"?>
+<p:notes xmlns:a="http://schemas.openxmlformats.org/drawingml/2006/main" xmlns:p="http://schemas.openxmlformats.org/presentationml/2006/main" xmlns:r="http://schemas.openxmlformats.org/officeDocument/2006/relationships">
+  <p:cSld>
+    <p:spTree>
+      <p:nvGrpSpPr>
+        <p:cNvPr id="1" name=""/>
+        <p:cNvGrpSpPr/>
+        <p:nvPr/>
+      </p:nvGrpSpPr>
+      <p:grpSpPr>
+        <a:xfrm>
+          <a:off x="0" y="0"/>
+          <a:ext cx="0" cy="0"/>
+          <a:chOff x="0" y="0"/>
+          <a:chExt cx="0" cy="0"/>
+        </a:xfrm>
+      </p:grpSpPr>
+      <p:sp>
+        <p:nvSpPr>
+          <p:cNvPr id="2" name="Slide Image Placeholder 1"/>
+          <p:cNvSpPr>
+            <a:spLocks noGrp="1"/>
+          </p:cNvSpPr>
+          <p:nvPr>
+            <p:ph type="sldImg" idx="2"/>
+          </p:nvPr>
+        </p:nvSpPr>
+        <p:spPr/>
+      </p:sp>
+      <p:sp>
+        <p:nvSpPr>
+          <p:cNvPr id="3" name="Notes Placeholder 2"/>
+          <p:cNvSpPr>
+            <a:spLocks noGrp="1"/>
+          </p:cNvSpPr>
+          <p:nvPr>
+            <p:ph type="body" idx="3" sz="quarter"/>
+          </p:nvPr>
+        </p:nvSpPr>
+        <p:spPr/>
+        <p:txBody>
+          <a:bodyPr/>
+          <a:lstStyle/>
+          <a:p>
+            <a:r>
+              <a:t>Analysis 1 of 5, module scoring. A heatmap: rows are samples (40 nm, 200 nm, mixture, control), columns are curated gene programs (stress, inflammation). Cell colour is the mean module score for that program in that sample -- darker/hotter means the program is more active. It shows the inflammation program lighting up under exposure, strongest where monocytes are most disrupted.</a:t>
+            </a:r>
+          </a:p>
+        </p:txBody>
+      </p:sp>
+      <p:sp>
+        <p:nvSpPr>
+          <p:cNvPr id="4" name="Slide Number Placeholder 3"/>
+          <p:cNvSpPr>
+            <a:spLocks noGrp="1"/>
+          </p:cNvSpPr>
+          <p:nvPr>
+            <p:ph type="sldNum" idx="5" sz="quarter"/>
+          </p:nvPr>
+        </p:nvSpPr>
+        <p:spPr/>
+      </p:sp>
+    </p:spTree>
+  </p:cSld>
+  <p:clrMapOvr>
+    <a:masterClrMapping/>
+  </p:clrMapOvr>
+</p:notes>
+</file>
+
+<file path=ppt/notesSlides/notesSlide14.xml><?xml version="1.0" encoding="utf-8"?>
+<p:notes xmlns:a="http://schemas.openxmlformats.org/drawingml/2006/main" xmlns:p="http://schemas.openxmlformats.org/presentationml/2006/main" xmlns:r="http://schemas.openxmlformats.org/officeDocument/2006/relationships">
+  <p:cSld>
+    <p:spTree>
+      <p:nvGrpSpPr>
+        <p:cNvPr id="1" name=""/>
+        <p:cNvGrpSpPr/>
+        <p:nvPr/>
+      </p:nvGrpSpPr>
+      <p:grpSpPr>
+        <a:xfrm>
+          <a:off x="0" y="0"/>
+          <a:ext cx="0" cy="0"/>
+          <a:chOff x="0" y="0"/>
+          <a:chExt cx="0" cy="0"/>
+        </a:xfrm>
+      </p:grpSpPr>
+      <p:sp>
+        <p:nvSpPr>
+          <p:cNvPr id="2" name="Slide Image Placeholder 1"/>
+          <p:cNvSpPr>
+            <a:spLocks noGrp="1"/>
+          </p:cNvSpPr>
+          <p:nvPr>
+            <p:ph type="sldImg" idx="2"/>
+          </p:nvPr>
+        </p:nvSpPr>
+        <p:spPr/>
+      </p:sp>
+      <p:sp>
+        <p:nvSpPr>
+          <p:cNvPr id="3" name="Notes Placeholder 2"/>
+          <p:cNvSpPr>
+            <a:spLocks noGrp="1"/>
+          </p:cNvSpPr>
+          <p:nvPr>
+            <p:ph type="body" idx="3" sz="quarter"/>
+          </p:nvPr>
+        </p:nvSpPr>
+        <p:spPr/>
+        <p:txBody>
+          <a:bodyPr/>
+          <a:lstStyle/>
+          <a:p>
+            <a:r>
+              <a:t>Analysis 2 of 5, mixture additivity -- the direct test of non-additivity. One small scatter per lineage. X-axis is the EXPECTED response if you simply add 40 nm and 200 nm effects; y-axis is the OBSERVED mixture response. The diagonal is 'mixture = sum of parts'. Points ABOVE the diagonal are super-additive (the mixture does more than the sum) -- that's what monocytes show. Points below are sub-additive, which is the lymphocytes. This is the quantitative backbone of the emergent-response claim.</a:t>
+            </a:r>
+          </a:p>
+        </p:txBody>
+      </p:sp>
+      <p:sp>
+        <p:nvSpPr>
+          <p:cNvPr id="4" name="Slide Number Placeholder 3"/>
+          <p:cNvSpPr>
+            <a:spLocks noGrp="1"/>
+          </p:cNvSpPr>
+          <p:nvPr>
+            <p:ph type="sldNum" idx="5" sz="quarter"/>
+          </p:nvPr>
+        </p:nvSpPr>
+        <p:spPr/>
+      </p:sp>
+    </p:spTree>
+  </p:cSld>
+  <p:clrMapOvr>
+    <a:masterClrMapping/>
+  </p:clrMapOvr>
+</p:notes>
+</file>
+
+<file path=ppt/notesSlides/notesSlide15.xml><?xml version="1.0" encoding="utf-8"?>
+<p:notes xmlns:a="http://schemas.openxmlformats.org/drawingml/2006/main" xmlns:p="http://schemas.openxmlformats.org/presentationml/2006/main" xmlns:r="http://schemas.openxmlformats.org/officeDocument/2006/relationships">
+  <p:cSld>
+    <p:spTree>
+      <p:nvGrpSpPr>
+        <p:cNvPr id="1" name=""/>
+        <p:cNvGrpSpPr/>
+        <p:nvPr/>
+      </p:nvGrpSpPr>
+      <p:grpSpPr>
+        <a:xfrm>
+          <a:off x="0" y="0"/>
+          <a:ext cx="0" cy="0"/>
+          <a:chOff x="0" y="0"/>
+          <a:chExt cx="0" cy="0"/>
+        </a:xfrm>
+      </p:grpSpPr>
+      <p:sp>
+        <p:nvSpPr>
+          <p:cNvPr id="2" name="Slide Image Placeholder 1"/>
+          <p:cNvSpPr>
+            <a:spLocks noGrp="1"/>
+          </p:cNvSpPr>
+          <p:nvPr>
+            <p:ph type="sldImg" idx="2"/>
+          </p:nvPr>
+        </p:nvSpPr>
+        <p:spPr/>
+      </p:sp>
+      <p:sp>
+        <p:nvSpPr>
+          <p:cNvPr id="3" name="Notes Placeholder 2"/>
+          <p:cNvSpPr>
+            <a:spLocks noGrp="1"/>
+          </p:cNvSpPr>
+          <p:nvPr>
+            <p:ph type="body" idx="3" sz="quarter"/>
+          </p:nvPr>
+        </p:nvSpPr>
+        <p:spPr/>
+        <p:txBody>
+          <a:bodyPr/>
+          <a:lstStyle/>
+          <a:p>
+            <a:r>
+              <a:t>Analyses 3 and 4. LEFT (robustness): x-axis is Leiden resolution (how finely you cut the clusters); left y-axis is the number of clusters, right y-axis (green, dashed) is the ARI -- adjusted Rand index, cluster agreement versus resolution 1.0, where 1.0 = identical. A flat-high ARI means the cell groupings are stable, not an artefact of one setting. RIGHT (ligand-receptor): x-axis is log2 fold-change versus control for signalling ligand-receptor pairs -- how cell-to-cell communication shifts on exposure. Analysis 5, dose-response, was already on the differential-expression slide.</a:t>
+            </a:r>
+          </a:p>
+        </p:txBody>
+      </p:sp>
+      <p:sp>
+        <p:nvSpPr>
+          <p:cNvPr id="4" name="Slide Number Placeholder 3"/>
+          <p:cNvSpPr>
+            <a:spLocks noGrp="1"/>
+          </p:cNvSpPr>
+          <p:nvPr>
+            <p:ph type="sldNum" idx="5" sz="quarter"/>
+          </p:nvPr>
+        </p:nvSpPr>
+        <p:spPr/>
+      </p:sp>
+    </p:spTree>
+  </p:cSld>
+  <p:clrMapOvr>
+    <a:masterClrMapping/>
+  </p:clrMapOvr>
+</p:notes>
+</file>
+
+<file path=ppt/notesSlides/notesSlide16.xml><?xml version="1.0" encoding="utf-8"?>
+<p:notes xmlns:a="http://schemas.openxmlformats.org/drawingml/2006/main" xmlns:p="http://schemas.openxmlformats.org/presentationml/2006/main" xmlns:r="http://schemas.openxmlformats.org/officeDocument/2006/relationships">
+  <p:cSld>
+    <p:spTree>
+      <p:nvGrpSpPr>
+        <p:cNvPr id="1" name=""/>
+        <p:cNvGrpSpPr/>
+        <p:nvPr/>
+      </p:nvGrpSpPr>
+      <p:grpSpPr>
+        <a:xfrm>
+          <a:off x="0" y="0"/>
+          <a:ext cx="0" cy="0"/>
+          <a:chOff x="0" y="0"/>
+          <a:chExt cx="0" cy="0"/>
+        </a:xfrm>
+      </p:grpSpPr>
+      <p:sp>
+        <p:nvSpPr>
+          <p:cNvPr id="2" name="Slide Image Placeholder 1"/>
+          <p:cNvSpPr>
+            <a:spLocks noGrp="1"/>
+          </p:cNvSpPr>
+          <p:nvPr>
+            <p:ph type="sldImg" idx="2"/>
+          </p:nvPr>
+        </p:nvSpPr>
+        <p:spPr/>
+      </p:sp>
+      <p:sp>
+        <p:nvSpPr>
+          <p:cNvPr id="3" name="Notes Placeholder 2"/>
+          <p:cNvSpPr>
+            <a:spLocks noGrp="1"/>
+          </p:cNvSpPr>
+          <p:nvPr>
+            <p:ph type="body" idx="3" sz="quarter"/>
+          </p:nvPr>
+        </p:nvSpPr>
+        <p:spPr/>
+        <p:txBody>
+          <a:bodyPr/>
+          <a:lstStyle/>
+          <a:p>
+            <a:r>
+              <a:t>The limits, stated plainly: one donor and no replicates mean the differential expression is per-cell and exploratory, with a pseudoreplication caveat. No external gene-level reference, so I validated internally and biologically. Everything reproduces from the repository with a single command and a 37-test suite. Thanks for watching.</a:t>
+            </a:r>
+          </a:p>
+        </p:txBody>
+      </p:sp>
+      <p:sp>
+        <p:nvSpPr>
+          <p:cNvPr id="4" name="Slide Number Placeholder 3"/>
+          <p:cNvSpPr>
+            <a:spLocks noGrp="1"/>
+          </p:cNvSpPr>
+          <p:nvPr>
+            <p:ph type="sldNum" idx="5" sz="quarter"/>
+          </p:nvPr>
+        </p:nvSpPr>
+        <p:spPr/>
+      </p:sp>
+    </p:spTree>
+  </p:cSld>
+  <p:clrMapOvr>
+    <a:masterClrMapping/>
+  </p:clrMapOvr>
+</p:notes>
+</file>
+
+<file path=ppt/notesSlides/notesSlide2.xml><?xml version="1.0" encoding="utf-8"?>
+<p:notes xmlns:a="http://schemas.openxmlformats.org/drawingml/2006/main" xmlns:p="http://schemas.openxmlformats.org/presentationml/2006/main" xmlns:r="http://schemas.openxmlformats.org/officeDocument/2006/relationships">
+  <p:cSld>
+    <p:spTree>
+      <p:nvGrpSpPr>
+        <p:cNvPr id="1" name=""/>
+        <p:cNvGrpSpPr/>
+        <p:nvPr/>
+      </p:nvGrpSpPr>
+      <p:grpSpPr>
+        <a:xfrm>
+          <a:off x="0" y="0"/>
+          <a:ext cx="0" cy="0"/>
+          <a:chOff x="0" y="0"/>
+          <a:chExt cx="0" cy="0"/>
+        </a:xfrm>
+      </p:grpSpPr>
+      <p:sp>
+        <p:nvSpPr>
+          <p:cNvPr id="2" name="Slide Image Placeholder 1"/>
+          <p:cNvSpPr>
+            <a:spLocks noGrp="1"/>
+          </p:cNvSpPr>
+          <p:nvPr>
+            <p:ph type="sldImg" idx="2"/>
+          </p:nvPr>
+        </p:nvSpPr>
+        <p:spPr/>
+      </p:sp>
+      <p:sp>
+        <p:nvSpPr>
+          <p:cNvPr id="3" name="Notes Placeholder 2"/>
+          <p:cNvSpPr>
+            <a:spLocks noGrp="1"/>
+          </p:cNvSpPr>
+          <p:nvPr>
+            <p:ph type="body" idx="3" sz="quarter"/>
+          </p:nvPr>
+        </p:nvSpPr>
+        <p:spPr/>
+        <p:txBody>
+          <a:bodyPr/>
+          <a:lstStyle/>
+          <a:p>
+            <a:r>
+              <a:t>The data is 4 samples from one donor: peripheral blood immune cells exposed to 40 nm particles, 200 nm particles, a 40+200 nm mixture, and an unexposed control. About 34,000 cells total. Be upfront: one donor, one sample per condition, so no biological replicates -- that shaped the statistics and I flag it throughout.</a:t>
+            </a:r>
+          </a:p>
+        </p:txBody>
+      </p:sp>
+      <p:sp>
+        <p:nvSpPr>
+          <p:cNvPr id="4" name="Slide Number Placeholder 3"/>
+          <p:cNvSpPr>
+            <a:spLocks noGrp="1"/>
+          </p:cNvSpPr>
+          <p:nvPr>
+            <p:ph type="sldNum" idx="5" sz="quarter"/>
+          </p:nvPr>
+        </p:nvSpPr>
+        <p:spPr/>
+      </p:sp>
+    </p:spTree>
+  </p:cSld>
+  <p:clrMapOvr>
+    <a:masterClrMapping/>
+  </p:clrMapOvr>
+</p:notes>
+</file>
+
+<file path=ppt/notesSlides/notesSlide3.xml><?xml version="1.0" encoding="utf-8"?>
+<p:notes xmlns:a="http://schemas.openxmlformats.org/drawingml/2006/main" xmlns:p="http://schemas.openxmlformats.org/presentationml/2006/main" xmlns:r="http://schemas.openxmlformats.org/officeDocument/2006/relationships">
+  <p:cSld>
+    <p:spTree>
+      <p:nvGrpSpPr>
+        <p:cNvPr id="1" name=""/>
+        <p:cNvGrpSpPr/>
+        <p:nvPr/>
+      </p:nvGrpSpPr>
+      <p:grpSpPr>
+        <a:xfrm>
+          <a:off x="0" y="0"/>
+          <a:ext cx="0" cy="0"/>
+          <a:chOff x="0" y="0"/>
+          <a:chExt cx="0" cy="0"/>
+        </a:xfrm>
+      </p:grpSpPr>
+      <p:sp>
+        <p:nvSpPr>
+          <p:cNvPr id="2" name="Slide Image Placeholder 1"/>
+          <p:cNvSpPr>
+            <a:spLocks noGrp="1"/>
+          </p:cNvSpPr>
+          <p:nvPr>
+            <p:ph type="sldImg" idx="2"/>
+          </p:nvPr>
+        </p:nvSpPr>
+        <p:spPr/>
+      </p:sp>
+      <p:sp>
+        <p:nvSpPr>
+          <p:cNvPr id="3" name="Notes Placeholder 2"/>
+          <p:cNvSpPr>
+            <a:spLocks noGrp="1"/>
+          </p:cNvSpPr>
+          <p:nvPr>
+            <p:ph type="body" idx="3" sz="quarter"/>
+          </p:nvPr>
+        </p:nvSpPr>
+        <p:spPr/>
+        <p:txBody>
+          <a:bodyPr/>
+          <a:lstStyle/>
+          <a:p>
+            <a:r>
+              <a:t>The analysis is one pipeline of six stages: QC, integration, annotation, composition, differential expression, and size-specific effects. A single command reproduces all of it from raw data, and each stage has automated tests.</a:t>
+            </a:r>
+          </a:p>
+        </p:txBody>
+      </p:sp>
+      <p:sp>
+        <p:nvSpPr>
+          <p:cNvPr id="4" name="Slide Number Placeholder 3"/>
+          <p:cNvSpPr>
+            <a:spLocks noGrp="1"/>
+          </p:cNvSpPr>
+          <p:nvPr>
+            <p:ph type="sldNum" idx="5" sz="quarter"/>
+          </p:nvPr>
+        </p:nvSpPr>
+        <p:spPr/>
+      </p:sp>
+    </p:spTree>
+  </p:cSld>
+  <p:clrMapOvr>
+    <a:masterClrMapping/>
+  </p:clrMapOvr>
+</p:notes>
+</file>
+
+<file path=ppt/notesSlides/notesSlide4.xml><?xml version="1.0" encoding="utf-8"?>
+<p:notes xmlns:a="http://schemas.openxmlformats.org/drawingml/2006/main" xmlns:p="http://schemas.openxmlformats.org/presentationml/2006/main" xmlns:r="http://schemas.openxmlformats.org/officeDocument/2006/relationships">
+  <p:cSld>
+    <p:spTree>
+      <p:nvGrpSpPr>
+        <p:cNvPr id="1" name=""/>
+        <p:cNvGrpSpPr/>
+        <p:nvPr/>
+      </p:nvGrpSpPr>
+      <p:grpSpPr>
+        <a:xfrm>
+          <a:off x="0" y="0"/>
+          <a:ext cx="0" cy="0"/>
+          <a:chOff x="0" y="0"/>
+          <a:chExt cx="0" cy="0"/>
+        </a:xfrm>
+      </p:grpSpPr>
+      <p:sp>
+        <p:nvSpPr>
+          <p:cNvPr id="2" name="Slide Image Placeholder 1"/>
+          <p:cNvSpPr>
+            <a:spLocks noGrp="1"/>
+          </p:cNvSpPr>
+          <p:nvPr>
+            <p:ph type="sldImg" idx="2"/>
+          </p:nvPr>
+        </p:nvSpPr>
+        <p:spPr/>
+      </p:sp>
+      <p:sp>
+        <p:nvSpPr>
+          <p:cNvPr id="3" name="Notes Placeholder 2"/>
+          <p:cNvSpPr>
+            <a:spLocks noGrp="1"/>
+          </p:cNvSpPr>
+          <p:nvPr>
+            <p:ph type="body" idx="3" sz="quarter"/>
+          </p:nvPr>
+        </p:nvSpPr>
+        <p:spPr/>
+        <p:txBody>
+          <a:bodyPr/>
+          <a:lstStyle/>
+          <a:p>
+            <a:r>
+              <a:t>Stage 1, quality control -- remove low-quality cells before trusting anything. Three violin plots, one per QC metric: n_genes_by_counts (genes detected per cell), total_counts (total UMIs per cell), and pct_counts_mt (percent mitochondrial reads). The y-axis on each is the value of that metric; the width of the violin is how many cells sit at that value. Cutoffs were set from the real distribution, not guessed: the upper gene cutoff near the 99th percentile removes likely doublets (two cells read as one), the mito cutoff between p95 and p99 removes dying cells.</a:t>
+            </a:r>
+          </a:p>
+        </p:txBody>
+      </p:sp>
+      <p:sp>
+        <p:nvSpPr>
+          <p:cNvPr id="4" name="Slide Number Placeholder 3"/>
+          <p:cNvSpPr>
+            <a:spLocks noGrp="1"/>
+          </p:cNvSpPr>
+          <p:nvPr>
+            <p:ph type="sldNum" idx="5" sz="quarter"/>
+          </p:nvPr>
+        </p:nvSpPr>
+        <p:spPr/>
+      </p:sp>
+    </p:spTree>
+  </p:cSld>
+  <p:clrMapOvr>
+    <a:masterClrMapping/>
+  </p:clrMapOvr>
+</p:notes>
+</file>
+
+<file path=ppt/notesSlides/notesSlide5.xml><?xml version="1.0" encoding="utf-8"?>
+<p:notes xmlns:a="http://schemas.openxmlformats.org/drawingml/2006/main" xmlns:p="http://schemas.openxmlformats.org/presentationml/2006/main" xmlns:r="http://schemas.openxmlformats.org/officeDocument/2006/relationships">
+  <p:cSld>
+    <p:spTree>
+      <p:nvGrpSpPr>
+        <p:cNvPr id="1" name=""/>
+        <p:cNvGrpSpPr/>
+        <p:nvPr/>
+      </p:nvGrpSpPr>
+      <p:grpSpPr>
+        <a:xfrm>
+          <a:off x="0" y="0"/>
+          <a:ext cx="0" cy="0"/>
+          <a:chOff x="0" y="0"/>
+          <a:chExt cx="0" cy="0"/>
+        </a:xfrm>
+      </p:grpSpPr>
+      <p:sp>
+        <p:nvSpPr>
+          <p:cNvPr id="2" name="Slide Image Placeholder 1"/>
+          <p:cNvSpPr>
+            <a:spLocks noGrp="1"/>
+          </p:cNvSpPr>
+          <p:nvPr>
+            <p:ph type="sldImg" idx="2"/>
+          </p:nvPr>
+        </p:nvSpPr>
+        <p:spPr/>
+      </p:sp>
+      <p:sp>
+        <p:nvSpPr>
+          <p:cNvPr id="3" name="Notes Placeholder 2"/>
+          <p:cNvSpPr>
+            <a:spLocks noGrp="1"/>
+          </p:cNvSpPr>
+          <p:nvPr>
+            <p:ph type="body" idx="3" sz="quarter"/>
+          </p:nvPr>
+        </p:nvSpPr>
+        <p:spPr/>
+        <p:txBody>
+          <a:bodyPr/>
+          <a:lstStyle/>
+          <a:p>
+            <a:r>
+              <a:t>Same QC stage, shown as a scatter. Each dot is one cell. X-axis is total_counts (total reads in the cell), y-axis is pct_counts_mt (percent mitochondrial). The threshold lines are drawn over the actual data -- cells that are high-mito or low-count fall outside them and get dropped. This is the same filtering as the violins, just showing the two metrics against each other.</a:t>
+            </a:r>
+          </a:p>
+        </p:txBody>
+      </p:sp>
+      <p:sp>
+        <p:nvSpPr>
+          <p:cNvPr id="4" name="Slide Number Placeholder 3"/>
+          <p:cNvSpPr>
+            <a:spLocks noGrp="1"/>
+          </p:cNvSpPr>
+          <p:nvPr>
+            <p:ph type="sldNum" idx="5" sz="quarter"/>
+          </p:nvPr>
+        </p:nvSpPr>
+        <p:spPr/>
+      </p:sp>
+    </p:spTree>
+  </p:cSld>
+  <p:clrMapOvr>
+    <a:masterClrMapping/>
+  </p:clrMapOvr>
+</p:notes>
+</file>
+
+<file path=ppt/notesSlides/notesSlide6.xml><?xml version="1.0" encoding="utf-8"?>
+<p:notes xmlns:a="http://schemas.openxmlformats.org/drawingml/2006/main" xmlns:p="http://schemas.openxmlformats.org/presentationml/2006/main" xmlns:r="http://schemas.openxmlformats.org/officeDocument/2006/relationships">
+  <p:cSld>
+    <p:spTree>
+      <p:nvGrpSpPr>
+        <p:cNvPr id="1" name=""/>
+        <p:cNvGrpSpPr/>
+        <p:nvPr/>
+      </p:nvGrpSpPr>
+      <p:grpSpPr>
+        <a:xfrm>
+          <a:off x="0" y="0"/>
+          <a:ext cx="0" cy="0"/>
+          <a:chOff x="0" y="0"/>
+          <a:chExt cx="0" cy="0"/>
+        </a:xfrm>
+      </p:grpSpPr>
+      <p:sp>
+        <p:nvSpPr>
+          <p:cNvPr id="2" name="Slide Image Placeholder 1"/>
+          <p:cNvSpPr>
+            <a:spLocks noGrp="1"/>
+          </p:cNvSpPr>
+          <p:nvPr>
+            <p:ph type="sldImg" idx="2"/>
+          </p:nvPr>
+        </p:nvSpPr>
+        <p:spPr/>
+      </p:sp>
+      <p:sp>
+        <p:nvSpPr>
+          <p:cNvPr id="3" name="Notes Placeholder 2"/>
+          <p:cNvSpPr>
+            <a:spLocks noGrp="1"/>
+          </p:cNvSpPr>
+          <p:nvPr>
+            <p:ph type="body" idx="3" sz="quarter"/>
+          </p:nvPr>
+        </p:nvSpPr>
+        <p:spPr/>
+        <p:txBody>
+          <a:bodyPr/>
+          <a:lstStyle/>
+          <a:p>
+            <a:r>
+              <a:t>Stage 2, integration. Both panels are UMAP plots -- a 2D map where nearby cells have similar expression; axes are UMAP1 and UMAP2 and have no units, only relative position matters. Colour = which sample a cell came from. LEFT (before correction): cells separate by sample -- a technical batch effect, not biology. RIGHT (after Harmony): the colours mix together and cells group by cell type instead. Caveat: because each condition is a single sample, batch and treatment are confounded, so the gene-level results later use the uncorrected data where this doesn't bias anything.</a:t>
+            </a:r>
+          </a:p>
+        </p:txBody>
+      </p:sp>
+      <p:sp>
+        <p:nvSpPr>
+          <p:cNvPr id="4" name="Slide Number Placeholder 3"/>
+          <p:cNvSpPr>
+            <a:spLocks noGrp="1"/>
+          </p:cNvSpPr>
+          <p:nvPr>
+            <p:ph type="sldNum" idx="5" sz="quarter"/>
+          </p:nvPr>
+        </p:nvSpPr>
+        <p:spPr/>
+      </p:sp>
+    </p:spTree>
+  </p:cSld>
+  <p:clrMapOvr>
+    <a:masterClrMapping/>
+  </p:clrMapOvr>
+</p:notes>
+</file>
+
+<file path=ppt/notesSlides/notesSlide7.xml><?xml version="1.0" encoding="utf-8"?>
+<p:notes xmlns:a="http://schemas.openxmlformats.org/drawingml/2006/main" xmlns:p="http://schemas.openxmlformats.org/presentationml/2006/main" xmlns:r="http://schemas.openxmlformats.org/officeDocument/2006/relationships">
+  <p:cSld>
+    <p:spTree>
+      <p:nvGrpSpPr>
+        <p:cNvPr id="1" name=""/>
+        <p:cNvGrpSpPr/>
+        <p:nvPr/>
+      </p:nvGrpSpPr>
+      <p:grpSpPr>
+        <a:xfrm>
+          <a:off x="0" y="0"/>
+          <a:ext cx="0" cy="0"/>
+          <a:chOff x="0" y="0"/>
+          <a:chExt cx="0" cy="0"/>
+        </a:xfrm>
+      </p:grpSpPr>
+      <p:sp>
+        <p:nvSpPr>
+          <p:cNvPr id="2" name="Slide Image Placeholder 1"/>
+          <p:cNvSpPr>
+            <a:spLocks noGrp="1"/>
+          </p:cNvSpPr>
+          <p:nvPr>
+            <p:ph type="sldImg" idx="2"/>
+          </p:nvPr>
+        </p:nvSpPr>
+        <p:spPr/>
+      </p:sp>
+      <p:sp>
+        <p:nvSpPr>
+          <p:cNvPr id="3" name="Notes Placeholder 2"/>
+          <p:cNvSpPr>
+            <a:spLocks noGrp="1"/>
+          </p:cNvSpPr>
+          <p:nvPr>
+            <p:ph type="body" idx="3" sz="quarter"/>
+          </p:nvPr>
+        </p:nvSpPr>
+        <p:spPr/>
+        <p:txBody>
+          <a:bodyPr/>
+          <a:lstStyle/>
+          <a:p>
+            <a:r>
+              <a:t>Stage 3, annotation. LEFT: the same UMAP (UMAP1 vs UMAP2), now coloured by cell-type lineage -- T cells, B cells, NK cells, monocytes. RIGHT: a marker dot-plot -- rows are cell types, columns are known marker genes; dot colour is mean expression and dot size is the fraction of cells expressing it, so a big dark dot means that gene is a clean marker for that type. I used celltypist plus markers, then cross-checked against two independent references already in the data (Azimuth 92.7%, CoDi 93.1%).</a:t>
+            </a:r>
+          </a:p>
+        </p:txBody>
+      </p:sp>
+      <p:sp>
+        <p:nvSpPr>
+          <p:cNvPr id="4" name="Slide Number Placeholder 3"/>
+          <p:cNvSpPr>
+            <a:spLocks noGrp="1"/>
+          </p:cNvSpPr>
+          <p:nvPr>
+            <p:ph type="sldNum" idx="5" sz="quarter"/>
+          </p:nvPr>
+        </p:nvSpPr>
+        <p:spPr/>
+      </p:sp>
+    </p:spTree>
+  </p:cSld>
+  <p:clrMapOvr>
+    <a:masterClrMapping/>
+  </p:clrMapOvr>
+</p:notes>
+</file>
+
+<file path=ppt/notesSlides/notesSlide8.xml><?xml version="1.0" encoding="utf-8"?>
+<p:notes xmlns:a="http://schemas.openxmlformats.org/drawingml/2006/main" xmlns:p="http://schemas.openxmlformats.org/presentationml/2006/main" xmlns:r="http://schemas.openxmlformats.org/officeDocument/2006/relationships">
+  <p:cSld>
+    <p:spTree>
+      <p:nvGrpSpPr>
+        <p:cNvPr id="1" name=""/>
+        <p:cNvGrpSpPr/>
+        <p:nvPr/>
+      </p:nvGrpSpPr>
+      <p:grpSpPr>
+        <a:xfrm>
+          <a:off x="0" y="0"/>
+          <a:ext cx="0" cy="0"/>
+          <a:chOff x="0" y="0"/>
+          <a:chExt cx="0" cy="0"/>
+        </a:xfrm>
+      </p:grpSpPr>
+      <p:sp>
+        <p:nvSpPr>
+          <p:cNvPr id="2" name="Slide Image Placeholder 1"/>
+          <p:cNvSpPr>
+            <a:spLocks noGrp="1"/>
+          </p:cNvSpPr>
+          <p:nvPr>
+            <p:ph type="sldImg" idx="2"/>
+          </p:nvPr>
+        </p:nvSpPr>
+        <p:spPr/>
+      </p:sp>
+      <p:sp>
+        <p:nvSpPr>
+          <p:cNvPr id="3" name="Notes Placeholder 2"/>
+          <p:cNvSpPr>
+            <a:spLocks noGrp="1"/>
+          </p:cNvSpPr>
+          <p:nvPr>
+            <p:ph type="body" idx="3" sz="quarter"/>
+          </p:nvPr>
+        </p:nvSpPr>
+        <p:spPr/>
+        <p:txBody>
+          <a:bodyPr/>
+          <a:lstStyle/>
+          <a:p>
+            <a:r>
+              <a:t>Stage 4, composition -- how the proportions of each cell type change across conditions. Y-axis on both is proportion of cells (fraction of the sample, 0 to 1). LEFT: stacked bars, one bar per sample, split into coloured cell-type bands. RIGHT: the same grouped by lineage so you can compare a type across samples side by side. The clear shift is monocytes under 200 nm -- roughly 2.5x more than control (log2 fold-change about +1.35) while other types barely move. No replicates, so these are descriptive proportions.</a:t>
+            </a:r>
+          </a:p>
+        </p:txBody>
+      </p:sp>
+      <p:sp>
+        <p:nvSpPr>
+          <p:cNvPr id="4" name="Slide Number Placeholder 3"/>
+          <p:cNvSpPr>
+            <a:spLocks noGrp="1"/>
+          </p:cNvSpPr>
+          <p:nvPr>
+            <p:ph type="sldNum" idx="5" sz="quarter"/>
+          </p:nvPr>
+        </p:nvSpPr>
+        <p:spPr/>
+      </p:sp>
+    </p:spTree>
+  </p:cSld>
+  <p:clrMapOvr>
+    <a:masterClrMapping/>
+  </p:clrMapOvr>
+</p:notes>
+</file>
+
+<file path=ppt/notesSlides/notesSlide9.xml><?xml version="1.0" encoding="utf-8"?>
+<p:notes xmlns:a="http://schemas.openxmlformats.org/drawingml/2006/main" xmlns:p="http://schemas.openxmlformats.org/presentationml/2006/main" xmlns:r="http://schemas.openxmlformats.org/officeDocument/2006/relationships">
+  <p:cSld>
+    <p:spTree>
+      <p:nvGrpSpPr>
+        <p:cNvPr id="1" name=""/>
+        <p:cNvGrpSpPr/>
+        <p:nvPr/>
+      </p:nvGrpSpPr>
+      <p:grpSpPr>
+        <a:xfrm>
+          <a:off x="0" y="0"/>
+          <a:ext cx="0" cy="0"/>
+          <a:chOff x="0" y="0"/>
+          <a:chExt cx="0" cy="0"/>
+        </a:xfrm>
+      </p:grpSpPr>
+      <p:sp>
+        <p:nvSpPr>
+          <p:cNvPr id="2" name="Slide Image Placeholder 1"/>
+          <p:cNvSpPr>
+            <a:spLocks noGrp="1"/>
+          </p:cNvSpPr>
+          <p:nvPr>
+            <p:ph type="sldImg" idx="2"/>
+          </p:nvPr>
+        </p:nvSpPr>
+        <p:spPr/>
+      </p:sp>
+      <p:sp>
+        <p:nvSpPr>
+          <p:cNvPr id="3" name="Notes Placeholder 2"/>
+          <p:cNvSpPr>
+            <a:spLocks noGrp="1"/>
+          </p:cNvSpPr>
+          <p:nvPr>
+            <p:ph type="body" idx="3" sz="quarter"/>
+          </p:nvPr>
+        </p:nvSpPr>
+        <p:spPr/>
+        <p:txBody>
+          <a:bodyPr/>
+          <a:lstStyle/>
+          <a:p>
+            <a:r>
+              <a:t>Stages 5 and 6 together. LEFT (dose-response): x-axis is particle size / condition, y-axis is the number of significant DE genes -- how many genes change on exposure. Monocytes stack highest (they eat and clear foreign particles) and 200 nm drives more than 40 nm: bigger particle, bigger response. RIGHT (size categories): grouped bars per lineage, y-axis = number of DE genes, split into four groups -- unique to 40 nm, unique to 200 nm, shared, and mixture-emergent (significant only in the mixture, neither single size). In monocytes about 180 genes are mixture-emergent: the combination does something the individual sizes do not.</a:t>
+            </a:r>
+          </a:p>
+        </p:txBody>
+      </p:sp>
+      <p:sp>
+        <p:nvSpPr>
+          <p:cNvPr id="4" name="Slide Number Placeholder 3"/>
+          <p:cNvSpPr>
+            <a:spLocks noGrp="1"/>
+          </p:cNvSpPr>
+          <p:nvPr>
+            <p:ph type="sldNum" idx="5" sz="quarter"/>
+          </p:nvPr>
+        </p:nvSpPr>
+        <p:spPr/>
+      </p:sp>
+    </p:spTree>
+  </p:cSld>
+  <p:clrMapOvr>
+    <a:masterClrMapping/>
+  </p:clrMapOvr>
+</p:notes>
 </file>
 
 <file path=ppt/slideLayouts/slideLayout1.xml><?xml version="1.0" encoding="utf-8"?>
@@ -175,9 +1630,10 @@
           <a:lstStyle/>
           <a:p>
             <a:r>
-              <a:rPr lang="en-US"/>
+              <a:rPr lang="en-US" smtClean="0"/>
               <a:t>Click to edit Master title style</a:t>
             </a:r>
+            <a:endParaRPr lang="en-US"/>
           </a:p>
         </p:txBody>
       </p:sp>
@@ -293,9 +1749,10 @@
           </a:lstStyle>
           <a:p>
             <a:r>
-              <a:rPr lang="en-US"/>
+              <a:rPr lang="en-US" smtClean="0"/>
               <a:t>Click to edit Master subtitle style</a:t>
             </a:r>
+            <a:endParaRPr lang="en-US"/>
           </a:p>
         </p:txBody>
       </p:sp>
@@ -316,7 +1773,7 @@
           <a:p>
             <a:fld id="{5BCAD085-E8A6-8845-BD4E-CB4CCA059FC4}" type="datetimeFigureOut">
               <a:rPr lang="en-US" smtClean="0"/>
-              <a:t>7/27/2026</a:t>
+              <a:t>1/27/13</a:t>
             </a:fld>
             <a:endParaRPr lang="en-US"/>
           </a:p>
@@ -410,9 +1867,10 @@
           <a:lstStyle/>
           <a:p>
             <a:r>
-              <a:rPr lang="en-US"/>
+              <a:rPr lang="en-US" smtClean="0"/>
               <a:t>Click to edit Master title style</a:t>
             </a:r>
+            <a:endParaRPr lang="en-US"/>
           </a:p>
         </p:txBody>
       </p:sp>
@@ -433,37 +1891,38 @@
           <a:p>
             <a:pPr lvl="0"/>
             <a:r>
-              <a:rPr lang="en-US"/>
+              <a:rPr lang="en-US" smtClean="0"/>
               <a:t>Click to edit Master text styles</a:t>
             </a:r>
           </a:p>
           <a:p>
             <a:pPr lvl="1"/>
             <a:r>
-              <a:rPr lang="en-US"/>
+              <a:rPr lang="en-US" smtClean="0"/>
               <a:t>Second level</a:t>
             </a:r>
           </a:p>
           <a:p>
             <a:pPr lvl="2"/>
             <a:r>
-              <a:rPr lang="en-US"/>
+              <a:rPr lang="en-US" smtClean="0"/>
               <a:t>Third level</a:t>
             </a:r>
           </a:p>
           <a:p>
             <a:pPr lvl="3"/>
             <a:r>
-              <a:rPr lang="en-US"/>
+              <a:rPr lang="en-US" smtClean="0"/>
               <a:t>Fourth level</a:t>
             </a:r>
           </a:p>
           <a:p>
             <a:pPr lvl="4"/>
             <a:r>
-              <a:rPr lang="en-US"/>
+              <a:rPr lang="en-US" smtClean="0"/>
               <a:t>Fifth level</a:t>
             </a:r>
+            <a:endParaRPr lang="en-US"/>
           </a:p>
         </p:txBody>
       </p:sp>
@@ -484,7 +1943,7 @@
           <a:p>
             <a:fld id="{5BCAD085-E8A6-8845-BD4E-CB4CCA059FC4}" type="datetimeFigureOut">
               <a:rPr lang="en-US" smtClean="0"/>
-              <a:t>7/27/2026</a:t>
+              <a:t>1/27/13</a:t>
             </a:fld>
             <a:endParaRPr lang="en-US"/>
           </a:p>
@@ -583,9 +2042,10 @@
           <a:lstStyle/>
           <a:p>
             <a:r>
-              <a:rPr lang="en-US"/>
+              <a:rPr lang="en-US" smtClean="0"/>
               <a:t>Click to edit Master title style</a:t>
             </a:r>
+            <a:endParaRPr lang="en-US"/>
           </a:p>
         </p:txBody>
       </p:sp>
@@ -611,37 +2071,38 @@
           <a:p>
             <a:pPr lvl="0"/>
             <a:r>
-              <a:rPr lang="en-US"/>
+              <a:rPr lang="en-US" smtClean="0"/>
               <a:t>Click to edit Master text styles</a:t>
             </a:r>
           </a:p>
           <a:p>
             <a:pPr lvl="1"/>
             <a:r>
-              <a:rPr lang="en-US"/>
+              <a:rPr lang="en-US" smtClean="0"/>
               <a:t>Second level</a:t>
             </a:r>
           </a:p>
           <a:p>
             <a:pPr lvl="2"/>
             <a:r>
-              <a:rPr lang="en-US"/>
+              <a:rPr lang="en-US" smtClean="0"/>
               <a:t>Third level</a:t>
             </a:r>
           </a:p>
           <a:p>
             <a:pPr lvl="3"/>
             <a:r>
-              <a:rPr lang="en-US"/>
+              <a:rPr lang="en-US" smtClean="0"/>
               <a:t>Fourth level</a:t>
             </a:r>
           </a:p>
           <a:p>
             <a:pPr lvl="4"/>
             <a:r>
-              <a:rPr lang="en-US"/>
+              <a:rPr lang="en-US" smtClean="0"/>
               <a:t>Fifth level</a:t>
             </a:r>
+            <a:endParaRPr lang="en-US"/>
           </a:p>
         </p:txBody>
       </p:sp>
@@ -662,7 +2123,7 @@
           <a:p>
             <a:fld id="{5BCAD085-E8A6-8845-BD4E-CB4CCA059FC4}" type="datetimeFigureOut">
               <a:rPr lang="en-US" smtClean="0"/>
-              <a:t>7/27/2026</a:t>
+              <a:t>1/27/13</a:t>
             </a:fld>
             <a:endParaRPr lang="en-US"/>
           </a:p>
@@ -756,9 +2217,10 @@
           <a:lstStyle/>
           <a:p>
             <a:r>
-              <a:rPr lang="en-US"/>
+              <a:rPr lang="en-US" smtClean="0"/>
               <a:t>Click to edit Master title style</a:t>
             </a:r>
+            <a:endParaRPr lang="en-US"/>
           </a:p>
         </p:txBody>
       </p:sp>
@@ -779,37 +2241,38 @@
           <a:p>
             <a:pPr lvl="0"/>
             <a:r>
-              <a:rPr lang="en-US"/>
+              <a:rPr lang="en-US" smtClean="0"/>
               <a:t>Click to edit Master text styles</a:t>
             </a:r>
           </a:p>
           <a:p>
             <a:pPr lvl="1"/>
             <a:r>
-              <a:rPr lang="en-US"/>
+              <a:rPr lang="en-US" smtClean="0"/>
               <a:t>Second level</a:t>
             </a:r>
           </a:p>
           <a:p>
             <a:pPr lvl="2"/>
             <a:r>
-              <a:rPr lang="en-US"/>
+              <a:rPr lang="en-US" smtClean="0"/>
               <a:t>Third level</a:t>
             </a:r>
           </a:p>
           <a:p>
             <a:pPr lvl="3"/>
             <a:r>
-              <a:rPr lang="en-US"/>
+              <a:rPr lang="en-US" smtClean="0"/>
               <a:t>Fourth level</a:t>
             </a:r>
           </a:p>
           <a:p>
             <a:pPr lvl="4"/>
             <a:r>
-              <a:rPr lang="en-US"/>
+              <a:rPr lang="en-US" smtClean="0"/>
               <a:t>Fifth level</a:t>
             </a:r>
+            <a:endParaRPr lang="en-US"/>
           </a:p>
         </p:txBody>
       </p:sp>
@@ -830,7 +2293,7 @@
           <a:p>
             <a:fld id="{5BCAD085-E8A6-8845-BD4E-CB4CCA059FC4}" type="datetimeFigureOut">
               <a:rPr lang="en-US" smtClean="0"/>
-              <a:t>7/27/2026</a:t>
+              <a:t>1/27/13</a:t>
             </a:fld>
             <a:endParaRPr lang="en-US"/>
           </a:p>
@@ -933,9 +2396,10 @@
           </a:lstStyle>
           <a:p>
             <a:r>
-              <a:rPr lang="en-US"/>
+              <a:rPr lang="en-US" smtClean="0"/>
               <a:t>Click to edit Master title style</a:t>
             </a:r>
+            <a:endParaRPr lang="en-US"/>
           </a:p>
         </p:txBody>
       </p:sp>
@@ -1052,7 +2516,7 @@
           <a:p>
             <a:pPr lvl="0"/>
             <a:r>
-              <a:rPr lang="en-US"/>
+              <a:rPr lang="en-US" smtClean="0"/>
               <a:t>Click to edit Master text styles</a:t>
             </a:r>
           </a:p>
@@ -1075,7 +2539,7 @@
           <a:p>
             <a:fld id="{5BCAD085-E8A6-8845-BD4E-CB4CCA059FC4}" type="datetimeFigureOut">
               <a:rPr lang="en-US" smtClean="0"/>
-              <a:t>7/27/2026</a:t>
+              <a:t>1/27/13</a:t>
             </a:fld>
             <a:endParaRPr lang="en-US"/>
           </a:p>
@@ -1169,9 +2633,10 @@
           <a:lstStyle/>
           <a:p>
             <a:r>
-              <a:rPr lang="en-US"/>
+              <a:rPr lang="en-US" smtClean="0"/>
               <a:t>Click to edit Master title style</a:t>
             </a:r>
+            <a:endParaRPr lang="en-US"/>
           </a:p>
         </p:txBody>
       </p:sp>
@@ -1225,37 +2690,38 @@
           <a:p>
             <a:pPr lvl="0"/>
             <a:r>
-              <a:rPr lang="en-US"/>
+              <a:rPr lang="en-US" smtClean="0"/>
               <a:t>Click to edit Master text styles</a:t>
             </a:r>
           </a:p>
           <a:p>
             <a:pPr lvl="1"/>
             <a:r>
-              <a:rPr lang="en-US"/>
+              <a:rPr lang="en-US" smtClean="0"/>
               <a:t>Second level</a:t>
             </a:r>
           </a:p>
           <a:p>
             <a:pPr lvl="2"/>
             <a:r>
-              <a:rPr lang="en-US"/>
+              <a:rPr lang="en-US" smtClean="0"/>
               <a:t>Third level</a:t>
             </a:r>
           </a:p>
           <a:p>
             <a:pPr lvl="3"/>
             <a:r>
-              <a:rPr lang="en-US"/>
+              <a:rPr lang="en-US" smtClean="0"/>
               <a:t>Fourth level</a:t>
             </a:r>
           </a:p>
           <a:p>
             <a:pPr lvl="4"/>
             <a:r>
-              <a:rPr lang="en-US"/>
+              <a:rPr lang="en-US" smtClean="0"/>
               <a:t>Fifth level</a:t>
             </a:r>
+            <a:endParaRPr lang="en-US"/>
           </a:p>
         </p:txBody>
       </p:sp>
@@ -1309,37 +2775,38 @@
           <a:p>
             <a:pPr lvl="0"/>
             <a:r>
-              <a:rPr lang="en-US"/>
+              <a:rPr lang="en-US" smtClean="0"/>
               <a:t>Click to edit Master text styles</a:t>
             </a:r>
           </a:p>
           <a:p>
             <a:pPr lvl="1"/>
             <a:r>
-              <a:rPr lang="en-US"/>
+              <a:rPr lang="en-US" smtClean="0"/>
               <a:t>Second level</a:t>
             </a:r>
           </a:p>
           <a:p>
             <a:pPr lvl="2"/>
             <a:r>
-              <a:rPr lang="en-US"/>
+              <a:rPr lang="en-US" smtClean="0"/>
               <a:t>Third level</a:t>
             </a:r>
           </a:p>
           <a:p>
             <a:pPr lvl="3"/>
             <a:r>
-              <a:rPr lang="en-US"/>
+              <a:rPr lang="en-US" smtClean="0"/>
               <a:t>Fourth level</a:t>
             </a:r>
           </a:p>
           <a:p>
             <a:pPr lvl="4"/>
             <a:r>
-              <a:rPr lang="en-US"/>
+              <a:rPr lang="en-US" smtClean="0"/>
               <a:t>Fifth level</a:t>
             </a:r>
+            <a:endParaRPr lang="en-US"/>
           </a:p>
         </p:txBody>
       </p:sp>
@@ -1360,7 +2827,7 @@
           <a:p>
             <a:fld id="{5BCAD085-E8A6-8845-BD4E-CB4CCA059FC4}" type="datetimeFigureOut">
               <a:rPr lang="en-US" smtClean="0"/>
-              <a:t>7/27/2026</a:t>
+              <a:t>1/27/13</a:t>
             </a:fld>
             <a:endParaRPr lang="en-US"/>
           </a:p>
@@ -1458,9 +2925,10 @@
           </a:lstStyle>
           <a:p>
             <a:r>
-              <a:rPr lang="en-US"/>
+              <a:rPr lang="en-US" smtClean="0"/>
               <a:t>Click to edit Master title style</a:t>
             </a:r>
+            <a:endParaRPr lang="en-US"/>
           </a:p>
         </p:txBody>
       </p:sp>
@@ -1523,7 +2991,7 @@
           <a:p>
             <a:pPr lvl="0"/>
             <a:r>
-              <a:rPr lang="en-US"/>
+              <a:rPr lang="en-US" smtClean="0"/>
               <a:t>Click to edit Master text styles</a:t>
             </a:r>
           </a:p>
@@ -1579,37 +3047,38 @@
           <a:p>
             <a:pPr lvl="0"/>
             <a:r>
-              <a:rPr lang="en-US"/>
+              <a:rPr lang="en-US" smtClean="0"/>
               <a:t>Click to edit Master text styles</a:t>
             </a:r>
           </a:p>
           <a:p>
             <a:pPr lvl="1"/>
             <a:r>
-              <a:rPr lang="en-US"/>
+              <a:rPr lang="en-US" smtClean="0"/>
               <a:t>Second level</a:t>
             </a:r>
           </a:p>
           <a:p>
             <a:pPr lvl="2"/>
             <a:r>
-              <a:rPr lang="en-US"/>
+              <a:rPr lang="en-US" smtClean="0"/>
               <a:t>Third level</a:t>
             </a:r>
           </a:p>
           <a:p>
             <a:pPr lvl="3"/>
             <a:r>
-              <a:rPr lang="en-US"/>
+              <a:rPr lang="en-US" smtClean="0"/>
               <a:t>Fourth level</a:t>
             </a:r>
           </a:p>
           <a:p>
             <a:pPr lvl="4"/>
             <a:r>
-              <a:rPr lang="en-US"/>
+              <a:rPr lang="en-US" smtClean="0"/>
               <a:t>Fifth level</a:t>
             </a:r>
+            <a:endParaRPr lang="en-US"/>
           </a:p>
         </p:txBody>
       </p:sp>
@@ -1672,7 +3141,7 @@
           <a:p>
             <a:pPr lvl="0"/>
             <a:r>
-              <a:rPr lang="en-US"/>
+              <a:rPr lang="en-US" smtClean="0"/>
               <a:t>Click to edit Master text styles</a:t>
             </a:r>
           </a:p>
@@ -1728,37 +3197,38 @@
           <a:p>
             <a:pPr lvl="0"/>
             <a:r>
-              <a:rPr lang="en-US"/>
+              <a:rPr lang="en-US" smtClean="0"/>
               <a:t>Click to edit Master text styles</a:t>
             </a:r>
           </a:p>
           <a:p>
             <a:pPr lvl="1"/>
             <a:r>
-              <a:rPr lang="en-US"/>
+              <a:rPr lang="en-US" smtClean="0"/>
               <a:t>Second level</a:t>
             </a:r>
           </a:p>
           <a:p>
             <a:pPr lvl="2"/>
             <a:r>
-              <a:rPr lang="en-US"/>
+              <a:rPr lang="en-US" smtClean="0"/>
               <a:t>Third level</a:t>
             </a:r>
           </a:p>
           <a:p>
             <a:pPr lvl="3"/>
             <a:r>
-              <a:rPr lang="en-US"/>
+              <a:rPr lang="en-US" smtClean="0"/>
               <a:t>Fourth level</a:t>
             </a:r>
           </a:p>
           <a:p>
             <a:pPr lvl="4"/>
             <a:r>
-              <a:rPr lang="en-US"/>
+              <a:rPr lang="en-US" smtClean="0"/>
               <a:t>Fifth level</a:t>
             </a:r>
+            <a:endParaRPr lang="en-US"/>
           </a:p>
         </p:txBody>
       </p:sp>
@@ -1779,7 +3249,7 @@
           <a:p>
             <a:fld id="{5BCAD085-E8A6-8845-BD4E-CB4CCA059FC4}" type="datetimeFigureOut">
               <a:rPr lang="en-US" smtClean="0"/>
-              <a:t>7/27/2026</a:t>
+              <a:t>1/27/13</a:t>
             </a:fld>
             <a:endParaRPr lang="en-US"/>
           </a:p>
@@ -1873,9 +3343,10 @@
           <a:lstStyle/>
           <a:p>
             <a:r>
-              <a:rPr lang="en-US"/>
+              <a:rPr lang="en-US" smtClean="0"/>
               <a:t>Click to edit Master title style</a:t>
             </a:r>
+            <a:endParaRPr lang="en-US"/>
           </a:p>
         </p:txBody>
       </p:sp>
@@ -1896,7 +3367,7 @@
           <a:p>
             <a:fld id="{5BCAD085-E8A6-8845-BD4E-CB4CCA059FC4}" type="datetimeFigureOut">
               <a:rPr lang="en-US" smtClean="0"/>
-              <a:t>7/27/2026</a:t>
+              <a:t>1/27/13</a:t>
             </a:fld>
             <a:endParaRPr lang="en-US"/>
           </a:p>
@@ -1991,7 +3462,7 @@
           <a:p>
             <a:fld id="{5BCAD085-E8A6-8845-BD4E-CB4CCA059FC4}" type="datetimeFigureOut">
               <a:rPr lang="en-US" smtClean="0"/>
-              <a:t>7/27/2026</a:t>
+              <a:t>1/27/13</a:t>
             </a:fld>
             <a:endParaRPr lang="en-US"/>
           </a:p>
@@ -2094,9 +3565,10 @@
           </a:lstStyle>
           <a:p>
             <a:r>
-              <a:rPr lang="en-US"/>
+              <a:rPr lang="en-US" smtClean="0"/>
               <a:t>Click to edit Master title style</a:t>
             </a:r>
+            <a:endParaRPr lang="en-US"/>
           </a:p>
         </p:txBody>
       </p:sp>
@@ -2150,37 +3622,38 @@
           <a:p>
             <a:pPr lvl="0"/>
             <a:r>
-              <a:rPr lang="en-US"/>
+              <a:rPr lang="en-US" smtClean="0"/>
               <a:t>Click to edit Master text styles</a:t>
             </a:r>
           </a:p>
           <a:p>
             <a:pPr lvl="1"/>
             <a:r>
-              <a:rPr lang="en-US"/>
+              <a:rPr lang="en-US" smtClean="0"/>
               <a:t>Second level</a:t>
             </a:r>
           </a:p>
           <a:p>
             <a:pPr lvl="2"/>
             <a:r>
-              <a:rPr lang="en-US"/>
+              <a:rPr lang="en-US" smtClean="0"/>
               <a:t>Third level</a:t>
             </a:r>
           </a:p>
           <a:p>
             <a:pPr lvl="3"/>
             <a:r>
-              <a:rPr lang="en-US"/>
+              <a:rPr lang="en-US" smtClean="0"/>
               <a:t>Fourth level</a:t>
             </a:r>
           </a:p>
           <a:p>
             <a:pPr lvl="4"/>
             <a:r>
-              <a:rPr lang="en-US"/>
+              <a:rPr lang="en-US" smtClean="0"/>
               <a:t>Fifth level</a:t>
             </a:r>
+            <a:endParaRPr lang="en-US"/>
           </a:p>
         </p:txBody>
       </p:sp>
@@ -2243,7 +3716,7 @@
           <a:p>
             <a:pPr lvl="0"/>
             <a:r>
-              <a:rPr lang="en-US"/>
+              <a:rPr lang="en-US" smtClean="0"/>
               <a:t>Click to edit Master text styles</a:t>
             </a:r>
           </a:p>
@@ -2266,7 +3739,7 @@
           <a:p>
             <a:fld id="{5BCAD085-E8A6-8845-BD4E-CB4CCA059FC4}" type="datetimeFigureOut">
               <a:rPr lang="en-US" smtClean="0"/>
-              <a:t>7/27/2026</a:t>
+              <a:t>1/27/13</a:t>
             </a:fld>
             <a:endParaRPr lang="en-US"/>
           </a:p>
@@ -2369,9 +3842,10 @@
           </a:lstStyle>
           <a:p>
             <a:r>
-              <a:rPr lang="en-US"/>
+              <a:rPr lang="en-US" smtClean="0"/>
               <a:t>Click to edit Master title style</a:t>
             </a:r>
+            <a:endParaRPr lang="en-US"/>
           </a:p>
         </p:txBody>
       </p:sp>
@@ -2495,7 +3969,7 @@
           <a:p>
             <a:pPr lvl="0"/>
             <a:r>
-              <a:rPr lang="en-US"/>
+              <a:rPr lang="en-US" smtClean="0"/>
               <a:t>Click to edit Master text styles</a:t>
             </a:r>
           </a:p>
@@ -2518,7 +3992,7 @@
           <a:p>
             <a:fld id="{5BCAD085-E8A6-8845-BD4E-CB4CCA059FC4}" type="datetimeFigureOut">
               <a:rPr lang="en-US" smtClean="0"/>
-              <a:t>7/27/2026</a:t>
+              <a:t>1/27/13</a:t>
             </a:fld>
             <a:endParaRPr lang="en-US"/>
           </a:p>
@@ -2627,9 +4101,10 @@
           <a:lstStyle/>
           <a:p>
             <a:r>
-              <a:rPr lang="en-US"/>
+              <a:rPr lang="en-US" smtClean="0"/>
               <a:t>Click to edit Master title style</a:t>
             </a:r>
+            <a:endParaRPr lang="en-US"/>
           </a:p>
         </p:txBody>
       </p:sp>
@@ -2660,37 +4135,38 @@
           <a:p>
             <a:pPr lvl="0"/>
             <a:r>
-              <a:rPr lang="en-US"/>
+              <a:rPr lang="en-US" smtClean="0"/>
               <a:t>Click to edit Master text styles</a:t>
             </a:r>
           </a:p>
           <a:p>
             <a:pPr lvl="1"/>
             <a:r>
-              <a:rPr lang="en-US"/>
+              <a:rPr lang="en-US" smtClean="0"/>
               <a:t>Second level</a:t>
             </a:r>
           </a:p>
           <a:p>
             <a:pPr lvl="2"/>
             <a:r>
-              <a:rPr lang="en-US"/>
+              <a:rPr lang="en-US" smtClean="0"/>
               <a:t>Third level</a:t>
             </a:r>
           </a:p>
           <a:p>
             <a:pPr lvl="3"/>
             <a:r>
-              <a:rPr lang="en-US"/>
+              <a:rPr lang="en-US" smtClean="0"/>
               <a:t>Fourth level</a:t>
             </a:r>
           </a:p>
           <a:p>
             <a:pPr lvl="4"/>
             <a:r>
-              <a:rPr lang="en-US"/>
+              <a:rPr lang="en-US" smtClean="0"/>
               <a:t>Fifth level</a:t>
             </a:r>
+            <a:endParaRPr lang="en-US"/>
           </a:p>
         </p:txBody>
       </p:sp>
@@ -2729,7 +4205,7 @@
           <a:p>
             <a:fld id="{5BCAD085-E8A6-8845-BD4E-CB4CCA059FC4}" type="datetimeFigureOut">
               <a:rPr lang="en-US" smtClean="0"/>
-              <a:t>7/27/2026</a:t>
+              <a:t>1/27/13</a:t>
             </a:fld>
             <a:endParaRPr lang="en-US"/>
           </a:p>
@@ -3088,7 +4564,7 @@
 </file>
 
 <file path=ppt/slides/slide1.xml><?xml version="1.0" encoding="utf-8"?>
-<p:sld xmlns:a="http://schemas.openxmlformats.org/drawingml/2006/main" xmlns:r="http://schemas.openxmlformats.org/officeDocument/2006/relationships" xmlns:p="http://schemas.openxmlformats.org/presentationml/2006/main">
+<p:sld xmlns:a="http://schemas.openxmlformats.org/drawingml/2006/main" xmlns:p="http://schemas.openxmlformats.org/presentationml/2006/main" xmlns:r="http://schemas.openxmlformats.org/officeDocument/2006/relationships">
   <p:cSld>
     <p:spTree>
       <p:nvGrpSpPr>
@@ -3096,14 +4572,7 @@
         <p:cNvGrpSpPr/>
         <p:nvPr/>
       </p:nvGrpSpPr>
-      <p:grpSpPr>
-        <a:xfrm>
-          <a:off x="0" y="0"/>
-          <a:ext cx="0" cy="0"/>
-          <a:chOff x="0" y="0"/>
-          <a:chExt cx="0" cy="0"/>
-        </a:xfrm>
-      </p:grpSpPr>
+      <p:grpSpPr/>
       <p:sp>
         <p:nvSpPr>
           <p:cNvPr id="2" name="Title 1"/>
@@ -3151,40 +4620,8 @@
           <a:lstStyle/>
           <a:p>
             <a:r>
-              <a:rPr dirty="0" err="1"/>
-              <a:t>scRNA</a:t>
-            </a:r>
-            <a:r>
-              <a:rPr dirty="0"/>
-              <a:t>-seq of human PBMCs exposed to </a:t>
-            </a:r>
-            <a:br>
-              <a:rPr lang="en-US" dirty="0"/>
-            </a:br>
-            <a:r>
-              <a:rPr dirty="0"/>
-              <a:t>40 nm / 200 nm / mixed polystyrene nanoparticles vs control </a:t>
-            </a:r>
-            <a:endParaRPr lang="en-US" dirty="0"/>
-          </a:p>
-          <a:p>
-            <a:r>
-              <a:rPr dirty="0"/>
-              <a:t>Genom</a:t>
-            </a:r>
-            <a:r>
-              <a:rPr lang="en-US" dirty="0"/>
-              <a:t>e</a:t>
-            </a:r>
-            <a:r>
-              <a:rPr dirty="0"/>
-              <a:t> Informatics, ETF</a:t>
-            </a:r>
-            <a:r>
-              <a:rPr lang="en-US" dirty="0"/>
-              <a:t> Belgrade, 2026</a:t>
-            </a:r>
-            <a:endParaRPr dirty="0"/>
+              <a:t>scRNA-seq of human PBMCs exposed to 40 nm / 200 nm / mixed polystyrene nanoparticles vs control  -  Genomics Informatics, ETF</a:t>
+            </a:r>
           </a:p>
         </p:txBody>
       </p:sp>
@@ -3197,7 +4634,7 @@
 </file>
 
 <file path=ppt/slides/slide10.xml><?xml version="1.0" encoding="utf-8"?>
-<p:sld xmlns:a="http://schemas.openxmlformats.org/drawingml/2006/main" xmlns:r="http://schemas.openxmlformats.org/officeDocument/2006/relationships" xmlns:p="http://schemas.openxmlformats.org/presentationml/2006/main">
+<p:sld xmlns:a="http://schemas.openxmlformats.org/drawingml/2006/main" xmlns:p="http://schemas.openxmlformats.org/presentationml/2006/main" xmlns:r="http://schemas.openxmlformats.org/officeDocument/2006/relationships">
   <p:cSld>
     <p:spTree>
       <p:nvGrpSpPr>
@@ -3205,14 +4642,7 @@
         <p:cNvGrpSpPr/>
         <p:nvPr/>
       </p:nvGrpSpPr>
-      <p:grpSpPr>
-        <a:xfrm>
-          <a:off x="0" y="0"/>
-          <a:ext cx="0" cy="0"/>
-          <a:chOff x="0" y="0"/>
-          <a:chExt cx="0" cy="0"/>
-        </a:xfrm>
-      </p:grpSpPr>
+      <p:grpSpPr/>
       <p:sp>
         <p:nvSpPr>
           <p:cNvPr id="2" name="Title 1"/>
@@ -3256,25 +4686,14 @@
           </a:xfrm>
         </p:spPr>
         <p:txBody>
-          <a:bodyPr>
-            <a:normAutofit/>
-          </a:bodyPr>
+          <a:bodyPr/>
           <a:lstStyle/>
           <a:p>
             <a:pPr>
               <a:defRPr sz="1800"/>
             </a:pPr>
             <a:r>
-              <a:rPr sz="2400" dirty="0"/>
-              <a:t>Monocytes show the strongest transcriptional response to </a:t>
-            </a:r>
-            <a:r>
-              <a:rPr sz="2400" dirty="0" err="1"/>
-              <a:t>nanoplastic</a:t>
-            </a:r>
-            <a:r>
-              <a:rPr sz="2400" dirty="0"/>
-              <a:t>.</a:t>
+              <a:t>Monocytes show the strongest transcriptional response to nanoplastic.</a:t>
             </a:r>
           </a:p>
           <a:p>
@@ -3282,7 +4701,6 @@
               <a:defRPr sz="1800"/>
             </a:pPr>
             <a:r>
-              <a:rPr sz="2400" dirty="0"/>
               <a:t>200 nm particles drive MORE lineage-unique genes than 40 nm.</a:t>
             </a:r>
           </a:p>
@@ -3291,19 +4709,7 @@
               <a:defRPr sz="1800"/>
             </a:pPr>
             <a:r>
-              <a:rPr sz="2400" dirty="0"/>
-              <a:t>The 40+200 nm mixture produces an EMERGENT monocyte response </a:t>
-            </a:r>
-            <a:r>
-              <a:rPr lang="en-US" sz="2400" dirty="0"/>
-              <a:t>– </a:t>
-            </a:r>
-            <a:br>
-              <a:rPr lang="en-US" sz="2400" dirty="0"/>
-            </a:br>
-            <a:r>
-              <a:rPr sz="2400" dirty="0"/>
-              <a:t>genes significant only in the mixture, in neither single size.</a:t>
+              <a:t>The 40+200 nm mixture produces an EMERGENT monocyte response -</a:t>
             </a:r>
           </a:p>
           <a:p>
@@ -3311,7 +4717,14 @@
               <a:defRPr sz="1800"/>
             </a:pPr>
             <a:r>
-              <a:rPr sz="2400" dirty="0"/>
+              <a:t>  genes significant only in the mixture, in neither single size.</a:t>
+            </a:r>
+          </a:p>
+          <a:p>
+            <a:pPr>
+              <a:defRPr sz="1800"/>
+            </a:pPr>
+            <a:r>
               <a:t>In lymphocytes the mixture is weaker than either size (sub-additive).</a:t>
             </a:r>
           </a:p>
@@ -3326,7 +4739,7 @@
 </file>
 
 <file path=ppt/slides/slide11.xml><?xml version="1.0" encoding="utf-8"?>
-<p:sld xmlns:a="http://schemas.openxmlformats.org/drawingml/2006/main" xmlns:r="http://schemas.openxmlformats.org/officeDocument/2006/relationships" xmlns:p="http://schemas.openxmlformats.org/presentationml/2006/main">
+<p:sld xmlns:a="http://schemas.openxmlformats.org/drawingml/2006/main" xmlns:p="http://schemas.openxmlformats.org/presentationml/2006/main" xmlns:r="http://schemas.openxmlformats.org/officeDocument/2006/relationships">
   <p:cSld>
     <p:spTree>
       <p:nvGrpSpPr>
@@ -3334,14 +4747,7 @@
         <p:cNvGrpSpPr/>
         <p:nvPr/>
       </p:nvGrpSpPr>
-      <p:grpSpPr>
-        <a:xfrm>
-          <a:off x="0" y="0"/>
-          <a:ext cx="0" cy="0"/>
-          <a:chOff x="0" y="0"/>
-          <a:chExt cx="0" cy="0"/>
-        </a:xfrm>
-      </p:grpSpPr>
+      <p:grpSpPr/>
       <p:sp>
         <p:nvSpPr>
           <p:cNvPr id="2" name="Title 1"/>
@@ -3385,16 +4791,13 @@
           </a:xfrm>
         </p:spPr>
         <p:txBody>
-          <a:bodyPr>
-            <a:normAutofit/>
-          </a:bodyPr>
+          <a:bodyPr/>
           <a:lstStyle/>
           <a:p>
             <a:pPr>
               <a:defRPr sz="1800"/>
             </a:pPr>
             <a:r>
-              <a:rPr sz="2400" dirty="0"/>
               <a:t>The 180 mixture-only monocyte genes are dominated by INFLAMMATION.</a:t>
             </a:r>
           </a:p>
@@ -3403,27 +4806,7 @@
               <a:defRPr sz="1800"/>
             </a:pPr>
             <a:r>
-              <a:rPr sz="2400" dirty="0"/>
-              <a:t>Pathway enrichment (p ~ 1e-21): interleukin, cytokine &amp; TNF </a:t>
-            </a:r>
-            <a:r>
-              <a:rPr sz="2400" dirty="0" err="1"/>
-              <a:t>signalling</a:t>
-            </a:r>
-            <a:r>
-              <a:rPr sz="2400" dirty="0"/>
-              <a:t>,</a:t>
-            </a:r>
-            <a:r>
-              <a:rPr lang="en-US" sz="2400" dirty="0"/>
-              <a:t> </a:t>
-            </a:r>
-            <a:br>
-              <a:rPr lang="en-US" sz="2400" dirty="0"/>
-            </a:br>
-            <a:r>
-              <a:rPr sz="2400" dirty="0"/>
-              <a:t>and 'response to lipopolysaccharide' - i.e. a bacterial-attack-like program.</a:t>
+              <a:t>Pathway enrichment (p ~ 1e-21): interleukin, cytokine &amp; TNF signalling,</a:t>
             </a:r>
           </a:p>
           <a:p>
@@ -3431,16 +4814,7 @@
               <a:defRPr sz="1800"/>
             </a:pPr>
             <a:r>
-              <a:rPr sz="2400" dirty="0"/>
-              <a:t>Top mixture-only genes up: RIPK2, TRAF1, PIK3CB (innate/TNF </a:t>
-            </a:r>
-            <a:r>
-              <a:rPr sz="2400" dirty="0" err="1"/>
-              <a:t>signalling</a:t>
-            </a:r>
-            <a:r>
-              <a:rPr sz="2400" dirty="0"/>
-              <a:t>).</a:t>
+              <a:t>  and 'response to lipopolysaccharide' - i.e. a bacterial-attack-like program.</a:t>
             </a:r>
           </a:p>
           <a:p>
@@ -3448,19 +4822,7 @@
               <a:defRPr sz="1800"/>
             </a:pPr>
             <a:r>
-              <a:rPr sz="2400" dirty="0"/>
-              <a:t>Interpretation: two sub-threshold exposures together push monocytes over</a:t>
-            </a:r>
-            <a:r>
-              <a:rPr lang="en-US" sz="2400" dirty="0"/>
-              <a:t> </a:t>
-            </a:r>
-            <a:br>
-              <a:rPr lang="en-US" sz="2400" dirty="0"/>
-            </a:br>
-            <a:r>
-              <a:rPr sz="2400" dirty="0"/>
-              <a:t>an inflammatory activation threshold - an emergent, non-additive effect.</a:t>
+              <a:t>Top mixture-only genes up: RIPK2, TRAF1, PIK3CB (innate/TNF signalling).</a:t>
             </a:r>
           </a:p>
           <a:p>
@@ -3468,7 +4830,22 @@
               <a:defRPr sz="1800"/>
             </a:pPr>
             <a:r>
-              <a:rPr sz="2400" dirty="0"/>
+              <a:t>Interpretation: two sub-threshold exposures together push monocytes over</a:t>
+            </a:r>
+          </a:p>
+          <a:p>
+            <a:pPr>
+              <a:defRPr sz="1800"/>
+            </a:pPr>
+            <a:r>
+              <a:t>  an inflammatory activation threshold - an emergent, non-additive effect.</a:t>
+            </a:r>
+          </a:p>
+          <a:p>
+            <a:pPr>
+              <a:defRPr sz="1800"/>
+            </a:pPr>
+            <a:r>
               <a:t>Real exposure is always to mixtures -&gt; single-size studies may under-estimate risk.</a:t>
             </a:r>
           </a:p>
@@ -3483,7 +4860,7 @@
 </file>
 
 <file path=ppt/slides/slide12.xml><?xml version="1.0" encoding="utf-8"?>
-<p:sld xmlns:a="http://schemas.openxmlformats.org/drawingml/2006/main" xmlns:r="http://schemas.openxmlformats.org/officeDocument/2006/relationships" xmlns:p="http://schemas.openxmlformats.org/presentationml/2006/main">
+<p:sld xmlns:a="http://schemas.openxmlformats.org/drawingml/2006/main" xmlns:p="http://schemas.openxmlformats.org/presentationml/2006/main" xmlns:r="http://schemas.openxmlformats.org/officeDocument/2006/relationships">
   <p:cSld>
     <p:spTree>
       <p:nvGrpSpPr>
@@ -3491,14 +4868,7 @@
         <p:cNvGrpSpPr/>
         <p:nvPr/>
       </p:nvGrpSpPr>
-      <p:grpSpPr>
-        <a:xfrm>
-          <a:off x="0" y="0"/>
-          <a:ext cx="0" cy="0"/>
-          <a:chOff x="0" y="0"/>
-          <a:chExt cx="0" cy="0"/>
-        </a:xfrm>
-      </p:grpSpPr>
+      <p:grpSpPr/>
       <p:sp>
         <p:nvSpPr>
           <p:cNvPr id="2" name="Title 1"/>
@@ -3520,7 +4890,6 @@
           <a:lstStyle/>
           <a:p>
             <a:r>
-              <a:rPr dirty="0"/>
               <a:t>Additional analyses (5 implemented)</a:t>
             </a:r>
           </a:p>
@@ -3543,16 +4912,13 @@
           </a:xfrm>
         </p:spPr>
         <p:txBody>
-          <a:bodyPr>
-            <a:normAutofit/>
-          </a:bodyPr>
+          <a:bodyPr/>
           <a:lstStyle/>
           <a:p>
             <a:pPr>
               <a:defRPr sz="1800"/>
             </a:pPr>
             <a:r>
-              <a:rPr sz="2400" dirty="0"/>
               <a:t>1. Module scoring - stress &amp; inflammation gene programs per sample (shown next).</a:t>
             </a:r>
           </a:p>
@@ -3561,7 +4927,6 @@
               <a:defRPr sz="1800"/>
             </a:pPr>
             <a:r>
-              <a:rPr sz="2400" dirty="0"/>
               <a:t>2. Mixture additivity - is the mixture = 40nm + 200nm? (shown next).</a:t>
             </a:r>
           </a:p>
@@ -3570,7 +4935,6 @@
               <a:defRPr sz="1800"/>
             </a:pPr>
             <a:r>
-              <a:rPr sz="2400" dirty="0"/>
               <a:t>3. Clustering robustness - clusters stable across Leiden resolutions (ARI).</a:t>
             </a:r>
           </a:p>
@@ -3579,7 +4943,6 @@
               <a:defRPr sz="1800"/>
             </a:pPr>
             <a:r>
-              <a:rPr sz="2400" dirty="0"/>
               <a:t>4. Ligand-receptor - shift in cell-to-cell communication on exposure.</a:t>
             </a:r>
           </a:p>
@@ -3588,7 +4951,6 @@
               <a:defRPr sz="1800"/>
             </a:pPr>
             <a:r>
-              <a:rPr sz="2400" dirty="0"/>
               <a:t>5. Dose-response - disruption magnitude vs particle size.</a:t>
             </a:r>
           </a:p>
@@ -3597,16 +4959,7 @@
               <a:defRPr sz="1800"/>
             </a:pPr>
             <a:r>
-              <a:rPr sz="2400" dirty="0"/>
-              <a:t>All five reinforce the same story: size-dependent, non-additive, monocyte-</a:t>
-            </a:r>
-            <a:r>
-              <a:rPr sz="2400" dirty="0" err="1"/>
-              <a:t>centred</a:t>
-            </a:r>
-            <a:r>
-              <a:rPr sz="2400" dirty="0"/>
-              <a:t>.</a:t>
+              <a:t>All five reinforce the same story: size-dependent, non-additive, monocyte-centred.</a:t>
             </a:r>
           </a:p>
         </p:txBody>
@@ -3620,7 +4973,7 @@
 </file>
 
 <file path=ppt/slides/slide13.xml><?xml version="1.0" encoding="utf-8"?>
-<p:sld xmlns:a="http://schemas.openxmlformats.org/drawingml/2006/main" xmlns:r="http://schemas.openxmlformats.org/officeDocument/2006/relationships" xmlns:p="http://schemas.openxmlformats.org/presentationml/2006/main">
+<p:sld xmlns:a="http://schemas.openxmlformats.org/drawingml/2006/main" xmlns:p="http://schemas.openxmlformats.org/presentationml/2006/main" xmlns:r="http://schemas.openxmlformats.org/officeDocument/2006/relationships">
   <p:cSld>
     <p:spTree>
       <p:nvGrpSpPr>
@@ -3628,14 +4981,7 @@
         <p:cNvGrpSpPr/>
         <p:nvPr/>
       </p:nvGrpSpPr>
-      <p:grpSpPr>
-        <a:xfrm>
-          <a:off x="0" y="0"/>
-          <a:ext cx="0" cy="0"/>
-          <a:chOff x="0" y="0"/>
-          <a:chExt cx="0" cy="0"/>
-        </a:xfrm>
-      </p:grpSpPr>
+      <p:grpSpPr/>
       <p:sp>
         <p:nvSpPr>
           <p:cNvPr id="2" name="Title 1"/>
@@ -3657,7 +5003,6 @@
           <a:lstStyle/>
           <a:p>
             <a:r>
-              <a:rPr dirty="0"/>
               <a:t>Additional analyses: stress/inflammation module scores</a:t>
             </a:r>
           </a:p>
@@ -3679,7 +5024,7 @@
         </p:blipFill>
         <p:spPr>
           <a:xfrm>
-            <a:off x="2095347" y="1417638"/>
+            <a:off x="2095347" y="1371600"/>
             <a:ext cx="8001000" cy="4572000"/>
           </a:xfrm>
           <a:prstGeom prst="rect">
@@ -3727,7 +5072,7 @@
 </file>
 
 <file path=ppt/slides/slide14.xml><?xml version="1.0" encoding="utf-8"?>
-<p:sld xmlns:a="http://schemas.openxmlformats.org/drawingml/2006/main" xmlns:r="http://schemas.openxmlformats.org/officeDocument/2006/relationships" xmlns:p="http://schemas.openxmlformats.org/presentationml/2006/main">
+<p:sld xmlns:a="http://schemas.openxmlformats.org/drawingml/2006/main" xmlns:p="http://schemas.openxmlformats.org/presentationml/2006/main" xmlns:r="http://schemas.openxmlformats.org/officeDocument/2006/relationships">
   <p:cSld>
     <p:spTree>
       <p:nvGrpSpPr>
@@ -3735,14 +5080,7 @@
         <p:cNvGrpSpPr/>
         <p:nvPr/>
       </p:nvGrpSpPr>
-      <p:grpSpPr>
-        <a:xfrm>
-          <a:off x="0" y="0"/>
-          <a:ext cx="0" cy="0"/>
-          <a:chOff x="0" y="0"/>
-          <a:chExt cx="0" cy="0"/>
-        </a:xfrm>
-      </p:grpSpPr>
+      <p:grpSpPr/>
       <p:sp>
         <p:nvSpPr>
           <p:cNvPr id="2" name="Title 1"/>
@@ -3833,7 +5171,7 @@
 </file>
 
 <file path=ppt/slides/slide15.xml><?xml version="1.0" encoding="utf-8"?>
-<p:sld xmlns:a="http://schemas.openxmlformats.org/drawingml/2006/main" xmlns:r="http://schemas.openxmlformats.org/officeDocument/2006/relationships" xmlns:p="http://schemas.openxmlformats.org/presentationml/2006/main">
+<p:sld xmlns:a="http://schemas.openxmlformats.org/drawingml/2006/main" xmlns:p="http://schemas.openxmlformats.org/presentationml/2006/main" xmlns:r="http://schemas.openxmlformats.org/officeDocument/2006/relationships">
   <p:cSld>
     <p:spTree>
       <p:nvGrpSpPr>
@@ -3841,14 +5179,7 @@
         <p:cNvGrpSpPr/>
         <p:nvPr/>
       </p:nvGrpSpPr>
-      <p:grpSpPr>
-        <a:xfrm>
-          <a:off x="0" y="0"/>
-          <a:ext cx="0" cy="0"/>
-          <a:chOff x="0" y="0"/>
-          <a:chExt cx="0" cy="0"/>
-        </a:xfrm>
-      </p:grpSpPr>
+      <p:grpSpPr/>
       <p:sp>
         <p:nvSpPr>
           <p:cNvPr id="2" name="Title 1"/>
@@ -3870,7 +5201,129 @@
           <a:lstStyle/>
           <a:p>
             <a:r>
-              <a:rPr dirty="0"/>
+              <a:t>Additional analyses: robustness &amp; communication</a:t>
+            </a:r>
+          </a:p>
+        </p:txBody>
+      </p:sp>
+      <p:pic>
+        <p:nvPicPr>
+          <p:cNvPr id="3" name="Picture 2" descr="07_clustering_robustness.png"/>
+          <p:cNvPicPr>
+            <a:picLocks noChangeAspect="1"/>
+          </p:cNvPicPr>
+          <p:nvPr/>
+        </p:nvPicPr>
+        <p:blipFill>
+          <a:blip r:embed="rId2"/>
+          <a:stretch>
+            <a:fillRect/>
+          </a:stretch>
+        </p:blipFill>
+        <p:spPr>
+          <a:xfrm>
+            <a:off x="365760" y="1793290"/>
+            <a:ext cx="5592927" cy="3728618"/>
+          </a:xfrm>
+          <a:prstGeom prst="rect">
+            <a:avLst/>
+          </a:prstGeom>
+        </p:spPr>
+      </p:pic>
+      <p:pic>
+        <p:nvPicPr>
+          <p:cNvPr id="4" name="Picture 3" descr="07_ligand_receptor.png"/>
+          <p:cNvPicPr>
+            <a:picLocks noChangeAspect="1"/>
+          </p:cNvPicPr>
+          <p:nvPr/>
+        </p:nvPicPr>
+        <p:blipFill>
+          <a:blip r:embed="rId3"/>
+          <a:stretch>
+            <a:fillRect/>
+          </a:stretch>
+        </p:blipFill>
+        <p:spPr>
+          <a:xfrm>
+            <a:off x="6233007" y="1909810"/>
+            <a:ext cx="5592927" cy="3495579"/>
+          </a:xfrm>
+          <a:prstGeom prst="rect">
+            <a:avLst/>
+          </a:prstGeom>
+        </p:spPr>
+      </p:pic>
+      <p:sp>
+        <p:nvSpPr>
+          <p:cNvPr id="5" name="TextBox 4"/>
+          <p:cNvSpPr txBox="1"/>
+          <p:nvPr/>
+        </p:nvSpPr>
+        <p:spPr>
+          <a:xfrm>
+            <a:off x="365760" y="6309360"/>
+            <a:ext cx="11460175" cy="457200"/>
+          </a:xfrm>
+          <a:prstGeom prst="rect">
+            <a:avLst/>
+          </a:prstGeom>
+          <a:noFill/>
+        </p:spPr>
+        <p:txBody>
+          <a:bodyPr wrap="none">
+            <a:spAutoFit/>
+          </a:bodyPr>
+          <a:lstStyle/>
+          <a:p>
+            <a:pPr>
+              <a:defRPr sz="1200"/>
+            </a:pPr>
+            <a:r>
+              <a:t>Analyses 3 &amp; 4 of 5. Left: clustering robustness (ARI across Leiden resolutions). Right: ligand-receptor communication shift on exposure. (Analysis 5, dose-response, is on the DE slide.)</a:t>
+            </a:r>
+          </a:p>
+        </p:txBody>
+      </p:sp>
+    </p:spTree>
+  </p:cSld>
+  <p:clrMapOvr>
+    <a:masterClrMapping/>
+  </p:clrMapOvr>
+</p:sld>
+</file>
+
+<file path=ppt/slides/slide16.xml><?xml version="1.0" encoding="utf-8"?>
+<p:sld xmlns:a="http://schemas.openxmlformats.org/drawingml/2006/main" xmlns:p="http://schemas.openxmlformats.org/presentationml/2006/main" xmlns:r="http://schemas.openxmlformats.org/officeDocument/2006/relationships">
+  <p:cSld>
+    <p:spTree>
+      <p:nvGrpSpPr>
+        <p:cNvPr id="1" name=""/>
+        <p:cNvGrpSpPr/>
+        <p:nvPr/>
+      </p:nvGrpSpPr>
+      <p:grpSpPr/>
+      <p:sp>
+        <p:nvSpPr>
+          <p:cNvPr id="2" name="Title 1"/>
+          <p:cNvSpPr>
+            <a:spLocks noGrp="1"/>
+          </p:cNvSpPr>
+          <p:nvPr>
+            <p:ph type="title"/>
+          </p:nvPr>
+        </p:nvSpPr>
+        <p:spPr>
+          <a:xfrm>
+            <a:off x="365760" y="274638"/>
+            <a:ext cx="11460175" cy="1143000"/>
+          </a:xfrm>
+        </p:spPr>
+        <p:txBody>
+          <a:bodyPr/>
+          <a:lstStyle/>
+          <a:p>
+            <a:r>
               <a:t>Limitations &amp; reproducibility</a:t>
             </a:r>
           </a:p>
@@ -3893,16 +5346,13 @@
           </a:xfrm>
         </p:spPr>
         <p:txBody>
-          <a:bodyPr>
-            <a:normAutofit/>
-          </a:bodyPr>
+          <a:bodyPr/>
           <a:lstStyle/>
           <a:p>
             <a:pPr>
               <a:defRPr sz="1800"/>
             </a:pPr>
             <a:r>
-              <a:rPr sz="2400" dirty="0"/>
               <a:t>One donor, one sample per condition -&gt; NO biological replicates.</a:t>
             </a:r>
           </a:p>
@@ -3911,24 +5361,7 @@
               <a:defRPr sz="1800"/>
             </a:pPr>
             <a:r>
-              <a:rPr sz="2400" dirty="0"/>
-              <a:t>DE is cell-level Wilcoxon (not </a:t>
-            </a:r>
-            <a:r>
-              <a:rPr sz="2400" dirty="0" err="1"/>
-              <a:t>pseudobulk</a:t>
-            </a:r>
-            <a:r>
-              <a:rPr sz="2400" dirty="0"/>
-              <a:t>); p-values exploratory, </a:t>
-            </a:r>
-            <a:r>
-              <a:rPr sz="2400" dirty="0" err="1"/>
-              <a:t>pseudoreplication</a:t>
-            </a:r>
-            <a:r>
-              <a:rPr sz="2400" dirty="0"/>
-              <a:t> caveat.</a:t>
+              <a:t>DE is cell-level Wilcoxon (not pseudobulk); p-values exploratory, pseudoreplication caveat.</a:t>
             </a:r>
           </a:p>
           <a:p>
@@ -3936,7 +5369,6 @@
               <a:defRPr sz="1800"/>
             </a:pPr>
             <a:r>
-              <a:rPr sz="2400" dirty="0"/>
               <a:t>No external gene-level ground truth; DE validated internally + biologically.</a:t>
             </a:r>
           </a:p>
@@ -3945,7 +5377,6 @@
               <a:defRPr sz="1800"/>
             </a:pPr>
             <a:r>
-              <a:rPr sz="2400" dirty="0"/>
               <a:t>Everything reproduces: `python run_pipeline.py --all`; 37 offline intent tests.</a:t>
             </a:r>
           </a:p>
@@ -3960,7 +5391,7 @@
 </file>
 
 <file path=ppt/slides/slide2.xml><?xml version="1.0" encoding="utf-8"?>
-<p:sld xmlns:a="http://schemas.openxmlformats.org/drawingml/2006/main" xmlns:r="http://schemas.openxmlformats.org/officeDocument/2006/relationships" xmlns:p="http://schemas.openxmlformats.org/presentationml/2006/main">
+<p:sld xmlns:a="http://schemas.openxmlformats.org/drawingml/2006/main" xmlns:p="http://schemas.openxmlformats.org/presentationml/2006/main" xmlns:r="http://schemas.openxmlformats.org/officeDocument/2006/relationships">
   <p:cSld>
     <p:spTree>
       <p:nvGrpSpPr>
@@ -3968,14 +5399,7 @@
         <p:cNvGrpSpPr/>
         <p:nvPr/>
       </p:nvGrpSpPr>
-      <p:grpSpPr>
-        <a:xfrm>
-          <a:off x="0" y="0"/>
-          <a:ext cx="0" cy="0"/>
-          <a:chOff x="0" y="0"/>
-          <a:chExt cx="0" cy="0"/>
-        </a:xfrm>
-      </p:grpSpPr>
+      <p:grpSpPr/>
       <p:sp>
         <p:nvSpPr>
           <p:cNvPr id="2" name="Title 1"/>
@@ -4019,25 +5443,14 @@
           </a:xfrm>
         </p:spPr>
         <p:txBody>
-          <a:bodyPr>
-            <a:normAutofit/>
-          </a:bodyPr>
+          <a:bodyPr/>
           <a:lstStyle/>
           <a:p>
             <a:pPr>
               <a:defRPr sz="1800"/>
             </a:pPr>
             <a:r>
-              <a:rPr sz="2400" dirty="0"/>
-              <a:t>Do small vs large </a:t>
-            </a:r>
-            <a:r>
-              <a:rPr sz="2400" dirty="0" err="1"/>
-              <a:t>nanoplastics</a:t>
-            </a:r>
-            <a:r>
-              <a:rPr sz="2400" dirty="0"/>
-              <a:t> provoke different immune responses?</a:t>
+              <a:t>Do small vs large nanoplastics provoke different immune responses?</a:t>
             </a:r>
           </a:p>
           <a:p>
@@ -4045,7 +5458,6 @@
               <a:defRPr sz="1800"/>
             </a:pPr>
             <a:r>
-              <a:rPr sz="2400" dirty="0"/>
               <a:t>Does the 40+200 nm mixture do something neither size does alone?</a:t>
             </a:r>
           </a:p>
@@ -4054,16 +5466,7 @@
               <a:defRPr sz="1800"/>
             </a:pPr>
             <a:r>
-              <a:rPr sz="2400" dirty="0"/>
-              <a:t>4 samples, one donor: PSNP_40nm, PSNP_200nm, </a:t>
-            </a:r>
-            <a:r>
-              <a:rPr sz="2400" dirty="0" err="1"/>
-              <a:t>PSNP_mixture</a:t>
-            </a:r>
-            <a:r>
-              <a:rPr sz="2400" dirty="0"/>
-              <a:t>, control</a:t>
+              <a:t>4 samples, one donor: PSNP_40nm, PSNP_200nm, PSNP_mixture, control</a:t>
             </a:r>
           </a:p>
           <a:p>
@@ -4071,24 +5474,7 @@
               <a:defRPr sz="1800"/>
             </a:pPr>
             <a:r>
-              <a:rPr sz="2400" dirty="0"/>
-              <a:t>~34,000 PBMCs, </a:t>
-            </a:r>
-            <a:r>
-              <a:rPr sz="2400" dirty="0" err="1"/>
-              <a:t>AnnData</a:t>
-            </a:r>
-            <a:r>
-              <a:rPr sz="2400" dirty="0"/>
-              <a:t>/.h5ad (</a:t>
-            </a:r>
-            <a:r>
-              <a:rPr sz="2400" dirty="0" err="1"/>
-              <a:t>Zenodo</a:t>
-            </a:r>
-            <a:r>
-              <a:rPr sz="2400" dirty="0"/>
-              <a:t> 10.5281/zenodo.15866724)</a:t>
+              <a:t>~34,000 PBMCs, AnnData/.h5ad (Zenodo 10.5281/zenodo.15866724)</a:t>
             </a:r>
           </a:p>
         </p:txBody>
@@ -4102,7 +5488,7 @@
 </file>
 
 <file path=ppt/slides/slide3.xml><?xml version="1.0" encoding="utf-8"?>
-<p:sld xmlns:a="http://schemas.openxmlformats.org/drawingml/2006/main" xmlns:r="http://schemas.openxmlformats.org/officeDocument/2006/relationships" xmlns:p="http://schemas.openxmlformats.org/presentationml/2006/main">
+<p:sld xmlns:a="http://schemas.openxmlformats.org/drawingml/2006/main" xmlns:p="http://schemas.openxmlformats.org/presentationml/2006/main" xmlns:r="http://schemas.openxmlformats.org/officeDocument/2006/relationships">
   <p:cSld>
     <p:spTree>
       <p:nvGrpSpPr>
@@ -4110,14 +5496,7 @@
         <p:cNvGrpSpPr/>
         <p:nvPr/>
       </p:nvGrpSpPr>
-      <p:grpSpPr>
-        <a:xfrm>
-          <a:off x="0" y="0"/>
-          <a:ext cx="0" cy="0"/>
-          <a:chOff x="0" y="0"/>
-          <a:chExt cx="0" cy="0"/>
-        </a:xfrm>
-      </p:grpSpPr>
+      <p:grpSpPr/>
       <p:sp>
         <p:nvSpPr>
           <p:cNvPr id="2" name="Title 1"/>
@@ -4161,16 +5540,13 @@
           </a:xfrm>
         </p:spPr>
         <p:txBody>
-          <a:bodyPr>
-            <a:normAutofit/>
-          </a:bodyPr>
+          <a:bodyPr/>
           <a:lstStyle/>
           <a:p>
             <a:pPr>
               <a:defRPr sz="1800"/>
             </a:pPr>
             <a:r>
-              <a:rPr sz="2400" dirty="0"/>
               <a:t>1. QC &amp; preprocessing  -  thresholds justified on real percentiles</a:t>
             </a:r>
           </a:p>
@@ -4179,7 +5555,6 @@
               <a:defRPr sz="1800"/>
             </a:pPr>
             <a:r>
-              <a:rPr sz="2400" dirty="0"/>
               <a:t>2. Integration  -  Harmony batch correction, UMAP, Leiden</a:t>
             </a:r>
           </a:p>
@@ -4188,24 +5563,7 @@
               <a:defRPr sz="1800"/>
             </a:pPr>
             <a:r>
-              <a:rPr sz="2400" dirty="0"/>
-              <a:t>3. Annotation  -  </a:t>
-            </a:r>
-            <a:r>
-              <a:rPr sz="2400" dirty="0" err="1"/>
-              <a:t>celltypist</a:t>
-            </a:r>
-            <a:r>
-              <a:rPr sz="2400" dirty="0"/>
-              <a:t>, cross-checked vs Azimuth &amp; </a:t>
-            </a:r>
-            <a:r>
-              <a:rPr sz="2400" dirty="0" err="1"/>
-              <a:t>CoDi</a:t>
-            </a:r>
-            <a:r>
-              <a:rPr sz="2400" dirty="0"/>
-              <a:t> (~93%)</a:t>
+              <a:t>3. Annotation  -  celltypist, cross-checked vs Azimuth &amp; CoDi (~93%)</a:t>
             </a:r>
           </a:p>
           <a:p>
@@ -4213,7 +5571,6 @@
               <a:defRPr sz="1800"/>
             </a:pPr>
             <a:r>
-              <a:rPr sz="2400" dirty="0"/>
               <a:t>4. Composition  -  proportions + log2 fold-change vs control</a:t>
             </a:r>
           </a:p>
@@ -4222,7 +5579,6 @@
               <a:defRPr sz="1800"/>
             </a:pPr>
             <a:r>
-              <a:rPr sz="2400" dirty="0"/>
               <a:t>5. Differential expression  -  per-lineage Wilcoxon + pathway enrichment</a:t>
             </a:r>
           </a:p>
@@ -4231,7 +5587,6 @@
               <a:defRPr sz="1800"/>
             </a:pPr>
             <a:r>
-              <a:rPr sz="2400" dirty="0"/>
               <a:t>6. Size-specific effects  -  unique / shared / mixture-emergent genes</a:t>
             </a:r>
           </a:p>
@@ -4246,7 +5601,7 @@
 </file>
 
 <file path=ppt/slides/slide4.xml><?xml version="1.0" encoding="utf-8"?>
-<p:sld xmlns:a="http://schemas.openxmlformats.org/drawingml/2006/main" xmlns:r="http://schemas.openxmlformats.org/officeDocument/2006/relationships" xmlns:p="http://schemas.openxmlformats.org/presentationml/2006/main">
+<p:sld xmlns:a="http://schemas.openxmlformats.org/drawingml/2006/main" xmlns:p="http://schemas.openxmlformats.org/presentationml/2006/main" xmlns:r="http://schemas.openxmlformats.org/officeDocument/2006/relationships">
   <p:cSld>
     <p:spTree>
       <p:nvGrpSpPr>
@@ -4254,14 +5609,7 @@
         <p:cNvGrpSpPr/>
         <p:nvPr/>
       </p:nvGrpSpPr>
-      <p:grpSpPr>
-        <a:xfrm>
-          <a:off x="0" y="0"/>
-          <a:ext cx="0" cy="0"/>
-          <a:chOff x="0" y="0"/>
-          <a:chExt cx="0" cy="0"/>
-        </a:xfrm>
-      </p:grpSpPr>
+      <p:grpSpPr/>
       <p:sp>
         <p:nvSpPr>
           <p:cNvPr id="2" name="Title 1"/>
@@ -4283,7 +5631,6 @@
           <a:lstStyle/>
           <a:p>
             <a:r>
-              <a:rPr dirty="0"/>
               <a:t>QC &amp; preprocessing (1/2): per-sample QC metrics</a:t>
             </a:r>
           </a:p>
@@ -4353,7 +5700,7 @@
 </file>
 
 <file path=ppt/slides/slide5.xml><?xml version="1.0" encoding="utf-8"?>
-<p:sld xmlns:a="http://schemas.openxmlformats.org/drawingml/2006/main" xmlns:r="http://schemas.openxmlformats.org/officeDocument/2006/relationships" xmlns:p="http://schemas.openxmlformats.org/presentationml/2006/main">
+<p:sld xmlns:a="http://schemas.openxmlformats.org/drawingml/2006/main" xmlns:p="http://schemas.openxmlformats.org/presentationml/2006/main" xmlns:r="http://schemas.openxmlformats.org/officeDocument/2006/relationships">
   <p:cSld>
     <p:spTree>
       <p:nvGrpSpPr>
@@ -4361,14 +5708,7 @@
         <p:cNvGrpSpPr/>
         <p:nvPr/>
       </p:nvGrpSpPr>
-      <p:grpSpPr>
-        <a:xfrm>
-          <a:off x="0" y="0"/>
-          <a:ext cx="0" cy="0"/>
-          <a:chOff x="0" y="0"/>
-          <a:chExt cx="0" cy="0"/>
-        </a:xfrm>
-      </p:grpSpPr>
+      <p:grpSpPr/>
       <p:sp>
         <p:nvSpPr>
           <p:cNvPr id="2" name="Title 1"/>
@@ -4459,7 +5799,7 @@
 </file>
 
 <file path=ppt/slides/slide6.xml><?xml version="1.0" encoding="utf-8"?>
-<p:sld xmlns:a="http://schemas.openxmlformats.org/drawingml/2006/main" xmlns:r="http://schemas.openxmlformats.org/officeDocument/2006/relationships" xmlns:p="http://schemas.openxmlformats.org/presentationml/2006/main">
+<p:sld xmlns:a="http://schemas.openxmlformats.org/drawingml/2006/main" xmlns:p="http://schemas.openxmlformats.org/presentationml/2006/main" xmlns:r="http://schemas.openxmlformats.org/officeDocument/2006/relationships">
   <p:cSld>
     <p:spTree>
       <p:nvGrpSpPr>
@@ -4467,14 +5807,7 @@
         <p:cNvGrpSpPr/>
         <p:nvPr/>
       </p:nvGrpSpPr>
-      <p:grpSpPr>
-        <a:xfrm>
-          <a:off x="0" y="0"/>
-          <a:ext cx="0" cy="0"/>
-          <a:chOff x="0" y="0"/>
-          <a:chExt cx="0" cy="0"/>
-        </a:xfrm>
-      </p:grpSpPr>
+      <p:grpSpPr/>
       <p:sp>
         <p:nvSpPr>
           <p:cNvPr id="2" name="Title 1"/>
@@ -4589,7 +5922,7 @@
 </file>
 
 <file path=ppt/slides/slide7.xml><?xml version="1.0" encoding="utf-8"?>
-<p:sld xmlns:a="http://schemas.openxmlformats.org/drawingml/2006/main" xmlns:r="http://schemas.openxmlformats.org/officeDocument/2006/relationships" xmlns:p="http://schemas.openxmlformats.org/presentationml/2006/main">
+<p:sld xmlns:a="http://schemas.openxmlformats.org/drawingml/2006/main" xmlns:p="http://schemas.openxmlformats.org/presentationml/2006/main" xmlns:r="http://schemas.openxmlformats.org/officeDocument/2006/relationships">
   <p:cSld>
     <p:spTree>
       <p:nvGrpSpPr>
@@ -4597,14 +5930,7 @@
         <p:cNvGrpSpPr/>
         <p:nvPr/>
       </p:nvGrpSpPr>
-      <p:grpSpPr>
-        <a:xfrm>
-          <a:off x="0" y="0"/>
-          <a:ext cx="0" cy="0"/>
-          <a:chOff x="0" y="0"/>
-          <a:chExt cx="0" cy="0"/>
-        </a:xfrm>
-      </p:grpSpPr>
+      <p:grpSpPr/>
       <p:sp>
         <p:nvSpPr>
           <p:cNvPr id="2" name="Title 1"/>
@@ -4719,7 +6045,7 @@
 </file>
 
 <file path=ppt/slides/slide8.xml><?xml version="1.0" encoding="utf-8"?>
-<p:sld xmlns:a="http://schemas.openxmlformats.org/drawingml/2006/main" xmlns:r="http://schemas.openxmlformats.org/officeDocument/2006/relationships" xmlns:p="http://schemas.openxmlformats.org/presentationml/2006/main">
+<p:sld xmlns:a="http://schemas.openxmlformats.org/drawingml/2006/main" xmlns:p="http://schemas.openxmlformats.org/presentationml/2006/main" xmlns:r="http://schemas.openxmlformats.org/officeDocument/2006/relationships">
   <p:cSld>
     <p:spTree>
       <p:nvGrpSpPr>
@@ -4727,14 +6053,7 @@
         <p:cNvGrpSpPr/>
         <p:nvPr/>
       </p:nvGrpSpPr>
-      <p:grpSpPr>
-        <a:xfrm>
-          <a:off x="0" y="0"/>
-          <a:ext cx="0" cy="0"/>
-          <a:chOff x="0" y="0"/>
-          <a:chExt cx="0" cy="0"/>
-        </a:xfrm>
-      </p:grpSpPr>
+      <p:grpSpPr/>
       <p:sp>
         <p:nvSpPr>
           <p:cNvPr id="2" name="Title 1"/>
@@ -4849,7 +6168,7 @@
 </file>
 
 <file path=ppt/slides/slide9.xml><?xml version="1.0" encoding="utf-8"?>
-<p:sld xmlns:a="http://schemas.openxmlformats.org/drawingml/2006/main" xmlns:r="http://schemas.openxmlformats.org/officeDocument/2006/relationships" xmlns:p="http://schemas.openxmlformats.org/presentationml/2006/main">
+<p:sld xmlns:a="http://schemas.openxmlformats.org/drawingml/2006/main" xmlns:p="http://schemas.openxmlformats.org/presentationml/2006/main" xmlns:r="http://schemas.openxmlformats.org/officeDocument/2006/relationships">
   <p:cSld>
     <p:spTree>
       <p:nvGrpSpPr>
@@ -4857,14 +6176,7 @@
         <p:cNvGrpSpPr/>
         <p:nvPr/>
       </p:nvGrpSpPr>
-      <p:grpSpPr>
-        <a:xfrm>
-          <a:off x="0" y="0"/>
-          <a:ext cx="0" cy="0"/>
-          <a:chOff x="0" y="0"/>
-          <a:chExt cx="0" cy="0"/>
-        </a:xfrm>
-      </p:grpSpPr>
+      <p:grpSpPr/>
       <p:sp>
         <p:nvSpPr>
           <p:cNvPr id="2" name="Title 1"/>
@@ -5298,8 +6610,322 @@
 </a:theme>
 </file>
 
-<file path=docMetadata/LabelInfo.xml><?xml version="1.0" encoding="utf-8"?>
-<clbl:labelList xmlns:clbl="http://schemas.microsoft.com/office/2020/mipLabelMetadata">
-  <clbl:label id="{f39aa4b3-b62d-42bf-8097-75e2c573ddfa}" enabled="1" method="Privileged" siteId="{3dd8961f-e488-4e60-8e11-a82d994e183d}" contentBits="0" removed="0"/>
-</clbl:labelList>
+<file path=ppt/theme/theme2.xml><?xml version="1.0" encoding="utf-8"?>
+<a:theme xmlns:a="http://schemas.openxmlformats.org/drawingml/2006/main" name="Office Theme">
+  <a:themeElements>
+    <a:clrScheme name="Office">
+      <a:dk1>
+        <a:sysClr val="windowText" lastClr="000000"/>
+      </a:dk1>
+      <a:lt1>
+        <a:sysClr val="window" lastClr="FFFFFF"/>
+      </a:lt1>
+      <a:dk2>
+        <a:srgbClr val="1F497D"/>
+      </a:dk2>
+      <a:lt2>
+        <a:srgbClr val="EEECE1"/>
+      </a:lt2>
+      <a:accent1>
+        <a:srgbClr val="4F81BD"/>
+      </a:accent1>
+      <a:accent2>
+        <a:srgbClr val="C0504D"/>
+      </a:accent2>
+      <a:accent3>
+        <a:srgbClr val="9BBB59"/>
+      </a:accent3>
+      <a:accent4>
+        <a:srgbClr val="8064A2"/>
+      </a:accent4>
+      <a:accent5>
+        <a:srgbClr val="4BACC6"/>
+      </a:accent5>
+      <a:accent6>
+        <a:srgbClr val="F79646"/>
+      </a:accent6>
+      <a:hlink>
+        <a:srgbClr val="0000FF"/>
+      </a:hlink>
+      <a:folHlink>
+        <a:srgbClr val="800080"/>
+      </a:folHlink>
+    </a:clrScheme>
+    <a:fontScheme name="Office">
+      <a:majorFont>
+        <a:latin typeface="Calibri"/>
+        <a:ea typeface=""/>
+        <a:cs typeface=""/>
+        <a:font script="Jpan" typeface="ＭＳ Ｐゴシック"/>
+        <a:font script="Hang" typeface="맑은 고딕"/>
+        <a:font script="Hans" typeface="宋体"/>
+        <a:font script="Hant" typeface="新細明體"/>
+        <a:font script="Arab" typeface="Times New Roman"/>
+        <a:font script="Hebr" typeface="Times New Roman"/>
+        <a:font script="Thai" typeface="Angsana New"/>
+        <a:font script="Ethi" typeface="Nyala"/>
+        <a:font script="Beng" typeface="Vrinda"/>
+        <a:font script="Gujr" typeface="Shruti"/>
+        <a:font script="Khmr" typeface="MoolBoran"/>
+        <a:font script="Knda" typeface="Tunga"/>
+        <a:font script="Guru" typeface="Raavi"/>
+        <a:font script="Cans" typeface="Euphemia"/>
+        <a:font script="Cher" typeface="Plantagenet Cherokee"/>
+        <a:font script="Yiii" typeface="Microsoft Yi Baiti"/>
+        <a:font script="Tibt" typeface="Microsoft Himalaya"/>
+        <a:font script="Thaa" typeface="MV Boli"/>
+        <a:font script="Deva" typeface="Mangal"/>
+        <a:font script="Telu" typeface="Gautami"/>
+        <a:font script="Taml" typeface="Latha"/>
+        <a:font script="Syrc" typeface="Estrangelo Edessa"/>
+        <a:font script="Orya" typeface="Kalinga"/>
+        <a:font script="Mlym" typeface="Kartika"/>
+        <a:font script="Laoo" typeface="DokChampa"/>
+        <a:font script="Sinh" typeface="Iskoola Pota"/>
+        <a:font script="Mong" typeface="Mongolian Baiti"/>
+        <a:font script="Viet" typeface="Times New Roman"/>
+        <a:font script="Uigh" typeface="Microsoft Uighur"/>
+        <a:font script="Geor" typeface="Sylfaen"/>
+      </a:majorFont>
+      <a:minorFont>
+        <a:latin typeface="Calibri"/>
+        <a:ea typeface=""/>
+        <a:cs typeface=""/>
+        <a:font script="Jpan" typeface="ＭＳ Ｐゴシック"/>
+        <a:font script="Hang" typeface="맑은 고딕"/>
+        <a:font script="Hans" typeface="宋体"/>
+        <a:font script="Hant" typeface="新細明體"/>
+        <a:font script="Arab" typeface="Arial"/>
+        <a:font script="Hebr" typeface="Arial"/>
+        <a:font script="Thai" typeface="Cordia New"/>
+        <a:font script="Ethi" typeface="Nyala"/>
+        <a:font script="Beng" typeface="Vrinda"/>
+        <a:font script="Gujr" typeface="Shruti"/>
+        <a:font script="Khmr" typeface="DaunPenh"/>
+        <a:font script="Knda" typeface="Tunga"/>
+        <a:font script="Guru" typeface="Raavi"/>
+        <a:font script="Cans" typeface="Euphemia"/>
+        <a:font script="Cher" typeface="Plantagenet Cherokee"/>
+        <a:font script="Yiii" typeface="Microsoft Yi Baiti"/>
+        <a:font script="Tibt" typeface="Microsoft Himalaya"/>
+        <a:font script="Thaa" typeface="MV Boli"/>
+        <a:font script="Deva" typeface="Mangal"/>
+        <a:font script="Telu" typeface="Gautami"/>
+        <a:font script="Taml" typeface="Latha"/>
+        <a:font script="Syrc" typeface="Estrangelo Edessa"/>
+        <a:font script="Orya" typeface="Kalinga"/>
+        <a:font script="Mlym" typeface="Kartika"/>
+        <a:font script="Laoo" typeface="DokChampa"/>
+        <a:font script="Sinh" typeface="Iskoola Pota"/>
+        <a:font script="Mong" typeface="Mongolian Baiti"/>
+        <a:font script="Viet" typeface="Arial"/>
+        <a:font script="Uigh" typeface="Microsoft Uighur"/>
+        <a:font script="Geor" typeface="Sylfaen"/>
+      </a:minorFont>
+    </a:fontScheme>
+    <a:fmtScheme name="Office">
+      <a:fillStyleLst>
+        <a:solidFill>
+          <a:schemeClr val="phClr"/>
+        </a:solidFill>
+        <a:gradFill rotWithShape="1">
+          <a:gsLst>
+            <a:gs pos="0">
+              <a:schemeClr val="phClr">
+                <a:tint val="50000"/>
+                <a:satMod val="300000"/>
+              </a:schemeClr>
+            </a:gs>
+            <a:gs pos="35000">
+              <a:schemeClr val="phClr">
+                <a:tint val="37000"/>
+                <a:satMod val="300000"/>
+              </a:schemeClr>
+            </a:gs>
+            <a:gs pos="100000">
+              <a:schemeClr val="phClr">
+                <a:tint val="15000"/>
+                <a:satMod val="350000"/>
+              </a:schemeClr>
+            </a:gs>
+          </a:gsLst>
+          <a:lin ang="16200000" scaled="1"/>
+        </a:gradFill>
+        <a:gradFill rotWithShape="1">
+          <a:gsLst>
+            <a:gs pos="0">
+              <a:schemeClr val="phClr">
+                <a:tint val="100000"/>
+                <a:shade val="100000"/>
+                <a:satMod val="130000"/>
+              </a:schemeClr>
+            </a:gs>
+            <a:gs pos="100000">
+              <a:schemeClr val="phClr">
+                <a:tint val="50000"/>
+                <a:shade val="100000"/>
+                <a:satMod val="350000"/>
+              </a:schemeClr>
+            </a:gs>
+          </a:gsLst>
+          <a:lin ang="16200000" scaled="0"/>
+        </a:gradFill>
+      </a:fillStyleLst>
+      <a:lnStyleLst>
+        <a:ln w="9525" cap="flat" cmpd="sng" algn="ctr">
+          <a:solidFill>
+            <a:schemeClr val="phClr">
+              <a:shade val="95000"/>
+              <a:satMod val="105000"/>
+            </a:schemeClr>
+          </a:solidFill>
+          <a:prstDash val="solid"/>
+        </a:ln>
+        <a:ln w="25400" cap="flat" cmpd="sng" algn="ctr">
+          <a:solidFill>
+            <a:schemeClr val="phClr"/>
+          </a:solidFill>
+          <a:prstDash val="solid"/>
+        </a:ln>
+        <a:ln w="38100" cap="flat" cmpd="sng" algn="ctr">
+          <a:solidFill>
+            <a:schemeClr val="phClr"/>
+          </a:solidFill>
+          <a:prstDash val="solid"/>
+        </a:ln>
+      </a:lnStyleLst>
+      <a:effectStyleLst>
+        <a:effectStyle>
+          <a:effectLst>
+            <a:outerShdw blurRad="40000" dist="20000" dir="5400000" rotWithShape="0">
+              <a:srgbClr val="000000">
+                <a:alpha val="38000"/>
+              </a:srgbClr>
+            </a:outerShdw>
+          </a:effectLst>
+        </a:effectStyle>
+        <a:effectStyle>
+          <a:effectLst>
+            <a:outerShdw blurRad="40000" dist="23000" dir="5400000" rotWithShape="0">
+              <a:srgbClr val="000000">
+                <a:alpha val="35000"/>
+              </a:srgbClr>
+            </a:outerShdw>
+          </a:effectLst>
+        </a:effectStyle>
+        <a:effectStyle>
+          <a:effectLst>
+            <a:outerShdw blurRad="40000" dist="23000" dir="5400000" rotWithShape="0">
+              <a:srgbClr val="000000">
+                <a:alpha val="35000"/>
+              </a:srgbClr>
+            </a:outerShdw>
+          </a:effectLst>
+          <a:scene3d>
+            <a:camera prst="orthographicFront">
+              <a:rot lat="0" lon="0" rev="0"/>
+            </a:camera>
+            <a:lightRig rig="threePt" dir="t">
+              <a:rot lat="0" lon="0" rev="1200000"/>
+            </a:lightRig>
+          </a:scene3d>
+          <a:sp3d>
+            <a:bevelT w="63500" h="25400"/>
+          </a:sp3d>
+        </a:effectStyle>
+      </a:effectStyleLst>
+      <a:bgFillStyleLst>
+        <a:solidFill>
+          <a:schemeClr val="phClr"/>
+        </a:solidFill>
+        <a:gradFill rotWithShape="1">
+          <a:gsLst>
+            <a:gs pos="0">
+              <a:schemeClr val="phClr">
+                <a:tint val="40000"/>
+                <a:satMod val="350000"/>
+              </a:schemeClr>
+            </a:gs>
+            <a:gs pos="40000">
+              <a:schemeClr val="phClr">
+                <a:tint val="45000"/>
+                <a:shade val="99000"/>
+                <a:satMod val="350000"/>
+              </a:schemeClr>
+            </a:gs>
+            <a:gs pos="100000">
+              <a:schemeClr val="phClr">
+                <a:shade val="20000"/>
+                <a:satMod val="255000"/>
+              </a:schemeClr>
+            </a:gs>
+          </a:gsLst>
+          <a:path path="circle">
+            <a:fillToRect l="50000" t="-80000" r="50000" b="180000"/>
+          </a:path>
+        </a:gradFill>
+        <a:gradFill rotWithShape="1">
+          <a:gsLst>
+            <a:gs pos="0">
+              <a:schemeClr val="phClr">
+                <a:tint val="80000"/>
+                <a:satMod val="300000"/>
+              </a:schemeClr>
+            </a:gs>
+            <a:gs pos="100000">
+              <a:schemeClr val="phClr">
+                <a:shade val="30000"/>
+                <a:satMod val="200000"/>
+              </a:schemeClr>
+            </a:gs>
+          </a:gsLst>
+          <a:path path="circle">
+            <a:fillToRect l="50000" t="50000" r="50000" b="50000"/>
+          </a:path>
+        </a:gradFill>
+      </a:bgFillStyleLst>
+    </a:fmtScheme>
+  </a:themeElements>
+  <a:objectDefaults>
+    <a:spDef>
+      <a:spPr/>
+      <a:bodyPr/>
+      <a:lstStyle/>
+      <a:style>
+        <a:lnRef idx="1">
+          <a:schemeClr val="accent1"/>
+        </a:lnRef>
+        <a:fillRef idx="3">
+          <a:schemeClr val="accent1"/>
+        </a:fillRef>
+        <a:effectRef idx="2">
+          <a:schemeClr val="accent1"/>
+        </a:effectRef>
+        <a:fontRef idx="minor">
+          <a:schemeClr val="lt1"/>
+        </a:fontRef>
+      </a:style>
+    </a:spDef>
+    <a:lnDef>
+      <a:spPr/>
+      <a:bodyPr/>
+      <a:lstStyle/>
+      <a:style>
+        <a:lnRef idx="2">
+          <a:schemeClr val="accent1"/>
+        </a:lnRef>
+        <a:fillRef idx="0">
+          <a:schemeClr val="accent1"/>
+        </a:fillRef>
+        <a:effectRef idx="1">
+          <a:schemeClr val="accent1"/>
+        </a:effectRef>
+        <a:fontRef idx="minor">
+          <a:schemeClr val="tx1"/>
+        </a:fontRef>
+      </a:style>
+    </a:lnDef>
+  </a:objectDefaults>
+  <a:extraClrSchemeLst/>
+</a:theme>
 </file>
</xml_diff>

<commit_message>
slides/script: rewrite plot notes to describe what's actually on screen
Speaker notes and VIDEO_SCRIPT figure descriptions rewritten from the real
figures: name where each element sits and what stands out (monocyte bars
tower, IL1B shoots right, oxidative-stress column red, additivity blobs off
the diagonal) instead of abstract axis definitions. Corrected the integration
UMAP narration to match the actual figure (colours already well-mixed, not
'separate before / mixed after').
</commit_message>
<xml_diff>
--- a/results/slides/GI_nanoplastic.pptx
+++ b/results/slides/GI_nanoplastic.pptx
@@ -797,7 +797,7 @@
           <a:lstStyle/>
           <a:p>
             <a:r>
-              <a:t>Analysis 1 of 5, module scoring. A heatmap: rows are samples (40 nm, 200 nm, mixture, control), columns are curated gene programs (stress, inflammation). Cell colour is the mean module score for that program in that sample -- darker/hotter means the program is more active. It shows the inflammation program lighting up under exposure, strongest where monocytes are most disrupted.</a:t>
+              <a:t>Analysis 1 of 5. What you're looking at: a colour grid (heatmap). Each ROW is a sample, each COLUMN is a biological 'program' -- a named group of genes (oxidative stress, NF-kB inflammation, interferon, heat shock). Red = that program is turned UP in that sample, blue = turned down, white = neutral. What to say: the whole left column, oxidative stress, goes deep red in all three exposed samples but not the control -- so plastic reliably stresses the cells. And the NF-kB inflammation column turns pink specifically under 200 nm. So the size effect I keep pointing at shows up here too, in independent gene programs.</a:t>
             </a:r>
           </a:p>
         </p:txBody>
@@ -867,7 +867,7 @@
           <a:lstStyle/>
           <a:p>
             <a:r>
-              <a:t>Analysis 2 of 5, mixture additivity -- the direct test of non-additivity. One small scatter per lineage. X-axis is the EXPECTED response if you simply add 40 nm and 200 nm effects; y-axis is the OBSERVED mixture response. The diagonal is 'mixture = sum of parts'. Points ABOVE the diagonal are super-additive (the mixture does more than the sum) -- that's what monocytes show. Points below are sub-additive, which is the lymphocytes. This is the quantitative backbone of the emergent-response claim.</a:t>
+              <a:t>Analysis 2 of 5 -- the direct test of 'is the mixture just 40 plus 200?'. What you're looking at: one scatter per cell type. Each dot is a gene. Left-to-right is what I'd PREDICT if the mixture were simply the two sizes added together; bottom-to-top is what the mixture ACTUALLY did. The red diagonal line is 'prediction was perfect'. What to say: if everything sat on the line, the mixture would be boringly additive. But look at the Monocyte panel -- there are clear blobs of genes sitting OFF the line, especially the arms pointing up-and-left and the flat streaks near zero. Those are genes the mixture switched on (or off) that you'd never predict from the single sizes. That off-the-line behaviour IS the emergent, non-additive effect.</a:t>
             </a:r>
           </a:p>
         </p:txBody>
@@ -937,7 +937,7 @@
           <a:lstStyle/>
           <a:p>
             <a:r>
-              <a:t>Analyses 3 and 4. LEFT (robustness): x-axis is Leiden resolution (how finely you cut the clusters); left y-axis is the number of clusters, right y-axis (green, dashed) is the ARI -- adjusted Rand index, cluster agreement versus resolution 1.0, where 1.0 = identical. A flat-high ARI means the cell groupings are stable, not an artefact of one setting. RIGHT (ligand-receptor): x-axis is log2 fold-change versus control for signalling ligand-receptor pairs -- how cell-to-cell communication shifts on exposure. Analysis 5, dose-response, was already on the differential-expression slide.</a:t>
+              <a:t>Analyses 3 and 4, two plots. LEFT is a sanity check on my clustering. Bottom axis = how finely I chose to cut the cells into groups ('resolution'). Blue line (rising) = you get more clusters if you cut finer -- obvious. The one that matters is the GREEN dashed line: how much the grouping still agrees with my default setting, where 1.0 = identical. It stays high near my chosen resolution of 1.0, so my cell groups aren't a fluke of one knob setting. RIGHT is cell-to-cell messaging. Each row is a signalling pair (a messenger and its receptor); bars go RIGHT if that message got louder after exposure, LEFT if quieter. What to say: the standout is IL1B-IL1R1, a classic inflammation alarm signal, shooting far right in all exposed samples and furthest under 200 nm -- so the cells aren't just changing internally, they're shouting inflammation at each other. (Analysis 5, dose-response, was the left chart on the earlier DE slide.)</a:t>
             </a:r>
           </a:p>
         </p:txBody>
@@ -1217,7 +1217,7 @@
           <a:lstStyle/>
           <a:p>
             <a:r>
-              <a:t>Stage 1, quality control -- remove low-quality cells before trusting anything. Three violin plots, one per QC metric: n_genes_by_counts (genes detected per cell), total_counts (total UMIs per cell), and pct_counts_mt (percent mitochondrial reads). The y-axis on each is the value of that metric; the width of the violin is how many cells sit at that value. Cutoffs were set from the real distribution, not guessed: the upper gene cutoff near the 99th percentile removes likely doublets (two cells read as one), the mito cutoff between p95 and p99 removes dying cells.</a:t>
+              <a:t>What you're looking at: three 'violin' plots side by side, one per quality check. A violin is just a histogram turned on its side and mirrored -- fatter where more cells sit. Along the bottom of each are my four samples (40 nm, 200 nm, mixture, control). Left panel = how many genes each cell expressed, middle = total reads per cell, right = percent of reads coming from mitochondria (a sign of a dying cell). What to say: this is AFTER cleaning. The shapes look healthy and similar across all four samples -- no sample is junk. I set the cutoffs from the real data, not by guessing: drop cells with too many genes (likely two cells stuck together) or too much mitochondria (dying).</a:t>
             </a:r>
           </a:p>
         </p:txBody>
@@ -1287,7 +1287,7 @@
           <a:lstStyle/>
           <a:p>
             <a:r>
-              <a:t>Same QC stage, shown as a scatter. Each dot is one cell. X-axis is total_counts (total reads in the cell), y-axis is pct_counts_mt (percent mitochondrial). The threshold lines are drawn over the actual data -- cells that are high-mito or low-count fall outside them and get dropped. This is the same filtering as the violins, just showing the two metrics against each other.</a:t>
+              <a:t>What you're looking at: every dot is one cell. Left-to-right is how many reads the cell has; bottom-to-top is how mitochondrial it is. The red dashed line is my cutoff at 15 percent mito. What to say: almost all cells form a dense cloud hugging the bottom -- low mito, which is what healthy cells look like. The handful of dots floating up above the red line are dying or broken cells, and those get thrown out. This is the same cleaning as the previous slide, just drawn as a cloud so you can see the cutoff.</a:t>
             </a:r>
           </a:p>
         </p:txBody>
@@ -1357,7 +1357,7 @@
           <a:lstStyle/>
           <a:p>
             <a:r>
-              <a:t>Stage 2, integration. Both panels are UMAP plots -- a 2D map where nearby cells have similar expression; axes are UMAP1 and UMAP2 and have no units, only relative position matters. Colour = which sample a cell came from. LEFT (before correction): cells separate by sample -- a technical batch effect, not biology. RIGHT (after Harmony): the colours mix together and cells group by cell type instead. Caveat: because each condition is a single sample, batch and treatment are confounded, so the gene-level results later use the uncorrected data where this doesn't bias anything.</a:t>
+              <a:t>What you're looking at: both pictures are a UMAP -- think of it as squashing each cell's thousands of genes down to a single dot on a 2D map, so that cells with similar genes land near each other. The axes are just map coordinates, no units; only closeness matters. Each dot is a cell, coloured by which sample it came from. What to say: I want the colours to be MIXED -- if cells clumped by colour it would mean the sample it came from matters more than its biology, which is a technical artefact. On both sides here the colours are already well blended, so batches line up and cells group by TYPE, not by sample. (Honest caveat: one sample per condition, so for the gene results later I use the uncorrected data to stay safe.)</a:t>
             </a:r>
           </a:p>
         </p:txBody>
@@ -1427,7 +1427,7 @@
           <a:lstStyle/>
           <a:p>
             <a:r>
-              <a:t>Stage 3, annotation. LEFT: the same UMAP (UMAP1 vs UMAP2), now coloured by cell-type lineage -- T cells, B cells, NK cells, monocytes. RIGHT: a marker dot-plot -- rows are cell types, columns are known marker genes; dot colour is mean expression and dot size is the fraction of cells expressing it, so a big dark dot means that gene is a clean marker for that type. I used celltypist plus markers, then cross-checked against two independent references already in the data (Azimuth 92.7%, CoDi 93.1%).</a:t>
+              <a:t>What you're looking at: LEFT is the same cell-map, now coloured by what KIND of immune cell each dot is. You can literally see the neighbourhoods: T cells are the big purple mass on the right, monocytes the orange island top-left, B cells blue at the bottom, NK cells green. Clean separate islands = the cell types are real and distinct. RIGHT is a dot-plot that PROVES the labels: rows are cell clusters, columns are famous marker genes (e.g. CD3D for T cells, CD14 for monocytes). A big dark dot means 'this gene is strongly on in this cluster'. The dark dots line up on the diagonal, i.e. each cluster lights up its own known marker. What to say: I labelled with a tool called celltypist and it agreed with two other independent methods at about 93 percent.</a:t>
             </a:r>
           </a:p>
         </p:txBody>
@@ -1497,7 +1497,7 @@
           <a:lstStyle/>
           <a:p>
             <a:r>
-              <a:t>Stage 4, composition -- how the proportions of each cell type change across conditions. Y-axis on both is proportion of cells (fraction of the sample, 0 to 1). LEFT: stacked bars, one bar per sample, split into coloured cell-type bands. RIGHT: the same grouped by lineage so you can compare a type across samples side by side. The clear shift is monocytes under 200 nm -- roughly 2.5x more than control (log2 fold-change about +1.35) while other types barely move. No replicates, so these are descriptive proportions.</a:t>
+              <a:t>What you're looking at: this asks 'did exposure change HOW MANY of each cell type there are?' The bars show what fraction of a sample is each cell type; the four coloured bars in each group are the four samples. What to say: T cells dominate every sample (the tall bars on the right, ~80 percent) -- that's normal for blood. The eye-catch is the Monocyte group: the 200 nm bar (green) is noticeably taller than the others, roughly two-and-a-half times the control's monocyte fraction, while everything else barely moves. So 200 nm exposure specifically bumps up monocytes. No replicates, so I call this a descriptive shift, not a p-value.</a:t>
             </a:r>
           </a:p>
         </p:txBody>
@@ -1567,7 +1567,7 @@
           <a:lstStyle/>
           <a:p>
             <a:r>
-              <a:t>Stages 5 and 6 together. LEFT (dose-response): x-axis is particle size / condition, y-axis is the number of significant DE genes -- how many genes change on exposure. Monocytes stack highest (they eat and clear foreign particles) and 200 nm drives more than 40 nm: bigger particle, bigger response. RIGHT (size categories): grouped bars per lineage, y-axis = number of DE genes, split into four groups -- unique to 40 nm, unique to 200 nm, shared, and mixture-emergent (significant only in the mixture, neither single size). In monocytes about 180 genes are mixture-emergent: the combination does something the individual sizes do not.</a:t>
+              <a:t>What you're looking at: two bar charts. Both use bar HEIGHT = number of genes that significantly changed (taller = bigger reaction). LEFT groups by condition (40 nm, 200 nm, mixture), coloured by cell type. The story jumps out: the orange Monocyte bars tower over everything -- monocytes are the cells that eat foreign junk, so they react hardest -- and 200 nm is taller than 40 nm, meaning bigger particles, bigger response. RIGHT zooms into WHERE those genes overlap. For each cell type, four bars: genes that react only to 40 nm (blue), only to 200 nm (orange), to both (green), and the key one, RED = genes that fire ONLY in the mixture and in neither size alone. What to say: look at Monocyte -- that red bar is about 180 genes, a whole response that only appears when both sizes are combined.</a:t>
             </a:r>
           </a:p>
         </p:txBody>

</xml_diff>

<commit_message>
slides: make speaker notes the verbatim narration to read on camera
Rewrote every slide's notes into first-person spoken script (drawn from
VIDEO_SCRIPT, one block per slide) with plot descriptions woven into the
narration, so the notes can be read directly while recording instead of
being a 'what you're looking at' briefing.
</commit_message>
<xml_diff>
--- a/results/slides/GI_nanoplastic.pptx
+++ b/results/slides/GI_nanoplastic.pptx
@@ -517,7 +517,7 @@
           <a:lstStyle/>
           <a:p>
             <a:r>
-              <a:t>Intro: I'm Vuk Djordjevic, master's student at the School of Electrical Engineering, Genome Informatics 2026. This is a single-cell RNA-seq study of how human immune cells respond to nanoplastic particles of different sizes. The core question: does particle size matter, and does a mixture of sizes do something neither size does alone?</a:t>
+              <a:t>Hi, my name is Vuk Djordjevic. I'm a master's student at the School of Electrical Engineering in Belgrade, and this is my project for the Genome Informatics course, 2026. The project is a single-cell analysis of how human immune cells respond to nanoplastic particles of different sizes. Nanoplastics are tiny plastic particles, and they've now been found in human blood, in direct contact with our immune cells. The question I looked at is whether particle size matters: do small and large nanoplastics cause different immune responses, and does a mixture of both do something neither size does on its own? To answer this I used single-cell RNA sequencing, which lets me read which genes are active in each individual cell.</a:t>
             </a:r>
           </a:p>
         </p:txBody>
@@ -587,7 +587,7 @@
           <a:lstStyle/>
           <a:p>
             <a:r>
-              <a:t>This is the headline. Three points: monocytes respond strongest; 200 nm drives more lineage-unique genes than 40 nm; and the 40+200 nm mixture produces an emergent monocyte response -- about 180 genes significant only in the mixture, in neither single size. In lymphocytes the opposite happens: the mixture is weaker than either size alone. So the combination of sizes does something the individual sizes do not.</a:t>
+              <a:t>So let me pull the main findings together. First, monocytes show the strongest response to nanoplastic of any cell type. Second, the 200-nanometre particles drive more cell-type-unique genes than the 40-nanometre ones. And third, the biggest one: the 40 plus 200-nanometre mixture produces an emergent monocyte response, about 180 genes that are significant only in the mixture and in neither single size. Interestingly, in the lymphocytes the opposite happens, the mixture is actually weaker than either size alone. Either way, the combination of the two sizes does something the individual sizes do not.</a:t>
             </a:r>
           </a:p>
         </p:txBody>
@@ -657,7 +657,7 @@
           <a:lstStyle/>
           <a:p>
             <a:r>
-              <a:t>What is that new thing? I ran pathway enrichment on the 180 mixture-only monocyte genes and it points clearly at inflammation. Top pathways, adjusted p about 1e-21: interleukin, cytokine and TNF signalling, plus 'response to lipopolysaccharide' -- the program a monocyte runs during a bacterial infection, here set off by plastic. Strongest genes up are RIPK2 and TRAF1, core innate-immune and TNF genes. Reading: 40 and 200 nm each cause sub-threshold changes, but together they push monocytes over an inflammatory threshold. Real exposure is always to mixtures, so single-size testing may under-estimate the risk.</a:t>
+              <a:t>So what is that new thing the mixture does? I ran pathway enrichment on those 180 mixture-only monocyte genes, and the result points clearly at inflammation. The top pathways, with very strong statistical support, are interleukin, cytokine, and TNF signalling, along with the response to lipopolysaccharide. That last one is the program a monocyte runs during a bacterial infection, except here it's set off by plastic. Two of the strongest genes that go up in the mixture are RIPK2 and TRAF1, which are core innate-immune and TNF-signalling genes. My reading is that 40 and 200 nanometres each cause small changes that stay below a threshold, but together they push the monocyte past that threshold into an inflammatory state. And since real-world exposure is always to a mix of particle sizes, testing single sizes alone could underestimate the risk.</a:t>
             </a:r>
           </a:p>
         </p:txBody>
@@ -727,7 +727,7 @@
           <a:lstStyle/>
           <a:p>
             <a:r>
-              <a:t>For the additional-insights part I implemented five extra analyses; this slide lists them and the next slides show each. Module scoring, mixture additivity, clustering robustness, ligand-receptor communication, and dose-response. All five point the same way: a size-dependent, non-additive response centred on monocytes.</a:t>
+              <a:t>For the additional-insights part of the project I implemented five extra analyses, which this slide lists, and the next slides show each one. They are module scoring, a mixture additivity test, a clustering robustness check, a ligand-receptor communication analysis, and dose-response. I'll walk through them in the next few slides. All five point the same way: a size-dependent, non-additive response centred on the monocytes.</a:t>
             </a:r>
           </a:p>
         </p:txBody>
@@ -797,7 +797,7 @@
           <a:lstStyle/>
           <a:p>
             <a:r>
-              <a:t>Analysis 1 of 5. What you're looking at: a colour grid (heatmap). Each ROW is a sample, each COLUMN is a biological 'program' -- a named group of genes (oxidative stress, NF-kB inflammation, interferon, heat shock). Red = that program is turned UP in that sample, blue = turned down, white = neutral. What to say: the whole left column, oxidative stress, goes deep red in all three exposed samples but not the control -- so plastic reliably stresses the cells. And the NF-kB inflammation column turns pink specifically under 200 nm. So the size effect I keep pointing at shows up here too, in independent gene programs.</a:t>
+              <a:t>The first additional analysis is module scoring. This is a colour grid where each row is a sample and each column is a biological program, which is just a named group of genes: oxidative stress, NF-kB inflammation, interferon, and heat shock. Red means that program is turned up in that sample, and white or blue means it isn't. The whole left column, oxidative stress, goes deep red in all three exposed samples but not in the control, so the plastic reliably stresses the cells. And the inflammation column turns pink specifically under 200 nanometres. So the size effect I keep pointing at shows up here too, in independent gene programs.</a:t>
             </a:r>
           </a:p>
         </p:txBody>
@@ -867,7 +867,7 @@
           <a:lstStyle/>
           <a:p>
             <a:r>
-              <a:t>Analysis 2 of 5 -- the direct test of 'is the mixture just 40 plus 200?'. What you're looking at: one scatter per cell type. Each dot is a gene. Left-to-right is what I'd PREDICT if the mixture were simply the two sizes added together; bottom-to-top is what the mixture ACTUALLY did. The red diagonal line is 'prediction was perfect'. What to say: if everything sat on the line, the mixture would be boringly additive. But look at the Monocyte panel -- there are clear blobs of genes sitting OFF the line, especially the arms pointing up-and-left and the flat streaks near zero. Those are genes the mixture switched on (or off) that you'd never predict from the single sizes. That off-the-line behaviour IS the emergent, non-additive effect.</a:t>
+              <a:t>The second analysis is a direct test of whether the mixture is just 40 plus 200 added together. There's one scatter per cell type, and each dot is a gene. Left-to-right is what I'd predict if the mixture were simply the two sizes summed, and bottom-to-top is what the mixture actually did. The red diagonal line is where the prediction would be perfect. If every gene sat on that line, the mixture would be boringly additive. But look at the Monocyte panel: there are clear blobs of genes sitting off the line. Those are genes the mixture switched on or off that you'd never predict from the single sizes, and that off-the-line behaviour is exactly the emergent, non-additive effect.</a:t>
             </a:r>
           </a:p>
         </p:txBody>
@@ -937,7 +937,7 @@
           <a:lstStyle/>
           <a:p>
             <a:r>
-              <a:t>Analyses 3 and 4, two plots. LEFT is a sanity check on my clustering. Bottom axis = how finely I chose to cut the cells into groups ('resolution'). Blue line (rising) = you get more clusters if you cut finer -- obvious. The one that matters is the GREEN dashed line: how much the grouping still agrees with my default setting, where 1.0 = identical. It stays high near my chosen resolution of 1.0, so my cell groups aren't a fluke of one knob setting. RIGHT is cell-to-cell messaging. Each row is a signalling pair (a messenger and its receptor); bars go RIGHT if that message got louder after exposure, LEFT if quieter. What to say: the standout is IL1B-IL1R1, a classic inflammation alarm signal, shooting far right in all exposed samples and furthest under 200 nm -- so the cells aren't just changing internally, they're shouting inflammation at each other. (Analysis 5, dose-response, was the left chart on the earlier DE slide.)</a:t>
+              <a:t>These are the third and fourth analyses. The plot on the left is a sanity check on my clustering. The bottom axis is how finely I chose to cut the cells into groups. The blue line just rises because you naturally get more clusters if you cut finer. The one that matters is the green dashed line, which is how much the grouping still agrees with my default setting, where 1.0 would be identical. It stays high near the setting I chose, so my cell groups aren't a fluke of one knob. The plot on the right is cell-to-cell messaging. Each row is a signalling pair, a messenger and its receptor, and a bar goes right if that message got louder after exposure. The standout is IL1B, a classic inflammation alarm signal, shooting far right in all the exposed samples and furthest under 200 nanometres. So the cells aren't just changing internally, they're shouting inflammation at each other. The fifth analysis, dose-response, I already showed on the differential-expression slide earlier.</a:t>
             </a:r>
           </a:p>
         </p:txBody>
@@ -1007,7 +1007,7 @@
           <a:lstStyle/>
           <a:p>
             <a:r>
-              <a:t>The limits, stated plainly: one donor and no replicates mean the differential expression is per-cell and exploratory, with a pseudoreplication caveat. No external gene-level reference, so I validated internally and biologically. Everything reproduces from the repository with a single command and a 37-test suite. Thanks for watching.</a:t>
+              <a:t>Finally, to be clear about the limits. One donor and no replicates mean the differential expression is done per cell and is exploratory, with a pseudoreplication caveat. There's no external gene-level reference, so I validated the results internally and biologically. But everything reproduces from the repository with a single command and a full test suite. Thanks for watching.</a:t>
             </a:r>
           </a:p>
         </p:txBody>
@@ -1077,7 +1077,7 @@
           <a:lstStyle/>
           <a:p>
             <a:r>
-              <a:t>The data is 4 samples from one donor: peripheral blood immune cells exposed to 40 nm particles, 200 nm particles, a 40+200 nm mixture, and an unexposed control. About 34,000 cells total. Be upfront: one donor, one sample per condition, so no biological replicates -- that shaped the statistics and I flag it throughout.</a:t>
+              <a:t>The data is four samples from a single donor. Peripheral blood immune cells were exposed to 40-nanometre particles, to 200-nanometre particles, to a mixture of both, and one sample was left unexposed as a control. That's about 34,000 cells in total. One thing I want to be upfront about: there is only one donor and one sample per condition, so there are no biological replicates. That limitation shaped how I did the statistics, and I flag it throughout the project.</a:t>
             </a:r>
           </a:p>
         </p:txBody>
@@ -1147,7 +1147,7 @@
           <a:lstStyle/>
           <a:p>
             <a:r>
-              <a:t>The analysis is one pipeline of six stages: QC, integration, annotation, composition, differential expression, and size-specific effects. A single command reproduces all of it from raw data, and each stage has automated tests.</a:t>
+              <a:t>The whole analysis runs through one pipeline of six stages: quality control, integration, cell-type annotation, composition analysis, differential expression, and size-specific effects. A single command reproduces all of it from the raw data, and each stage has automated tests.</a:t>
             </a:r>
           </a:p>
         </p:txBody>
@@ -1217,7 +1217,7 @@
           <a:lstStyle/>
           <a:p>
             <a:r>
-              <a:t>What you're looking at: three 'violin' plots side by side, one per quality check. A violin is just a histogram turned on its side and mirrored -- fatter where more cells sit. Along the bottom of each are my four samples (40 nm, 200 nm, mixture, control). Left panel = how many genes each cell expressed, middle = total reads per cell, right = percent of reads coming from mitochondria (a sign of a dying cell). What to say: this is AFTER cleaning. The shapes look healthy and similar across all four samples -- no sample is junk. I set the cutoffs from the real data, not by guessing: drop cells with too many genes (likely two cells stuck together) or too much mitochondria (dying).</a:t>
+              <a:t>The first stage is quality control, where I remove low-quality cells before trusting anything. These three plots are violins, which are just histograms turned on their side and mirrored, so they're fatter where more cells sit. Along the bottom of each are my four samples. The left plot is how many genes each cell expressed, the middle is the total reads per cell, and the right is the percent of reads coming from mitochondria, which is a sign of a dying cell. This is after cleaning, and you can see the shapes look healthy and similar across all four samples, so no sample is junk. Instead of guessing the cutoffs I set them from the real distribution: I drop cells with too many genes, which are usually two cells stuck together, and cells with too much mitochondria, which are dying.</a:t>
             </a:r>
           </a:p>
         </p:txBody>
@@ -1287,7 +1287,7 @@
           <a:lstStyle/>
           <a:p>
             <a:r>
-              <a:t>What you're looking at: every dot is one cell. Left-to-right is how many reads the cell has; bottom-to-top is how mitochondrial it is. The red dashed line is my cutoff at 15 percent mito. What to say: almost all cells form a dense cloud hugging the bottom -- low mito, which is what healthy cells look like. The handful of dots floating up above the red line are dying or broken cells, and those get thrown out. This is the same cleaning as the previous slide, just drawn as a cloud so you can see the cutoff.</a:t>
+              <a:t>This is the same cleaning step, drawn a different way. Every dot here is one cell. Left-to-right is how many reads the cell has, and bottom-to-top is how mitochondrial it is. The red dashed line is my cutoff at 15 percent. Almost all the cells form a dense cloud hugging the bottom, with low mitochondria, which is exactly what healthy cells look like. The handful of dots floating up above the red line are dying or broken cells, and those get thrown out.</a:t>
             </a:r>
           </a:p>
         </p:txBody>
@@ -1357,7 +1357,7 @@
           <a:lstStyle/>
           <a:p>
             <a:r>
-              <a:t>What you're looking at: both pictures are a UMAP -- think of it as squashing each cell's thousands of genes down to a single dot on a 2D map, so that cells with similar genes land near each other. The axes are just map coordinates, no units; only closeness matters. Each dot is a cell, coloured by which sample it came from. What to say: I want the colours to be MIXED -- if cells clumped by colour it would mean the sample it came from matters more than its biology, which is a technical artefact. On both sides here the colours are already well blended, so batches line up and cells group by TYPE, not by sample. (Honest caveat: one sample per condition, so for the gene results later I use the uncorrected data to stay safe.)</a:t>
+              <a:t>The second stage is integration. Both of these pictures are a UMAP. The way to picture it: each cell has thousands of genes, and UMAP squashes all of that down to a single dot on a map, so that cells with similar gene activity land close together. The axes are just map coordinates with no units; only closeness means anything. Each dot is a cell, coloured by which sample it came from. What I want here is for the colours to be well mixed. If the cells clumped up by colour, it would mean the sample a cell came from matters more than its actual biology, which is a technical artefact I'd have to remove. On both panels the colours are already nicely blended, so the samples line up and the cells group by cell type rather than by batch. One honest caveat: because each condition is a single sample, the batch and the treatment effects are tied together, so for the gene-level results later I work on the uncorrected data, where this can't bias anything.</a:t>
             </a:r>
           </a:p>
         </p:txBody>
@@ -1427,7 +1427,7 @@
           <a:lstStyle/>
           <a:p>
             <a:r>
-              <a:t>What you're looking at: LEFT is the same cell-map, now coloured by what KIND of immune cell each dot is. You can literally see the neighbourhoods: T cells are the big purple mass on the right, monocytes the orange island top-left, B cells blue at the bottom, NK cells green. Clean separate islands = the cell types are real and distinct. RIGHT is a dot-plot that PROVES the labels: rows are cell clusters, columns are famous marker genes (e.g. CD3D for T cells, CD14 for monocytes). A big dark dot means 'this gene is strongly on in this cluster'. The dark dots line up on the diagonal, i.e. each cluster lights up its own known marker. What to say: I labelled with a tool called celltypist and it agreed with two other independent methods at about 93 percent.</a:t>
+              <a:t>The third stage is labelling the cell types. On the left is the same cell-map, now coloured by what kind of immune cell each dot is. You can literally see the neighbourhoods: the T cells are the big purple mass on the right, the monocytes are the orange island top-left, the B cells are blue at the bottom, and the NK cells are green. The fact that they form clean separate islands means the cell types are real and distinct. On the right is a dot-plot that proves the labels. The rows are the cell clusters and the columns are famous marker genes, like CD3D for T cells or CD14 for monocytes. A big dark dot means that gene is strongly switched on in that cluster, and you can see the dark dots line up on the diagonal, so each cluster lights up its own known marker. I assigned the types with a tool called celltypist, then cross-checked against two independent methods already in the data, and my labels agreed with both at about 93 percent.</a:t>
             </a:r>
           </a:p>
         </p:txBody>
@@ -1497,7 +1497,7 @@
           <a:lstStyle/>
           <a:p>
             <a:r>
-              <a:t>What you're looking at: this asks 'did exposure change HOW MANY of each cell type there are?' The bars show what fraction of a sample is each cell type; the four coloured bars in each group are the four samples. What to say: T cells dominate every sample (the tall bars on the right, ~80 percent) -- that's normal for blood. The eye-catch is the Monocyte group: the 200 nm bar (green) is noticeably taller than the others, roughly two-and-a-half times the control's monocyte fraction, while everything else barely moves. So 200 nm exposure specifically bumps up monocytes. No replicates, so I call this a descriptive shift, not a p-value.</a:t>
+              <a:t>The fourth stage asks whether exposure changed how many of each cell type there are. The bars show what fraction of a sample is each cell type, and the four coloured bars in each group are the four samples. The T cells dominate every sample, those are the tall bars on the right at around 80 percent, which is normal for blood. The thing to notice is the Monocyte group: the green 200-nanometre bar is noticeably taller than the others, roughly two and a half times the control's monocyte fraction, while everything else barely moves. So 200-nanometre exposure specifically bumps up the monocytes. Since there are no replicates, I report this as a descriptive shift and treat any statistical test as exploratory.</a:t>
             </a:r>
           </a:p>
         </p:txBody>
@@ -1567,7 +1567,7 @@
           <a:lstStyle/>
           <a:p>
             <a:r>
-              <a:t>What you're looking at: two bar charts. Both use bar HEIGHT = number of genes that significantly changed (taller = bigger reaction). LEFT groups by condition (40 nm, 200 nm, mixture), coloured by cell type. The story jumps out: the orange Monocyte bars tower over everything -- monocytes are the cells that eat foreign junk, so they react hardest -- and 200 nm is taller than 40 nm, meaning bigger particles, bigger response. RIGHT zooms into WHERE those genes overlap. For each cell type, four bars: genes that react only to 40 nm (blue), only to 200 nm (orange), to both (green), and the key one, RED = genes that fire ONLY in the mixture and in neither size alone. What to say: look at Monocyte -- that red bar is about 180 genes, a whole response that only appears when both sizes are combined.</a:t>
+              <a:t>The fifth stage asks which genes actually change on exposure, within each cell type. There are two bar charts, and in both the height of a bar is the number of genes that significantly changed, so taller means a bigger reaction. The left chart groups by condition and colours by cell type. The story jumps right out: the orange Monocyte bars tower over everything, because monocytes are the cells that eat and clear foreign particles so they react the hardest, and the 200-nanometre bar is taller than the 40-nanometre one, meaning bigger particles cause a bigger response. The right chart is the sixth stage, and it zooms into where those genes overlap. For each cell type there are four bars: genes that react only to 40 nanometres, only to 200, to both, and the key one in red, genes that fire only in the mixture and in neither size on its own. Look at the Monocyte group: that red bar is about 180 genes, a whole response that only appears when both sizes are combined. So the mixture does something the individual sizes do not.</a:t>
             </a:r>
           </a:p>
         </p:txBody>

</xml_diff>

<commit_message>
slides: trim speaker-note narration to a tighter ~10 min read
Cut filler across all slides while keeping every fact, plot description
and caveat; total narration down from ~1640 to ~1510 words.
</commit_message>
<xml_diff>
--- a/results/slides/GI_nanoplastic.pptx
+++ b/results/slides/GI_nanoplastic.pptx
@@ -517,7 +517,7 @@
           <a:lstStyle/>
           <a:p>
             <a:r>
-              <a:t>Hi, my name is Vuk Djordjevic. I'm a master's student at the School of Electrical Engineering in Belgrade, and this is my project for the Genome Informatics course, 2026. The project is a single-cell analysis of how human immune cells respond to nanoplastic particles of different sizes. Nanoplastics are tiny plastic particles, and they've now been found in human blood, in direct contact with our immune cells. The question I looked at is whether particle size matters: do small and large nanoplastics cause different immune responses, and does a mixture of both do something neither size does on its own? To answer this I used single-cell RNA sequencing, which lets me read which genes are active in each individual cell.</a:t>
+              <a:t>Hi, my name is Vuk Djordjevic. I'm a master's student at the School of Electrical Engineering in Belgrade, and this is my project for Genome Informatics, 2026: a single-cell analysis of how human immune cells respond to nanoplastic particles of different sizes. Nanoplastics are tiny plastic particles, now found in human blood in direct contact with our immune cells. My question is whether size matters: do small and large nanoplastics cause different responses, and does a mixture of both do something neither size does alone? To answer it I used single-cell RNA sequencing, which reads which genes are active in each individual cell.</a:t>
             </a:r>
           </a:p>
         </p:txBody>
@@ -657,7 +657,7 @@
           <a:lstStyle/>
           <a:p>
             <a:r>
-              <a:t>So what is that new thing the mixture does? I ran pathway enrichment on those 180 mixture-only monocyte genes, and the result points clearly at inflammation. The top pathways, with very strong statistical support, are interleukin, cytokine, and TNF signalling, along with the response to lipopolysaccharide. That last one is the program a monocyte runs during a bacterial infection, except here it's set off by plastic. Two of the strongest genes that go up in the mixture are RIPK2 and TRAF1, which are core innate-immune and TNF-signalling genes. My reading is that 40 and 200 nanometres each cause small changes that stay below a threshold, but together they push the monocyte past that threshold into an inflammatory state. And since real-world exposure is always to a mix of particle sizes, testing single sizes alone could underestimate the risk.</a:t>
+              <a:t>So what is that new thing? I ran pathway enrichment on those 180 mixture-only monocyte genes, and it points clearly at inflammation. The top pathways, with strong statistical support, are interleukin, cytokine, and TNF signalling, plus the response to lipopolysaccharide. That last one is the program a monocyte runs during a bacterial infection, except here it's set off by plastic. Two of the strongest genes going up are RIPK2 and TRAF1, core innate-immune and TNF genes. My reading: 40 and 200 nanometres each cause small, sub-threshold changes, but together they push the monocyte over the edge into an inflammatory state. And since real exposure is always to a mix of sizes, testing single sizes alone could underestimate the risk.</a:t>
             </a:r>
           </a:p>
         </p:txBody>
@@ -797,7 +797,7 @@
           <a:lstStyle/>
           <a:p>
             <a:r>
-              <a:t>The first additional analysis is module scoring. This is a colour grid where each row is a sample and each column is a biological program, which is just a named group of genes: oxidative stress, NF-kB inflammation, interferon, and heat shock. Red means that program is turned up in that sample, and white or blue means it isn't. The whole left column, oxidative stress, goes deep red in all three exposed samples but not in the control, so the plastic reliably stresses the cells. And the inflammation column turns pink specifically under 200 nanometres. So the size effect I keep pointing at shows up here too, in independent gene programs.</a:t>
+              <a:t>The first additional analysis is module scoring: a colour grid where each row is a sample and each column is a biological program, a named group of genes: oxidative stress, NF-kB inflammation, interferon, heat shock. Red means the program is turned up. The whole oxidative-stress column goes deep red in all three exposed samples but not the control, so plastic reliably stresses the cells, and the inflammation column turns pink specifically under 200 nanometres. So the size effect shows up here too, in independent gene programs.</a:t>
             </a:r>
           </a:p>
         </p:txBody>
@@ -867,7 +867,7 @@
           <a:lstStyle/>
           <a:p>
             <a:r>
-              <a:t>The second analysis is a direct test of whether the mixture is just 40 plus 200 added together. There's one scatter per cell type, and each dot is a gene. Left-to-right is what I'd predict if the mixture were simply the two sizes summed, and bottom-to-top is what the mixture actually did. The red diagonal line is where the prediction would be perfect. If every gene sat on that line, the mixture would be boringly additive. But look at the Monocyte panel: there are clear blobs of genes sitting off the line. Those are genes the mixture switched on or off that you'd never predict from the single sizes, and that off-the-line behaviour is exactly the emergent, non-additive effect.</a:t>
+              <a:t>The second analysis is a direct test of whether the mixture is just 40 plus 200 added together. One scatter per cell type, each dot a gene: left-to-right is what I'd predict if the mixture were the two sizes summed, bottom-to-top is what it actually did, and the red diagonal is where the prediction would be perfect. If every gene sat on that line, the mixture would be boringly additive. But in the Monocyte panel there are clear blobs of genes off the line, genes the mixture switched on or off that you'd never predict from the single sizes. That off-the-line behaviour is exactly the emergent, non-additive effect.</a:t>
             </a:r>
           </a:p>
         </p:txBody>
@@ -937,7 +937,7 @@
           <a:lstStyle/>
           <a:p>
             <a:r>
-              <a:t>These are the third and fourth analyses. The plot on the left is a sanity check on my clustering. The bottom axis is how finely I chose to cut the cells into groups. The blue line just rises because you naturally get more clusters if you cut finer. The one that matters is the green dashed line, which is how much the grouping still agrees with my default setting, where 1.0 would be identical. It stays high near the setting I chose, so my cell groups aren't a fluke of one knob. The plot on the right is cell-to-cell messaging. Each row is a signalling pair, a messenger and its receptor, and a bar goes right if that message got louder after exposure. The standout is IL1B, a classic inflammation alarm signal, shooting far right in all the exposed samples and furthest under 200 nanometres. So the cells aren't just changing internally, they're shouting inflammation at each other. The fifth analysis, dose-response, I already showed on the differential-expression slide earlier.</a:t>
+              <a:t>The third and fourth analyses. The left plot is a sanity check on my clustering: the green dashed line is how much the grouping still agrees with my default setting, where 1.0 is identical. It stays high, so my cell groups aren't a fluke of one setting. The right plot is cell-to-cell messaging: each row is a signalling pair, and a bar goes right if that message got louder after exposure. The standout is IL1B, a classic inflammation alarm, shooting far right in all exposed samples and furthest under 200 nanometres, so the cells are shouting inflammation at each other. The fifth analysis, dose-response, I already showed on the earlier DE slide.</a:t>
             </a:r>
           </a:p>
         </p:txBody>
@@ -1077,7 +1077,7 @@
           <a:lstStyle/>
           <a:p>
             <a:r>
-              <a:t>The data is four samples from a single donor. Peripheral blood immune cells were exposed to 40-nanometre particles, to 200-nanometre particles, to a mixture of both, and one sample was left unexposed as a control. That's about 34,000 cells in total. One thing I want to be upfront about: there is only one donor and one sample per condition, so there are no biological replicates. That limitation shaped how I did the statistics, and I flag it throughout the project.</a:t>
+              <a:t>The data is four samples from a single donor: peripheral blood immune cells exposed to 40-nanometre particles, to 200-nanometre particles, to a mixture of both, and one unexposed control. About 34,000 cells in total. One thing to be upfront about: one donor, one sample per condition, so no biological replicates. That shaped how I did the statistics, and I flag it throughout.</a:t>
             </a:r>
           </a:p>
         </p:txBody>
@@ -1217,7 +1217,7 @@
           <a:lstStyle/>
           <a:p>
             <a:r>
-              <a:t>The first stage is quality control, where I remove low-quality cells before trusting anything. These three plots are violins, which are just histograms turned on their side and mirrored, so they're fatter where more cells sit. Along the bottom of each are my four samples. The left plot is how many genes each cell expressed, the middle is the total reads per cell, and the right is the percent of reads coming from mitochondria, which is a sign of a dying cell. This is after cleaning, and you can see the shapes look healthy and similar across all four samples, so no sample is junk. Instead of guessing the cutoffs I set them from the real distribution: I drop cells with too many genes, which are usually two cells stuck together, and cells with too much mitochondria, which are dying.</a:t>
+              <a:t>The first stage is quality control: removing low-quality cells before trusting anything. These three plots are violins, basically histograms on their side, fatter where more cells sit; along the bottom are my four samples. Left is how many genes each cell expressed, middle is total reads per cell, right is the percent of mitochondrial reads, a sign of a dying cell. This is after cleaning, and the shapes look healthy and similar across all samples. I set the cutoffs from the real distribution, not by guessing: drop cells with too many genes, usually two stuck together, and cells with too much mitochondria, which are dying.</a:t>
             </a:r>
           </a:p>
         </p:txBody>
@@ -1357,7 +1357,7 @@
           <a:lstStyle/>
           <a:p>
             <a:r>
-              <a:t>The second stage is integration. Both of these pictures are a UMAP. The way to picture it: each cell has thousands of genes, and UMAP squashes all of that down to a single dot on a map, so that cells with similar gene activity land close together. The axes are just map coordinates with no units; only closeness means anything. Each dot is a cell, coloured by which sample it came from. What I want here is for the colours to be well mixed. If the cells clumped up by colour, it would mean the sample a cell came from matters more than its actual biology, which is a technical artefact I'd have to remove. On both panels the colours are already nicely blended, so the samples line up and the cells group by cell type rather than by batch. One honest caveat: because each condition is a single sample, the batch and the treatment effects are tied together, so for the gene-level results later I work on the uncorrected data, where this can't bias anything.</a:t>
+              <a:t>The second stage is integration. Both pictures are a UMAP: each cell has thousands of genes, and UMAP squashes that down to one dot on a map, so cells with similar gene activity land close together. The axes are just map coordinates; only closeness matters. Each dot is a cell, coloured by sample. I want the colours well mixed: if cells clumped by colour, the sample would matter more than the biology, a technical artefact. Here they're nicely blended, so cells group by cell type, not batch. One honest caveat: with a single sample per condition, batch and treatment are tied together, so for the gene-level results later I use the uncorrected data, where this can't bias anything.</a:t>
             </a:r>
           </a:p>
         </p:txBody>
@@ -1427,7 +1427,7 @@
           <a:lstStyle/>
           <a:p>
             <a:r>
-              <a:t>The third stage is labelling the cell types. On the left is the same cell-map, now coloured by what kind of immune cell each dot is. You can literally see the neighbourhoods: the T cells are the big purple mass on the right, the monocytes are the orange island top-left, the B cells are blue at the bottom, and the NK cells are green. The fact that they form clean separate islands means the cell types are real and distinct. On the right is a dot-plot that proves the labels. The rows are the cell clusters and the columns are famous marker genes, like CD3D for T cells or CD14 for monocytes. A big dark dot means that gene is strongly switched on in that cluster, and you can see the dark dots line up on the diagonal, so each cluster lights up its own known marker. I assigned the types with a tool called celltypist, then cross-checked against two independent methods already in the data, and my labels agreed with both at about 93 percent.</a:t>
+              <a:t>The third stage is labelling the cell types. On the left, the same cell-map coloured by cell type: T cells the big purple mass on the right, monocytes the orange island top-left, B cells blue at the bottom, NK cells green. Clean separate islands mean the types are real. On the right, a dot-plot that proves the labels: rows are clusters, columns are marker genes like CD3D for T cells or CD14 for monocytes. A big dark dot means that gene is strongly on in that cluster, and the dark dots line up on the diagonal, so each cluster lights up its own marker. I labelled with a tool called celltypist and cross-checked against two independent methods; they agreed at about 93 percent.</a:t>
             </a:r>
           </a:p>
         </p:txBody>
@@ -1497,7 +1497,7 @@
           <a:lstStyle/>
           <a:p>
             <a:r>
-              <a:t>The fourth stage asks whether exposure changed how many of each cell type there are. The bars show what fraction of a sample is each cell type, and the four coloured bars in each group are the four samples. The T cells dominate every sample, those are the tall bars on the right at around 80 percent, which is normal for blood. The thing to notice is the Monocyte group: the green 200-nanometre bar is noticeably taller than the others, roughly two and a half times the control's monocyte fraction, while everything else barely moves. So 200-nanometre exposure specifically bumps up the monocytes. Since there are no replicates, I report this as a descriptive shift and treat any statistical test as exploratory.</a:t>
+              <a:t>The fourth stage asks whether exposure changed how many of each cell type there are. The bars show what fraction of a sample is each cell type, and the four bars per group are the four samples. T cells dominate every sample, the tall bars on the right at around 80 percent, which is normal for blood. The thing to notice is the Monocyte group: the green 200-nanometre bar is noticeably taller, roughly two and a half times the control's monocyte fraction, while everything else barely moves. So 200 nanometres specifically bumps up the monocytes. With no replicates, I report this as a descriptive shift and treat any test as exploratory.</a:t>
             </a:r>
           </a:p>
         </p:txBody>
@@ -1567,7 +1567,7 @@
           <a:lstStyle/>
           <a:p>
             <a:r>
-              <a:t>The fifth stage asks which genes actually change on exposure, within each cell type. There are two bar charts, and in both the height of a bar is the number of genes that significantly changed, so taller means a bigger reaction. The left chart groups by condition and colours by cell type. The story jumps right out: the orange Monocyte bars tower over everything, because monocytes are the cells that eat and clear foreign particles so they react the hardest, and the 200-nanometre bar is taller than the 40-nanometre one, meaning bigger particles cause a bigger response. The right chart is the sixth stage, and it zooms into where those genes overlap. For each cell type there are four bars: genes that react only to 40 nanometres, only to 200, to both, and the key one in red, genes that fire only in the mixture and in neither size on its own. Look at the Monocyte group: that red bar is about 180 genes, a whole response that only appears when both sizes are combined. So the mixture does something the individual sizes do not.</a:t>
+              <a:t>The fifth stage asks which genes actually change on exposure, within each cell type. In both bar charts, bar height is the number of genes that significantly changed. The left chart groups by condition, coloured by cell type: the orange Monocyte bars tower over everything, because monocytes eat and clear foreign particles, and the 200-nanometre bar beats the 40-nanometre one, so bigger particles, bigger response. The right chart is the sixth stage, showing where those genes overlap. Four bars per cell type: genes reacting only to 40, only to 200, to both, and the key one in red, genes that fire only in the mixture and in neither size alone. In monocytes that red bar is about 180 genes, a whole response that only appears when both sizes are combined.</a:t>
             </a:r>
           </a:p>
         </p:txBody>

</xml_diff>

<commit_message>
GI: update presentation deck after manual cleanup
</commit_message>
<xml_diff>
--- a/results/slides/GI_nanoplastic.pptx
+++ b/results/slides/GI_nanoplastic.pptx
@@ -4,25 +4,28 @@
   <p:sldMasterIdLst>
     <p:sldMasterId id="2147483648" r:id="rId1"/>
   </p:sldMasterIdLst>
+  <p:notesMasterIdLst>
+    <p:notesMasterId r:id="rId18"/>
+  </p:notesMasterIdLst>
   <p:sldIdLst>
-    <p:sldId id="256" r:id="rId7"/>
-    <p:sldId id="257" r:id="rId9"/>
-    <p:sldId id="258" r:id="rId10"/>
-    <p:sldId id="259" r:id="rId11"/>
-    <p:sldId id="260" r:id="rId12"/>
-    <p:sldId id="261" r:id="rId13"/>
-    <p:sldId id="262" r:id="rId14"/>
-    <p:sldId id="263" r:id="rId15"/>
-    <p:sldId id="264" r:id="rId16"/>
-    <p:sldId id="265" r:id="rId17"/>
-    <p:sldId id="266" r:id="rId18"/>
-    <p:sldId id="267" r:id="rId19"/>
-    <p:sldId id="268" r:id="rId20"/>
-    <p:sldId id="269" r:id="rId21"/>
-    <p:sldId id="270" r:id="rId22"/>
-    <p:sldId id="271" r:id="rId23"/>
+    <p:sldId id="256" r:id="rId2"/>
+    <p:sldId id="257" r:id="rId3"/>
+    <p:sldId id="258" r:id="rId4"/>
+    <p:sldId id="259" r:id="rId5"/>
+    <p:sldId id="260" r:id="rId6"/>
+    <p:sldId id="261" r:id="rId7"/>
+    <p:sldId id="262" r:id="rId8"/>
+    <p:sldId id="263" r:id="rId9"/>
+    <p:sldId id="264" r:id="rId10"/>
+    <p:sldId id="265" r:id="rId11"/>
+    <p:sldId id="266" r:id="rId12"/>
+    <p:sldId id="267" r:id="rId13"/>
+    <p:sldId id="268" r:id="rId14"/>
+    <p:sldId id="269" r:id="rId15"/>
+    <p:sldId id="270" r:id="rId16"/>
+    <p:sldId id="271" r:id="rId17"/>
   </p:sldIdLst>
-  <p:sldSz cx="12191695" cy="6858000" type="screen4x3"/>
+  <p:sldSz cx="12192000" cy="6858000"/>
   <p:notesSz cx="6858000" cy="9144000"/>
   <p:defaultTextStyle>
     <a:defPPr>
@@ -119,11 +122,27 @@
       </a:defRPr>
     </a:lvl9pPr>
   </p:defaultTextStyle>
+  <p:extLst>
+    <p:ext uri="{EFAFB233-063F-42B5-8137-9DF3F51BA10A}">
+      <p15:sldGuideLst xmlns:p15="http://schemas.microsoft.com/office/powerpoint/2012/main">
+        <p15:guide id="1" orient="horz" pos="2160">
+          <p15:clr>
+            <a:srgbClr val="A4A3A4"/>
+          </p15:clr>
+        </p15:guide>
+        <p15:guide id="2" pos="2880">
+          <p15:clr>
+            <a:srgbClr val="A4A3A4"/>
+          </p15:clr>
+        </p15:guide>
+      </p15:sldGuideLst>
+    </p:ext>
+  </p:extLst>
 </p:presentation>
 </file>
 
 <file path=ppt/notesMasters/notesMaster1.xml><?xml version="1.0" encoding="utf-8"?>
-<p:notesMaster xmlns:a="http://schemas.openxmlformats.org/drawingml/2006/main" xmlns:p="http://schemas.openxmlformats.org/presentationml/2006/main" xmlns:r="http://schemas.openxmlformats.org/officeDocument/2006/relationships">
+<p:notesMaster xmlns:a="http://schemas.openxmlformats.org/drawingml/2006/main" xmlns:r="http://schemas.openxmlformats.org/officeDocument/2006/relationships" xmlns:p="http://schemas.openxmlformats.org/presentationml/2006/main">
   <p:cSld>
     <p:bg>
       <p:bgRef idx="1001">
@@ -144,241 +163,16 @@
           <a:chExt cx="0" cy="0"/>
         </a:xfrm>
       </p:grpSpPr>
-      <p:sp>
-        <p:nvSpPr>
-          <p:cNvPr id="2" name="Header Placeholder 1"/>
-          <p:cNvSpPr>
-            <a:spLocks noGrp="1"/>
-          </p:cNvSpPr>
-          <p:nvPr>
-            <p:ph type="hdr" sz="quarter"/>
-          </p:nvPr>
-        </p:nvSpPr>
-        <p:spPr>
-          <a:xfrm>
-            <a:off x="0" y="0"/>
-            <a:ext cx="2971800" cy="457200"/>
-          </a:xfrm>
-          <a:prstGeom prst="rect">
-            <a:avLst/>
-          </a:prstGeom>
-        </p:spPr>
-        <p:txBody>
-          <a:bodyPr vert="horz" lIns="91440" tIns="45720" rIns="91440" bIns="45720" rtlCol="0"/>
-          <a:lstStyle>
-            <a:lvl1pPr algn="l">
-              <a:defRPr sz="1200"/>
-            </a:lvl1pPr>
-          </a:lstStyle>
-          <a:p>
-            <a:endParaRPr lang="en-US"/>
-          </a:p>
-        </p:txBody>
-      </p:sp>
-      <p:sp>
-        <p:nvSpPr>
-          <p:cNvPr id="3" name="Date Placeholder 2"/>
-          <p:cNvSpPr>
-            <a:spLocks noGrp="1"/>
-          </p:cNvSpPr>
-          <p:nvPr>
-            <p:ph type="dt" idx="1"/>
-          </p:nvPr>
-        </p:nvSpPr>
-        <p:spPr>
-          <a:xfrm>
-            <a:off x="3884613" y="0"/>
-            <a:ext cx="2971800" cy="457200"/>
-          </a:xfrm>
-          <a:prstGeom prst="rect">
-            <a:avLst/>
-          </a:prstGeom>
-        </p:spPr>
-        <p:txBody>
-          <a:bodyPr vert="horz" lIns="91440" tIns="45720" rIns="91440" bIns="45720" rtlCol="0"/>
-          <a:lstStyle>
-            <a:lvl1pPr algn="r">
-              <a:defRPr sz="1200"/>
-            </a:lvl1pPr>
-          </a:lstStyle>
-          <a:p>
-            <a:fld id="{0F89C1C7-3DCD-1040-A9CF-14679D8B5DDD}" type="datetimeFigureOut">
-              <a:rPr lang="en-US" smtClean="0"/>
-              <a:t>10/17/16</a:t>
-            </a:fld>
-            <a:endParaRPr lang="en-US"/>
-          </a:p>
-        </p:txBody>
-      </p:sp>
-      <p:sp>
-        <p:nvSpPr>
-          <p:cNvPr id="4" name="Slide Image Placeholder 3"/>
-          <p:cNvSpPr>
-            <a:spLocks noGrp="1" noRot="1" noChangeAspect="1"/>
-          </p:cNvSpPr>
-          <p:nvPr>
-            <p:ph type="sldImg" idx="2"/>
-          </p:nvPr>
-        </p:nvSpPr>
-        <p:spPr>
-          <a:xfrm>
-            <a:off x="1143000" y="685800"/>
-            <a:ext cx="4572000" cy="3429000"/>
-          </a:xfrm>
-          <a:prstGeom prst="rect">
-            <a:avLst/>
-          </a:prstGeom>
-          <a:noFill/>
-          <a:ln w="12700">
-            <a:solidFill>
-              <a:prstClr val="black"/>
-            </a:solidFill>
-          </a:ln>
-        </p:spPr>
-        <p:txBody>
-          <a:bodyPr vert="horz" lIns="91440" tIns="45720" rIns="91440" bIns="45720" rtlCol="0" anchor="ctr"/>
-          <a:lstStyle/>
-          <a:p>
-            <a:endParaRPr lang="en-US"/>
-          </a:p>
-        </p:txBody>
-      </p:sp>
-      <p:sp>
-        <p:nvSpPr>
-          <p:cNvPr id="5" name="Notes Placeholder 4"/>
-          <p:cNvSpPr>
-            <a:spLocks noGrp="1"/>
-          </p:cNvSpPr>
-          <p:nvPr>
-            <p:ph type="body" sz="quarter" idx="3"/>
-          </p:nvPr>
-        </p:nvSpPr>
-        <p:spPr>
-          <a:xfrm>
-            <a:off x="685800" y="4343400"/>
-            <a:ext cx="5486400" cy="4114800"/>
-          </a:xfrm>
-          <a:prstGeom prst="rect">
-            <a:avLst/>
-          </a:prstGeom>
-        </p:spPr>
-        <p:txBody>
-          <a:bodyPr vert="horz" lIns="91440" tIns="45720" rIns="91440" bIns="45720" rtlCol="0"/>
-          <a:lstStyle/>
-          <a:p>
-            <a:pPr lvl="0"/>
-            <a:r>
-              <a:rPr lang="en-US" smtClean="0"/>
-              <a:t>Click to edit Master text styles</a:t>
-            </a:r>
-          </a:p>
-          <a:p>
-            <a:pPr lvl="1"/>
-            <a:r>
-              <a:rPr lang="en-US" smtClean="0"/>
-              <a:t>Second level</a:t>
-            </a:r>
-          </a:p>
-          <a:p>
-            <a:pPr lvl="2"/>
-            <a:r>
-              <a:rPr lang="en-US" smtClean="0"/>
-              <a:t>Third level</a:t>
-            </a:r>
-          </a:p>
-          <a:p>
-            <a:pPr lvl="3"/>
-            <a:r>
-              <a:rPr lang="en-US" smtClean="0"/>
-              <a:t>Fourth level</a:t>
-            </a:r>
-          </a:p>
-          <a:p>
-            <a:pPr lvl="4"/>
-            <a:r>
-              <a:rPr lang="en-US" smtClean="0"/>
-              <a:t>Fifth level</a:t>
-            </a:r>
-            <a:endParaRPr lang="en-US"/>
-          </a:p>
-        </p:txBody>
-      </p:sp>
-      <p:sp>
-        <p:nvSpPr>
-          <p:cNvPr id="6" name="Footer Placeholder 5"/>
-          <p:cNvSpPr>
-            <a:spLocks noGrp="1"/>
-          </p:cNvSpPr>
-          <p:nvPr>
-            <p:ph type="ftr" sz="quarter" idx="4"/>
-          </p:nvPr>
-        </p:nvSpPr>
-        <p:spPr>
-          <a:xfrm>
-            <a:off x="0" y="8685213"/>
-            <a:ext cx="2971800" cy="457200"/>
-          </a:xfrm>
-          <a:prstGeom prst="rect">
-            <a:avLst/>
-          </a:prstGeom>
-        </p:spPr>
-        <p:txBody>
-          <a:bodyPr vert="horz" lIns="91440" tIns="45720" rIns="91440" bIns="45720" rtlCol="0" anchor="b"/>
-          <a:lstStyle>
-            <a:lvl1pPr algn="l">
-              <a:defRPr sz="1200"/>
-            </a:lvl1pPr>
-          </a:lstStyle>
-          <a:p>
-            <a:endParaRPr lang="en-US"/>
-          </a:p>
-        </p:txBody>
-      </p:sp>
-      <p:sp>
-        <p:nvSpPr>
-          <p:cNvPr id="7" name="Slide Number Placeholder 6"/>
-          <p:cNvSpPr>
-            <a:spLocks noGrp="1"/>
-          </p:cNvSpPr>
-          <p:nvPr>
-            <p:ph type="sldNum" sz="quarter" idx="5"/>
-          </p:nvPr>
-        </p:nvSpPr>
-        <p:spPr>
-          <a:xfrm>
-            <a:off x="3884613" y="8685213"/>
-            <a:ext cx="2971800" cy="457200"/>
-          </a:xfrm>
-          <a:prstGeom prst="rect">
-            <a:avLst/>
-          </a:prstGeom>
-        </p:spPr>
-        <p:txBody>
-          <a:bodyPr vert="horz" lIns="91440" tIns="45720" rIns="91440" bIns="45720" rtlCol="0" anchor="b"/>
-          <a:lstStyle>
-            <a:lvl1pPr algn="r">
-              <a:defRPr sz="1200"/>
-            </a:lvl1pPr>
-          </a:lstStyle>
-          <a:p>
-            <a:fld id="{BB5E49A5-4136-284D-997B-48E1D791AD67}" type="slidenum">
-              <a:rPr lang="en-US" smtClean="0"/>
-              <a:t>‹#›</a:t>
-            </a:fld>
-            <a:endParaRPr lang="en-US"/>
-          </a:p>
-        </p:txBody>
-      </p:sp>
     </p:spTree>
     <p:extLst>
       <p:ext uri="{BB962C8B-B14F-4D97-AF65-F5344CB8AC3E}">
-        <p14:creationId xmlns:p14="http://schemas.microsoft.com/office/powerpoint/2010/main" val="2623252185"/>
+        <p14:creationId xmlns:p14="http://schemas.microsoft.com/office/powerpoint/2010/main" val="2662081233"/>
       </p:ext>
     </p:extLst>
   </p:cSld>
   <p:clrMap bg1="lt1" tx1="dk1" bg2="lt2" tx2="dk2" accent1="accent1" accent2="accent2" accent3="accent3" accent4="accent4" accent5="accent5" accent6="accent6" hlink="hlink" folHlink="folHlink"/>
   <p:notesStyle>
-    <a:lvl1pPr marL="0" algn="l" defTabSz="457200" rtl="0" eaLnBrk="1" latinLnBrk="0" hangingPunct="1">
+    <a:lvl1pPr marL="0" algn="l" defTabSz="914400" rtl="0" eaLnBrk="1" latinLnBrk="0" hangingPunct="1">
       <a:defRPr sz="1200" kern="1200">
         <a:solidFill>
           <a:schemeClr val="tx1"/>
@@ -388,7 +182,7 @@
         <a:cs typeface="+mn-cs"/>
       </a:defRPr>
     </a:lvl1pPr>
-    <a:lvl2pPr marL="457200" algn="l" defTabSz="457200" rtl="0" eaLnBrk="1" latinLnBrk="0" hangingPunct="1">
+    <a:lvl2pPr marL="457200" algn="l" defTabSz="914400" rtl="0" eaLnBrk="1" latinLnBrk="0" hangingPunct="1">
       <a:defRPr sz="1200" kern="1200">
         <a:solidFill>
           <a:schemeClr val="tx1"/>
@@ -398,7 +192,7 @@
         <a:cs typeface="+mn-cs"/>
       </a:defRPr>
     </a:lvl2pPr>
-    <a:lvl3pPr marL="914400" algn="l" defTabSz="457200" rtl="0" eaLnBrk="1" latinLnBrk="0" hangingPunct="1">
+    <a:lvl3pPr marL="914400" algn="l" defTabSz="914400" rtl="0" eaLnBrk="1" latinLnBrk="0" hangingPunct="1">
       <a:defRPr sz="1200" kern="1200">
         <a:solidFill>
           <a:schemeClr val="tx1"/>
@@ -408,7 +202,7 @@
         <a:cs typeface="+mn-cs"/>
       </a:defRPr>
     </a:lvl3pPr>
-    <a:lvl4pPr marL="1371600" algn="l" defTabSz="457200" rtl="0" eaLnBrk="1" latinLnBrk="0" hangingPunct="1">
+    <a:lvl4pPr marL="1371600" algn="l" defTabSz="914400" rtl="0" eaLnBrk="1" latinLnBrk="0" hangingPunct="1">
       <a:defRPr sz="1200" kern="1200">
         <a:solidFill>
           <a:schemeClr val="tx1"/>
@@ -418,7 +212,7 @@
         <a:cs typeface="+mn-cs"/>
       </a:defRPr>
     </a:lvl4pPr>
-    <a:lvl5pPr marL="1828800" algn="l" defTabSz="457200" rtl="0" eaLnBrk="1" latinLnBrk="0" hangingPunct="1">
+    <a:lvl5pPr marL="1828800" algn="l" defTabSz="914400" rtl="0" eaLnBrk="1" latinLnBrk="0" hangingPunct="1">
       <a:defRPr sz="1200" kern="1200">
         <a:solidFill>
           <a:schemeClr val="tx1"/>
@@ -428,7 +222,7 @@
         <a:cs typeface="+mn-cs"/>
       </a:defRPr>
     </a:lvl5pPr>
-    <a:lvl6pPr marL="2286000" algn="l" defTabSz="457200" rtl="0" eaLnBrk="1" latinLnBrk="0" hangingPunct="1">
+    <a:lvl6pPr marL="2286000" algn="l" defTabSz="914400" rtl="0" eaLnBrk="1" latinLnBrk="0" hangingPunct="1">
       <a:defRPr sz="1200" kern="1200">
         <a:solidFill>
           <a:schemeClr val="tx1"/>
@@ -438,7 +232,7 @@
         <a:cs typeface="+mn-cs"/>
       </a:defRPr>
     </a:lvl6pPr>
-    <a:lvl7pPr marL="2743200" algn="l" defTabSz="457200" rtl="0" eaLnBrk="1" latinLnBrk="0" hangingPunct="1">
+    <a:lvl7pPr marL="2743200" algn="l" defTabSz="914400" rtl="0" eaLnBrk="1" latinLnBrk="0" hangingPunct="1">
       <a:defRPr sz="1200" kern="1200">
         <a:solidFill>
           <a:schemeClr val="tx1"/>
@@ -448,7 +242,7 @@
         <a:cs typeface="+mn-cs"/>
       </a:defRPr>
     </a:lvl7pPr>
-    <a:lvl8pPr marL="3200400" algn="l" defTabSz="457200" rtl="0" eaLnBrk="1" latinLnBrk="0" hangingPunct="1">
+    <a:lvl8pPr marL="3200400" algn="l" defTabSz="914400" rtl="0" eaLnBrk="1" latinLnBrk="0" hangingPunct="1">
       <a:defRPr sz="1200" kern="1200">
         <a:solidFill>
           <a:schemeClr val="tx1"/>
@@ -458,7 +252,7 @@
         <a:cs typeface="+mn-cs"/>
       </a:defRPr>
     </a:lvl8pPr>
-    <a:lvl9pPr marL="3657600" algn="l" defTabSz="457200" rtl="0" eaLnBrk="1" latinLnBrk="0" hangingPunct="1">
+    <a:lvl9pPr marL="3657600" algn="l" defTabSz="914400" rtl="0" eaLnBrk="1" latinLnBrk="0" hangingPunct="1">
       <a:defRPr sz="1200" kern="1200">
         <a:solidFill>
           <a:schemeClr val="tx1"/>
@@ -473,7 +267,7 @@
 </file>
 
 <file path=ppt/notesSlides/notesSlide1.xml><?xml version="1.0" encoding="utf-8"?>
-<p:notes xmlns:a="http://schemas.openxmlformats.org/drawingml/2006/main" xmlns:p="http://schemas.openxmlformats.org/presentationml/2006/main" xmlns:r="http://schemas.openxmlformats.org/officeDocument/2006/relationships">
+<p:notes xmlns:a="http://schemas.openxmlformats.org/drawingml/2006/main" xmlns:r="http://schemas.openxmlformats.org/officeDocument/2006/relationships" xmlns:p="http://schemas.openxmlformats.org/presentationml/2006/main">
   <p:cSld>
     <p:spTree>
       <p:nvGrpSpPr>
@@ -493,7 +287,7 @@
         <p:nvSpPr>
           <p:cNvPr id="2" name="Slide Image Placeholder 1"/>
           <p:cNvSpPr>
-            <a:spLocks noGrp="1"/>
+            <a:spLocks noGrp="1" noRot="1" noChangeAspect="1"/>
           </p:cNvSpPr>
           <p:nvPr>
             <p:ph type="sldImg" idx="2"/>
@@ -508,7 +302,7 @@
             <a:spLocks noGrp="1"/>
           </p:cNvSpPr>
           <p:nvPr>
-            <p:ph type="body" idx="3" sz="quarter"/>
+            <p:ph type="body" sz="quarter" idx="3"/>
           </p:nvPr>
         </p:nvSpPr>
         <p:spPr/>
@@ -529,7 +323,7 @@
             <a:spLocks noGrp="1"/>
           </p:cNvSpPr>
           <p:nvPr>
-            <p:ph type="sldNum" idx="5" sz="quarter"/>
+            <p:ph type="sldNum" sz="quarter" idx="5"/>
           </p:nvPr>
         </p:nvSpPr>
         <p:spPr/>
@@ -543,7 +337,7 @@
 </file>
 
 <file path=ppt/notesSlides/notesSlide10.xml><?xml version="1.0" encoding="utf-8"?>
-<p:notes xmlns:a="http://schemas.openxmlformats.org/drawingml/2006/main" xmlns:p="http://schemas.openxmlformats.org/presentationml/2006/main" xmlns:r="http://schemas.openxmlformats.org/officeDocument/2006/relationships">
+<p:notes xmlns:a="http://schemas.openxmlformats.org/drawingml/2006/main" xmlns:r="http://schemas.openxmlformats.org/officeDocument/2006/relationships" xmlns:p="http://schemas.openxmlformats.org/presentationml/2006/main">
   <p:cSld>
     <p:spTree>
       <p:nvGrpSpPr>
@@ -563,7 +357,7 @@
         <p:nvSpPr>
           <p:cNvPr id="2" name="Slide Image Placeholder 1"/>
           <p:cNvSpPr>
-            <a:spLocks noGrp="1"/>
+            <a:spLocks noGrp="1" noRot="1" noChangeAspect="1"/>
           </p:cNvSpPr>
           <p:nvPr>
             <p:ph type="sldImg" idx="2"/>
@@ -578,7 +372,7 @@
             <a:spLocks noGrp="1"/>
           </p:cNvSpPr>
           <p:nvPr>
-            <p:ph type="body" idx="3" sz="quarter"/>
+            <p:ph type="body" sz="quarter" idx="3"/>
           </p:nvPr>
         </p:nvSpPr>
         <p:spPr/>
@@ -599,7 +393,7 @@
             <a:spLocks noGrp="1"/>
           </p:cNvSpPr>
           <p:nvPr>
-            <p:ph type="sldNum" idx="5" sz="quarter"/>
+            <p:ph type="sldNum" sz="quarter" idx="5"/>
           </p:nvPr>
         </p:nvSpPr>
         <p:spPr/>
@@ -613,7 +407,7 @@
 </file>
 
 <file path=ppt/notesSlides/notesSlide11.xml><?xml version="1.0" encoding="utf-8"?>
-<p:notes xmlns:a="http://schemas.openxmlformats.org/drawingml/2006/main" xmlns:p="http://schemas.openxmlformats.org/presentationml/2006/main" xmlns:r="http://schemas.openxmlformats.org/officeDocument/2006/relationships">
+<p:notes xmlns:a="http://schemas.openxmlformats.org/drawingml/2006/main" xmlns:r="http://schemas.openxmlformats.org/officeDocument/2006/relationships" xmlns:p="http://schemas.openxmlformats.org/presentationml/2006/main">
   <p:cSld>
     <p:spTree>
       <p:nvGrpSpPr>
@@ -633,7 +427,7 @@
         <p:nvSpPr>
           <p:cNvPr id="2" name="Slide Image Placeholder 1"/>
           <p:cNvSpPr>
-            <a:spLocks noGrp="1"/>
+            <a:spLocks noGrp="1" noRot="1" noChangeAspect="1"/>
           </p:cNvSpPr>
           <p:nvPr>
             <p:ph type="sldImg" idx="2"/>
@@ -648,7 +442,7 @@
             <a:spLocks noGrp="1"/>
           </p:cNvSpPr>
           <p:nvPr>
-            <p:ph type="body" idx="3" sz="quarter"/>
+            <p:ph type="body" sz="quarter" idx="3"/>
           </p:nvPr>
         </p:nvSpPr>
         <p:spPr/>
@@ -669,7 +463,7 @@
             <a:spLocks noGrp="1"/>
           </p:cNvSpPr>
           <p:nvPr>
-            <p:ph type="sldNum" idx="5" sz="quarter"/>
+            <p:ph type="sldNum" sz="quarter" idx="5"/>
           </p:nvPr>
         </p:nvSpPr>
         <p:spPr/>
@@ -683,7 +477,7 @@
 </file>
 
 <file path=ppt/notesSlides/notesSlide12.xml><?xml version="1.0" encoding="utf-8"?>
-<p:notes xmlns:a="http://schemas.openxmlformats.org/drawingml/2006/main" xmlns:p="http://schemas.openxmlformats.org/presentationml/2006/main" xmlns:r="http://schemas.openxmlformats.org/officeDocument/2006/relationships">
+<p:notes xmlns:a="http://schemas.openxmlformats.org/drawingml/2006/main" xmlns:r="http://schemas.openxmlformats.org/officeDocument/2006/relationships" xmlns:p="http://schemas.openxmlformats.org/presentationml/2006/main">
   <p:cSld>
     <p:spTree>
       <p:nvGrpSpPr>
@@ -703,7 +497,7 @@
         <p:nvSpPr>
           <p:cNvPr id="2" name="Slide Image Placeholder 1"/>
           <p:cNvSpPr>
-            <a:spLocks noGrp="1"/>
+            <a:spLocks noGrp="1" noRot="1" noChangeAspect="1"/>
           </p:cNvSpPr>
           <p:nvPr>
             <p:ph type="sldImg" idx="2"/>
@@ -718,7 +512,7 @@
             <a:spLocks noGrp="1"/>
           </p:cNvSpPr>
           <p:nvPr>
-            <p:ph type="body" idx="3" sz="quarter"/>
+            <p:ph type="body" sz="quarter" idx="3"/>
           </p:nvPr>
         </p:nvSpPr>
         <p:spPr/>
@@ -739,7 +533,7 @@
             <a:spLocks noGrp="1"/>
           </p:cNvSpPr>
           <p:nvPr>
-            <p:ph type="sldNum" idx="5" sz="quarter"/>
+            <p:ph type="sldNum" sz="quarter" idx="5"/>
           </p:nvPr>
         </p:nvSpPr>
         <p:spPr/>
@@ -753,7 +547,7 @@
 </file>
 
 <file path=ppt/notesSlides/notesSlide13.xml><?xml version="1.0" encoding="utf-8"?>
-<p:notes xmlns:a="http://schemas.openxmlformats.org/drawingml/2006/main" xmlns:p="http://schemas.openxmlformats.org/presentationml/2006/main" xmlns:r="http://schemas.openxmlformats.org/officeDocument/2006/relationships">
+<p:notes xmlns:a="http://schemas.openxmlformats.org/drawingml/2006/main" xmlns:r="http://schemas.openxmlformats.org/officeDocument/2006/relationships" xmlns:p="http://schemas.openxmlformats.org/presentationml/2006/main">
   <p:cSld>
     <p:spTree>
       <p:nvGrpSpPr>
@@ -773,7 +567,7 @@
         <p:nvSpPr>
           <p:cNvPr id="2" name="Slide Image Placeholder 1"/>
           <p:cNvSpPr>
-            <a:spLocks noGrp="1"/>
+            <a:spLocks noGrp="1" noRot="1" noChangeAspect="1"/>
           </p:cNvSpPr>
           <p:nvPr>
             <p:ph type="sldImg" idx="2"/>
@@ -788,7 +582,7 @@
             <a:spLocks noGrp="1"/>
           </p:cNvSpPr>
           <p:nvPr>
-            <p:ph type="body" idx="3" sz="quarter"/>
+            <p:ph type="body" sz="quarter" idx="3"/>
           </p:nvPr>
         </p:nvSpPr>
         <p:spPr/>
@@ -809,7 +603,7 @@
             <a:spLocks noGrp="1"/>
           </p:cNvSpPr>
           <p:nvPr>
-            <p:ph type="sldNum" idx="5" sz="quarter"/>
+            <p:ph type="sldNum" sz="quarter" idx="5"/>
           </p:nvPr>
         </p:nvSpPr>
         <p:spPr/>
@@ -823,7 +617,7 @@
 </file>
 
 <file path=ppt/notesSlides/notesSlide14.xml><?xml version="1.0" encoding="utf-8"?>
-<p:notes xmlns:a="http://schemas.openxmlformats.org/drawingml/2006/main" xmlns:p="http://schemas.openxmlformats.org/presentationml/2006/main" xmlns:r="http://schemas.openxmlformats.org/officeDocument/2006/relationships">
+<p:notes xmlns:a="http://schemas.openxmlformats.org/drawingml/2006/main" xmlns:r="http://schemas.openxmlformats.org/officeDocument/2006/relationships" xmlns:p="http://schemas.openxmlformats.org/presentationml/2006/main">
   <p:cSld>
     <p:spTree>
       <p:nvGrpSpPr>
@@ -843,7 +637,7 @@
         <p:nvSpPr>
           <p:cNvPr id="2" name="Slide Image Placeholder 1"/>
           <p:cNvSpPr>
-            <a:spLocks noGrp="1"/>
+            <a:spLocks noGrp="1" noRot="1" noChangeAspect="1"/>
           </p:cNvSpPr>
           <p:nvPr>
             <p:ph type="sldImg" idx="2"/>
@@ -858,7 +652,7 @@
             <a:spLocks noGrp="1"/>
           </p:cNvSpPr>
           <p:nvPr>
-            <p:ph type="body" idx="3" sz="quarter"/>
+            <p:ph type="body" sz="quarter" idx="3"/>
           </p:nvPr>
         </p:nvSpPr>
         <p:spPr/>
@@ -879,7 +673,7 @@
             <a:spLocks noGrp="1"/>
           </p:cNvSpPr>
           <p:nvPr>
-            <p:ph type="sldNum" idx="5" sz="quarter"/>
+            <p:ph type="sldNum" sz="quarter" idx="5"/>
           </p:nvPr>
         </p:nvSpPr>
         <p:spPr/>
@@ -893,7 +687,7 @@
 </file>
 
 <file path=ppt/notesSlides/notesSlide15.xml><?xml version="1.0" encoding="utf-8"?>
-<p:notes xmlns:a="http://schemas.openxmlformats.org/drawingml/2006/main" xmlns:p="http://schemas.openxmlformats.org/presentationml/2006/main" xmlns:r="http://schemas.openxmlformats.org/officeDocument/2006/relationships">
+<p:notes xmlns:a="http://schemas.openxmlformats.org/drawingml/2006/main" xmlns:r="http://schemas.openxmlformats.org/officeDocument/2006/relationships" xmlns:p="http://schemas.openxmlformats.org/presentationml/2006/main">
   <p:cSld>
     <p:spTree>
       <p:nvGrpSpPr>
@@ -913,7 +707,7 @@
         <p:nvSpPr>
           <p:cNvPr id="2" name="Slide Image Placeholder 1"/>
           <p:cNvSpPr>
-            <a:spLocks noGrp="1"/>
+            <a:spLocks noGrp="1" noRot="1" noChangeAspect="1"/>
           </p:cNvSpPr>
           <p:nvPr>
             <p:ph type="sldImg" idx="2"/>
@@ -928,7 +722,7 @@
             <a:spLocks noGrp="1"/>
           </p:cNvSpPr>
           <p:nvPr>
-            <p:ph type="body" idx="3" sz="quarter"/>
+            <p:ph type="body" sz="quarter" idx="3"/>
           </p:nvPr>
         </p:nvSpPr>
         <p:spPr/>
@@ -949,7 +743,7 @@
             <a:spLocks noGrp="1"/>
           </p:cNvSpPr>
           <p:nvPr>
-            <p:ph type="sldNum" idx="5" sz="quarter"/>
+            <p:ph type="sldNum" sz="quarter" idx="5"/>
           </p:nvPr>
         </p:nvSpPr>
         <p:spPr/>
@@ -963,7 +757,7 @@
 </file>
 
 <file path=ppt/notesSlides/notesSlide16.xml><?xml version="1.0" encoding="utf-8"?>
-<p:notes xmlns:a="http://schemas.openxmlformats.org/drawingml/2006/main" xmlns:p="http://schemas.openxmlformats.org/presentationml/2006/main" xmlns:r="http://schemas.openxmlformats.org/officeDocument/2006/relationships">
+<p:notes xmlns:a="http://schemas.openxmlformats.org/drawingml/2006/main" xmlns:r="http://schemas.openxmlformats.org/officeDocument/2006/relationships" xmlns:p="http://schemas.openxmlformats.org/presentationml/2006/main">
   <p:cSld>
     <p:spTree>
       <p:nvGrpSpPr>
@@ -983,7 +777,7 @@
         <p:nvSpPr>
           <p:cNvPr id="2" name="Slide Image Placeholder 1"/>
           <p:cNvSpPr>
-            <a:spLocks noGrp="1"/>
+            <a:spLocks noGrp="1" noRot="1" noChangeAspect="1"/>
           </p:cNvSpPr>
           <p:nvPr>
             <p:ph type="sldImg" idx="2"/>
@@ -998,7 +792,7 @@
             <a:spLocks noGrp="1"/>
           </p:cNvSpPr>
           <p:nvPr>
-            <p:ph type="body" idx="3" sz="quarter"/>
+            <p:ph type="body" sz="quarter" idx="3"/>
           </p:nvPr>
         </p:nvSpPr>
         <p:spPr/>
@@ -1019,7 +813,7 @@
             <a:spLocks noGrp="1"/>
           </p:cNvSpPr>
           <p:nvPr>
-            <p:ph type="sldNum" idx="5" sz="quarter"/>
+            <p:ph type="sldNum" sz="quarter" idx="5"/>
           </p:nvPr>
         </p:nvSpPr>
         <p:spPr/>
@@ -1033,7 +827,7 @@
 </file>
 
 <file path=ppt/notesSlides/notesSlide2.xml><?xml version="1.0" encoding="utf-8"?>
-<p:notes xmlns:a="http://schemas.openxmlformats.org/drawingml/2006/main" xmlns:p="http://schemas.openxmlformats.org/presentationml/2006/main" xmlns:r="http://schemas.openxmlformats.org/officeDocument/2006/relationships">
+<p:notes xmlns:a="http://schemas.openxmlformats.org/drawingml/2006/main" xmlns:r="http://schemas.openxmlformats.org/officeDocument/2006/relationships" xmlns:p="http://schemas.openxmlformats.org/presentationml/2006/main">
   <p:cSld>
     <p:spTree>
       <p:nvGrpSpPr>
@@ -1053,7 +847,7 @@
         <p:nvSpPr>
           <p:cNvPr id="2" name="Slide Image Placeholder 1"/>
           <p:cNvSpPr>
-            <a:spLocks noGrp="1"/>
+            <a:spLocks noGrp="1" noRot="1" noChangeAspect="1"/>
           </p:cNvSpPr>
           <p:nvPr>
             <p:ph type="sldImg" idx="2"/>
@@ -1068,7 +862,7 @@
             <a:spLocks noGrp="1"/>
           </p:cNvSpPr>
           <p:nvPr>
-            <p:ph type="body" idx="3" sz="quarter"/>
+            <p:ph type="body" sz="quarter" idx="3"/>
           </p:nvPr>
         </p:nvSpPr>
         <p:spPr/>
@@ -1089,7 +883,7 @@
             <a:spLocks noGrp="1"/>
           </p:cNvSpPr>
           <p:nvPr>
-            <p:ph type="sldNum" idx="5" sz="quarter"/>
+            <p:ph type="sldNum" sz="quarter" idx="5"/>
           </p:nvPr>
         </p:nvSpPr>
         <p:spPr/>
@@ -1103,7 +897,7 @@
 </file>
 
 <file path=ppt/notesSlides/notesSlide3.xml><?xml version="1.0" encoding="utf-8"?>
-<p:notes xmlns:a="http://schemas.openxmlformats.org/drawingml/2006/main" xmlns:p="http://schemas.openxmlformats.org/presentationml/2006/main" xmlns:r="http://schemas.openxmlformats.org/officeDocument/2006/relationships">
+<p:notes xmlns:a="http://schemas.openxmlformats.org/drawingml/2006/main" xmlns:r="http://schemas.openxmlformats.org/officeDocument/2006/relationships" xmlns:p="http://schemas.openxmlformats.org/presentationml/2006/main">
   <p:cSld>
     <p:spTree>
       <p:nvGrpSpPr>
@@ -1123,7 +917,7 @@
         <p:nvSpPr>
           <p:cNvPr id="2" name="Slide Image Placeholder 1"/>
           <p:cNvSpPr>
-            <a:spLocks noGrp="1"/>
+            <a:spLocks noGrp="1" noRot="1" noChangeAspect="1"/>
           </p:cNvSpPr>
           <p:nvPr>
             <p:ph type="sldImg" idx="2"/>
@@ -1138,7 +932,7 @@
             <a:spLocks noGrp="1"/>
           </p:cNvSpPr>
           <p:nvPr>
-            <p:ph type="body" idx="3" sz="quarter"/>
+            <p:ph type="body" sz="quarter" idx="3"/>
           </p:nvPr>
         </p:nvSpPr>
         <p:spPr/>
@@ -1159,7 +953,7 @@
             <a:spLocks noGrp="1"/>
           </p:cNvSpPr>
           <p:nvPr>
-            <p:ph type="sldNum" idx="5" sz="quarter"/>
+            <p:ph type="sldNum" sz="quarter" idx="5"/>
           </p:nvPr>
         </p:nvSpPr>
         <p:spPr/>
@@ -1173,7 +967,7 @@
 </file>
 
 <file path=ppt/notesSlides/notesSlide4.xml><?xml version="1.0" encoding="utf-8"?>
-<p:notes xmlns:a="http://schemas.openxmlformats.org/drawingml/2006/main" xmlns:p="http://schemas.openxmlformats.org/presentationml/2006/main" xmlns:r="http://schemas.openxmlformats.org/officeDocument/2006/relationships">
+<p:notes xmlns:a="http://schemas.openxmlformats.org/drawingml/2006/main" xmlns:r="http://schemas.openxmlformats.org/officeDocument/2006/relationships" xmlns:p="http://schemas.openxmlformats.org/presentationml/2006/main">
   <p:cSld>
     <p:spTree>
       <p:nvGrpSpPr>
@@ -1193,7 +987,7 @@
         <p:nvSpPr>
           <p:cNvPr id="2" name="Slide Image Placeholder 1"/>
           <p:cNvSpPr>
-            <a:spLocks noGrp="1"/>
+            <a:spLocks noGrp="1" noRot="1" noChangeAspect="1"/>
           </p:cNvSpPr>
           <p:nvPr>
             <p:ph type="sldImg" idx="2"/>
@@ -1208,7 +1002,7 @@
             <a:spLocks noGrp="1"/>
           </p:cNvSpPr>
           <p:nvPr>
-            <p:ph type="body" idx="3" sz="quarter"/>
+            <p:ph type="body" sz="quarter" idx="3"/>
           </p:nvPr>
         </p:nvSpPr>
         <p:spPr/>
@@ -1229,7 +1023,7 @@
             <a:spLocks noGrp="1"/>
           </p:cNvSpPr>
           <p:nvPr>
-            <p:ph type="sldNum" idx="5" sz="quarter"/>
+            <p:ph type="sldNum" sz="quarter" idx="5"/>
           </p:nvPr>
         </p:nvSpPr>
         <p:spPr/>
@@ -1243,7 +1037,7 @@
 </file>
 
 <file path=ppt/notesSlides/notesSlide5.xml><?xml version="1.0" encoding="utf-8"?>
-<p:notes xmlns:a="http://schemas.openxmlformats.org/drawingml/2006/main" xmlns:p="http://schemas.openxmlformats.org/presentationml/2006/main" xmlns:r="http://schemas.openxmlformats.org/officeDocument/2006/relationships">
+<p:notes xmlns:a="http://schemas.openxmlformats.org/drawingml/2006/main" xmlns:r="http://schemas.openxmlformats.org/officeDocument/2006/relationships" xmlns:p="http://schemas.openxmlformats.org/presentationml/2006/main">
   <p:cSld>
     <p:spTree>
       <p:nvGrpSpPr>
@@ -1263,7 +1057,7 @@
         <p:nvSpPr>
           <p:cNvPr id="2" name="Slide Image Placeholder 1"/>
           <p:cNvSpPr>
-            <a:spLocks noGrp="1"/>
+            <a:spLocks noGrp="1" noRot="1" noChangeAspect="1"/>
           </p:cNvSpPr>
           <p:nvPr>
             <p:ph type="sldImg" idx="2"/>
@@ -1278,7 +1072,7 @@
             <a:spLocks noGrp="1"/>
           </p:cNvSpPr>
           <p:nvPr>
-            <p:ph type="body" idx="3" sz="quarter"/>
+            <p:ph type="body" sz="quarter" idx="3"/>
           </p:nvPr>
         </p:nvSpPr>
         <p:spPr/>
@@ -1299,7 +1093,7 @@
             <a:spLocks noGrp="1"/>
           </p:cNvSpPr>
           <p:nvPr>
-            <p:ph type="sldNum" idx="5" sz="quarter"/>
+            <p:ph type="sldNum" sz="quarter" idx="5"/>
           </p:nvPr>
         </p:nvSpPr>
         <p:spPr/>
@@ -1313,7 +1107,7 @@
 </file>
 
 <file path=ppt/notesSlides/notesSlide6.xml><?xml version="1.0" encoding="utf-8"?>
-<p:notes xmlns:a="http://schemas.openxmlformats.org/drawingml/2006/main" xmlns:p="http://schemas.openxmlformats.org/presentationml/2006/main" xmlns:r="http://schemas.openxmlformats.org/officeDocument/2006/relationships">
+<p:notes xmlns:a="http://schemas.openxmlformats.org/drawingml/2006/main" xmlns:r="http://schemas.openxmlformats.org/officeDocument/2006/relationships" xmlns:p="http://schemas.openxmlformats.org/presentationml/2006/main">
   <p:cSld>
     <p:spTree>
       <p:nvGrpSpPr>
@@ -1333,7 +1127,7 @@
         <p:nvSpPr>
           <p:cNvPr id="2" name="Slide Image Placeholder 1"/>
           <p:cNvSpPr>
-            <a:spLocks noGrp="1"/>
+            <a:spLocks noGrp="1" noRot="1" noChangeAspect="1"/>
           </p:cNvSpPr>
           <p:nvPr>
             <p:ph type="sldImg" idx="2"/>
@@ -1348,7 +1142,7 @@
             <a:spLocks noGrp="1"/>
           </p:cNvSpPr>
           <p:nvPr>
-            <p:ph type="body" idx="3" sz="quarter"/>
+            <p:ph type="body" sz="quarter" idx="3"/>
           </p:nvPr>
         </p:nvSpPr>
         <p:spPr/>
@@ -1369,7 +1163,7 @@
             <a:spLocks noGrp="1"/>
           </p:cNvSpPr>
           <p:nvPr>
-            <p:ph type="sldNum" idx="5" sz="quarter"/>
+            <p:ph type="sldNum" sz="quarter" idx="5"/>
           </p:nvPr>
         </p:nvSpPr>
         <p:spPr/>
@@ -1383,7 +1177,7 @@
 </file>
 
 <file path=ppt/notesSlides/notesSlide7.xml><?xml version="1.0" encoding="utf-8"?>
-<p:notes xmlns:a="http://schemas.openxmlformats.org/drawingml/2006/main" xmlns:p="http://schemas.openxmlformats.org/presentationml/2006/main" xmlns:r="http://schemas.openxmlformats.org/officeDocument/2006/relationships">
+<p:notes xmlns:a="http://schemas.openxmlformats.org/drawingml/2006/main" xmlns:r="http://schemas.openxmlformats.org/officeDocument/2006/relationships" xmlns:p="http://schemas.openxmlformats.org/presentationml/2006/main">
   <p:cSld>
     <p:spTree>
       <p:nvGrpSpPr>
@@ -1403,7 +1197,7 @@
         <p:nvSpPr>
           <p:cNvPr id="2" name="Slide Image Placeholder 1"/>
           <p:cNvSpPr>
-            <a:spLocks noGrp="1"/>
+            <a:spLocks noGrp="1" noRot="1" noChangeAspect="1"/>
           </p:cNvSpPr>
           <p:nvPr>
             <p:ph type="sldImg" idx="2"/>
@@ -1418,7 +1212,7 @@
             <a:spLocks noGrp="1"/>
           </p:cNvSpPr>
           <p:nvPr>
-            <p:ph type="body" idx="3" sz="quarter"/>
+            <p:ph type="body" sz="quarter" idx="3"/>
           </p:nvPr>
         </p:nvSpPr>
         <p:spPr/>
@@ -1439,7 +1233,7 @@
             <a:spLocks noGrp="1"/>
           </p:cNvSpPr>
           <p:nvPr>
-            <p:ph type="sldNum" idx="5" sz="quarter"/>
+            <p:ph type="sldNum" sz="quarter" idx="5"/>
           </p:nvPr>
         </p:nvSpPr>
         <p:spPr/>
@@ -1453,7 +1247,7 @@
 </file>
 
 <file path=ppt/notesSlides/notesSlide8.xml><?xml version="1.0" encoding="utf-8"?>
-<p:notes xmlns:a="http://schemas.openxmlformats.org/drawingml/2006/main" xmlns:p="http://schemas.openxmlformats.org/presentationml/2006/main" xmlns:r="http://schemas.openxmlformats.org/officeDocument/2006/relationships">
+<p:notes xmlns:a="http://schemas.openxmlformats.org/drawingml/2006/main" xmlns:r="http://schemas.openxmlformats.org/officeDocument/2006/relationships" xmlns:p="http://schemas.openxmlformats.org/presentationml/2006/main">
   <p:cSld>
     <p:spTree>
       <p:nvGrpSpPr>
@@ -1473,7 +1267,7 @@
         <p:nvSpPr>
           <p:cNvPr id="2" name="Slide Image Placeholder 1"/>
           <p:cNvSpPr>
-            <a:spLocks noGrp="1"/>
+            <a:spLocks noGrp="1" noRot="1" noChangeAspect="1"/>
           </p:cNvSpPr>
           <p:nvPr>
             <p:ph type="sldImg" idx="2"/>
@@ -1488,7 +1282,7 @@
             <a:spLocks noGrp="1"/>
           </p:cNvSpPr>
           <p:nvPr>
-            <p:ph type="body" idx="3" sz="quarter"/>
+            <p:ph type="body" sz="quarter" idx="3"/>
           </p:nvPr>
         </p:nvSpPr>
         <p:spPr/>
@@ -1509,7 +1303,7 @@
             <a:spLocks noGrp="1"/>
           </p:cNvSpPr>
           <p:nvPr>
-            <p:ph type="sldNum" idx="5" sz="quarter"/>
+            <p:ph type="sldNum" sz="quarter" idx="5"/>
           </p:nvPr>
         </p:nvSpPr>
         <p:spPr/>
@@ -1523,7 +1317,7 @@
 </file>
 
 <file path=ppt/notesSlides/notesSlide9.xml><?xml version="1.0" encoding="utf-8"?>
-<p:notes xmlns:a="http://schemas.openxmlformats.org/drawingml/2006/main" xmlns:p="http://schemas.openxmlformats.org/presentationml/2006/main" xmlns:r="http://schemas.openxmlformats.org/officeDocument/2006/relationships">
+<p:notes xmlns:a="http://schemas.openxmlformats.org/drawingml/2006/main" xmlns:r="http://schemas.openxmlformats.org/officeDocument/2006/relationships" xmlns:p="http://schemas.openxmlformats.org/presentationml/2006/main">
   <p:cSld>
     <p:spTree>
       <p:nvGrpSpPr>
@@ -1543,7 +1337,7 @@
         <p:nvSpPr>
           <p:cNvPr id="2" name="Slide Image Placeholder 1"/>
           <p:cNvSpPr>
-            <a:spLocks noGrp="1"/>
+            <a:spLocks noGrp="1" noRot="1" noChangeAspect="1"/>
           </p:cNvSpPr>
           <p:nvPr>
             <p:ph type="sldImg" idx="2"/>
@@ -1558,7 +1352,7 @@
             <a:spLocks noGrp="1"/>
           </p:cNvSpPr>
           <p:nvPr>
-            <p:ph type="body" idx="3" sz="quarter"/>
+            <p:ph type="body" sz="quarter" idx="3"/>
           </p:nvPr>
         </p:nvSpPr>
         <p:spPr/>
@@ -1579,7 +1373,7 @@
             <a:spLocks noGrp="1"/>
           </p:cNvSpPr>
           <p:nvPr>
-            <p:ph type="sldNum" idx="5" sz="quarter"/>
+            <p:ph type="sldNum" sz="quarter" idx="5"/>
           </p:nvPr>
         </p:nvSpPr>
         <p:spPr/>
@@ -1630,10 +1424,9 @@
           <a:lstStyle/>
           <a:p>
             <a:r>
-              <a:rPr lang="en-US" smtClean="0"/>
+              <a:rPr lang="en-US"/>
               <a:t>Click to edit Master title style</a:t>
             </a:r>
-            <a:endParaRPr lang="en-US"/>
           </a:p>
         </p:txBody>
       </p:sp>
@@ -1749,10 +1542,9 @@
           </a:lstStyle>
           <a:p>
             <a:r>
-              <a:rPr lang="en-US" smtClean="0"/>
+              <a:rPr lang="en-US"/>
               <a:t>Click to edit Master subtitle style</a:t>
             </a:r>
-            <a:endParaRPr lang="en-US"/>
           </a:p>
         </p:txBody>
       </p:sp>
@@ -1773,7 +1565,7 @@
           <a:p>
             <a:fld id="{5BCAD085-E8A6-8845-BD4E-CB4CCA059FC4}" type="datetimeFigureOut">
               <a:rPr lang="en-US" smtClean="0"/>
-              <a:t>1/27/13</a:t>
+              <a:t>7/28/2026</a:t>
             </a:fld>
             <a:endParaRPr lang="en-US"/>
           </a:p>
@@ -1867,10 +1659,9 @@
           <a:lstStyle/>
           <a:p>
             <a:r>
-              <a:rPr lang="en-US" smtClean="0"/>
+              <a:rPr lang="en-US"/>
               <a:t>Click to edit Master title style</a:t>
             </a:r>
-            <a:endParaRPr lang="en-US"/>
           </a:p>
         </p:txBody>
       </p:sp>
@@ -1891,38 +1682,37 @@
           <a:p>
             <a:pPr lvl="0"/>
             <a:r>
-              <a:rPr lang="en-US" smtClean="0"/>
+              <a:rPr lang="en-US"/>
               <a:t>Click to edit Master text styles</a:t>
             </a:r>
           </a:p>
           <a:p>
             <a:pPr lvl="1"/>
             <a:r>
-              <a:rPr lang="en-US" smtClean="0"/>
+              <a:rPr lang="en-US"/>
               <a:t>Second level</a:t>
             </a:r>
           </a:p>
           <a:p>
             <a:pPr lvl="2"/>
             <a:r>
-              <a:rPr lang="en-US" smtClean="0"/>
+              <a:rPr lang="en-US"/>
               <a:t>Third level</a:t>
             </a:r>
           </a:p>
           <a:p>
             <a:pPr lvl="3"/>
             <a:r>
-              <a:rPr lang="en-US" smtClean="0"/>
+              <a:rPr lang="en-US"/>
               <a:t>Fourth level</a:t>
             </a:r>
           </a:p>
           <a:p>
             <a:pPr lvl="4"/>
             <a:r>
-              <a:rPr lang="en-US" smtClean="0"/>
+              <a:rPr lang="en-US"/>
               <a:t>Fifth level</a:t>
             </a:r>
-            <a:endParaRPr lang="en-US"/>
           </a:p>
         </p:txBody>
       </p:sp>
@@ -1943,7 +1733,7 @@
           <a:p>
             <a:fld id="{5BCAD085-E8A6-8845-BD4E-CB4CCA059FC4}" type="datetimeFigureOut">
               <a:rPr lang="en-US" smtClean="0"/>
-              <a:t>1/27/13</a:t>
+              <a:t>7/28/2026</a:t>
             </a:fld>
             <a:endParaRPr lang="en-US"/>
           </a:p>
@@ -2042,10 +1832,9 @@
           <a:lstStyle/>
           <a:p>
             <a:r>
-              <a:rPr lang="en-US" smtClean="0"/>
+              <a:rPr lang="en-US"/>
               <a:t>Click to edit Master title style</a:t>
             </a:r>
-            <a:endParaRPr lang="en-US"/>
           </a:p>
         </p:txBody>
       </p:sp>
@@ -2071,38 +1860,37 @@
           <a:p>
             <a:pPr lvl="0"/>
             <a:r>
-              <a:rPr lang="en-US" smtClean="0"/>
+              <a:rPr lang="en-US"/>
               <a:t>Click to edit Master text styles</a:t>
             </a:r>
           </a:p>
           <a:p>
             <a:pPr lvl="1"/>
             <a:r>
-              <a:rPr lang="en-US" smtClean="0"/>
+              <a:rPr lang="en-US"/>
               <a:t>Second level</a:t>
             </a:r>
           </a:p>
           <a:p>
             <a:pPr lvl="2"/>
             <a:r>
-              <a:rPr lang="en-US" smtClean="0"/>
+              <a:rPr lang="en-US"/>
               <a:t>Third level</a:t>
             </a:r>
           </a:p>
           <a:p>
             <a:pPr lvl="3"/>
             <a:r>
-              <a:rPr lang="en-US" smtClean="0"/>
+              <a:rPr lang="en-US"/>
               <a:t>Fourth level</a:t>
             </a:r>
           </a:p>
           <a:p>
             <a:pPr lvl="4"/>
             <a:r>
-              <a:rPr lang="en-US" smtClean="0"/>
+              <a:rPr lang="en-US"/>
               <a:t>Fifth level</a:t>
             </a:r>
-            <a:endParaRPr lang="en-US"/>
           </a:p>
         </p:txBody>
       </p:sp>
@@ -2123,7 +1911,7 @@
           <a:p>
             <a:fld id="{5BCAD085-E8A6-8845-BD4E-CB4CCA059FC4}" type="datetimeFigureOut">
               <a:rPr lang="en-US" smtClean="0"/>
-              <a:t>1/27/13</a:t>
+              <a:t>7/28/2026</a:t>
             </a:fld>
             <a:endParaRPr lang="en-US"/>
           </a:p>
@@ -2217,10 +2005,9 @@
           <a:lstStyle/>
           <a:p>
             <a:r>
-              <a:rPr lang="en-US" smtClean="0"/>
+              <a:rPr lang="en-US"/>
               <a:t>Click to edit Master title style</a:t>
             </a:r>
-            <a:endParaRPr lang="en-US"/>
           </a:p>
         </p:txBody>
       </p:sp>
@@ -2241,38 +2028,37 @@
           <a:p>
             <a:pPr lvl="0"/>
             <a:r>
-              <a:rPr lang="en-US" smtClean="0"/>
+              <a:rPr lang="en-US"/>
               <a:t>Click to edit Master text styles</a:t>
             </a:r>
           </a:p>
           <a:p>
             <a:pPr lvl="1"/>
             <a:r>
-              <a:rPr lang="en-US" smtClean="0"/>
+              <a:rPr lang="en-US"/>
               <a:t>Second level</a:t>
             </a:r>
           </a:p>
           <a:p>
             <a:pPr lvl="2"/>
             <a:r>
-              <a:rPr lang="en-US" smtClean="0"/>
+              <a:rPr lang="en-US"/>
               <a:t>Third level</a:t>
             </a:r>
           </a:p>
           <a:p>
             <a:pPr lvl="3"/>
             <a:r>
-              <a:rPr lang="en-US" smtClean="0"/>
+              <a:rPr lang="en-US"/>
               <a:t>Fourth level</a:t>
             </a:r>
           </a:p>
           <a:p>
             <a:pPr lvl="4"/>
             <a:r>
-              <a:rPr lang="en-US" smtClean="0"/>
+              <a:rPr lang="en-US"/>
               <a:t>Fifth level</a:t>
             </a:r>
-            <a:endParaRPr lang="en-US"/>
           </a:p>
         </p:txBody>
       </p:sp>
@@ -2293,7 +2079,7 @@
           <a:p>
             <a:fld id="{5BCAD085-E8A6-8845-BD4E-CB4CCA059FC4}" type="datetimeFigureOut">
               <a:rPr lang="en-US" smtClean="0"/>
-              <a:t>1/27/13</a:t>
+              <a:t>7/28/2026</a:t>
             </a:fld>
             <a:endParaRPr lang="en-US"/>
           </a:p>
@@ -2396,10 +2182,9 @@
           </a:lstStyle>
           <a:p>
             <a:r>
-              <a:rPr lang="en-US" smtClean="0"/>
+              <a:rPr lang="en-US"/>
               <a:t>Click to edit Master title style</a:t>
             </a:r>
-            <a:endParaRPr lang="en-US"/>
           </a:p>
         </p:txBody>
       </p:sp>
@@ -2516,7 +2301,7 @@
           <a:p>
             <a:pPr lvl="0"/>
             <a:r>
-              <a:rPr lang="en-US" smtClean="0"/>
+              <a:rPr lang="en-US"/>
               <a:t>Click to edit Master text styles</a:t>
             </a:r>
           </a:p>
@@ -2539,7 +2324,7 @@
           <a:p>
             <a:fld id="{5BCAD085-E8A6-8845-BD4E-CB4CCA059FC4}" type="datetimeFigureOut">
               <a:rPr lang="en-US" smtClean="0"/>
-              <a:t>1/27/13</a:t>
+              <a:t>7/28/2026</a:t>
             </a:fld>
             <a:endParaRPr lang="en-US"/>
           </a:p>
@@ -2633,10 +2418,9 @@
           <a:lstStyle/>
           <a:p>
             <a:r>
-              <a:rPr lang="en-US" smtClean="0"/>
+              <a:rPr lang="en-US"/>
               <a:t>Click to edit Master title style</a:t>
             </a:r>
-            <a:endParaRPr lang="en-US"/>
           </a:p>
         </p:txBody>
       </p:sp>
@@ -2690,38 +2474,37 @@
           <a:p>
             <a:pPr lvl="0"/>
             <a:r>
-              <a:rPr lang="en-US" smtClean="0"/>
+              <a:rPr lang="en-US"/>
               <a:t>Click to edit Master text styles</a:t>
             </a:r>
           </a:p>
           <a:p>
             <a:pPr lvl="1"/>
             <a:r>
-              <a:rPr lang="en-US" smtClean="0"/>
+              <a:rPr lang="en-US"/>
               <a:t>Second level</a:t>
             </a:r>
           </a:p>
           <a:p>
             <a:pPr lvl="2"/>
             <a:r>
-              <a:rPr lang="en-US" smtClean="0"/>
+              <a:rPr lang="en-US"/>
               <a:t>Third level</a:t>
             </a:r>
           </a:p>
           <a:p>
             <a:pPr lvl="3"/>
             <a:r>
-              <a:rPr lang="en-US" smtClean="0"/>
+              <a:rPr lang="en-US"/>
               <a:t>Fourth level</a:t>
             </a:r>
           </a:p>
           <a:p>
             <a:pPr lvl="4"/>
             <a:r>
-              <a:rPr lang="en-US" smtClean="0"/>
+              <a:rPr lang="en-US"/>
               <a:t>Fifth level</a:t>
             </a:r>
-            <a:endParaRPr lang="en-US"/>
           </a:p>
         </p:txBody>
       </p:sp>
@@ -2775,38 +2558,37 @@
           <a:p>
             <a:pPr lvl="0"/>
             <a:r>
-              <a:rPr lang="en-US" smtClean="0"/>
+              <a:rPr lang="en-US"/>
               <a:t>Click to edit Master text styles</a:t>
             </a:r>
           </a:p>
           <a:p>
             <a:pPr lvl="1"/>
             <a:r>
-              <a:rPr lang="en-US" smtClean="0"/>
+              <a:rPr lang="en-US"/>
               <a:t>Second level</a:t>
             </a:r>
           </a:p>
           <a:p>
             <a:pPr lvl="2"/>
             <a:r>
-              <a:rPr lang="en-US" smtClean="0"/>
+              <a:rPr lang="en-US"/>
               <a:t>Third level</a:t>
             </a:r>
           </a:p>
           <a:p>
             <a:pPr lvl="3"/>
             <a:r>
-              <a:rPr lang="en-US" smtClean="0"/>
+              <a:rPr lang="en-US"/>
               <a:t>Fourth level</a:t>
             </a:r>
           </a:p>
           <a:p>
             <a:pPr lvl="4"/>
             <a:r>
-              <a:rPr lang="en-US" smtClean="0"/>
+              <a:rPr lang="en-US"/>
               <a:t>Fifth level</a:t>
             </a:r>
-            <a:endParaRPr lang="en-US"/>
           </a:p>
         </p:txBody>
       </p:sp>
@@ -2827,7 +2609,7 @@
           <a:p>
             <a:fld id="{5BCAD085-E8A6-8845-BD4E-CB4CCA059FC4}" type="datetimeFigureOut">
               <a:rPr lang="en-US" smtClean="0"/>
-              <a:t>1/27/13</a:t>
+              <a:t>7/28/2026</a:t>
             </a:fld>
             <a:endParaRPr lang="en-US"/>
           </a:p>
@@ -2925,10 +2707,9 @@
           </a:lstStyle>
           <a:p>
             <a:r>
-              <a:rPr lang="en-US" smtClean="0"/>
+              <a:rPr lang="en-US"/>
               <a:t>Click to edit Master title style</a:t>
             </a:r>
-            <a:endParaRPr lang="en-US"/>
           </a:p>
         </p:txBody>
       </p:sp>
@@ -2991,7 +2772,7 @@
           <a:p>
             <a:pPr lvl="0"/>
             <a:r>
-              <a:rPr lang="en-US" smtClean="0"/>
+              <a:rPr lang="en-US"/>
               <a:t>Click to edit Master text styles</a:t>
             </a:r>
           </a:p>
@@ -3047,38 +2828,37 @@
           <a:p>
             <a:pPr lvl="0"/>
             <a:r>
-              <a:rPr lang="en-US" smtClean="0"/>
+              <a:rPr lang="en-US"/>
               <a:t>Click to edit Master text styles</a:t>
             </a:r>
           </a:p>
           <a:p>
             <a:pPr lvl="1"/>
             <a:r>
-              <a:rPr lang="en-US" smtClean="0"/>
+              <a:rPr lang="en-US"/>
               <a:t>Second level</a:t>
             </a:r>
           </a:p>
           <a:p>
             <a:pPr lvl="2"/>
             <a:r>
-              <a:rPr lang="en-US" smtClean="0"/>
+              <a:rPr lang="en-US"/>
               <a:t>Third level</a:t>
             </a:r>
           </a:p>
           <a:p>
             <a:pPr lvl="3"/>
             <a:r>
-              <a:rPr lang="en-US" smtClean="0"/>
+              <a:rPr lang="en-US"/>
               <a:t>Fourth level</a:t>
             </a:r>
           </a:p>
           <a:p>
             <a:pPr lvl="4"/>
             <a:r>
-              <a:rPr lang="en-US" smtClean="0"/>
+              <a:rPr lang="en-US"/>
               <a:t>Fifth level</a:t>
             </a:r>
-            <a:endParaRPr lang="en-US"/>
           </a:p>
         </p:txBody>
       </p:sp>
@@ -3141,7 +2921,7 @@
           <a:p>
             <a:pPr lvl="0"/>
             <a:r>
-              <a:rPr lang="en-US" smtClean="0"/>
+              <a:rPr lang="en-US"/>
               <a:t>Click to edit Master text styles</a:t>
             </a:r>
           </a:p>
@@ -3197,38 +2977,37 @@
           <a:p>
             <a:pPr lvl="0"/>
             <a:r>
-              <a:rPr lang="en-US" smtClean="0"/>
+              <a:rPr lang="en-US"/>
               <a:t>Click to edit Master text styles</a:t>
             </a:r>
           </a:p>
           <a:p>
             <a:pPr lvl="1"/>
             <a:r>
-              <a:rPr lang="en-US" smtClean="0"/>
+              <a:rPr lang="en-US"/>
               <a:t>Second level</a:t>
             </a:r>
           </a:p>
           <a:p>
             <a:pPr lvl="2"/>
             <a:r>
-              <a:rPr lang="en-US" smtClean="0"/>
+              <a:rPr lang="en-US"/>
               <a:t>Third level</a:t>
             </a:r>
           </a:p>
           <a:p>
             <a:pPr lvl="3"/>
             <a:r>
-              <a:rPr lang="en-US" smtClean="0"/>
+              <a:rPr lang="en-US"/>
               <a:t>Fourth level</a:t>
             </a:r>
           </a:p>
           <a:p>
             <a:pPr lvl="4"/>
             <a:r>
-              <a:rPr lang="en-US" smtClean="0"/>
+              <a:rPr lang="en-US"/>
               <a:t>Fifth level</a:t>
             </a:r>
-            <a:endParaRPr lang="en-US"/>
           </a:p>
         </p:txBody>
       </p:sp>
@@ -3249,7 +3028,7 @@
           <a:p>
             <a:fld id="{5BCAD085-E8A6-8845-BD4E-CB4CCA059FC4}" type="datetimeFigureOut">
               <a:rPr lang="en-US" smtClean="0"/>
-              <a:t>1/27/13</a:t>
+              <a:t>7/28/2026</a:t>
             </a:fld>
             <a:endParaRPr lang="en-US"/>
           </a:p>
@@ -3343,10 +3122,9 @@
           <a:lstStyle/>
           <a:p>
             <a:r>
-              <a:rPr lang="en-US" smtClean="0"/>
+              <a:rPr lang="en-US"/>
               <a:t>Click to edit Master title style</a:t>
             </a:r>
-            <a:endParaRPr lang="en-US"/>
           </a:p>
         </p:txBody>
       </p:sp>
@@ -3367,7 +3145,7 @@
           <a:p>
             <a:fld id="{5BCAD085-E8A6-8845-BD4E-CB4CCA059FC4}" type="datetimeFigureOut">
               <a:rPr lang="en-US" smtClean="0"/>
-              <a:t>1/27/13</a:t>
+              <a:t>7/28/2026</a:t>
             </a:fld>
             <a:endParaRPr lang="en-US"/>
           </a:p>
@@ -3462,7 +3240,7 @@
           <a:p>
             <a:fld id="{5BCAD085-E8A6-8845-BD4E-CB4CCA059FC4}" type="datetimeFigureOut">
               <a:rPr lang="en-US" smtClean="0"/>
-              <a:t>1/27/13</a:t>
+              <a:t>7/28/2026</a:t>
             </a:fld>
             <a:endParaRPr lang="en-US"/>
           </a:p>
@@ -3565,10 +3343,9 @@
           </a:lstStyle>
           <a:p>
             <a:r>
-              <a:rPr lang="en-US" smtClean="0"/>
+              <a:rPr lang="en-US"/>
               <a:t>Click to edit Master title style</a:t>
             </a:r>
-            <a:endParaRPr lang="en-US"/>
           </a:p>
         </p:txBody>
       </p:sp>
@@ -3622,38 +3399,37 @@
           <a:p>
             <a:pPr lvl="0"/>
             <a:r>
-              <a:rPr lang="en-US" smtClean="0"/>
+              <a:rPr lang="en-US"/>
               <a:t>Click to edit Master text styles</a:t>
             </a:r>
           </a:p>
           <a:p>
             <a:pPr lvl="1"/>
             <a:r>
-              <a:rPr lang="en-US" smtClean="0"/>
+              <a:rPr lang="en-US"/>
               <a:t>Second level</a:t>
             </a:r>
           </a:p>
           <a:p>
             <a:pPr lvl="2"/>
             <a:r>
-              <a:rPr lang="en-US" smtClean="0"/>
+              <a:rPr lang="en-US"/>
               <a:t>Third level</a:t>
             </a:r>
           </a:p>
           <a:p>
             <a:pPr lvl="3"/>
             <a:r>
-              <a:rPr lang="en-US" smtClean="0"/>
+              <a:rPr lang="en-US"/>
               <a:t>Fourth level</a:t>
             </a:r>
           </a:p>
           <a:p>
             <a:pPr lvl="4"/>
             <a:r>
-              <a:rPr lang="en-US" smtClean="0"/>
+              <a:rPr lang="en-US"/>
               <a:t>Fifth level</a:t>
             </a:r>
-            <a:endParaRPr lang="en-US"/>
           </a:p>
         </p:txBody>
       </p:sp>
@@ -3716,7 +3492,7 @@
           <a:p>
             <a:pPr lvl="0"/>
             <a:r>
-              <a:rPr lang="en-US" smtClean="0"/>
+              <a:rPr lang="en-US"/>
               <a:t>Click to edit Master text styles</a:t>
             </a:r>
           </a:p>
@@ -3739,7 +3515,7 @@
           <a:p>
             <a:fld id="{5BCAD085-E8A6-8845-BD4E-CB4CCA059FC4}" type="datetimeFigureOut">
               <a:rPr lang="en-US" smtClean="0"/>
-              <a:t>1/27/13</a:t>
+              <a:t>7/28/2026</a:t>
             </a:fld>
             <a:endParaRPr lang="en-US"/>
           </a:p>
@@ -3842,10 +3618,9 @@
           </a:lstStyle>
           <a:p>
             <a:r>
-              <a:rPr lang="en-US" smtClean="0"/>
+              <a:rPr lang="en-US"/>
               <a:t>Click to edit Master title style</a:t>
             </a:r>
-            <a:endParaRPr lang="en-US"/>
           </a:p>
         </p:txBody>
       </p:sp>
@@ -3969,7 +3744,7 @@
           <a:p>
             <a:pPr lvl="0"/>
             <a:r>
-              <a:rPr lang="en-US" smtClean="0"/>
+              <a:rPr lang="en-US"/>
               <a:t>Click to edit Master text styles</a:t>
             </a:r>
           </a:p>
@@ -3992,7 +3767,7 @@
           <a:p>
             <a:fld id="{5BCAD085-E8A6-8845-BD4E-CB4CCA059FC4}" type="datetimeFigureOut">
               <a:rPr lang="en-US" smtClean="0"/>
-              <a:t>1/27/13</a:t>
+              <a:t>7/28/2026</a:t>
             </a:fld>
             <a:endParaRPr lang="en-US"/>
           </a:p>
@@ -4101,10 +3876,9 @@
           <a:lstStyle/>
           <a:p>
             <a:r>
-              <a:rPr lang="en-US" smtClean="0"/>
+              <a:rPr lang="en-US"/>
               <a:t>Click to edit Master title style</a:t>
             </a:r>
-            <a:endParaRPr lang="en-US"/>
           </a:p>
         </p:txBody>
       </p:sp>
@@ -4135,38 +3909,37 @@
           <a:p>
             <a:pPr lvl="0"/>
             <a:r>
-              <a:rPr lang="en-US" smtClean="0"/>
+              <a:rPr lang="en-US"/>
               <a:t>Click to edit Master text styles</a:t>
             </a:r>
           </a:p>
           <a:p>
             <a:pPr lvl="1"/>
             <a:r>
-              <a:rPr lang="en-US" smtClean="0"/>
+              <a:rPr lang="en-US"/>
               <a:t>Second level</a:t>
             </a:r>
           </a:p>
           <a:p>
             <a:pPr lvl="2"/>
             <a:r>
-              <a:rPr lang="en-US" smtClean="0"/>
+              <a:rPr lang="en-US"/>
               <a:t>Third level</a:t>
             </a:r>
           </a:p>
           <a:p>
             <a:pPr lvl="3"/>
             <a:r>
-              <a:rPr lang="en-US" smtClean="0"/>
+              <a:rPr lang="en-US"/>
               <a:t>Fourth level</a:t>
             </a:r>
           </a:p>
           <a:p>
             <a:pPr lvl="4"/>
             <a:r>
-              <a:rPr lang="en-US" smtClean="0"/>
+              <a:rPr lang="en-US"/>
               <a:t>Fifth level</a:t>
             </a:r>
-            <a:endParaRPr lang="en-US"/>
           </a:p>
         </p:txBody>
       </p:sp>
@@ -4205,7 +3978,7 @@
           <a:p>
             <a:fld id="{5BCAD085-E8A6-8845-BD4E-CB4CCA059FC4}" type="datetimeFigureOut">
               <a:rPr lang="en-US" smtClean="0"/>
-              <a:t>1/27/13</a:t>
+              <a:t>7/28/2026</a:t>
             </a:fld>
             <a:endParaRPr lang="en-US"/>
           </a:p>
@@ -4564,7 +4337,7 @@
 </file>
 
 <file path=ppt/slides/slide1.xml><?xml version="1.0" encoding="utf-8"?>
-<p:sld xmlns:a="http://schemas.openxmlformats.org/drawingml/2006/main" xmlns:p="http://schemas.openxmlformats.org/presentationml/2006/main" xmlns:r="http://schemas.openxmlformats.org/officeDocument/2006/relationships">
+<p:sld xmlns:a="http://schemas.openxmlformats.org/drawingml/2006/main" xmlns:r="http://schemas.openxmlformats.org/officeDocument/2006/relationships" xmlns:p="http://schemas.openxmlformats.org/presentationml/2006/main">
   <p:cSld>
     <p:spTree>
       <p:nvGrpSpPr>
@@ -4572,7 +4345,14 @@
         <p:cNvGrpSpPr/>
         <p:nvPr/>
       </p:nvGrpSpPr>
-      <p:grpSpPr/>
+      <p:grpSpPr>
+        <a:xfrm>
+          <a:off x="0" y="0"/>
+          <a:ext cx="0" cy="0"/>
+          <a:chOff x="0" y="0"/>
+          <a:chExt cx="0" cy="0"/>
+        </a:xfrm>
+      </p:grpSpPr>
       <p:sp>
         <p:nvSpPr>
           <p:cNvPr id="2" name="Title 1"/>
@@ -4620,8 +4400,40 @@
           <a:lstStyle/>
           <a:p>
             <a:r>
-              <a:t>scRNA-seq of human PBMCs exposed to 40 nm / 200 nm / mixed polystyrene nanoparticles vs control  -  Genomics Informatics, ETF</a:t>
-            </a:r>
+              <a:rPr dirty="0" err="1"/>
+              <a:t>scRNA</a:t>
+            </a:r>
+            <a:r>
+              <a:rPr dirty="0"/>
+              <a:t>-seq of human PBMCs exposed to </a:t>
+            </a:r>
+            <a:br>
+              <a:rPr lang="en-US" dirty="0"/>
+            </a:br>
+            <a:r>
+              <a:rPr dirty="0"/>
+              <a:t>40 nm / 200 nm / mixed polystyrene nanoparticles vs control </a:t>
+            </a:r>
+            <a:endParaRPr lang="en-US" dirty="0"/>
+          </a:p>
+          <a:p>
+            <a:r>
+              <a:rPr dirty="0"/>
+              <a:t>Genom</a:t>
+            </a:r>
+            <a:r>
+              <a:rPr lang="en-US" dirty="0"/>
+              <a:t>e</a:t>
+            </a:r>
+            <a:r>
+              <a:rPr dirty="0"/>
+              <a:t> Informatics, ETF</a:t>
+            </a:r>
+            <a:r>
+              <a:rPr lang="en-US" dirty="0"/>
+              <a:t> Belgrade, 2026</a:t>
+            </a:r>
+            <a:endParaRPr dirty="0"/>
           </a:p>
         </p:txBody>
       </p:sp>
@@ -4634,7 +4446,7 @@
 </file>
 
 <file path=ppt/slides/slide10.xml><?xml version="1.0" encoding="utf-8"?>
-<p:sld xmlns:a="http://schemas.openxmlformats.org/drawingml/2006/main" xmlns:p="http://schemas.openxmlformats.org/presentationml/2006/main" xmlns:r="http://schemas.openxmlformats.org/officeDocument/2006/relationships">
+<p:sld xmlns:a="http://schemas.openxmlformats.org/drawingml/2006/main" xmlns:r="http://schemas.openxmlformats.org/officeDocument/2006/relationships" xmlns:p="http://schemas.openxmlformats.org/presentationml/2006/main">
   <p:cSld>
     <p:spTree>
       <p:nvGrpSpPr>
@@ -4642,7 +4454,14 @@
         <p:cNvGrpSpPr/>
         <p:nvPr/>
       </p:nvGrpSpPr>
-      <p:grpSpPr/>
+      <p:grpSpPr>
+        <a:xfrm>
+          <a:off x="0" y="0"/>
+          <a:ext cx="0" cy="0"/>
+          <a:chOff x="0" y="0"/>
+          <a:chExt cx="0" cy="0"/>
+        </a:xfrm>
+      </p:grpSpPr>
       <p:sp>
         <p:nvSpPr>
           <p:cNvPr id="2" name="Title 1"/>
@@ -4686,14 +4505,25 @@
           </a:xfrm>
         </p:spPr>
         <p:txBody>
-          <a:bodyPr/>
+          <a:bodyPr>
+            <a:normAutofit/>
+          </a:bodyPr>
           <a:lstStyle/>
           <a:p>
             <a:pPr>
               <a:defRPr sz="1800"/>
             </a:pPr>
             <a:r>
-              <a:t>Monocytes show the strongest transcriptional response to nanoplastic.</a:t>
+              <a:rPr sz="2400" dirty="0"/>
+              <a:t>Monocytes show the strongest transcriptional response to </a:t>
+            </a:r>
+            <a:r>
+              <a:rPr sz="2400" dirty="0" err="1"/>
+              <a:t>nanoplastic</a:t>
+            </a:r>
+            <a:r>
+              <a:rPr sz="2400" dirty="0"/>
+              <a:t>.</a:t>
             </a:r>
           </a:p>
           <a:p>
@@ -4701,6 +4531,7 @@
               <a:defRPr sz="1800"/>
             </a:pPr>
             <a:r>
+              <a:rPr sz="2400" dirty="0"/>
               <a:t>200 nm particles drive MORE lineage-unique genes than 40 nm.</a:t>
             </a:r>
           </a:p>
@@ -4709,7 +4540,19 @@
               <a:defRPr sz="1800"/>
             </a:pPr>
             <a:r>
-              <a:t>The 40+200 nm mixture produces an EMERGENT monocyte response -</a:t>
+              <a:rPr sz="2400" dirty="0"/>
+              <a:t>The 40+200 nm mixture produces an EMERGENT monocyte response </a:t>
+            </a:r>
+            <a:r>
+              <a:rPr lang="en-US" sz="2400" dirty="0"/>
+              <a:t>– </a:t>
+            </a:r>
+            <a:br>
+              <a:rPr lang="en-US" sz="2400" dirty="0"/>
+            </a:br>
+            <a:r>
+              <a:rPr sz="2400" dirty="0"/>
+              <a:t>genes significant only in the mixture, in neither single size.</a:t>
             </a:r>
           </a:p>
           <a:p>
@@ -4717,14 +4560,7 @@
               <a:defRPr sz="1800"/>
             </a:pPr>
             <a:r>
-              <a:t>  genes significant only in the mixture, in neither single size.</a:t>
-            </a:r>
-          </a:p>
-          <a:p>
-            <a:pPr>
-              <a:defRPr sz="1800"/>
-            </a:pPr>
-            <a:r>
+              <a:rPr sz="2400" dirty="0"/>
               <a:t>In lymphocytes the mixture is weaker than either size (sub-additive).</a:t>
             </a:r>
           </a:p>
@@ -4739,7 +4575,7 @@
 </file>
 
 <file path=ppt/slides/slide11.xml><?xml version="1.0" encoding="utf-8"?>
-<p:sld xmlns:a="http://schemas.openxmlformats.org/drawingml/2006/main" xmlns:p="http://schemas.openxmlformats.org/presentationml/2006/main" xmlns:r="http://schemas.openxmlformats.org/officeDocument/2006/relationships">
+<p:sld xmlns:a="http://schemas.openxmlformats.org/drawingml/2006/main" xmlns:r="http://schemas.openxmlformats.org/officeDocument/2006/relationships" xmlns:p="http://schemas.openxmlformats.org/presentationml/2006/main">
   <p:cSld>
     <p:spTree>
       <p:nvGrpSpPr>
@@ -4747,7 +4583,14 @@
         <p:cNvGrpSpPr/>
         <p:nvPr/>
       </p:nvGrpSpPr>
-      <p:grpSpPr/>
+      <p:grpSpPr>
+        <a:xfrm>
+          <a:off x="0" y="0"/>
+          <a:ext cx="0" cy="0"/>
+          <a:chOff x="0" y="0"/>
+          <a:chExt cx="0" cy="0"/>
+        </a:xfrm>
+      </p:grpSpPr>
       <p:sp>
         <p:nvSpPr>
           <p:cNvPr id="2" name="Title 1"/>
@@ -4791,13 +4634,16 @@
           </a:xfrm>
         </p:spPr>
         <p:txBody>
-          <a:bodyPr/>
+          <a:bodyPr>
+            <a:normAutofit/>
+          </a:bodyPr>
           <a:lstStyle/>
           <a:p>
             <a:pPr>
               <a:defRPr sz="1800"/>
             </a:pPr>
             <a:r>
+              <a:rPr sz="2400" dirty="0"/>
               <a:t>The 180 mixture-only monocyte genes are dominated by INFLAMMATION.</a:t>
             </a:r>
           </a:p>
@@ -4806,7 +4652,27 @@
               <a:defRPr sz="1800"/>
             </a:pPr>
             <a:r>
-              <a:t>Pathway enrichment (p ~ 1e-21): interleukin, cytokine &amp; TNF signalling,</a:t>
+              <a:rPr sz="2400" dirty="0"/>
+              <a:t>Pathway enrichment (p ~ 1e-21): interleukin, cytokine &amp; TNF </a:t>
+            </a:r>
+            <a:r>
+              <a:rPr sz="2400" dirty="0" err="1"/>
+              <a:t>signalling</a:t>
+            </a:r>
+            <a:r>
+              <a:rPr sz="2400" dirty="0"/>
+              <a:t>,</a:t>
+            </a:r>
+            <a:r>
+              <a:rPr lang="en-US" sz="2400" dirty="0"/>
+              <a:t> </a:t>
+            </a:r>
+            <a:br>
+              <a:rPr lang="en-US" sz="2400" dirty="0"/>
+            </a:br>
+            <a:r>
+              <a:rPr sz="2400" dirty="0"/>
+              <a:t>and 'response to lipopolysaccharide' - i.e. a bacterial-attack-like program.</a:t>
             </a:r>
           </a:p>
           <a:p>
@@ -4814,7 +4680,16 @@
               <a:defRPr sz="1800"/>
             </a:pPr>
             <a:r>
-              <a:t>  and 'response to lipopolysaccharide' - i.e. a bacterial-attack-like program.</a:t>
+              <a:rPr sz="2400" dirty="0"/>
+              <a:t>Top mixture-only genes up: RIPK2, TRAF1, PIK3CB (innate/TNF </a:t>
+            </a:r>
+            <a:r>
+              <a:rPr sz="2400" dirty="0" err="1"/>
+              <a:t>signalling</a:t>
+            </a:r>
+            <a:r>
+              <a:rPr sz="2400" dirty="0"/>
+              <a:t>).</a:t>
             </a:r>
           </a:p>
           <a:p>
@@ -4822,7 +4697,19 @@
               <a:defRPr sz="1800"/>
             </a:pPr>
             <a:r>
-              <a:t>Top mixture-only genes up: RIPK2, TRAF1, PIK3CB (innate/TNF signalling).</a:t>
+              <a:rPr sz="2400" dirty="0"/>
+              <a:t>Interpretation: two sub-threshold exposures together push monocytes over</a:t>
+            </a:r>
+            <a:r>
+              <a:rPr lang="en-US" sz="2400" dirty="0"/>
+              <a:t> </a:t>
+            </a:r>
+            <a:br>
+              <a:rPr lang="en-US" sz="2400" dirty="0"/>
+            </a:br>
+            <a:r>
+              <a:rPr sz="2400" dirty="0"/>
+              <a:t>an inflammatory activation threshold - an emergent, non-additive effect.</a:t>
             </a:r>
           </a:p>
           <a:p>
@@ -4830,22 +4717,7 @@
               <a:defRPr sz="1800"/>
             </a:pPr>
             <a:r>
-              <a:t>Interpretation: two sub-threshold exposures together push monocytes over</a:t>
-            </a:r>
-          </a:p>
-          <a:p>
-            <a:pPr>
-              <a:defRPr sz="1800"/>
-            </a:pPr>
-            <a:r>
-              <a:t>  an inflammatory activation threshold - an emergent, non-additive effect.</a:t>
-            </a:r>
-          </a:p>
-          <a:p>
-            <a:pPr>
-              <a:defRPr sz="1800"/>
-            </a:pPr>
-            <a:r>
+              <a:rPr sz="2400" dirty="0"/>
               <a:t>Real exposure is always to mixtures -&gt; single-size studies may under-estimate risk.</a:t>
             </a:r>
           </a:p>
@@ -4860,7 +4732,7 @@
 </file>
 
 <file path=ppt/slides/slide12.xml><?xml version="1.0" encoding="utf-8"?>
-<p:sld xmlns:a="http://schemas.openxmlformats.org/drawingml/2006/main" xmlns:p="http://schemas.openxmlformats.org/presentationml/2006/main" xmlns:r="http://schemas.openxmlformats.org/officeDocument/2006/relationships">
+<p:sld xmlns:a="http://schemas.openxmlformats.org/drawingml/2006/main" xmlns:r="http://schemas.openxmlformats.org/officeDocument/2006/relationships" xmlns:p="http://schemas.openxmlformats.org/presentationml/2006/main">
   <p:cSld>
     <p:spTree>
       <p:nvGrpSpPr>
@@ -4868,7 +4740,14 @@
         <p:cNvGrpSpPr/>
         <p:nvPr/>
       </p:nvGrpSpPr>
-      <p:grpSpPr/>
+      <p:grpSpPr>
+        <a:xfrm>
+          <a:off x="0" y="0"/>
+          <a:ext cx="0" cy="0"/>
+          <a:chOff x="0" y="0"/>
+          <a:chExt cx="0" cy="0"/>
+        </a:xfrm>
+      </p:grpSpPr>
       <p:sp>
         <p:nvSpPr>
           <p:cNvPr id="2" name="Title 1"/>
@@ -4912,13 +4791,16 @@
           </a:xfrm>
         </p:spPr>
         <p:txBody>
-          <a:bodyPr/>
+          <a:bodyPr>
+            <a:normAutofit/>
+          </a:bodyPr>
           <a:lstStyle/>
           <a:p>
             <a:pPr>
               <a:defRPr sz="1800"/>
             </a:pPr>
             <a:r>
+              <a:rPr sz="2400" dirty="0"/>
               <a:t>1. Module scoring - stress &amp; inflammation gene programs per sample (shown next).</a:t>
             </a:r>
           </a:p>
@@ -4927,6 +4809,7 @@
               <a:defRPr sz="1800"/>
             </a:pPr>
             <a:r>
+              <a:rPr sz="2400" dirty="0"/>
               <a:t>2. Mixture additivity - is the mixture = 40nm + 200nm? (shown next).</a:t>
             </a:r>
           </a:p>
@@ -4935,6 +4818,7 @@
               <a:defRPr sz="1800"/>
             </a:pPr>
             <a:r>
+              <a:rPr sz="2400" dirty="0"/>
               <a:t>3. Clustering robustness - clusters stable across Leiden resolutions (ARI).</a:t>
             </a:r>
           </a:p>
@@ -4943,6 +4827,7 @@
               <a:defRPr sz="1800"/>
             </a:pPr>
             <a:r>
+              <a:rPr sz="2400" dirty="0"/>
               <a:t>4. Ligand-receptor - shift in cell-to-cell communication on exposure.</a:t>
             </a:r>
           </a:p>
@@ -4951,6 +4836,7 @@
               <a:defRPr sz="1800"/>
             </a:pPr>
             <a:r>
+              <a:rPr sz="2400" dirty="0"/>
               <a:t>5. Dose-response - disruption magnitude vs particle size.</a:t>
             </a:r>
           </a:p>
@@ -4959,7 +4845,16 @@
               <a:defRPr sz="1800"/>
             </a:pPr>
             <a:r>
-              <a:t>All five reinforce the same story: size-dependent, non-additive, monocyte-centred.</a:t>
+              <a:rPr sz="2400" dirty="0"/>
+              <a:t>All five reinforce the same story: size-dependent, non-additive, monocyte-</a:t>
+            </a:r>
+            <a:r>
+              <a:rPr sz="2400" dirty="0" err="1"/>
+              <a:t>centred</a:t>
+            </a:r>
+            <a:r>
+              <a:rPr sz="2400" dirty="0"/>
+              <a:t>.</a:t>
             </a:r>
           </a:p>
         </p:txBody>
@@ -4973,7 +4868,7 @@
 </file>
 
 <file path=ppt/slides/slide13.xml><?xml version="1.0" encoding="utf-8"?>
-<p:sld xmlns:a="http://schemas.openxmlformats.org/drawingml/2006/main" xmlns:p="http://schemas.openxmlformats.org/presentationml/2006/main" xmlns:r="http://schemas.openxmlformats.org/officeDocument/2006/relationships">
+<p:sld xmlns:a="http://schemas.openxmlformats.org/drawingml/2006/main" xmlns:r="http://schemas.openxmlformats.org/officeDocument/2006/relationships" xmlns:p="http://schemas.openxmlformats.org/presentationml/2006/main">
   <p:cSld>
     <p:spTree>
       <p:nvGrpSpPr>
@@ -4981,7 +4876,14 @@
         <p:cNvGrpSpPr/>
         <p:nvPr/>
       </p:nvGrpSpPr>
-      <p:grpSpPr/>
+      <p:grpSpPr>
+        <a:xfrm>
+          <a:off x="0" y="0"/>
+          <a:ext cx="0" cy="0"/>
+          <a:chOff x="0" y="0"/>
+          <a:chExt cx="0" cy="0"/>
+        </a:xfrm>
+      </p:grpSpPr>
       <p:sp>
         <p:nvSpPr>
           <p:cNvPr id="2" name="Title 1"/>
@@ -5003,6 +4905,7 @@
           <a:lstStyle/>
           <a:p>
             <a:r>
+              <a:rPr dirty="0"/>
               <a:t>Additional analyses: stress/inflammation module scores</a:t>
             </a:r>
           </a:p>
@@ -5017,14 +4920,14 @@
           <p:nvPr/>
         </p:nvPicPr>
         <p:blipFill>
-          <a:blip r:embed="rId2"/>
+          <a:blip r:embed="rId3"/>
           <a:stretch>
             <a:fillRect/>
           </a:stretch>
         </p:blipFill>
         <p:spPr>
           <a:xfrm>
-            <a:off x="2095347" y="1371600"/>
+            <a:off x="2095347" y="1408924"/>
             <a:ext cx="8001000" cy="4572000"/>
           </a:xfrm>
           <a:prstGeom prst="rect">
@@ -5072,7 +4975,7 @@
 </file>
 
 <file path=ppt/slides/slide14.xml><?xml version="1.0" encoding="utf-8"?>
-<p:sld xmlns:a="http://schemas.openxmlformats.org/drawingml/2006/main" xmlns:p="http://schemas.openxmlformats.org/presentationml/2006/main" xmlns:r="http://schemas.openxmlformats.org/officeDocument/2006/relationships">
+<p:sld xmlns:a="http://schemas.openxmlformats.org/drawingml/2006/main" xmlns:r="http://schemas.openxmlformats.org/officeDocument/2006/relationships" xmlns:p="http://schemas.openxmlformats.org/presentationml/2006/main">
   <p:cSld>
     <p:spTree>
       <p:nvGrpSpPr>
@@ -5080,7 +4983,14 @@
         <p:cNvGrpSpPr/>
         <p:nvPr/>
       </p:nvGrpSpPr>
-      <p:grpSpPr/>
+      <p:grpSpPr>
+        <a:xfrm>
+          <a:off x="0" y="0"/>
+          <a:ext cx="0" cy="0"/>
+          <a:chOff x="0" y="0"/>
+          <a:chExt cx="0" cy="0"/>
+        </a:xfrm>
+      </p:grpSpPr>
       <p:sp>
         <p:nvSpPr>
           <p:cNvPr id="2" name="Title 1"/>
@@ -5116,7 +5026,7 @@
           <p:nvPr/>
         </p:nvPicPr>
         <p:blipFill>
-          <a:blip r:embed="rId2"/>
+          <a:blip r:embed="rId3"/>
           <a:stretch>
             <a:fillRect/>
           </a:stretch>
@@ -5171,7 +5081,7 @@
 </file>
 
 <file path=ppt/slides/slide15.xml><?xml version="1.0" encoding="utf-8"?>
-<p:sld xmlns:a="http://schemas.openxmlformats.org/drawingml/2006/main" xmlns:p="http://schemas.openxmlformats.org/presentationml/2006/main" xmlns:r="http://schemas.openxmlformats.org/officeDocument/2006/relationships">
+<p:sld xmlns:a="http://schemas.openxmlformats.org/drawingml/2006/main" xmlns:r="http://schemas.openxmlformats.org/officeDocument/2006/relationships" xmlns:p="http://schemas.openxmlformats.org/presentationml/2006/main">
   <p:cSld>
     <p:spTree>
       <p:nvGrpSpPr>
@@ -5179,7 +5089,14 @@
         <p:cNvGrpSpPr/>
         <p:nvPr/>
       </p:nvGrpSpPr>
-      <p:grpSpPr/>
+      <p:grpSpPr>
+        <a:xfrm>
+          <a:off x="0" y="0"/>
+          <a:ext cx="0" cy="0"/>
+          <a:chOff x="0" y="0"/>
+          <a:chExt cx="0" cy="0"/>
+        </a:xfrm>
+      </p:grpSpPr>
       <p:sp>
         <p:nvSpPr>
           <p:cNvPr id="2" name="Title 1"/>
@@ -5215,7 +5132,7 @@
           <p:nvPr/>
         </p:nvPicPr>
         <p:blipFill>
-          <a:blip r:embed="rId2"/>
+          <a:blip r:embed="rId3"/>
           <a:stretch>
             <a:fillRect/>
           </a:stretch>
@@ -5239,7 +5156,7 @@
           <p:nvPr/>
         </p:nvPicPr>
         <p:blipFill>
-          <a:blip r:embed="rId3"/>
+          <a:blip r:embed="rId4"/>
           <a:stretch>
             <a:fillRect/>
           </a:stretch>
@@ -5294,7 +5211,7 @@
 </file>
 
 <file path=ppt/slides/slide16.xml><?xml version="1.0" encoding="utf-8"?>
-<p:sld xmlns:a="http://schemas.openxmlformats.org/drawingml/2006/main" xmlns:p="http://schemas.openxmlformats.org/presentationml/2006/main" xmlns:r="http://schemas.openxmlformats.org/officeDocument/2006/relationships">
+<p:sld xmlns:a="http://schemas.openxmlformats.org/drawingml/2006/main" xmlns:r="http://schemas.openxmlformats.org/officeDocument/2006/relationships" xmlns:p="http://schemas.openxmlformats.org/presentationml/2006/main">
   <p:cSld>
     <p:spTree>
       <p:nvGrpSpPr>
@@ -5302,7 +5219,14 @@
         <p:cNvGrpSpPr/>
         <p:nvPr/>
       </p:nvGrpSpPr>
-      <p:grpSpPr/>
+      <p:grpSpPr>
+        <a:xfrm>
+          <a:off x="0" y="0"/>
+          <a:ext cx="0" cy="0"/>
+          <a:chOff x="0" y="0"/>
+          <a:chExt cx="0" cy="0"/>
+        </a:xfrm>
+      </p:grpSpPr>
       <p:sp>
         <p:nvSpPr>
           <p:cNvPr id="2" name="Title 1"/>
@@ -5346,13 +5270,16 @@
           </a:xfrm>
         </p:spPr>
         <p:txBody>
-          <a:bodyPr/>
+          <a:bodyPr>
+            <a:normAutofit/>
+          </a:bodyPr>
           <a:lstStyle/>
           <a:p>
             <a:pPr>
               <a:defRPr sz="1800"/>
             </a:pPr>
             <a:r>
+              <a:rPr sz="2400" dirty="0"/>
               <a:t>One donor, one sample per condition -&gt; NO biological replicates.</a:t>
             </a:r>
           </a:p>
@@ -5361,7 +5288,24 @@
               <a:defRPr sz="1800"/>
             </a:pPr>
             <a:r>
-              <a:t>DE is cell-level Wilcoxon (not pseudobulk); p-values exploratory, pseudoreplication caveat.</a:t>
+              <a:rPr sz="2400" dirty="0"/>
+              <a:t>DE is cell-level Wilcoxon (not </a:t>
+            </a:r>
+            <a:r>
+              <a:rPr sz="2400" dirty="0" err="1"/>
+              <a:t>pseudobulk</a:t>
+            </a:r>
+            <a:r>
+              <a:rPr sz="2400" dirty="0"/>
+              <a:t>); p-values exploratory, </a:t>
+            </a:r>
+            <a:r>
+              <a:rPr sz="2400" dirty="0" err="1"/>
+              <a:t>pseudoreplication</a:t>
+            </a:r>
+            <a:r>
+              <a:rPr sz="2400" dirty="0"/>
+              <a:t> caveat.</a:t>
             </a:r>
           </a:p>
           <a:p>
@@ -5369,6 +5313,7 @@
               <a:defRPr sz="1800"/>
             </a:pPr>
             <a:r>
+              <a:rPr sz="2400" dirty="0"/>
               <a:t>No external gene-level ground truth; DE validated internally + biologically.</a:t>
             </a:r>
           </a:p>
@@ -5377,6 +5322,7 @@
               <a:defRPr sz="1800"/>
             </a:pPr>
             <a:r>
+              <a:rPr sz="2400" dirty="0"/>
               <a:t>Everything reproduces: `python run_pipeline.py --all`; 37 offline intent tests.</a:t>
             </a:r>
           </a:p>
@@ -5391,7 +5337,7 @@
 </file>
 
 <file path=ppt/slides/slide2.xml><?xml version="1.0" encoding="utf-8"?>
-<p:sld xmlns:a="http://schemas.openxmlformats.org/drawingml/2006/main" xmlns:p="http://schemas.openxmlformats.org/presentationml/2006/main" xmlns:r="http://schemas.openxmlformats.org/officeDocument/2006/relationships">
+<p:sld xmlns:a="http://schemas.openxmlformats.org/drawingml/2006/main" xmlns:r="http://schemas.openxmlformats.org/officeDocument/2006/relationships" xmlns:p="http://schemas.openxmlformats.org/presentationml/2006/main">
   <p:cSld>
     <p:spTree>
       <p:nvGrpSpPr>
@@ -5399,7 +5345,14 @@
         <p:cNvGrpSpPr/>
         <p:nvPr/>
       </p:nvGrpSpPr>
-      <p:grpSpPr/>
+      <p:grpSpPr>
+        <a:xfrm>
+          <a:off x="0" y="0"/>
+          <a:ext cx="0" cy="0"/>
+          <a:chOff x="0" y="0"/>
+          <a:chExt cx="0" cy="0"/>
+        </a:xfrm>
+      </p:grpSpPr>
       <p:sp>
         <p:nvSpPr>
           <p:cNvPr id="2" name="Title 1"/>
@@ -5443,14 +5396,25 @@
           </a:xfrm>
         </p:spPr>
         <p:txBody>
-          <a:bodyPr/>
+          <a:bodyPr>
+            <a:normAutofit/>
+          </a:bodyPr>
           <a:lstStyle/>
           <a:p>
             <a:pPr>
               <a:defRPr sz="1800"/>
             </a:pPr>
             <a:r>
-              <a:t>Do small vs large nanoplastics provoke different immune responses?</a:t>
+              <a:rPr sz="2400" dirty="0"/>
+              <a:t>Do small vs large </a:t>
+            </a:r>
+            <a:r>
+              <a:rPr sz="2400" dirty="0" err="1"/>
+              <a:t>nanoplastics</a:t>
+            </a:r>
+            <a:r>
+              <a:rPr sz="2400" dirty="0"/>
+              <a:t> provoke different immune responses?</a:t>
             </a:r>
           </a:p>
           <a:p>
@@ -5458,6 +5422,7 @@
               <a:defRPr sz="1800"/>
             </a:pPr>
             <a:r>
+              <a:rPr sz="2400" dirty="0"/>
               <a:t>Does the 40+200 nm mixture do something neither size does alone?</a:t>
             </a:r>
           </a:p>
@@ -5466,7 +5431,16 @@
               <a:defRPr sz="1800"/>
             </a:pPr>
             <a:r>
-              <a:t>4 samples, one donor: PSNP_40nm, PSNP_200nm, PSNP_mixture, control</a:t>
+              <a:rPr sz="2400" dirty="0"/>
+              <a:t>4 samples, one donor: PSNP_40nm, PSNP_200nm, </a:t>
+            </a:r>
+            <a:r>
+              <a:rPr sz="2400" dirty="0" err="1"/>
+              <a:t>PSNP_mixture</a:t>
+            </a:r>
+            <a:r>
+              <a:rPr sz="2400" dirty="0"/>
+              <a:t>, control</a:t>
             </a:r>
           </a:p>
           <a:p>
@@ -5474,7 +5448,24 @@
               <a:defRPr sz="1800"/>
             </a:pPr>
             <a:r>
-              <a:t>~34,000 PBMCs, AnnData/.h5ad (Zenodo 10.5281/zenodo.15866724)</a:t>
+              <a:rPr sz="2400" dirty="0"/>
+              <a:t>~34,000 PBMCs, </a:t>
+            </a:r>
+            <a:r>
+              <a:rPr sz="2400" dirty="0" err="1"/>
+              <a:t>AnnData</a:t>
+            </a:r>
+            <a:r>
+              <a:rPr sz="2400" dirty="0"/>
+              <a:t>/.h5ad (</a:t>
+            </a:r>
+            <a:r>
+              <a:rPr sz="2400" dirty="0" err="1"/>
+              <a:t>Zenodo</a:t>
+            </a:r>
+            <a:r>
+              <a:rPr sz="2400" dirty="0"/>
+              <a:t> 10.5281/zenodo.15866724)</a:t>
             </a:r>
           </a:p>
         </p:txBody>
@@ -5488,7 +5479,7 @@
 </file>
 
 <file path=ppt/slides/slide3.xml><?xml version="1.0" encoding="utf-8"?>
-<p:sld xmlns:a="http://schemas.openxmlformats.org/drawingml/2006/main" xmlns:p="http://schemas.openxmlformats.org/presentationml/2006/main" xmlns:r="http://schemas.openxmlformats.org/officeDocument/2006/relationships">
+<p:sld xmlns:a="http://schemas.openxmlformats.org/drawingml/2006/main" xmlns:r="http://schemas.openxmlformats.org/officeDocument/2006/relationships" xmlns:p="http://schemas.openxmlformats.org/presentationml/2006/main">
   <p:cSld>
     <p:spTree>
       <p:nvGrpSpPr>
@@ -5496,7 +5487,14 @@
         <p:cNvGrpSpPr/>
         <p:nvPr/>
       </p:nvGrpSpPr>
-      <p:grpSpPr/>
+      <p:grpSpPr>
+        <a:xfrm>
+          <a:off x="0" y="0"/>
+          <a:ext cx="0" cy="0"/>
+          <a:chOff x="0" y="0"/>
+          <a:chExt cx="0" cy="0"/>
+        </a:xfrm>
+      </p:grpSpPr>
       <p:sp>
         <p:nvSpPr>
           <p:cNvPr id="2" name="Title 1"/>
@@ -5540,13 +5538,16 @@
           </a:xfrm>
         </p:spPr>
         <p:txBody>
-          <a:bodyPr/>
+          <a:bodyPr>
+            <a:normAutofit/>
+          </a:bodyPr>
           <a:lstStyle/>
           <a:p>
             <a:pPr>
               <a:defRPr sz="1800"/>
             </a:pPr>
             <a:r>
+              <a:rPr sz="2400" dirty="0"/>
               <a:t>1. QC &amp; preprocessing  -  thresholds justified on real percentiles</a:t>
             </a:r>
           </a:p>
@@ -5555,6 +5556,7 @@
               <a:defRPr sz="1800"/>
             </a:pPr>
             <a:r>
+              <a:rPr sz="2400" dirty="0"/>
               <a:t>2. Integration  -  Harmony batch correction, UMAP, Leiden</a:t>
             </a:r>
           </a:p>
@@ -5563,7 +5565,24 @@
               <a:defRPr sz="1800"/>
             </a:pPr>
             <a:r>
-              <a:t>3. Annotation  -  celltypist, cross-checked vs Azimuth &amp; CoDi (~93%)</a:t>
+              <a:rPr sz="2400" dirty="0"/>
+              <a:t>3. Annotation  -  </a:t>
+            </a:r>
+            <a:r>
+              <a:rPr sz="2400" dirty="0" err="1"/>
+              <a:t>celltypist</a:t>
+            </a:r>
+            <a:r>
+              <a:rPr sz="2400" dirty="0"/>
+              <a:t>, cross-checked vs Azimuth &amp; </a:t>
+            </a:r>
+            <a:r>
+              <a:rPr sz="2400" dirty="0" err="1"/>
+              <a:t>CoDi</a:t>
+            </a:r>
+            <a:r>
+              <a:rPr sz="2400" dirty="0"/>
+              <a:t> (~93%)</a:t>
             </a:r>
           </a:p>
           <a:p>
@@ -5571,6 +5590,7 @@
               <a:defRPr sz="1800"/>
             </a:pPr>
             <a:r>
+              <a:rPr sz="2400" dirty="0"/>
               <a:t>4. Composition  -  proportions + log2 fold-change vs control</a:t>
             </a:r>
           </a:p>
@@ -5579,6 +5599,7 @@
               <a:defRPr sz="1800"/>
             </a:pPr>
             <a:r>
+              <a:rPr sz="2400" dirty="0"/>
               <a:t>5. Differential expression  -  per-lineage Wilcoxon + pathway enrichment</a:t>
             </a:r>
           </a:p>
@@ -5587,6 +5608,7 @@
               <a:defRPr sz="1800"/>
             </a:pPr>
             <a:r>
+              <a:rPr sz="2400" dirty="0"/>
               <a:t>6. Size-specific effects  -  unique / shared / mixture-emergent genes</a:t>
             </a:r>
           </a:p>
@@ -5601,7 +5623,7 @@
 </file>
 
 <file path=ppt/slides/slide4.xml><?xml version="1.0" encoding="utf-8"?>
-<p:sld xmlns:a="http://schemas.openxmlformats.org/drawingml/2006/main" xmlns:p="http://schemas.openxmlformats.org/presentationml/2006/main" xmlns:r="http://schemas.openxmlformats.org/officeDocument/2006/relationships">
+<p:sld xmlns:a="http://schemas.openxmlformats.org/drawingml/2006/main" xmlns:r="http://schemas.openxmlformats.org/officeDocument/2006/relationships" xmlns:p="http://schemas.openxmlformats.org/presentationml/2006/main">
   <p:cSld>
     <p:spTree>
       <p:nvGrpSpPr>
@@ -5609,7 +5631,14 @@
         <p:cNvGrpSpPr/>
         <p:nvPr/>
       </p:nvGrpSpPr>
-      <p:grpSpPr/>
+      <p:grpSpPr>
+        <a:xfrm>
+          <a:off x="0" y="0"/>
+          <a:ext cx="0" cy="0"/>
+          <a:chOff x="0" y="0"/>
+          <a:chExt cx="0" cy="0"/>
+        </a:xfrm>
+      </p:grpSpPr>
       <p:sp>
         <p:nvSpPr>
           <p:cNvPr id="2" name="Title 1"/>
@@ -5645,7 +5674,7 @@
           <p:nvPr/>
         </p:nvPicPr>
         <p:blipFill>
-          <a:blip r:embed="rId2"/>
+          <a:blip r:embed="rId3"/>
           <a:stretch>
             <a:fillRect/>
           </a:stretch>
@@ -5700,7 +5729,7 @@
 </file>
 
 <file path=ppt/slides/slide5.xml><?xml version="1.0" encoding="utf-8"?>
-<p:sld xmlns:a="http://schemas.openxmlformats.org/drawingml/2006/main" xmlns:p="http://schemas.openxmlformats.org/presentationml/2006/main" xmlns:r="http://schemas.openxmlformats.org/officeDocument/2006/relationships">
+<p:sld xmlns:a="http://schemas.openxmlformats.org/drawingml/2006/main" xmlns:r="http://schemas.openxmlformats.org/officeDocument/2006/relationships" xmlns:p="http://schemas.openxmlformats.org/presentationml/2006/main">
   <p:cSld>
     <p:spTree>
       <p:nvGrpSpPr>
@@ -5708,7 +5737,14 @@
         <p:cNvGrpSpPr/>
         <p:nvPr/>
       </p:nvGrpSpPr>
-      <p:grpSpPr/>
+      <p:grpSpPr>
+        <a:xfrm>
+          <a:off x="0" y="0"/>
+          <a:ext cx="0" cy="0"/>
+          <a:chOff x="0" y="0"/>
+          <a:chExt cx="0" cy="0"/>
+        </a:xfrm>
+      </p:grpSpPr>
       <p:sp>
         <p:nvSpPr>
           <p:cNvPr id="2" name="Title 1"/>
@@ -5744,7 +5780,7 @@
           <p:nvPr/>
         </p:nvPicPr>
         <p:blipFill>
-          <a:blip r:embed="rId2"/>
+          <a:blip r:embed="rId3"/>
           <a:stretch>
             <a:fillRect/>
           </a:stretch>
@@ -5799,7 +5835,7 @@
 </file>
 
 <file path=ppt/slides/slide6.xml><?xml version="1.0" encoding="utf-8"?>
-<p:sld xmlns:a="http://schemas.openxmlformats.org/drawingml/2006/main" xmlns:p="http://schemas.openxmlformats.org/presentationml/2006/main" xmlns:r="http://schemas.openxmlformats.org/officeDocument/2006/relationships">
+<p:sld xmlns:a="http://schemas.openxmlformats.org/drawingml/2006/main" xmlns:r="http://schemas.openxmlformats.org/officeDocument/2006/relationships" xmlns:p="http://schemas.openxmlformats.org/presentationml/2006/main">
   <p:cSld>
     <p:spTree>
       <p:nvGrpSpPr>
@@ -5807,7 +5843,14 @@
         <p:cNvGrpSpPr/>
         <p:nvPr/>
       </p:nvGrpSpPr>
-      <p:grpSpPr/>
+      <p:grpSpPr>
+        <a:xfrm>
+          <a:off x="0" y="0"/>
+          <a:ext cx="0" cy="0"/>
+          <a:chOff x="0" y="0"/>
+          <a:chExt cx="0" cy="0"/>
+        </a:xfrm>
+      </p:grpSpPr>
       <p:sp>
         <p:nvSpPr>
           <p:cNvPr id="2" name="Title 1"/>
@@ -5843,7 +5886,7 @@
           <p:nvPr/>
         </p:nvPicPr>
         <p:blipFill>
-          <a:blip r:embed="rId2"/>
+          <a:blip r:embed="rId3"/>
           <a:stretch>
             <a:fillRect/>
           </a:stretch>
@@ -5867,7 +5910,7 @@
           <p:nvPr/>
         </p:nvPicPr>
         <p:blipFill>
-          <a:blip r:embed="rId3"/>
+          <a:blip r:embed="rId4"/>
           <a:stretch>
             <a:fillRect/>
           </a:stretch>
@@ -5922,7 +5965,7 @@
 </file>
 
 <file path=ppt/slides/slide7.xml><?xml version="1.0" encoding="utf-8"?>
-<p:sld xmlns:a="http://schemas.openxmlformats.org/drawingml/2006/main" xmlns:p="http://schemas.openxmlformats.org/presentationml/2006/main" xmlns:r="http://schemas.openxmlformats.org/officeDocument/2006/relationships">
+<p:sld xmlns:a="http://schemas.openxmlformats.org/drawingml/2006/main" xmlns:r="http://schemas.openxmlformats.org/officeDocument/2006/relationships" xmlns:p="http://schemas.openxmlformats.org/presentationml/2006/main">
   <p:cSld>
     <p:spTree>
       <p:nvGrpSpPr>
@@ -5930,7 +5973,14 @@
         <p:cNvGrpSpPr/>
         <p:nvPr/>
       </p:nvGrpSpPr>
-      <p:grpSpPr/>
+      <p:grpSpPr>
+        <a:xfrm>
+          <a:off x="0" y="0"/>
+          <a:ext cx="0" cy="0"/>
+          <a:chOff x="0" y="0"/>
+          <a:chExt cx="0" cy="0"/>
+        </a:xfrm>
+      </p:grpSpPr>
       <p:sp>
         <p:nvSpPr>
           <p:cNvPr id="2" name="Title 1"/>
@@ -5966,7 +6016,7 @@
           <p:nvPr/>
         </p:nvPicPr>
         <p:blipFill>
-          <a:blip r:embed="rId2"/>
+          <a:blip r:embed="rId3"/>
           <a:stretch>
             <a:fillRect/>
           </a:stretch>
@@ -5990,7 +6040,7 @@
           <p:nvPr/>
         </p:nvPicPr>
         <p:blipFill>
-          <a:blip r:embed="rId3"/>
+          <a:blip r:embed="rId4"/>
           <a:stretch>
             <a:fillRect/>
           </a:stretch>
@@ -6045,7 +6095,7 @@
 </file>
 
 <file path=ppt/slides/slide8.xml><?xml version="1.0" encoding="utf-8"?>
-<p:sld xmlns:a="http://schemas.openxmlformats.org/drawingml/2006/main" xmlns:p="http://schemas.openxmlformats.org/presentationml/2006/main" xmlns:r="http://schemas.openxmlformats.org/officeDocument/2006/relationships">
+<p:sld xmlns:a="http://schemas.openxmlformats.org/drawingml/2006/main" xmlns:r="http://schemas.openxmlformats.org/officeDocument/2006/relationships" xmlns:p="http://schemas.openxmlformats.org/presentationml/2006/main">
   <p:cSld>
     <p:spTree>
       <p:nvGrpSpPr>
@@ -6053,7 +6103,14 @@
         <p:cNvGrpSpPr/>
         <p:nvPr/>
       </p:nvGrpSpPr>
-      <p:grpSpPr/>
+      <p:grpSpPr>
+        <a:xfrm>
+          <a:off x="0" y="0"/>
+          <a:ext cx="0" cy="0"/>
+          <a:chOff x="0" y="0"/>
+          <a:chExt cx="0" cy="0"/>
+        </a:xfrm>
+      </p:grpSpPr>
       <p:sp>
         <p:nvSpPr>
           <p:cNvPr id="2" name="Title 1"/>
@@ -6089,7 +6146,7 @@
           <p:nvPr/>
         </p:nvPicPr>
         <p:blipFill>
-          <a:blip r:embed="rId2"/>
+          <a:blip r:embed="rId3"/>
           <a:stretch>
             <a:fillRect/>
           </a:stretch>
@@ -6113,7 +6170,7 @@
           <p:nvPr/>
         </p:nvPicPr>
         <p:blipFill>
-          <a:blip r:embed="rId3"/>
+          <a:blip r:embed="rId4"/>
           <a:stretch>
             <a:fillRect/>
           </a:stretch>
@@ -6168,7 +6225,7 @@
 </file>
 
 <file path=ppt/slides/slide9.xml><?xml version="1.0" encoding="utf-8"?>
-<p:sld xmlns:a="http://schemas.openxmlformats.org/drawingml/2006/main" xmlns:p="http://schemas.openxmlformats.org/presentationml/2006/main" xmlns:r="http://schemas.openxmlformats.org/officeDocument/2006/relationships">
+<p:sld xmlns:a="http://schemas.openxmlformats.org/drawingml/2006/main" xmlns:r="http://schemas.openxmlformats.org/officeDocument/2006/relationships" xmlns:p="http://schemas.openxmlformats.org/presentationml/2006/main">
   <p:cSld>
     <p:spTree>
       <p:nvGrpSpPr>
@@ -6176,7 +6233,14 @@
         <p:cNvGrpSpPr/>
         <p:nvPr/>
       </p:nvGrpSpPr>
-      <p:grpSpPr/>
+      <p:grpSpPr>
+        <a:xfrm>
+          <a:off x="0" y="0"/>
+          <a:ext cx="0" cy="0"/>
+          <a:chOff x="0" y="0"/>
+          <a:chExt cx="0" cy="0"/>
+        </a:xfrm>
+      </p:grpSpPr>
       <p:sp>
         <p:nvSpPr>
           <p:cNvPr id="2" name="Title 1"/>
@@ -6212,7 +6276,7 @@
           <p:nvPr/>
         </p:nvPicPr>
         <p:blipFill>
-          <a:blip r:embed="rId2"/>
+          <a:blip r:embed="rId3"/>
           <a:stretch>
             <a:fillRect/>
           </a:stretch>
@@ -6236,7 +6300,7 @@
           <p:nvPr/>
         </p:nvPicPr>
         <p:blipFill>
-          <a:blip r:embed="rId3"/>
+          <a:blip r:embed="rId4"/>
           <a:stretch>
             <a:fillRect/>
           </a:stretch>
@@ -6621,44 +6685,44 @@
         <a:sysClr val="window" lastClr="FFFFFF"/>
       </a:lt1>
       <a:dk2>
-        <a:srgbClr val="1F497D"/>
+        <a:srgbClr val="0E2841"/>
       </a:dk2>
       <a:lt2>
-        <a:srgbClr val="EEECE1"/>
+        <a:srgbClr val="E8E8E8"/>
       </a:lt2>
       <a:accent1>
-        <a:srgbClr val="4F81BD"/>
+        <a:srgbClr val="156082"/>
       </a:accent1>
       <a:accent2>
-        <a:srgbClr val="C0504D"/>
+        <a:srgbClr val="E97132"/>
       </a:accent2>
       <a:accent3>
-        <a:srgbClr val="9BBB59"/>
+        <a:srgbClr val="196B24"/>
       </a:accent3>
       <a:accent4>
-        <a:srgbClr val="8064A2"/>
+        <a:srgbClr val="0F9ED5"/>
       </a:accent4>
       <a:accent5>
-        <a:srgbClr val="4BACC6"/>
+        <a:srgbClr val="A02B93"/>
       </a:accent5>
       <a:accent6>
-        <a:srgbClr val="F79646"/>
+        <a:srgbClr val="4EA72E"/>
       </a:accent6>
       <a:hlink>
-        <a:srgbClr val="0000FF"/>
+        <a:srgbClr val="467886"/>
       </a:hlink>
       <a:folHlink>
-        <a:srgbClr val="800080"/>
+        <a:srgbClr val="96607D"/>
       </a:folHlink>
     </a:clrScheme>
     <a:fontScheme name="Office">
       <a:majorFont>
-        <a:latin typeface="Calibri"/>
+        <a:latin typeface="Aptos Display" panose="02110004020202020204"/>
         <a:ea typeface=""/>
         <a:cs typeface=""/>
-        <a:font script="Jpan" typeface="ＭＳ Ｐゴシック"/>
+        <a:font script="Jpan" typeface="游ゴシック Light"/>
         <a:font script="Hang" typeface="맑은 고딕"/>
-        <a:font script="Hans" typeface="宋体"/>
+        <a:font script="Hans" typeface="等线 Light"/>
         <a:font script="Hant" typeface="新細明體"/>
         <a:font script="Arab" typeface="Times New Roman"/>
         <a:font script="Hebr" typeface="Times New Roman"/>
@@ -6686,14 +6750,31 @@
         <a:font script="Viet" typeface="Times New Roman"/>
         <a:font script="Uigh" typeface="Microsoft Uighur"/>
         <a:font script="Geor" typeface="Sylfaen"/>
+        <a:font script="Armn" typeface="Arial"/>
+        <a:font script="Bugi" typeface="Leelawadee UI"/>
+        <a:font script="Bopo" typeface="Microsoft JhengHei"/>
+        <a:font script="Java" typeface="Javanese Text"/>
+        <a:font script="Lisu" typeface="Segoe UI"/>
+        <a:font script="Mymr" typeface="Myanmar Text"/>
+        <a:font script="Nkoo" typeface="Ebrima"/>
+        <a:font script="Olck" typeface="Nirmala UI"/>
+        <a:font script="Osma" typeface="Ebrima"/>
+        <a:font script="Phag" typeface="Phagspa"/>
+        <a:font script="Syrn" typeface="Estrangelo Edessa"/>
+        <a:font script="Syrj" typeface="Estrangelo Edessa"/>
+        <a:font script="Syre" typeface="Estrangelo Edessa"/>
+        <a:font script="Sora" typeface="Nirmala UI"/>
+        <a:font script="Tale" typeface="Microsoft Tai Le"/>
+        <a:font script="Talu" typeface="Microsoft New Tai Lue"/>
+        <a:font script="Tfng" typeface="Ebrima"/>
       </a:majorFont>
       <a:minorFont>
-        <a:latin typeface="Calibri"/>
+        <a:latin typeface="Aptos" panose="02110004020202020204"/>
         <a:ea typeface=""/>
         <a:cs typeface=""/>
-        <a:font script="Jpan" typeface="ＭＳ Ｐゴシック"/>
+        <a:font script="Jpan" typeface="游ゴシック"/>
         <a:font script="Hang" typeface="맑은 고딕"/>
-        <a:font script="Hans" typeface="宋体"/>
+        <a:font script="Hans" typeface="等线"/>
         <a:font script="Hant" typeface="新細明體"/>
         <a:font script="Arab" typeface="Arial"/>
         <a:font script="Hebr" typeface="Arial"/>
@@ -6721,6 +6802,23 @@
         <a:font script="Viet" typeface="Arial"/>
         <a:font script="Uigh" typeface="Microsoft Uighur"/>
         <a:font script="Geor" typeface="Sylfaen"/>
+        <a:font script="Armn" typeface="Arial"/>
+        <a:font script="Bugi" typeface="Leelawadee UI"/>
+        <a:font script="Bopo" typeface="Microsoft JhengHei"/>
+        <a:font script="Java" typeface="Javanese Text"/>
+        <a:font script="Lisu" typeface="Segoe UI"/>
+        <a:font script="Mymr" typeface="Myanmar Text"/>
+        <a:font script="Nkoo" typeface="Ebrima"/>
+        <a:font script="Olck" typeface="Nirmala UI"/>
+        <a:font script="Osma" typeface="Ebrima"/>
+        <a:font script="Phag" typeface="Phagspa"/>
+        <a:font script="Syrn" typeface="Estrangelo Edessa"/>
+        <a:font script="Syrj" typeface="Estrangelo Edessa"/>
+        <a:font script="Syre" typeface="Estrangelo Edessa"/>
+        <a:font script="Sora" typeface="Nirmala UI"/>
+        <a:font script="Tale" typeface="Microsoft Tai Le"/>
+        <a:font script="Talu" typeface="Microsoft New Tai Lue"/>
+        <a:font script="Tfng" typeface="Ebrima"/>
       </a:minorFont>
     </a:fontScheme>
     <a:fmtScheme name="Office">
@@ -6732,180 +6830,136 @@
           <a:gsLst>
             <a:gs pos="0">
               <a:schemeClr val="phClr">
-                <a:tint val="50000"/>
-                <a:satMod val="300000"/>
+                <a:lumMod val="110000"/>
+                <a:satMod val="105000"/>
+                <a:tint val="67000"/>
               </a:schemeClr>
             </a:gs>
-            <a:gs pos="35000">
+            <a:gs pos="50000">
               <a:schemeClr val="phClr">
-                <a:tint val="37000"/>
-                <a:satMod val="300000"/>
+                <a:lumMod val="105000"/>
+                <a:satMod val="103000"/>
+                <a:tint val="73000"/>
               </a:schemeClr>
             </a:gs>
             <a:gs pos="100000">
               <a:schemeClr val="phClr">
-                <a:tint val="15000"/>
-                <a:satMod val="350000"/>
+                <a:lumMod val="105000"/>
+                <a:satMod val="109000"/>
+                <a:tint val="81000"/>
               </a:schemeClr>
             </a:gs>
           </a:gsLst>
-          <a:lin ang="16200000" scaled="1"/>
+          <a:lin ang="5400000" scaled="0"/>
         </a:gradFill>
         <a:gradFill rotWithShape="1">
           <a:gsLst>
             <a:gs pos="0">
               <a:schemeClr val="phClr">
-                <a:tint val="100000"/>
+                <a:satMod val="103000"/>
+                <a:lumMod val="102000"/>
+                <a:tint val="94000"/>
+              </a:schemeClr>
+            </a:gs>
+            <a:gs pos="50000">
+              <a:schemeClr val="phClr">
+                <a:satMod val="110000"/>
+                <a:lumMod val="100000"/>
                 <a:shade val="100000"/>
-                <a:satMod val="130000"/>
               </a:schemeClr>
             </a:gs>
             <a:gs pos="100000">
               <a:schemeClr val="phClr">
-                <a:tint val="50000"/>
-                <a:shade val="100000"/>
-                <a:satMod val="350000"/>
+                <a:lumMod val="99000"/>
+                <a:satMod val="120000"/>
+                <a:shade val="78000"/>
               </a:schemeClr>
             </a:gs>
           </a:gsLst>
-          <a:lin ang="16200000" scaled="0"/>
+          <a:lin ang="5400000" scaled="0"/>
         </a:gradFill>
       </a:fillStyleLst>
       <a:lnStyleLst>
-        <a:ln w="9525" cap="flat" cmpd="sng" algn="ctr">
+        <a:ln w="12700" cap="flat" cmpd="sng" algn="ctr">
           <a:solidFill>
-            <a:schemeClr val="phClr">
-              <a:shade val="95000"/>
-              <a:satMod val="105000"/>
-            </a:schemeClr>
+            <a:schemeClr val="phClr"/>
           </a:solidFill>
           <a:prstDash val="solid"/>
+          <a:miter lim="800000"/>
+        </a:ln>
+        <a:ln w="19050" cap="flat" cmpd="sng" algn="ctr">
+          <a:solidFill>
+            <a:schemeClr val="phClr"/>
+          </a:solidFill>
+          <a:prstDash val="solid"/>
+          <a:miter lim="800000"/>
         </a:ln>
         <a:ln w="25400" cap="flat" cmpd="sng" algn="ctr">
           <a:solidFill>
             <a:schemeClr val="phClr"/>
           </a:solidFill>
           <a:prstDash val="solid"/>
-        </a:ln>
-        <a:ln w="38100" cap="flat" cmpd="sng" algn="ctr">
-          <a:solidFill>
-            <a:schemeClr val="phClr"/>
-          </a:solidFill>
-          <a:prstDash val="solid"/>
+          <a:miter lim="800000"/>
         </a:ln>
       </a:lnStyleLst>
       <a:effectStyleLst>
         <a:effectStyle>
+          <a:effectLst/>
+        </a:effectStyle>
+        <a:effectStyle>
+          <a:effectLst/>
+        </a:effectStyle>
+        <a:effectStyle>
           <a:effectLst>
-            <a:outerShdw blurRad="40000" dist="20000" dir="5400000" rotWithShape="0">
+            <a:outerShdw blurRad="57150" dist="19050" dir="5400000" algn="ctr" rotWithShape="0">
               <a:srgbClr val="000000">
-                <a:alpha val="38000"/>
+                <a:alpha val="63000"/>
               </a:srgbClr>
             </a:outerShdw>
           </a:effectLst>
-        </a:effectStyle>
-        <a:effectStyle>
-          <a:effectLst>
-            <a:outerShdw blurRad="40000" dist="23000" dir="5400000" rotWithShape="0">
-              <a:srgbClr val="000000">
-                <a:alpha val="35000"/>
-              </a:srgbClr>
-            </a:outerShdw>
-          </a:effectLst>
-        </a:effectStyle>
-        <a:effectStyle>
-          <a:effectLst>
-            <a:outerShdw blurRad="40000" dist="23000" dir="5400000" rotWithShape="0">
-              <a:srgbClr val="000000">
-                <a:alpha val="35000"/>
-              </a:srgbClr>
-            </a:outerShdw>
-          </a:effectLst>
-          <a:scene3d>
-            <a:camera prst="orthographicFront">
-              <a:rot lat="0" lon="0" rev="0"/>
-            </a:camera>
-            <a:lightRig rig="threePt" dir="t">
-              <a:rot lat="0" lon="0" rev="1200000"/>
-            </a:lightRig>
-          </a:scene3d>
-          <a:sp3d>
-            <a:bevelT w="63500" h="25400"/>
-          </a:sp3d>
         </a:effectStyle>
       </a:effectStyleLst>
       <a:bgFillStyleLst>
         <a:solidFill>
           <a:schemeClr val="phClr"/>
         </a:solidFill>
+        <a:solidFill>
+          <a:schemeClr val="phClr">
+            <a:tint val="95000"/>
+            <a:satMod val="170000"/>
+          </a:schemeClr>
+        </a:solidFill>
         <a:gradFill rotWithShape="1">
           <a:gsLst>
             <a:gs pos="0">
               <a:schemeClr val="phClr">
-                <a:tint val="40000"/>
-                <a:satMod val="350000"/>
+                <a:tint val="93000"/>
+                <a:satMod val="150000"/>
+                <a:shade val="98000"/>
+                <a:lumMod val="102000"/>
               </a:schemeClr>
             </a:gs>
-            <a:gs pos="40000">
+            <a:gs pos="50000">
               <a:schemeClr val="phClr">
-                <a:tint val="45000"/>
-                <a:shade val="99000"/>
-                <a:satMod val="350000"/>
+                <a:tint val="98000"/>
+                <a:satMod val="130000"/>
+                <a:shade val="90000"/>
+                <a:lumMod val="103000"/>
               </a:schemeClr>
             </a:gs>
             <a:gs pos="100000">
               <a:schemeClr val="phClr">
-                <a:shade val="20000"/>
-                <a:satMod val="255000"/>
+                <a:shade val="63000"/>
+                <a:satMod val="120000"/>
               </a:schemeClr>
             </a:gs>
           </a:gsLst>
-          <a:path path="circle">
-            <a:fillToRect l="50000" t="-80000" r="50000" b="180000"/>
-          </a:path>
-        </a:gradFill>
-        <a:gradFill rotWithShape="1">
-          <a:gsLst>
-            <a:gs pos="0">
-              <a:schemeClr val="phClr">
-                <a:tint val="80000"/>
-                <a:satMod val="300000"/>
-              </a:schemeClr>
-            </a:gs>
-            <a:gs pos="100000">
-              <a:schemeClr val="phClr">
-                <a:shade val="30000"/>
-                <a:satMod val="200000"/>
-              </a:schemeClr>
-            </a:gs>
-          </a:gsLst>
-          <a:path path="circle">
-            <a:fillToRect l="50000" t="50000" r="50000" b="50000"/>
-          </a:path>
+          <a:lin ang="5400000" scaled="0"/>
         </a:gradFill>
       </a:bgFillStyleLst>
     </a:fmtScheme>
   </a:themeElements>
   <a:objectDefaults>
-    <a:spDef>
-      <a:spPr/>
-      <a:bodyPr/>
-      <a:lstStyle/>
-      <a:style>
-        <a:lnRef idx="1">
-          <a:schemeClr val="accent1"/>
-        </a:lnRef>
-        <a:fillRef idx="3">
-          <a:schemeClr val="accent1"/>
-        </a:fillRef>
-        <a:effectRef idx="2">
-          <a:schemeClr val="accent1"/>
-        </a:effectRef>
-        <a:fontRef idx="minor">
-          <a:schemeClr val="lt1"/>
-        </a:fontRef>
-      </a:style>
-    </a:spDef>
     <a:lnDef>
       <a:spPr/>
       <a:bodyPr/>
@@ -6927,5 +6981,16 @@
     </a:lnDef>
   </a:objectDefaults>
   <a:extraClrSchemeLst/>
+  <a:extLst>
+    <a:ext uri="{05A4C25C-085E-4340-85A3-A5531E510DB2}">
+      <thm15:themeFamily xmlns:thm15="http://schemas.microsoft.com/office/thememl/2012/main" name="Office Theme" id="{2E142A2C-CD16-42D6-873A-C26D2A0506FA}" vid="{1BDDFF52-6CD6-40A5-AB3C-68EB2F1E4D0A}"/>
+    </a:ext>
+  </a:extLst>
 </a:theme>
+</file>
+
+<file path=docMetadata/LabelInfo.xml><?xml version="1.0" encoding="utf-8"?>
+<clbl:labelList xmlns:clbl="http://schemas.microsoft.com/office/2020/mipLabelMetadata">
+  <clbl:label id="{f39aa4b3-b62d-42bf-8097-75e2c573ddfa}" enabled="1" method="Privileged" siteId="{3dd8961f-e488-4e60-8e11-a82d994e183d}" contentBits="0" removed="0"/>
+</clbl:labelList>
 </file>
</xml_diff>